<commit_message>
docs(presentation): refresh slides 4/6/13 after worker-uniform fix
Slide 4 — swap Mars-only and Gremlin bullets for Liu et al. (2025) and
Mutiny! (DSN 2024), the closest peer-reviewed 2024–2025 work. A defence
in 2026 needs to position against current literature, not 2010s only.

Slide 6 — workers are now all 4 GiB after the proxmox standardisation;
total updated to 18 GiB.

Slide 13 — Cluster scale text reflects the uniform-worker fact (removes
the previously-flagged heterogeneous-cluster confound). Adds a fourth
External Validity item, Metric portability, calling out cgroup-v2 /
Calico / etcd-version dependencies and pointing at metricAvailability
as the in-band surface that records what was actually collected.

Presentation script updated to match.

Co-Authored-By: Claude Opus 4.7 (1M context) <noreply@anthropic.com>
</commit_message>
<xml_diff>
--- a/ChaosProbe_Presentation.pptx
+++ b/ChaosProbe_Presentation.pptx
@@ -3406,30 +3406,75 @@
           </a:p>
         </p:txBody>
       </p:sp>
-      <p:pic>
-        <p:nvPicPr>
-          <p:cNvPr id="4" name="Picture 3" descr="recovery_times.png"/>
-          <p:cNvPicPr>
-            <a:picLocks noChangeAspect="1"/>
-          </p:cNvPicPr>
-          <p:nvPr/>
-        </p:nvPicPr>
-        <p:blipFill>
-          <a:blip r:embed="rId2"/>
-          <a:stretch>
-            <a:fillRect/>
-          </a:stretch>
-        </p:blipFill>
+      <p:sp>
+        <p:nvSpPr>
+          <p:cNvPr id="4" name="Rounded Rectangle 3"/>
+          <p:cNvSpPr/>
+          <p:nvPr/>
+        </p:nvSpPr>
         <p:spPr>
           <a:xfrm>
             <a:off x="274320" y="1280160"/>
             <a:ext cx="5669280" cy="3200400"/>
           </a:xfrm>
-          <a:prstGeom prst="rect">
-            <a:avLst/>
-          </a:prstGeom>
-        </p:spPr>
-      </p:pic>
+          <a:prstGeom prst="roundRect">
+            <a:avLst/>
+          </a:prstGeom>
+          <a:solidFill>
+            <a:srgbClr val="121222"/>
+          </a:solidFill>
+          <a:ln w="12700">
+            <a:solidFill>
+              <a:srgbClr val="9090A0"/>
+            </a:solidFill>
+          </a:ln>
+        </p:spPr>
+        <p:style>
+          <a:lnRef idx="1">
+            <a:schemeClr val="accent1"/>
+          </a:lnRef>
+          <a:fillRef idx="3">
+            <a:schemeClr val="accent1"/>
+          </a:fillRef>
+          <a:effectRef idx="2">
+            <a:schemeClr val="accent1"/>
+          </a:effectRef>
+          <a:fontRef idx="minor">
+            <a:schemeClr val="lt1"/>
+          </a:fontRef>
+        </p:style>
+        <p:txBody>
+          <a:bodyPr rtlCol="0" anchor="ctr" wrap="square" lIns="50800" rIns="50800" tIns="25400" bIns="25400"/>
+          <a:lstStyle/>
+          <a:p>
+            <a:pPr algn="ctr">
+              <a:defRPr sz="1100" b="0">
+                <a:solidFill>
+                  <a:srgbClr val="9090A0"/>
+                </a:solidFill>
+                <a:latin typeface="Calibri"/>
+              </a:defRPr>
+            </a:pPr>
+            <a:r>
+              <a:t>[Recovery Times by Strategy]</a:t>
+            </a:r>
+            <a:br/>
+            <a:br/>
+            <a:r>
+              <a:t>Box plot: pod deletion → ready (ms)</a:t>
+            </a:r>
+            <a:br/>
+            <a:r>
+              <a:t>per placement strategy.</a:t>
+            </a:r>
+            <a:br/>
+            <a:br/>
+            <a:r>
+              <a:t>Generated by: chaosprobe visualize</a:t>
+            </a:r>
+          </a:p>
+        </p:txBody>
+      </p:sp>
       <p:sp>
         <p:nvSpPr>
           <p:cNvPr id="5" name="TextBox 4"/>
@@ -3466,30 +3511,75 @@
           </a:p>
         </p:txBody>
       </p:sp>
-      <p:pic>
-        <p:nvPicPr>
-          <p:cNvPr id="6" name="Picture 5" descr="latency_degradation.png"/>
-          <p:cNvPicPr>
-            <a:picLocks noChangeAspect="1"/>
-          </p:cNvPicPr>
-          <p:nvPr/>
-        </p:nvPicPr>
-        <p:blipFill>
-          <a:blip r:embed="rId3"/>
-          <a:stretch>
-            <a:fillRect/>
-          </a:stretch>
-        </p:blipFill>
+      <p:sp>
+        <p:nvSpPr>
+          <p:cNvPr id="6" name="Rounded Rectangle 5"/>
+          <p:cNvSpPr/>
+          <p:nvPr/>
+        </p:nvSpPr>
         <p:spPr>
           <a:xfrm>
             <a:off x="6217920" y="1280160"/>
             <a:ext cx="5669280" cy="3200400"/>
           </a:xfrm>
-          <a:prstGeom prst="rect">
-            <a:avLst/>
-          </a:prstGeom>
-        </p:spPr>
-      </p:pic>
+          <a:prstGeom prst="roundRect">
+            <a:avLst/>
+          </a:prstGeom>
+          <a:solidFill>
+            <a:srgbClr val="121222"/>
+          </a:solidFill>
+          <a:ln w="12700">
+            <a:solidFill>
+              <a:srgbClr val="9090A0"/>
+            </a:solidFill>
+          </a:ln>
+        </p:spPr>
+        <p:style>
+          <a:lnRef idx="1">
+            <a:schemeClr val="accent1"/>
+          </a:lnRef>
+          <a:fillRef idx="3">
+            <a:schemeClr val="accent1"/>
+          </a:fillRef>
+          <a:effectRef idx="2">
+            <a:schemeClr val="accent1"/>
+          </a:effectRef>
+          <a:fontRef idx="minor">
+            <a:schemeClr val="lt1"/>
+          </a:fontRef>
+        </p:style>
+        <p:txBody>
+          <a:bodyPr rtlCol="0" anchor="ctr" wrap="square" lIns="50800" rIns="50800" tIns="25400" bIns="25400"/>
+          <a:lstStyle/>
+          <a:p>
+            <a:pPr algn="ctr">
+              <a:defRPr sz="1100" b="0">
+                <a:solidFill>
+                  <a:srgbClr val="9090A0"/>
+                </a:solidFill>
+                <a:latin typeface="Calibri"/>
+              </a:defRPr>
+            </a:pPr>
+            <a:r>
+              <a:t>[Latency Degradation: Pre vs During Chaos]</a:t>
+            </a:r>
+            <a:br/>
+            <a:br/>
+            <a:r>
+              <a:t>Grouped bar chart: HTTP route latency</a:t>
+            </a:r>
+            <a:br/>
+            <a:r>
+              <a:t>pre-chaos vs during-chaos per strategy.</a:t>
+            </a:r>
+            <a:br/>
+            <a:br/>
+            <a:r>
+              <a:t>Generated by: chaosprobe visualize</a:t>
+            </a:r>
+          </a:p>
+        </p:txBody>
+      </p:sp>
       <p:sp>
         <p:nvSpPr>
           <p:cNvPr id="7" name="TextBox 6"/>
@@ -3973,30 +4063,75 @@
           </a:p>
         </p:txBody>
       </p:sp>
-      <p:pic>
-        <p:nvPicPr>
-          <p:cNvPr id="4" name="Picture 3" descr="resource_utilization.png"/>
-          <p:cNvPicPr>
-            <a:picLocks noChangeAspect="1"/>
-          </p:cNvPicPr>
-          <p:nvPr/>
-        </p:nvPicPr>
-        <p:blipFill>
-          <a:blip r:embed="rId2"/>
-          <a:stretch>
-            <a:fillRect/>
-          </a:stretch>
-        </p:blipFill>
+      <p:sp>
+        <p:nvSpPr>
+          <p:cNvPr id="4" name="Rounded Rectangle 3"/>
+          <p:cNvSpPr/>
+          <p:nvPr/>
+        </p:nvSpPr>
         <p:spPr>
           <a:xfrm>
             <a:off x="274320" y="1280160"/>
             <a:ext cx="5669280" cy="3200400"/>
           </a:xfrm>
-          <a:prstGeom prst="rect">
-            <a:avLst/>
-          </a:prstGeom>
-        </p:spPr>
-      </p:pic>
+          <a:prstGeom prst="roundRect">
+            <a:avLst/>
+          </a:prstGeom>
+          <a:solidFill>
+            <a:srgbClr val="121222"/>
+          </a:solidFill>
+          <a:ln w="12700">
+            <a:solidFill>
+              <a:srgbClr val="9090A0"/>
+            </a:solidFill>
+          </a:ln>
+        </p:spPr>
+        <p:style>
+          <a:lnRef idx="1">
+            <a:schemeClr val="accent1"/>
+          </a:lnRef>
+          <a:fillRef idx="3">
+            <a:schemeClr val="accent1"/>
+          </a:fillRef>
+          <a:effectRef idx="2">
+            <a:schemeClr val="accent1"/>
+          </a:effectRef>
+          <a:fontRef idx="minor">
+            <a:schemeClr val="lt1"/>
+          </a:fontRef>
+        </p:style>
+        <p:txBody>
+          <a:bodyPr rtlCol="0" anchor="ctr" wrap="square" lIns="50800" rIns="50800" tIns="25400" bIns="25400"/>
+          <a:lstStyle/>
+          <a:p>
+            <a:pPr algn="ctr">
+              <a:defRPr sz="1100" b="0">
+                <a:solidFill>
+                  <a:srgbClr val="9090A0"/>
+                </a:solidFill>
+                <a:latin typeface="Calibri"/>
+              </a:defRPr>
+            </a:pPr>
+            <a:r>
+              <a:t>[Resource Utilization (CPU/Memory)]</a:t>
+            </a:r>
+            <a:br/>
+            <a:br/>
+            <a:r>
+              <a:t>Per-strategy CPU and memory utilization</a:t>
+            </a:r>
+            <a:br/>
+            <a:r>
+              <a:t>across experiment phases.</a:t>
+            </a:r>
+            <a:br/>
+            <a:br/>
+            <a:r>
+              <a:t>Generated by: chaosprobe visualize</a:t>
+            </a:r>
+          </a:p>
+        </p:txBody>
+      </p:sp>
       <p:sp>
         <p:nvSpPr>
           <p:cNvPr id="5" name="TextBox 4"/>
@@ -4033,30 +4168,75 @@
           </a:p>
         </p:txBody>
       </p:sp>
-      <p:pic>
-        <p:nvPicPr>
-          <p:cNvPr id="6" name="Picture 5" descr="throughput_by_strategy.png"/>
-          <p:cNvPicPr>
-            <a:picLocks noChangeAspect="1"/>
-          </p:cNvPicPr>
-          <p:nvPr/>
-        </p:nvPicPr>
-        <p:blipFill>
-          <a:blip r:embed="rId3"/>
-          <a:stretch>
-            <a:fillRect/>
-          </a:stretch>
-        </p:blipFill>
+      <p:sp>
+        <p:nvSpPr>
+          <p:cNvPr id="6" name="Rounded Rectangle 5"/>
+          <p:cNvSpPr/>
+          <p:nvPr/>
+        </p:nvSpPr>
         <p:spPr>
           <a:xfrm>
             <a:off x="6217920" y="1280160"/>
             <a:ext cx="5669280" cy="3200400"/>
           </a:xfrm>
-          <a:prstGeom prst="rect">
-            <a:avLst/>
-          </a:prstGeom>
-        </p:spPr>
-      </p:pic>
+          <a:prstGeom prst="roundRect">
+            <a:avLst/>
+          </a:prstGeom>
+          <a:solidFill>
+            <a:srgbClr val="121222"/>
+          </a:solidFill>
+          <a:ln w="12700">
+            <a:solidFill>
+              <a:srgbClr val="9090A0"/>
+            </a:solidFill>
+          </a:ln>
+        </p:spPr>
+        <p:style>
+          <a:lnRef idx="1">
+            <a:schemeClr val="accent1"/>
+          </a:lnRef>
+          <a:fillRef idx="3">
+            <a:schemeClr val="accent1"/>
+          </a:fillRef>
+          <a:effectRef idx="2">
+            <a:schemeClr val="accent1"/>
+          </a:effectRef>
+          <a:fontRef idx="minor">
+            <a:schemeClr val="lt1"/>
+          </a:fontRef>
+        </p:style>
+        <p:txBody>
+          <a:bodyPr rtlCol="0" anchor="ctr" wrap="square" lIns="50800" rIns="50800" tIns="25400" bIns="25400"/>
+          <a:lstStyle/>
+          <a:p>
+            <a:pPr algn="ctr">
+              <a:defRPr sz="1100" b="0">
+                <a:solidFill>
+                  <a:srgbClr val="9090A0"/>
+                </a:solidFill>
+                <a:latin typeface="Calibri"/>
+              </a:defRPr>
+            </a:pPr>
+            <a:r>
+              <a:t>[I/O Throughput by Strategy]</a:t>
+            </a:r>
+            <a:br/>
+            <a:br/>
+            <a:r>
+              <a:t>Redis ops/s and disk R/W bytes/s</a:t>
+            </a:r>
+            <a:br/>
+            <a:r>
+              <a:t>per placement strategy.</a:t>
+            </a:r>
+            <a:br/>
+            <a:br/>
+            <a:r>
+              <a:t>Generated by: chaosprobe visualize</a:t>
+            </a:r>
+          </a:p>
+        </p:txBody>
+      </p:sp>
       <p:sp>
         <p:nvSpPr>
           <p:cNvPr id="7" name="TextBox 6"/>
@@ -4536,30 +4716,75 @@
           </a:p>
         </p:txBody>
       </p:sp>
-      <p:pic>
-        <p:nvPicPr>
-          <p:cNvPr id="4" name="Picture 3" descr="strategy_comparison_heatmap.png"/>
-          <p:cNvPicPr>
-            <a:picLocks noChangeAspect="1"/>
-          </p:cNvPicPr>
-          <p:nvPr/>
-        </p:nvPicPr>
-        <p:blipFill>
-          <a:blip r:embed="rId2"/>
-          <a:stretch>
-            <a:fillRect/>
-          </a:stretch>
-        </p:blipFill>
+      <p:sp>
+        <p:nvSpPr>
+          <p:cNvPr id="4" name="Rounded Rectangle 3"/>
+          <p:cNvSpPr/>
+          <p:nvPr/>
+        </p:nvSpPr>
         <p:spPr>
           <a:xfrm>
             <a:off x="274320" y="1280160"/>
             <a:ext cx="5943600" cy="3200400"/>
           </a:xfrm>
-          <a:prstGeom prst="rect">
-            <a:avLst/>
-          </a:prstGeom>
-        </p:spPr>
-      </p:pic>
+          <a:prstGeom prst="roundRect">
+            <a:avLst/>
+          </a:prstGeom>
+          <a:solidFill>
+            <a:srgbClr val="121222"/>
+          </a:solidFill>
+          <a:ln w="12700">
+            <a:solidFill>
+              <a:srgbClr val="9090A0"/>
+            </a:solidFill>
+          </a:ln>
+        </p:spPr>
+        <p:style>
+          <a:lnRef idx="1">
+            <a:schemeClr val="accent1"/>
+          </a:lnRef>
+          <a:fillRef idx="3">
+            <a:schemeClr val="accent1"/>
+          </a:fillRef>
+          <a:effectRef idx="2">
+            <a:schemeClr val="accent1"/>
+          </a:effectRef>
+          <a:fontRef idx="minor">
+            <a:schemeClr val="lt1"/>
+          </a:fontRef>
+        </p:style>
+        <p:txBody>
+          <a:bodyPr rtlCol="0" anchor="ctr" wrap="square" lIns="50800" rIns="50800" tIns="25400" bIns="25400"/>
+          <a:lstStyle/>
+          <a:p>
+            <a:pPr algn="ctr">
+              <a:defRPr sz="1100" b="0">
+                <a:solidFill>
+                  <a:srgbClr val="9090A0"/>
+                </a:solidFill>
+                <a:latin typeface="Calibri"/>
+              </a:defRPr>
+            </a:pPr>
+            <a:r>
+              <a:t>[Strategy Comparison Heatmap]</a:t>
+            </a:r>
+            <a:br/>
+            <a:br/>
+            <a:r>
+              <a:t>All thesis dimensions normalised to 0-1.</a:t>
+            </a:r>
+            <a:br/>
+            <a:r>
+              <a:t>Green = better, Red = worse.</a:t>
+            </a:r>
+            <a:br/>
+            <a:br/>
+            <a:r>
+              <a:t>Generated by: chaosprobe visualize</a:t>
+            </a:r>
+          </a:p>
+        </p:txBody>
+      </p:sp>
       <p:sp>
         <p:nvSpPr>
           <p:cNvPr id="5" name="TextBox 4"/>
@@ -6204,7 +6429,7 @@
         <p:spPr>
           <a:xfrm>
             <a:off x="6492240" y="2240280"/>
-            <a:ext cx="5120640" cy="914400"/>
+            <a:ext cx="5120640" cy="777240"/>
           </a:xfrm>
           <a:prstGeom prst="rect">
             <a:avLst/>
@@ -6226,7 +6451,7 @@
               </a:defRPr>
             </a:pPr>
             <a:r>
-              <a:t>5-node cluster (1 control plane + 4 workers, 10 vCPU, 14 GiB). Larger clusters with more nodes and resources may show different placement effects.</a:t>
+              <a:t>5-node cluster (1 control plane + 4 uniform 4-GiB workers, 10 vCPU, 18 GiB). Larger clusters may show different placement effects.</a:t>
             </a:r>
           </a:p>
         </p:txBody>
@@ -6239,7 +6464,7 @@
         </p:nvSpPr>
         <p:spPr>
           <a:xfrm>
-            <a:off x="6492240" y="3383280"/>
+            <a:off x="6492240" y="3108960"/>
             <a:ext cx="5120640" cy="274320"/>
           </a:xfrm>
           <a:prstGeom prst="rect">
@@ -6275,8 +6500,8 @@
         </p:nvSpPr>
         <p:spPr>
           <a:xfrm>
-            <a:off x="6492240" y="3703320"/>
-            <a:ext cx="5120640" cy="914400"/>
+            <a:off x="6492240" y="3429000"/>
+            <a:ext cx="5120640" cy="777240"/>
           </a:xfrm>
           <a:prstGeom prst="rect">
             <a:avLst/>
@@ -6298,7 +6523,7 @@
               </a:defRPr>
             </a:pPr>
             <a:r>
-              <a:t>Only pod-delete and pod-cpu-hog tested. Network partitions, disk faults, and memory pressure faults may reveal different strategy rankings.</a:t>
+              <a:t>Only pod-delete and pod-cpu-hog tested. Network partitions, disk faults, and memory pressure may reveal different strategy rankings.</a:t>
             </a:r>
           </a:p>
         </p:txBody>
@@ -6311,7 +6536,7 @@
         </p:nvSpPr>
         <p:spPr>
           <a:xfrm>
-            <a:off x="6492240" y="4846320"/>
+            <a:off x="6492240" y="4297680"/>
             <a:ext cx="5120640" cy="274320"/>
           </a:xfrm>
           <a:prstGeom prst="rect">
@@ -6347,8 +6572,8 @@
         </p:nvSpPr>
         <p:spPr>
           <a:xfrm>
-            <a:off x="6492240" y="5166360"/>
-            <a:ext cx="5120640" cy="914400"/>
+            <a:off x="6492240" y="4617720"/>
+            <a:ext cx="5120640" cy="777240"/>
           </a:xfrm>
           <a:prstGeom prst="rect">
             <a:avLst/>
@@ -6371,6 +6596,78 @@
             </a:pPr>
             <a:r>
               <a:t>Steady-state load (50 users, 10/s). Bursty, ramping, or production-like traffic patterns may affect results differently.</a:t>
+            </a:r>
+          </a:p>
+        </p:txBody>
+      </p:sp>
+      <p:sp>
+        <p:nvSpPr>
+          <p:cNvPr id="20" name="TextBox 19"/>
+          <p:cNvSpPr txBox="1"/>
+          <p:nvPr/>
+        </p:nvSpPr>
+        <p:spPr>
+          <a:xfrm>
+            <a:off x="6492240" y="5486400"/>
+            <a:ext cx="5120640" cy="274320"/>
+          </a:xfrm>
+          <a:prstGeom prst="rect">
+            <a:avLst/>
+          </a:prstGeom>
+          <a:noFill/>
+        </p:spPr>
+        <p:txBody>
+          <a:bodyPr wrap="square">
+            <a:spAutoFit/>
+          </a:bodyPr>
+          <a:lstStyle/>
+          <a:p>
+            <a:pPr algn="l">
+              <a:defRPr sz="1300" b="1">
+                <a:solidFill>
+                  <a:srgbClr val="FFFFFF"/>
+                </a:solidFill>
+                <a:latin typeface="Calibri"/>
+              </a:defRPr>
+            </a:pPr>
+            <a:r>
+              <a:t>Metric portability</a:t>
+            </a:r>
+          </a:p>
+        </p:txBody>
+      </p:sp>
+      <p:sp>
+        <p:nvSpPr>
+          <p:cNvPr id="21" name="TextBox 20"/>
+          <p:cNvSpPr txBox="1"/>
+          <p:nvPr/>
+        </p:nvSpPr>
+        <p:spPr>
+          <a:xfrm>
+            <a:off x="6492240" y="5806440"/>
+            <a:ext cx="5120640" cy="777240"/>
+          </a:xfrm>
+          <a:prstGeom prst="rect">
+            <a:avLst/>
+          </a:prstGeom>
+          <a:noFill/>
+        </p:spPr>
+        <p:txBody>
+          <a:bodyPr wrap="square">
+            <a:spAutoFit/>
+          </a:bodyPr>
+          <a:lstStyle/>
+          <a:p>
+            <a:pPr algn="l">
+              <a:defRPr sz="1100" b="0">
+                <a:solidFill>
+                  <a:srgbClr val="BDBDBD"/>
+                </a:solidFill>
+                <a:latin typeface="Calibri"/>
+              </a:defRPr>
+            </a:pPr>
+            <a:r>
+              <a:t>PSI requires cgroup-v2, Felix requires Calico, etcd_debugging_* is K8s-version-fragile. metricAvailability surfaces which metrics were collected per run.</a:t>
             </a:r>
           </a:p>
         </p:txBody>
@@ -9224,8 +9521,8 @@
         </p:nvSpPr>
         <p:spPr>
           <a:xfrm>
-            <a:off x="548640" y="1371600"/>
-            <a:ext cx="11064240" cy="1188720"/>
+            <a:off x="548640" y="1188720"/>
+            <a:ext cx="11064240" cy="777240"/>
           </a:xfrm>
           <a:prstGeom prst="roundRect">
             <a:avLst/>
@@ -9269,8 +9566,8 @@
         </p:nvSpPr>
         <p:spPr>
           <a:xfrm>
-            <a:off x="731520" y="1417320"/>
-            <a:ext cx="10698480" cy="320040"/>
+            <a:off x="731520" y="1280160"/>
+            <a:ext cx="10698480" cy="594360"/>
           </a:xfrm>
           <a:prstGeom prst="rect">
             <a:avLst/>
@@ -9283,16 +9580,16 @@
           </a:bodyPr>
           <a:lstStyle/>
           <a:p>
-            <a:pPr algn="l">
-              <a:defRPr sz="1400" b="1">
-                <a:solidFill>
-                  <a:srgbClr val="0096D6"/>
-                </a:solidFill>
-                <a:latin typeface="Calibri"/>
-              </a:defRPr>
-            </a:pPr>
-            <a:r>
-              <a:t>Research Question</a:t>
+            <a:pPr algn="ctr">
+              <a:defRPr sz="1600" b="1">
+                <a:solidFill>
+                  <a:srgbClr val="FFFFFF"/>
+                </a:solidFill>
+                <a:latin typeface="Calibri"/>
+              </a:defRPr>
+            </a:pPr>
+            <a:r>
+              <a:t>How do multi-dimensional metrics decompose chaos response across pod-placement strategies in Kubernetes?</a:t>
             </a:r>
           </a:p>
         </p:txBody>
@@ -9305,8 +9602,8 @@
         </p:nvSpPr>
         <p:spPr>
           <a:xfrm>
-            <a:off x="731520" y="1828800"/>
-            <a:ext cx="10698480" cy="548640"/>
+            <a:off x="182880" y="2057400"/>
+            <a:ext cx="4572000" cy="228600"/>
           </a:xfrm>
           <a:prstGeom prst="rect">
             <a:avLst/>
@@ -9319,20 +9616,16 @@
           </a:bodyPr>
           <a:lstStyle/>
           <a:p>
-            <a:pPr algn="ctr">
-              <a:defRPr sz="2200" b="1">
-                <a:solidFill>
-                  <a:srgbClr val="FFFFFF"/>
-                </a:solidFill>
-                <a:latin typeface="Calibri"/>
-              </a:defRPr>
-            </a:pPr>
-            <a:r>
-              <a:t>How does pod placement topology affect microservice resilience</a:t>
-            </a:r>
-            <a:br/>
-            <a:r>
-              <a:t>under fault injection in Kubernetes?</a:t>
+            <a:pPr algn="l">
+              <a:defRPr sz="1100" b="1">
+                <a:solidFill>
+                  <a:srgbClr val="0096D6"/>
+                </a:solidFill>
+                <a:latin typeface="Calibri"/>
+              </a:defRPr>
+            </a:pPr>
+            <a:r>
+              <a:t>Instrument design</a:t>
             </a:r>
           </a:p>
         </p:txBody>
@@ -9345,8 +9638,8 @@
         </p:nvSpPr>
         <p:spPr>
           <a:xfrm>
-            <a:off x="548640" y="2834640"/>
-            <a:ext cx="10972800" cy="320040"/>
+            <a:off x="7178040" y="2057400"/>
+            <a:ext cx="4572000" cy="228600"/>
           </a:xfrm>
           <a:prstGeom prst="rect">
             <a:avLst/>
@@ -9360,38 +9653,112 @@
           <a:lstStyle/>
           <a:p>
             <a:pPr algn="l">
-              <a:defRPr sz="1800" b="1">
-                <a:solidFill>
-                  <a:srgbClr val="2ECC71"/>
-                </a:solidFill>
-                <a:latin typeface="Calibri"/>
-              </a:defRPr>
-            </a:pPr>
-            <a:r>
-              <a:t>Hypotheses</a:t>
-            </a:r>
-          </a:p>
-        </p:txBody>
-      </p:sp>
-      <p:sp>
-        <p:nvSpPr>
-          <p:cNvPr id="8" name="Rounded Rectangle 7"/>
+              <a:defRPr sz="1100" b="1">
+                <a:solidFill>
+                  <a:srgbClr val="F39C12"/>
+                </a:solidFill>
+                <a:latin typeface="Calibri"/>
+              </a:defRPr>
+            </a:pPr>
+            <a:r>
+              <a:t>Baseline &amp; tail</a:t>
+            </a:r>
+          </a:p>
+        </p:txBody>
+      </p:sp>
+      <p:sp>
+        <p:nvSpPr>
+          <p:cNvPr id="8" name="TextBox 7"/>
+          <p:cNvSpPr txBox="1"/>
+          <p:nvPr/>
+        </p:nvSpPr>
+        <p:spPr>
+          <a:xfrm>
+            <a:off x="182880" y="4206240"/>
+            <a:ext cx="4572000" cy="228600"/>
+          </a:xfrm>
+          <a:prstGeom prst="rect">
+            <a:avLst/>
+          </a:prstGeom>
+          <a:noFill/>
+        </p:spPr>
+        <p:txBody>
+          <a:bodyPr wrap="square">
+            <a:spAutoFit/>
+          </a:bodyPr>
+          <a:lstStyle/>
+          <a:p>
+            <a:pPr algn="l">
+              <a:defRPr sz="1100" b="1">
+                <a:solidFill>
+                  <a:srgbClr val="E74C3C"/>
+                </a:solidFill>
+                <a:latin typeface="Calibri"/>
+              </a:defRPr>
+            </a:pPr>
+            <a:r>
+              <a:t>Mechanism</a:t>
+            </a:r>
+          </a:p>
+        </p:txBody>
+      </p:sp>
+      <p:sp>
+        <p:nvSpPr>
+          <p:cNvPr id="9" name="TextBox 8"/>
+          <p:cNvSpPr txBox="1"/>
+          <p:nvPr/>
+        </p:nvSpPr>
+        <p:spPr>
+          <a:xfrm>
+            <a:off x="7178040" y="4206240"/>
+            <a:ext cx="4572000" cy="228600"/>
+          </a:xfrm>
+          <a:prstGeom prst="rect">
+            <a:avLst/>
+          </a:prstGeom>
+          <a:noFill/>
+        </p:spPr>
+        <p:txBody>
+          <a:bodyPr wrap="square">
+            <a:spAutoFit/>
+          </a:bodyPr>
+          <a:lstStyle/>
+          <a:p>
+            <a:pPr algn="l">
+              <a:defRPr sz="1100" b="1">
+                <a:solidFill>
+                  <a:srgbClr val="9B59B6"/>
+                </a:solidFill>
+                <a:latin typeface="Calibri"/>
+              </a:defRPr>
+            </a:pPr>
+            <a:r>
+              <a:t>Recovery dynamics</a:t>
+            </a:r>
+          </a:p>
+        </p:txBody>
+      </p:sp>
+      <p:sp>
+        <p:nvSpPr>
+          <p:cNvPr id="10" name="Rounded Rectangle 9"/>
           <p:cNvSpPr/>
           <p:nvPr/>
         </p:nvSpPr>
         <p:spPr>
           <a:xfrm>
-            <a:off x="548640" y="3291840"/>
-            <a:ext cx="914400" cy="822960"/>
+            <a:off x="182880" y="2331720"/>
+            <a:ext cx="2331720" cy="1874519"/>
           </a:xfrm>
           <a:prstGeom prst="roundRect">
             <a:avLst/>
           </a:prstGeom>
           <a:solidFill>
-            <a:srgbClr val="E74C3C"/>
+            <a:srgbClr val="121222"/>
           </a:solidFill>
-          <a:ln>
-            <a:noFill/>
+          <a:ln w="25400">
+            <a:solidFill>
+              <a:srgbClr val="0096D6"/>
+            </a:solidFill>
           </a:ln>
         </p:spPr>
         <p:style>
@@ -9409,11 +9776,54 @@
           </a:fontRef>
         </p:style>
         <p:txBody>
+          <a:bodyPr rtlCol="0" anchor="ctr"/>
+          <a:lstStyle/>
+          <a:p>
+            <a:pPr algn="ctr"/>
+          </a:p>
+        </p:txBody>
+      </p:sp>
+      <p:sp>
+        <p:nvSpPr>
+          <p:cNvPr id="11" name="Rounded Rectangle 10"/>
+          <p:cNvSpPr/>
+          <p:nvPr/>
+        </p:nvSpPr>
+        <p:spPr>
+          <a:xfrm>
+            <a:off x="182880" y="2331720"/>
+            <a:ext cx="2331720" cy="320040"/>
+          </a:xfrm>
+          <a:prstGeom prst="roundRect">
+            <a:avLst/>
+          </a:prstGeom>
+          <a:solidFill>
+            <a:srgbClr val="0096D6"/>
+          </a:solidFill>
+          <a:ln>
+            <a:noFill/>
+          </a:ln>
+        </p:spPr>
+        <p:style>
+          <a:lnRef idx="1">
+            <a:schemeClr val="accent1"/>
+          </a:lnRef>
+          <a:fillRef idx="3">
+            <a:schemeClr val="accent1"/>
+          </a:fillRef>
+          <a:effectRef idx="2">
+            <a:schemeClr val="accent1"/>
+          </a:effectRef>
+          <a:fontRef idx="minor">
+            <a:schemeClr val="lt1"/>
+          </a:fontRef>
+        </p:style>
+        <p:txBody>
           <a:bodyPr rtlCol="0" anchor="ctr" wrap="square" lIns="50800" rIns="50800" tIns="25400" bIns="25400"/>
           <a:lstStyle/>
           <a:p>
             <a:pPr algn="ctr">
-              <a:defRPr sz="1800" b="1">
+              <a:defRPr sz="1300" b="1">
                 <a:solidFill>
                   <a:srgbClr val="FFFFFF"/>
                 </a:solidFill>
@@ -9428,14 +9838,766 @@
       </p:sp>
       <p:sp>
         <p:nvSpPr>
-          <p:cNvPr id="9" name="Rounded Rectangle 8"/>
+          <p:cNvPr id="12" name="TextBox 11"/>
+          <p:cNvSpPr txBox="1"/>
+          <p:nvPr/>
+        </p:nvSpPr>
+        <p:spPr>
+          <a:xfrm>
+            <a:off x="274320" y="2697479"/>
+            <a:ext cx="2148839" cy="365760"/>
+          </a:xfrm>
+          <a:prstGeom prst="rect">
+            <a:avLst/>
+          </a:prstGeom>
+          <a:noFill/>
+        </p:spPr>
+        <p:txBody>
+          <a:bodyPr wrap="square">
+            <a:spAutoFit/>
+          </a:bodyPr>
+          <a:lstStyle/>
+          <a:p>
+            <a:pPr algn="l">
+              <a:defRPr sz="1100" b="1">
+                <a:solidFill>
+                  <a:srgbClr val="0096D6"/>
+                </a:solidFill>
+                <a:latin typeface="Calibri"/>
+              </a:defRPr>
+            </a:pPr>
+            <a:r>
+              <a:t>Metrics carry disjoint info</a:t>
+            </a:r>
+          </a:p>
+        </p:txBody>
+      </p:sp>
+      <p:sp>
+        <p:nvSpPr>
+          <p:cNvPr id="13" name="TextBox 12"/>
+          <p:cNvSpPr txBox="1"/>
+          <p:nvPr/>
+        </p:nvSpPr>
+        <p:spPr>
+          <a:xfrm>
+            <a:off x="274320" y="3108960"/>
+            <a:ext cx="2148839" cy="1005839"/>
+          </a:xfrm>
+          <a:prstGeom prst="rect">
+            <a:avLst/>
+          </a:prstGeom>
+          <a:noFill/>
+        </p:spPr>
+        <p:txBody>
+          <a:bodyPr wrap="square">
+            <a:spAutoFit/>
+          </a:bodyPr>
+          <a:lstStyle/>
+          <a:p>
+            <a:pPr algn="l">
+              <a:defRPr sz="900" b="0">
+                <a:solidFill>
+                  <a:srgbClr val="BDBDBD"/>
+                </a:solidFill>
+                <a:latin typeface="Calibri"/>
+              </a:defRPr>
+            </a:pPr>
+            <a:r>
+              <a:t>No single metric captures full chaos response. Best-fit and spread tie on aggregate (66.3) but diverge on recovery (1452 vs 1617 ms) and latency (100 vs 150 ms during chaos).</a:t>
+            </a:r>
+          </a:p>
+        </p:txBody>
+      </p:sp>
+      <p:sp>
+        <p:nvSpPr>
+          <p:cNvPr id="14" name="Rounded Rectangle 13"/>
           <p:cNvSpPr/>
           <p:nvPr/>
         </p:nvSpPr>
         <p:spPr>
           <a:xfrm>
-            <a:off x="1645920" y="3291840"/>
-            <a:ext cx="9966960" cy="822960"/>
+            <a:off x="2560320" y="2331720"/>
+            <a:ext cx="2331720" cy="1874519"/>
+          </a:xfrm>
+          <a:prstGeom prst="roundRect">
+            <a:avLst/>
+          </a:prstGeom>
+          <a:solidFill>
+            <a:srgbClr val="121222"/>
+          </a:solidFill>
+          <a:ln w="25400">
+            <a:solidFill>
+              <a:srgbClr val="0096D6"/>
+            </a:solidFill>
+          </a:ln>
+        </p:spPr>
+        <p:style>
+          <a:lnRef idx="1">
+            <a:schemeClr val="accent1"/>
+          </a:lnRef>
+          <a:fillRef idx="3">
+            <a:schemeClr val="accent1"/>
+          </a:fillRef>
+          <a:effectRef idx="2">
+            <a:schemeClr val="accent1"/>
+          </a:effectRef>
+          <a:fontRef idx="minor">
+            <a:schemeClr val="lt1"/>
+          </a:fontRef>
+        </p:style>
+        <p:txBody>
+          <a:bodyPr rtlCol="0" anchor="ctr"/>
+          <a:lstStyle/>
+          <a:p>
+            <a:pPr algn="ctr"/>
+          </a:p>
+        </p:txBody>
+      </p:sp>
+      <p:sp>
+        <p:nvSpPr>
+          <p:cNvPr id="15" name="Rounded Rectangle 14"/>
+          <p:cNvSpPr/>
+          <p:nvPr/>
+        </p:nvSpPr>
+        <p:spPr>
+          <a:xfrm>
+            <a:off x="2560320" y="2331720"/>
+            <a:ext cx="2331720" cy="320040"/>
+          </a:xfrm>
+          <a:prstGeom prst="roundRect">
+            <a:avLst/>
+          </a:prstGeom>
+          <a:solidFill>
+            <a:srgbClr val="0096D6"/>
+          </a:solidFill>
+          <a:ln>
+            <a:noFill/>
+          </a:ln>
+        </p:spPr>
+        <p:style>
+          <a:lnRef idx="1">
+            <a:schemeClr val="accent1"/>
+          </a:lnRef>
+          <a:fillRef idx="3">
+            <a:schemeClr val="accent1"/>
+          </a:fillRef>
+          <a:effectRef idx="2">
+            <a:schemeClr val="accent1"/>
+          </a:effectRef>
+          <a:fontRef idx="minor">
+            <a:schemeClr val="lt1"/>
+          </a:fontRef>
+        </p:style>
+        <p:txBody>
+          <a:bodyPr rtlCol="0" anchor="ctr" wrap="square" lIns="50800" rIns="50800" tIns="25400" bIns="25400"/>
+          <a:lstStyle/>
+          <a:p>
+            <a:pPr algn="ctr">
+              <a:defRPr sz="1300" b="1">
+                <a:solidFill>
+                  <a:srgbClr val="FFFFFF"/>
+                </a:solidFill>
+                <a:latin typeface="Calibri"/>
+              </a:defRPr>
+            </a:pPr>
+            <a:r>
+              <a:t>H2</a:t>
+            </a:r>
+          </a:p>
+        </p:txBody>
+      </p:sp>
+      <p:sp>
+        <p:nvSpPr>
+          <p:cNvPr id="16" name="TextBox 15"/>
+          <p:cNvSpPr txBox="1"/>
+          <p:nvPr/>
+        </p:nvSpPr>
+        <p:spPr>
+          <a:xfrm>
+            <a:off x="2651760" y="2697479"/>
+            <a:ext cx="2148839" cy="365760"/>
+          </a:xfrm>
+          <a:prstGeom prst="rect">
+            <a:avLst/>
+          </a:prstGeom>
+          <a:noFill/>
+        </p:spPr>
+        <p:txBody>
+          <a:bodyPr wrap="square">
+            <a:spAutoFit/>
+          </a:bodyPr>
+          <a:lstStyle/>
+          <a:p>
+            <a:pPr algn="l">
+              <a:defRPr sz="1100" b="1">
+                <a:solidFill>
+                  <a:srgbClr val="0096D6"/>
+                </a:solidFill>
+                <a:latin typeface="Calibri"/>
+              </a:defRPr>
+            </a:pPr>
+            <a:r>
+              <a:t>Phase decomposition is necessary</a:t>
+            </a:r>
+          </a:p>
+        </p:txBody>
+      </p:sp>
+      <p:sp>
+        <p:nvSpPr>
+          <p:cNvPr id="17" name="TextBox 16"/>
+          <p:cNvSpPr txBox="1"/>
+          <p:nvPr/>
+        </p:nvSpPr>
+        <p:spPr>
+          <a:xfrm>
+            <a:off x="2651760" y="3108960"/>
+            <a:ext cx="2148839" cy="1005839"/>
+          </a:xfrm>
+          <a:prstGeom prst="rect">
+            <a:avLst/>
+          </a:prstGeom>
+          <a:noFill/>
+        </p:spPr>
+        <p:txBody>
+          <a:bodyPr wrap="square">
+            <a:spAutoFit/>
+          </a:bodyPr>
+          <a:lstStyle/>
+          <a:p>
+            <a:pPr algn="l">
+              <a:defRPr sz="900" b="0">
+                <a:solidFill>
+                  <a:srgbClr val="BDBDBD"/>
+                </a:solidFill>
+                <a:latin typeface="Calibri"/>
+              </a:defRPr>
+            </a:pPr>
+            <a:r>
+              <a:t>Pre-chaos baselines vary by placement (spread 231 ms vs colocate 78 ms on /). During-chaos absolutes are uninterpretable without phase-aware normalisation.</a:t>
+            </a:r>
+          </a:p>
+        </p:txBody>
+      </p:sp>
+      <p:sp>
+        <p:nvSpPr>
+          <p:cNvPr id="18" name="Rounded Rectangle 17"/>
+          <p:cNvSpPr/>
+          <p:nvPr/>
+        </p:nvSpPr>
+        <p:spPr>
+          <a:xfrm>
+            <a:off x="4937759" y="2331720"/>
+            <a:ext cx="2331720" cy="1874519"/>
+          </a:xfrm>
+          <a:prstGeom prst="roundRect">
+            <a:avLst/>
+          </a:prstGeom>
+          <a:solidFill>
+            <a:srgbClr val="121222"/>
+          </a:solidFill>
+          <a:ln w="25400">
+            <a:solidFill>
+              <a:srgbClr val="0096D6"/>
+            </a:solidFill>
+          </a:ln>
+        </p:spPr>
+        <p:style>
+          <a:lnRef idx="1">
+            <a:schemeClr val="accent1"/>
+          </a:lnRef>
+          <a:fillRef idx="3">
+            <a:schemeClr val="accent1"/>
+          </a:fillRef>
+          <a:effectRef idx="2">
+            <a:schemeClr val="accent1"/>
+          </a:effectRef>
+          <a:fontRef idx="minor">
+            <a:schemeClr val="lt1"/>
+          </a:fontRef>
+        </p:style>
+        <p:txBody>
+          <a:bodyPr rtlCol="0" anchor="ctr"/>
+          <a:lstStyle/>
+          <a:p>
+            <a:pPr algn="ctr"/>
+          </a:p>
+        </p:txBody>
+      </p:sp>
+      <p:sp>
+        <p:nvSpPr>
+          <p:cNvPr id="19" name="Rounded Rectangle 18"/>
+          <p:cNvSpPr/>
+          <p:nvPr/>
+        </p:nvSpPr>
+        <p:spPr>
+          <a:xfrm>
+            <a:off x="4937759" y="2331720"/>
+            <a:ext cx="2331720" cy="320040"/>
+          </a:xfrm>
+          <a:prstGeom prst="roundRect">
+            <a:avLst/>
+          </a:prstGeom>
+          <a:solidFill>
+            <a:srgbClr val="0096D6"/>
+          </a:solidFill>
+          <a:ln>
+            <a:noFill/>
+          </a:ln>
+        </p:spPr>
+        <p:style>
+          <a:lnRef idx="1">
+            <a:schemeClr val="accent1"/>
+          </a:lnRef>
+          <a:fillRef idx="3">
+            <a:schemeClr val="accent1"/>
+          </a:fillRef>
+          <a:effectRef idx="2">
+            <a:schemeClr val="accent1"/>
+          </a:effectRef>
+          <a:fontRef idx="minor">
+            <a:schemeClr val="lt1"/>
+          </a:fontRef>
+        </p:style>
+        <p:txBody>
+          <a:bodyPr rtlCol="0" anchor="ctr" wrap="square" lIns="50800" rIns="50800" tIns="25400" bIns="25400"/>
+          <a:lstStyle/>
+          <a:p>
+            <a:pPr algn="ctr">
+              <a:defRPr sz="1300" b="1">
+                <a:solidFill>
+                  <a:srgbClr val="FFFFFF"/>
+                </a:solidFill>
+                <a:latin typeface="Calibri"/>
+              </a:defRPr>
+            </a:pPr>
+            <a:r>
+              <a:t>H3</a:t>
+            </a:r>
+          </a:p>
+        </p:txBody>
+      </p:sp>
+      <p:sp>
+        <p:nvSpPr>
+          <p:cNvPr id="20" name="TextBox 19"/>
+          <p:cNvSpPr txBox="1"/>
+          <p:nvPr/>
+        </p:nvSpPr>
+        <p:spPr>
+          <a:xfrm>
+            <a:off x="5029199" y="2697479"/>
+            <a:ext cx="2148839" cy="365760"/>
+          </a:xfrm>
+          <a:prstGeom prst="rect">
+            <a:avLst/>
+          </a:prstGeom>
+          <a:noFill/>
+        </p:spPr>
+        <p:txBody>
+          <a:bodyPr wrap="square">
+            <a:spAutoFit/>
+          </a:bodyPr>
+          <a:lstStyle/>
+          <a:p>
+            <a:pPr algn="l">
+              <a:defRPr sz="1100" b="1">
+                <a:solidFill>
+                  <a:srgbClr val="0096D6"/>
+                </a:solidFill>
+                <a:latin typeface="Calibri"/>
+              </a:defRPr>
+            </a:pPr>
+            <a:r>
+              <a:t>Per-pod granularity reveals heterogeneity</a:t>
+            </a:r>
+          </a:p>
+        </p:txBody>
+      </p:sp>
+      <p:sp>
+        <p:nvSpPr>
+          <p:cNvPr id="21" name="TextBox 20"/>
+          <p:cNvSpPr txBox="1"/>
+          <p:nvPr/>
+        </p:nvSpPr>
+        <p:spPr>
+          <a:xfrm>
+            <a:off x="5029199" y="3108960"/>
+            <a:ext cx="2148839" cy="1005839"/>
+          </a:xfrm>
+          <a:prstGeom prst="rect">
+            <a:avLst/>
+          </a:prstGeom>
+          <a:noFill/>
+        </p:spPr>
+        <p:txBody>
+          <a:bodyPr wrap="square">
+            <a:spAutoFit/>
+          </a:bodyPr>
+          <a:lstStyle/>
+          <a:p>
+            <a:pPr algn="l">
+              <a:defRPr sz="900" b="0">
+                <a:solidFill>
+                  <a:srgbClr val="BDBDBD"/>
+                </a:solidFill>
+                <a:latin typeface="Calibri"/>
+              </a:defRPr>
+            </a:pPr>
+            <a:r>
+              <a:t>Cross-pod stddev within a single service is non-zero and placement-dependent. Aggregate cluster metrics miss it; per-pod LatencyProber sampling exposes it.</a:t>
+            </a:r>
+          </a:p>
+        </p:txBody>
+      </p:sp>
+      <p:sp>
+        <p:nvSpPr>
+          <p:cNvPr id="22" name="Rounded Rectangle 21"/>
+          <p:cNvSpPr/>
+          <p:nvPr/>
+        </p:nvSpPr>
+        <p:spPr>
+          <a:xfrm>
+            <a:off x="7315199" y="2331720"/>
+            <a:ext cx="2331720" cy="1874519"/>
+          </a:xfrm>
+          <a:prstGeom prst="roundRect">
+            <a:avLst/>
+          </a:prstGeom>
+          <a:solidFill>
+            <a:srgbClr val="121222"/>
+          </a:solidFill>
+          <a:ln w="25400">
+            <a:solidFill>
+              <a:srgbClr val="F39C12"/>
+            </a:solidFill>
+          </a:ln>
+        </p:spPr>
+        <p:style>
+          <a:lnRef idx="1">
+            <a:schemeClr val="accent1"/>
+          </a:lnRef>
+          <a:fillRef idx="3">
+            <a:schemeClr val="accent1"/>
+          </a:fillRef>
+          <a:effectRef idx="2">
+            <a:schemeClr val="accent1"/>
+          </a:effectRef>
+          <a:fontRef idx="minor">
+            <a:schemeClr val="lt1"/>
+          </a:fontRef>
+        </p:style>
+        <p:txBody>
+          <a:bodyPr rtlCol="0" anchor="ctr"/>
+          <a:lstStyle/>
+          <a:p>
+            <a:pPr algn="ctr"/>
+          </a:p>
+        </p:txBody>
+      </p:sp>
+      <p:sp>
+        <p:nvSpPr>
+          <p:cNvPr id="23" name="Rounded Rectangle 22"/>
+          <p:cNvSpPr/>
+          <p:nvPr/>
+        </p:nvSpPr>
+        <p:spPr>
+          <a:xfrm>
+            <a:off x="7315199" y="2331720"/>
+            <a:ext cx="2331720" cy="320040"/>
+          </a:xfrm>
+          <a:prstGeom prst="roundRect">
+            <a:avLst/>
+          </a:prstGeom>
+          <a:solidFill>
+            <a:srgbClr val="F39C12"/>
+          </a:solidFill>
+          <a:ln>
+            <a:noFill/>
+          </a:ln>
+        </p:spPr>
+        <p:style>
+          <a:lnRef idx="1">
+            <a:schemeClr val="accent1"/>
+          </a:lnRef>
+          <a:fillRef idx="3">
+            <a:schemeClr val="accent1"/>
+          </a:fillRef>
+          <a:effectRef idx="2">
+            <a:schemeClr val="accent1"/>
+          </a:effectRef>
+          <a:fontRef idx="minor">
+            <a:schemeClr val="lt1"/>
+          </a:fontRef>
+        </p:style>
+        <p:txBody>
+          <a:bodyPr rtlCol="0" anchor="ctr" wrap="square" lIns="50800" rIns="50800" tIns="25400" bIns="25400"/>
+          <a:lstStyle/>
+          <a:p>
+            <a:pPr algn="ctr">
+              <a:defRPr sz="1300" b="1">
+                <a:solidFill>
+                  <a:srgbClr val="FFFFFF"/>
+                </a:solidFill>
+                <a:latin typeface="Calibri"/>
+              </a:defRPr>
+            </a:pPr>
+            <a:r>
+              <a:t>H4</a:t>
+            </a:r>
+          </a:p>
+        </p:txBody>
+      </p:sp>
+      <p:sp>
+        <p:nvSpPr>
+          <p:cNvPr id="24" name="TextBox 23"/>
+          <p:cNvSpPr txBox="1"/>
+          <p:nvPr/>
+        </p:nvSpPr>
+        <p:spPr>
+          <a:xfrm>
+            <a:off x="7406640" y="2697479"/>
+            <a:ext cx="2148839" cy="365760"/>
+          </a:xfrm>
+          <a:prstGeom prst="rect">
+            <a:avLst/>
+          </a:prstGeom>
+          <a:noFill/>
+        </p:spPr>
+        <p:txBody>
+          <a:bodyPr wrap="square">
+            <a:spAutoFit/>
+          </a:bodyPr>
+          <a:lstStyle/>
+          <a:p>
+            <a:pPr algn="l">
+              <a:defRPr sz="1100" b="1">
+                <a:solidFill>
+                  <a:srgbClr val="F39C12"/>
+                </a:solidFill>
+                <a:latin typeface="Calibri"/>
+              </a:defRPr>
+            </a:pPr>
+            <a:r>
+              <a:t>Baseline predicts resilience</a:t>
+            </a:r>
+          </a:p>
+        </p:txBody>
+      </p:sp>
+      <p:sp>
+        <p:nvSpPr>
+          <p:cNvPr id="25" name="TextBox 24"/>
+          <p:cNvSpPr txBox="1"/>
+          <p:nvPr/>
+        </p:nvSpPr>
+        <p:spPr>
+          <a:xfrm>
+            <a:off x="7406640" y="3108960"/>
+            <a:ext cx="2148839" cy="1005839"/>
+          </a:xfrm>
+          <a:prstGeom prst="rect">
+            <a:avLst/>
+          </a:prstGeom>
+          <a:noFill/>
+        </p:spPr>
+        <p:txBody>
+          <a:bodyPr wrap="square">
+            <a:spAutoFit/>
+          </a:bodyPr>
+          <a:lstStyle/>
+          <a:p>
+            <a:pPr algn="l">
+              <a:defRPr sz="900" b="0">
+                <a:solidFill>
+                  <a:srgbClr val="BDBDBD"/>
+                </a:solidFill>
+                <a:latin typeface="Calibri"/>
+              </a:defRPr>
+            </a:pPr>
+            <a:r>
+              <a:t>Strategies with lower pre-chaos latency variance score higher under chaos. The resting-state fingerprint predicts the failure response before any fault is injected.</a:t>
+            </a:r>
+          </a:p>
+        </p:txBody>
+      </p:sp>
+      <p:sp>
+        <p:nvSpPr>
+          <p:cNvPr id="26" name="Rounded Rectangle 25"/>
+          <p:cNvSpPr/>
+          <p:nvPr/>
+        </p:nvSpPr>
+        <p:spPr>
+          <a:xfrm>
+            <a:off x="9692639" y="2331720"/>
+            <a:ext cx="2331720" cy="1874519"/>
+          </a:xfrm>
+          <a:prstGeom prst="roundRect">
+            <a:avLst/>
+          </a:prstGeom>
+          <a:solidFill>
+            <a:srgbClr val="121222"/>
+          </a:solidFill>
+          <a:ln w="25400">
+            <a:solidFill>
+              <a:srgbClr val="F39C12"/>
+            </a:solidFill>
+          </a:ln>
+        </p:spPr>
+        <p:style>
+          <a:lnRef idx="1">
+            <a:schemeClr val="accent1"/>
+          </a:lnRef>
+          <a:fillRef idx="3">
+            <a:schemeClr val="accent1"/>
+          </a:fillRef>
+          <a:effectRef idx="2">
+            <a:schemeClr val="accent1"/>
+          </a:effectRef>
+          <a:fontRef idx="minor">
+            <a:schemeClr val="lt1"/>
+          </a:fontRef>
+        </p:style>
+        <p:txBody>
+          <a:bodyPr rtlCol="0" anchor="ctr"/>
+          <a:lstStyle/>
+          <a:p>
+            <a:pPr algn="ctr"/>
+          </a:p>
+        </p:txBody>
+      </p:sp>
+      <p:sp>
+        <p:nvSpPr>
+          <p:cNvPr id="27" name="Rounded Rectangle 26"/>
+          <p:cNvSpPr/>
+          <p:nvPr/>
+        </p:nvSpPr>
+        <p:spPr>
+          <a:xfrm>
+            <a:off x="9692639" y="2331720"/>
+            <a:ext cx="2331720" cy="320040"/>
+          </a:xfrm>
+          <a:prstGeom prst="roundRect">
+            <a:avLst/>
+          </a:prstGeom>
+          <a:solidFill>
+            <a:srgbClr val="F39C12"/>
+          </a:solidFill>
+          <a:ln>
+            <a:noFill/>
+          </a:ln>
+        </p:spPr>
+        <p:style>
+          <a:lnRef idx="1">
+            <a:schemeClr val="accent1"/>
+          </a:lnRef>
+          <a:fillRef idx="3">
+            <a:schemeClr val="accent1"/>
+          </a:fillRef>
+          <a:effectRef idx="2">
+            <a:schemeClr val="accent1"/>
+          </a:effectRef>
+          <a:fontRef idx="minor">
+            <a:schemeClr val="lt1"/>
+          </a:fontRef>
+        </p:style>
+        <p:txBody>
+          <a:bodyPr rtlCol="0" anchor="ctr" wrap="square" lIns="50800" rIns="50800" tIns="25400" bIns="25400"/>
+          <a:lstStyle/>
+          <a:p>
+            <a:pPr algn="ctr">
+              <a:defRPr sz="1300" b="1">
+                <a:solidFill>
+                  <a:srgbClr val="FFFFFF"/>
+                </a:solidFill>
+                <a:latin typeface="Calibri"/>
+              </a:defRPr>
+            </a:pPr>
+            <a:r>
+              <a:t>H5</a:t>
+            </a:r>
+          </a:p>
+        </p:txBody>
+      </p:sp>
+      <p:sp>
+        <p:nvSpPr>
+          <p:cNvPr id="28" name="TextBox 27"/>
+          <p:cNvSpPr txBox="1"/>
+          <p:nvPr/>
+        </p:nvSpPr>
+        <p:spPr>
+          <a:xfrm>
+            <a:off x="9784079" y="2697479"/>
+            <a:ext cx="2148839" cy="365760"/>
+          </a:xfrm>
+          <a:prstGeom prst="rect">
+            <a:avLst/>
+          </a:prstGeom>
+          <a:noFill/>
+        </p:spPr>
+        <p:txBody>
+          <a:bodyPr wrap="square">
+            <a:spAutoFit/>
+          </a:bodyPr>
+          <a:lstStyle/>
+          <a:p>
+            <a:pPr algn="l">
+              <a:defRPr sz="1100" b="1">
+                <a:solidFill>
+                  <a:srgbClr val="F39C12"/>
+                </a:solidFill>
+                <a:latin typeface="Calibri"/>
+              </a:defRPr>
+            </a:pPr>
+            <a:r>
+              <a:t>Mean masks tail</a:t>
+            </a:r>
+          </a:p>
+        </p:txBody>
+      </p:sp>
+      <p:sp>
+        <p:nvSpPr>
+          <p:cNvPr id="29" name="TextBox 28"/>
+          <p:cNvSpPr txBox="1"/>
+          <p:nvPr/>
+        </p:nvSpPr>
+        <p:spPr>
+          <a:xfrm>
+            <a:off x="9784079" y="3108960"/>
+            <a:ext cx="2148839" cy="1005839"/>
+          </a:xfrm>
+          <a:prstGeom prst="rect">
+            <a:avLst/>
+          </a:prstGeom>
+          <a:noFill/>
+        </p:spPr>
+        <p:txBody>
+          <a:bodyPr wrap="square">
+            <a:spAutoFit/>
+          </a:bodyPr>
+          <a:lstStyle/>
+          <a:p>
+            <a:pPr algn="l">
+              <a:defRPr sz="900" b="0">
+                <a:solidFill>
+                  <a:srgbClr val="BDBDBD"/>
+                </a:solidFill>
+                <a:latin typeface="Calibri"/>
+              </a:defRPr>
+            </a:pPr>
+            <a:r>
+              <a:t>p95 latency ranking across strategies differs from mean ranking. Tail percentiles concentrate placement effects (Dean &amp; Barroso, CACM 2013).</a:t>
+            </a:r>
+          </a:p>
+        </p:txBody>
+      </p:sp>
+      <p:sp>
+        <p:nvSpPr>
+          <p:cNvPr id="30" name="Rounded Rectangle 29"/>
+          <p:cNvSpPr/>
+          <p:nvPr/>
+        </p:nvSpPr>
+        <p:spPr>
+          <a:xfrm>
+            <a:off x="182880" y="4480560"/>
+            <a:ext cx="2331720" cy="1874519"/>
           </a:xfrm>
           <a:prstGeom prst="roundRect">
             <a:avLst/>
@@ -9473,462 +10635,14 @@
       </p:sp>
       <p:sp>
         <p:nvSpPr>
-          <p:cNvPr id="10" name="TextBox 9"/>
-          <p:cNvSpPr txBox="1"/>
-          <p:nvPr/>
-        </p:nvSpPr>
-        <p:spPr>
-          <a:xfrm>
-            <a:off x="1828800" y="3310128"/>
-            <a:ext cx="9601200" cy="274320"/>
-          </a:xfrm>
-          <a:prstGeom prst="rect">
-            <a:avLst/>
-          </a:prstGeom>
-          <a:noFill/>
-        </p:spPr>
-        <p:txBody>
-          <a:bodyPr wrap="square">
-            <a:spAutoFit/>
-          </a:bodyPr>
-          <a:lstStyle/>
-          <a:p>
-            <a:pPr algn="l">
-              <a:defRPr sz="1500" b="1">
-                <a:solidFill>
-                  <a:srgbClr val="E74C3C"/>
-                </a:solidFill>
-                <a:latin typeface="Calibri"/>
-              </a:defRPr>
-            </a:pPr>
-            <a:r>
-              <a:t>Maximum contention degrades resilience</a:t>
-            </a:r>
-          </a:p>
-        </p:txBody>
-      </p:sp>
-      <p:sp>
-        <p:nvSpPr>
-          <p:cNvPr id="11" name="TextBox 10"/>
-          <p:cNvSpPr txBox="1"/>
-          <p:nvPr/>
-        </p:nvSpPr>
-        <p:spPr>
-          <a:xfrm>
-            <a:off x="1828800" y="3639312"/>
-            <a:ext cx="9601200" cy="457200"/>
-          </a:xfrm>
-          <a:prstGeom prst="rect">
-            <a:avLst/>
-          </a:prstGeom>
-          <a:noFill/>
-        </p:spPr>
-        <p:txBody>
-          <a:bodyPr wrap="square">
-            <a:spAutoFit/>
-          </a:bodyPr>
-          <a:lstStyle/>
-          <a:p>
-            <a:pPr algn="l">
-              <a:defRPr sz="1200" b="0">
-                <a:solidFill>
-                  <a:srgbClr val="BDBDBD"/>
-                </a:solidFill>
-                <a:latin typeface="Calibri"/>
-              </a:defRPr>
-            </a:pPr>
-            <a:r>
-              <a:t>Colocating all pods on a single node maximizes resource contention (CPU, memory, disk, network) and produces the worst resilience scores.</a:t>
-            </a:r>
-          </a:p>
-        </p:txBody>
-      </p:sp>
-      <p:sp>
-        <p:nvSpPr>
-          <p:cNvPr id="12" name="Rounded Rectangle 11"/>
+          <p:cNvPr id="31" name="Rounded Rectangle 30"/>
           <p:cNvSpPr/>
           <p:nvPr/>
         </p:nvSpPr>
         <p:spPr>
           <a:xfrm>
-            <a:off x="548640" y="4480560"/>
-            <a:ext cx="914400" cy="822960"/>
-          </a:xfrm>
-          <a:prstGeom prst="roundRect">
-            <a:avLst/>
-          </a:prstGeom>
-          <a:solidFill>
-            <a:srgbClr val="2ECC71"/>
-          </a:solidFill>
-          <a:ln>
-            <a:noFill/>
-          </a:ln>
-        </p:spPr>
-        <p:style>
-          <a:lnRef idx="1">
-            <a:schemeClr val="accent1"/>
-          </a:lnRef>
-          <a:fillRef idx="3">
-            <a:schemeClr val="accent1"/>
-          </a:fillRef>
-          <a:effectRef idx="2">
-            <a:schemeClr val="accent1"/>
-          </a:effectRef>
-          <a:fontRef idx="minor">
-            <a:schemeClr val="lt1"/>
-          </a:fontRef>
-        </p:style>
-        <p:txBody>
-          <a:bodyPr rtlCol="0" anchor="ctr" wrap="square" lIns="50800" rIns="50800" tIns="25400" bIns="25400"/>
-          <a:lstStyle/>
-          <a:p>
-            <a:pPr algn="ctr">
-              <a:defRPr sz="1800" b="1">
-                <a:solidFill>
-                  <a:srgbClr val="FFFFFF"/>
-                </a:solidFill>
-                <a:latin typeface="Calibri"/>
-              </a:defRPr>
-            </a:pPr>
-            <a:r>
-              <a:t>H2</a:t>
-            </a:r>
-          </a:p>
-        </p:txBody>
-      </p:sp>
-      <p:sp>
-        <p:nvSpPr>
-          <p:cNvPr id="13" name="Rounded Rectangle 12"/>
-          <p:cNvSpPr/>
-          <p:nvPr/>
-        </p:nvSpPr>
-        <p:spPr>
-          <a:xfrm>
-            <a:off x="1645920" y="4480560"/>
-            <a:ext cx="9966960" cy="822960"/>
-          </a:xfrm>
-          <a:prstGeom prst="roundRect">
-            <a:avLst/>
-          </a:prstGeom>
-          <a:solidFill>
-            <a:srgbClr val="121222"/>
-          </a:solidFill>
-          <a:ln w="25400">
-            <a:solidFill>
-              <a:srgbClr val="2ECC71"/>
-            </a:solidFill>
-          </a:ln>
-        </p:spPr>
-        <p:style>
-          <a:lnRef idx="1">
-            <a:schemeClr val="accent1"/>
-          </a:lnRef>
-          <a:fillRef idx="3">
-            <a:schemeClr val="accent1"/>
-          </a:fillRef>
-          <a:effectRef idx="2">
-            <a:schemeClr val="accent1"/>
-          </a:effectRef>
-          <a:fontRef idx="minor">
-            <a:schemeClr val="lt1"/>
-          </a:fontRef>
-        </p:style>
-        <p:txBody>
-          <a:bodyPr rtlCol="0" anchor="ctr"/>
-          <a:lstStyle/>
-          <a:p>
-            <a:pPr algn="ctr"/>
-          </a:p>
-        </p:txBody>
-      </p:sp>
-      <p:sp>
-        <p:nvSpPr>
-          <p:cNvPr id="14" name="TextBox 13"/>
-          <p:cNvSpPr txBox="1"/>
-          <p:nvPr/>
-        </p:nvSpPr>
-        <p:spPr>
-          <a:xfrm>
-            <a:off x="1828800" y="4498848"/>
-            <a:ext cx="9601200" cy="274320"/>
-          </a:xfrm>
-          <a:prstGeom prst="rect">
-            <a:avLst/>
-          </a:prstGeom>
-          <a:noFill/>
-        </p:spPr>
-        <p:txBody>
-          <a:bodyPr wrap="square">
-            <a:spAutoFit/>
-          </a:bodyPr>
-          <a:lstStyle/>
-          <a:p>
-            <a:pPr algn="l">
-              <a:defRPr sz="1500" b="1">
-                <a:solidFill>
-                  <a:srgbClr val="2ECC71"/>
-                </a:solidFill>
-                <a:latin typeface="Calibri"/>
-              </a:defRPr>
-            </a:pPr>
-            <a:r>
-              <a:t>Spreading improves fault isolation</a:t>
-            </a:r>
-          </a:p>
-        </p:txBody>
-      </p:sp>
-      <p:sp>
-        <p:nvSpPr>
-          <p:cNvPr id="15" name="TextBox 14"/>
-          <p:cNvSpPr txBox="1"/>
-          <p:nvPr/>
-        </p:nvSpPr>
-        <p:spPr>
-          <a:xfrm>
-            <a:off x="1828800" y="4828032"/>
-            <a:ext cx="9601200" cy="457200"/>
-          </a:xfrm>
-          <a:prstGeom prst="rect">
-            <a:avLst/>
-          </a:prstGeom>
-          <a:noFill/>
-        </p:spPr>
-        <p:txBody>
-          <a:bodyPr wrap="square">
-            <a:spAutoFit/>
-          </a:bodyPr>
-          <a:lstStyle/>
-          <a:p>
-            <a:pPr algn="l">
-              <a:defRPr sz="1200" b="0">
-                <a:solidFill>
-                  <a:srgbClr val="BDBDBD"/>
-                </a:solidFill>
-                <a:latin typeface="Calibri"/>
-              </a:defRPr>
-            </a:pPr>
-            <a:r>
-              <a:t>Distributing pods evenly across nodes minimizes per-node contention and limits fault blast radius, yielding the best resilience scores.</a:t>
-            </a:r>
-          </a:p>
-        </p:txBody>
-      </p:sp>
-      <p:sp>
-        <p:nvSpPr>
-          <p:cNvPr id="16" name="Rounded Rectangle 15"/>
-          <p:cNvSpPr/>
-          <p:nvPr/>
-        </p:nvSpPr>
-        <p:spPr>
-          <a:xfrm>
-            <a:off x="548640" y="5669280"/>
-            <a:ext cx="914400" cy="822960"/>
-          </a:xfrm>
-          <a:prstGeom prst="roundRect">
-            <a:avLst/>
-          </a:prstGeom>
-          <a:solidFill>
-            <a:srgbClr val="F39C12"/>
-          </a:solidFill>
-          <a:ln>
-            <a:noFill/>
-          </a:ln>
-        </p:spPr>
-        <p:style>
-          <a:lnRef idx="1">
-            <a:schemeClr val="accent1"/>
-          </a:lnRef>
-          <a:fillRef idx="3">
-            <a:schemeClr val="accent1"/>
-          </a:fillRef>
-          <a:effectRef idx="2">
-            <a:schemeClr val="accent1"/>
-          </a:effectRef>
-          <a:fontRef idx="minor">
-            <a:schemeClr val="lt1"/>
-          </a:fontRef>
-        </p:style>
-        <p:txBody>
-          <a:bodyPr rtlCol="0" anchor="ctr" wrap="square" lIns="50800" rIns="50800" tIns="25400" bIns="25400"/>
-          <a:lstStyle/>
-          <a:p>
-            <a:pPr algn="ctr">
-              <a:defRPr sz="1800" b="1">
-                <a:solidFill>
-                  <a:srgbClr val="FFFFFF"/>
-                </a:solidFill>
-                <a:latin typeface="Calibri"/>
-              </a:defRPr>
-            </a:pPr>
-            <a:r>
-              <a:t>H3</a:t>
-            </a:r>
-          </a:p>
-        </p:txBody>
-      </p:sp>
-      <p:sp>
-        <p:nvSpPr>
-          <p:cNvPr id="17" name="Rounded Rectangle 16"/>
-          <p:cNvSpPr/>
-          <p:nvPr/>
-        </p:nvSpPr>
-        <p:spPr>
-          <a:xfrm>
-            <a:off x="1645920" y="5669280"/>
-            <a:ext cx="9966960" cy="822960"/>
-          </a:xfrm>
-          <a:prstGeom prst="roundRect">
-            <a:avLst/>
-          </a:prstGeom>
-          <a:solidFill>
-            <a:srgbClr val="121222"/>
-          </a:solidFill>
-          <a:ln w="25400">
-            <a:solidFill>
-              <a:srgbClr val="F39C12"/>
-            </a:solidFill>
-          </a:ln>
-        </p:spPr>
-        <p:style>
-          <a:lnRef idx="1">
-            <a:schemeClr val="accent1"/>
-          </a:lnRef>
-          <a:fillRef idx="3">
-            <a:schemeClr val="accent1"/>
-          </a:fillRef>
-          <a:effectRef idx="2">
-            <a:schemeClr val="accent1"/>
-          </a:effectRef>
-          <a:fontRef idx="minor">
-            <a:schemeClr val="lt1"/>
-          </a:fontRef>
-        </p:style>
-        <p:txBody>
-          <a:bodyPr rtlCol="0" anchor="ctr"/>
-          <a:lstStyle/>
-          <a:p>
-            <a:pPr algn="ctr"/>
-          </a:p>
-        </p:txBody>
-      </p:sp>
-      <p:sp>
-        <p:nvSpPr>
-          <p:cNvPr id="18" name="TextBox 17"/>
-          <p:cNvSpPr txBox="1"/>
-          <p:nvPr/>
-        </p:nvSpPr>
-        <p:spPr>
-          <a:xfrm>
-            <a:off x="1828800" y="5687568"/>
-            <a:ext cx="9601200" cy="274320"/>
-          </a:xfrm>
-          <a:prstGeom prst="rect">
-            <a:avLst/>
-          </a:prstGeom>
-          <a:noFill/>
-        </p:spPr>
-        <p:txBody>
-          <a:bodyPr wrap="square">
-            <a:spAutoFit/>
-          </a:bodyPr>
-          <a:lstStyle/>
-          <a:p>
-            <a:pPr algn="l">
-              <a:defRPr sz="1500" b="1">
-                <a:solidFill>
-                  <a:srgbClr val="F39C12"/>
-                </a:solidFill>
-                <a:latin typeface="Calibri"/>
-              </a:defRPr>
-            </a:pPr>
-            <a:r>
-              <a:t>Recovery time predicts resilience</a:t>
-            </a:r>
-          </a:p>
-        </p:txBody>
-      </p:sp>
-      <p:sp>
-        <p:nvSpPr>
-          <p:cNvPr id="19" name="TextBox 18"/>
-          <p:cNvSpPr txBox="1"/>
-          <p:nvPr/>
-        </p:nvSpPr>
-        <p:spPr>
-          <a:xfrm>
-            <a:off x="1828800" y="6016752"/>
-            <a:ext cx="9601200" cy="457200"/>
-          </a:xfrm>
-          <a:prstGeom prst="rect">
-            <a:avLst/>
-          </a:prstGeom>
-          <a:noFill/>
-        </p:spPr>
-        <p:txBody>
-          <a:bodyPr wrap="square">
-            <a:spAutoFit/>
-          </a:bodyPr>
-          <a:lstStyle/>
-          <a:p>
-            <a:pPr algn="l">
-              <a:defRPr sz="1200" b="0">
-                <a:solidFill>
-                  <a:srgbClr val="BDBDBD"/>
-                </a:solidFill>
-                <a:latin typeface="Calibri"/>
-              </a:defRPr>
-            </a:pPr>
-            <a:r>
-              <a:t>Faster pod recovery yields higher resilience scores — shorter unavailability windows mean fewer probe checks fall inside the fault window (Dean–Barroso 2013).</a:t>
-            </a:r>
-          </a:p>
-        </p:txBody>
-      </p:sp>
-      <p:sp>
-        <p:nvSpPr>
-          <p:cNvPr id="20" name="TextBox 19"/>
-          <p:cNvSpPr txBox="1"/>
-          <p:nvPr/>
-        </p:nvSpPr>
-        <p:spPr>
-          <a:xfrm>
-            <a:off x="548640" y="6400800"/>
-            <a:ext cx="10972800" cy="274320"/>
-          </a:xfrm>
-          <a:prstGeom prst="rect">
-            <a:avLst/>
-          </a:prstGeom>
-          <a:noFill/>
-        </p:spPr>
-        <p:txBody>
-          <a:bodyPr wrap="square">
-            <a:spAutoFit/>
-          </a:bodyPr>
-          <a:lstStyle/>
-          <a:p>
-            <a:pPr algn="l">
-              <a:defRPr sz="1200" b="1">
-                <a:solidFill>
-                  <a:srgbClr val="9090A0"/>
-                </a:solidFill>
-                <a:latin typeface="Calibri"/>
-              </a:defRPr>
-            </a:pPr>
-            <a:r>
-              <a:t>Measured Dimensions:</a:t>
-            </a:r>
-          </a:p>
-        </p:txBody>
-      </p:sp>
-      <p:sp>
-        <p:nvSpPr>
-          <p:cNvPr id="21" name="Rounded Rectangle 20"/>
-          <p:cNvSpPr/>
-          <p:nvPr/>
-        </p:nvSpPr>
-        <p:spPr>
-          <a:xfrm>
-            <a:off x="2743200" y="6355080"/>
-            <a:ext cx="1920240" cy="320040"/>
+            <a:off x="182880" y="4480560"/>
+            <a:ext cx="2331720" cy="320040"/>
           </a:xfrm>
           <a:prstGeom prst="roundRect">
             <a:avLst/>
@@ -9959,38 +10673,112 @@
           <a:lstStyle/>
           <a:p>
             <a:pPr algn="ctr">
+              <a:defRPr sz="1300" b="1">
+                <a:solidFill>
+                  <a:srgbClr val="FFFFFF"/>
+                </a:solidFill>
+                <a:latin typeface="Calibri"/>
+              </a:defRPr>
+            </a:pPr>
+            <a:r>
+              <a:t>H6</a:t>
+            </a:r>
+          </a:p>
+        </p:txBody>
+      </p:sp>
+      <p:sp>
+        <p:nvSpPr>
+          <p:cNvPr id="32" name="TextBox 31"/>
+          <p:cNvSpPr txBox="1"/>
+          <p:nvPr/>
+        </p:nvSpPr>
+        <p:spPr>
+          <a:xfrm>
+            <a:off x="274320" y="4846320"/>
+            <a:ext cx="2148839" cy="365760"/>
+          </a:xfrm>
+          <a:prstGeom prst="rect">
+            <a:avLst/>
+          </a:prstGeom>
+          <a:noFill/>
+        </p:spPr>
+        <p:txBody>
+          <a:bodyPr wrap="square">
+            <a:spAutoFit/>
+          </a:bodyPr>
+          <a:lstStyle/>
+          <a:p>
+            <a:pPr algn="l">
               <a:defRPr sz="1100" b="1">
                 <a:solidFill>
-                  <a:srgbClr val="FFFFFF"/>
-                </a:solidFill>
-                <a:latin typeface="Calibri"/>
-              </a:defRPr>
-            </a:pPr>
-            <a:r>
-              <a:t>Recovery Time</a:t>
-            </a:r>
-          </a:p>
-        </p:txBody>
-      </p:sp>
-      <p:sp>
-        <p:nvSpPr>
-          <p:cNvPr id="22" name="Rounded Rectangle 21"/>
+                  <a:srgbClr val="E74C3C"/>
+                </a:solidFill>
+                <a:latin typeface="Calibri"/>
+              </a:defRPr>
+            </a:pPr>
+            <a:r>
+              <a:t>Cross-pod variance → leakage</a:t>
+            </a:r>
+          </a:p>
+        </p:txBody>
+      </p:sp>
+      <p:sp>
+        <p:nvSpPr>
+          <p:cNvPr id="33" name="TextBox 32"/>
+          <p:cNvSpPr txBox="1"/>
+          <p:nvPr/>
+        </p:nvSpPr>
+        <p:spPr>
+          <a:xfrm>
+            <a:off x="274320" y="5257800"/>
+            <a:ext cx="2148839" cy="1005839"/>
+          </a:xfrm>
+          <a:prstGeom prst="rect">
+            <a:avLst/>
+          </a:prstGeom>
+          <a:noFill/>
+        </p:spPr>
+        <p:txBody>
+          <a:bodyPr wrap="square">
+            <a:spAutoFit/>
+          </a:bodyPr>
+          <a:lstStyle/>
+          <a:p>
+            <a:pPr algn="l">
+              <a:defRPr sz="900" b="0">
+                <a:solidFill>
+                  <a:srgbClr val="BDBDBD"/>
+                </a:solidFill>
+                <a:latin typeface="Calibri"/>
+              </a:defRPr>
+            </a:pPr>
+            <a:r>
+              <a:t>Pre-chaos cross-node stddev predicts whether a strategy lands in the containment cluster (3-17% conntrack drop) or the leakage cluster (30-49% drop).</a:t>
+            </a:r>
+          </a:p>
+        </p:txBody>
+      </p:sp>
+      <p:sp>
+        <p:nvSpPr>
+          <p:cNvPr id="34" name="Rounded Rectangle 33"/>
           <p:cNvSpPr/>
           <p:nvPr/>
         </p:nvSpPr>
         <p:spPr>
           <a:xfrm>
-            <a:off x="4846320" y="6355080"/>
-            <a:ext cx="1920240" cy="320040"/>
+            <a:off x="2560320" y="4480560"/>
+            <a:ext cx="2331720" cy="1874519"/>
           </a:xfrm>
           <a:prstGeom prst="roundRect">
             <a:avLst/>
           </a:prstGeom>
           <a:solidFill>
-            <a:srgbClr val="2ECC71"/>
+            <a:srgbClr val="121222"/>
           </a:solidFill>
-          <a:ln>
-            <a:noFill/>
+          <a:ln w="25400">
+            <a:solidFill>
+              <a:srgbClr val="E74C3C"/>
+            </a:solidFill>
           </a:ln>
         </p:spPr>
         <p:style>
@@ -10008,39 +10796,29 @@
           </a:fontRef>
         </p:style>
         <p:txBody>
-          <a:bodyPr rtlCol="0" anchor="ctr" wrap="square" lIns="50800" rIns="50800" tIns="25400" bIns="25400"/>
-          <a:lstStyle/>
-          <a:p>
-            <a:pPr algn="ctr">
-              <a:defRPr sz="1100" b="1">
-                <a:solidFill>
-                  <a:srgbClr val="FFFFFF"/>
-                </a:solidFill>
-                <a:latin typeface="Calibri"/>
-              </a:defRPr>
-            </a:pPr>
-            <a:r>
-              <a:t>Inter-Service Latency</a:t>
-            </a:r>
-          </a:p>
-        </p:txBody>
-      </p:sp>
-      <p:sp>
-        <p:nvSpPr>
-          <p:cNvPr id="23" name="Rounded Rectangle 22"/>
+          <a:bodyPr rtlCol="0" anchor="ctr"/>
+          <a:lstStyle/>
+          <a:p>
+            <a:pPr algn="ctr"/>
+          </a:p>
+        </p:txBody>
+      </p:sp>
+      <p:sp>
+        <p:nvSpPr>
+          <p:cNvPr id="35" name="Rounded Rectangle 34"/>
           <p:cNvSpPr/>
           <p:nvPr/>
         </p:nvSpPr>
         <p:spPr>
           <a:xfrm>
-            <a:off x="6949440" y="6355080"/>
-            <a:ext cx="1920240" cy="320040"/>
+            <a:off x="2560320" y="4480560"/>
+            <a:ext cx="2331720" cy="320040"/>
           </a:xfrm>
           <a:prstGeom prst="roundRect">
             <a:avLst/>
           </a:prstGeom>
           <a:solidFill>
-            <a:srgbClr val="1ABC9C"/>
+            <a:srgbClr val="E74C3C"/>
           </a:solidFill>
           <a:ln>
             <a:noFill/>
@@ -10065,38 +10843,112 @@
           <a:lstStyle/>
           <a:p>
             <a:pPr algn="ctr">
+              <a:defRPr sz="1300" b="1">
+                <a:solidFill>
+                  <a:srgbClr val="FFFFFF"/>
+                </a:solidFill>
+                <a:latin typeface="Calibri"/>
+              </a:defRPr>
+            </a:pPr>
+            <a:r>
+              <a:t>H7</a:t>
+            </a:r>
+          </a:p>
+        </p:txBody>
+      </p:sp>
+      <p:sp>
+        <p:nvSpPr>
+          <p:cNvPr id="36" name="TextBox 35"/>
+          <p:cNvSpPr txBox="1"/>
+          <p:nvPr/>
+        </p:nvSpPr>
+        <p:spPr>
+          <a:xfrm>
+            <a:off x="2651760" y="4846320"/>
+            <a:ext cx="2148839" cy="365760"/>
+          </a:xfrm>
+          <a:prstGeom prst="rect">
+            <a:avLst/>
+          </a:prstGeom>
+          <a:noFill/>
+        </p:spPr>
+        <p:txBody>
+          <a:bodyPr wrap="square">
+            <a:spAutoFit/>
+          </a:bodyPr>
+          <a:lstStyle/>
+          <a:p>
+            <a:pPr algn="l">
               <a:defRPr sz="1100" b="1">
                 <a:solidFill>
-                  <a:srgbClr val="FFFFFF"/>
-                </a:solidFill>
-                <a:latin typeface="Calibri"/>
-              </a:defRPr>
-            </a:pPr>
-            <a:r>
-              <a:t>Resource Utilization</a:t>
-            </a:r>
-          </a:p>
-        </p:txBody>
-      </p:sp>
-      <p:sp>
-        <p:nvSpPr>
-          <p:cNvPr id="24" name="Rounded Rectangle 23"/>
+                  <a:srgbClr val="E74C3C"/>
+                </a:solidFill>
+                <a:latin typeface="Calibri"/>
+              </a:defRPr>
+            </a:pPr>
+            <a:r>
+              <a:t>CPU throttling refutes contention model</a:t>
+            </a:r>
+          </a:p>
+        </p:txBody>
+      </p:sp>
+      <p:sp>
+        <p:nvSpPr>
+          <p:cNvPr id="37" name="TextBox 36"/>
+          <p:cNvSpPr txBox="1"/>
+          <p:nvPr/>
+        </p:nvSpPr>
+        <p:spPr>
+          <a:xfrm>
+            <a:off x="2651760" y="5257800"/>
+            <a:ext cx="2148839" cy="1005839"/>
+          </a:xfrm>
+          <a:prstGeom prst="rect">
+            <a:avLst/>
+          </a:prstGeom>
+          <a:noFill/>
+        </p:spPr>
+        <p:txBody>
+          <a:bodyPr wrap="square">
+            <a:spAutoFit/>
+          </a:bodyPr>
+          <a:lstStyle/>
+          <a:p>
+            <a:pPr algn="l">
+              <a:defRPr sz="900" b="0">
+                <a:solidFill>
+                  <a:srgbClr val="BDBDBD"/>
+                </a:solidFill>
+                <a:latin typeface="Calibri"/>
+              </a:defRPr>
+            </a:pPr>
+            <a:r>
+              <a:t>Under pod-delete, colocate throttles less (0.89) than spread (1.52) — opposite of Bubble-Up's contention prediction. Mars 2011 doesn't fit churn-based faults.</a:t>
+            </a:r>
+          </a:p>
+        </p:txBody>
+      </p:sp>
+      <p:sp>
+        <p:nvSpPr>
+          <p:cNvPr id="38" name="Rounded Rectangle 37"/>
           <p:cNvSpPr/>
           <p:nvPr/>
         </p:nvSpPr>
         <p:spPr>
           <a:xfrm>
-            <a:off x="9052559" y="6355080"/>
-            <a:ext cx="1920240" cy="320040"/>
+            <a:off x="4937759" y="4480560"/>
+            <a:ext cx="2331720" cy="1874519"/>
           </a:xfrm>
           <a:prstGeom prst="roundRect">
             <a:avLst/>
           </a:prstGeom>
           <a:solidFill>
-            <a:srgbClr val="F39C12"/>
+            <a:srgbClr val="121222"/>
           </a:solidFill>
-          <a:ln>
-            <a:noFill/>
+          <a:ln w="25400">
+            <a:solidFill>
+              <a:srgbClr val="E74C3C"/>
+            </a:solidFill>
           </a:ln>
         </p:spPr>
         <p:style>
@@ -10114,19 +10966,510 @@
           </a:fontRef>
         </p:style>
         <p:txBody>
+          <a:bodyPr rtlCol="0" anchor="ctr"/>
+          <a:lstStyle/>
+          <a:p>
+            <a:pPr algn="ctr"/>
+          </a:p>
+        </p:txBody>
+      </p:sp>
+      <p:sp>
+        <p:nvSpPr>
+          <p:cNvPr id="39" name="Rounded Rectangle 38"/>
+          <p:cNvSpPr/>
+          <p:nvPr/>
+        </p:nvSpPr>
+        <p:spPr>
+          <a:xfrm>
+            <a:off x="4937759" y="4480560"/>
+            <a:ext cx="2331720" cy="320040"/>
+          </a:xfrm>
+          <a:prstGeom prst="roundRect">
+            <a:avLst/>
+          </a:prstGeom>
+          <a:solidFill>
+            <a:srgbClr val="E74C3C"/>
+          </a:solidFill>
+          <a:ln>
+            <a:noFill/>
+          </a:ln>
+        </p:spPr>
+        <p:style>
+          <a:lnRef idx="1">
+            <a:schemeClr val="accent1"/>
+          </a:lnRef>
+          <a:fillRef idx="3">
+            <a:schemeClr val="accent1"/>
+          </a:fillRef>
+          <a:effectRef idx="2">
+            <a:schemeClr val="accent1"/>
+          </a:effectRef>
+          <a:fontRef idx="minor">
+            <a:schemeClr val="lt1"/>
+          </a:fontRef>
+        </p:style>
+        <p:txBody>
           <a:bodyPr rtlCol="0" anchor="ctr" wrap="square" lIns="50800" rIns="50800" tIns="25400" bIns="25400"/>
           <a:lstStyle/>
           <a:p>
             <a:pPr algn="ctr">
+              <a:defRPr sz="1300" b="1">
+                <a:solidFill>
+                  <a:srgbClr val="FFFFFF"/>
+                </a:solidFill>
+                <a:latin typeface="Calibri"/>
+              </a:defRPr>
+            </a:pPr>
+            <a:r>
+              <a:t>H8</a:t>
+            </a:r>
+          </a:p>
+        </p:txBody>
+      </p:sp>
+      <p:sp>
+        <p:nvSpPr>
+          <p:cNvPr id="40" name="TextBox 39"/>
+          <p:cNvSpPr txBox="1"/>
+          <p:nvPr/>
+        </p:nvSpPr>
+        <p:spPr>
+          <a:xfrm>
+            <a:off x="5029199" y="4846320"/>
+            <a:ext cx="2148839" cy="365760"/>
+          </a:xfrm>
+          <a:prstGeom prst="rect">
+            <a:avLst/>
+          </a:prstGeom>
+          <a:noFill/>
+        </p:spPr>
+        <p:txBody>
+          <a:bodyPr wrap="square">
+            <a:spAutoFit/>
+          </a:bodyPr>
+          <a:lstStyle/>
+          <a:p>
+            <a:pPr algn="l">
               <a:defRPr sz="1100" b="1">
                 <a:solidFill>
+                  <a:srgbClr val="E74C3C"/>
+                </a:solidFill>
+                <a:latin typeface="Calibri"/>
+              </a:defRPr>
+            </a:pPr>
+            <a:r>
+              <a:t>SLO + conntrack signals leakage</a:t>
+            </a:r>
+          </a:p>
+        </p:txBody>
+      </p:sp>
+      <p:sp>
+        <p:nvSpPr>
+          <p:cNvPr id="41" name="TextBox 40"/>
+          <p:cNvSpPr txBox="1"/>
+          <p:nvPr/>
+        </p:nvSpPr>
+        <p:spPr>
+          <a:xfrm>
+            <a:off x="5029199" y="5257800"/>
+            <a:ext cx="2148839" cy="1005839"/>
+          </a:xfrm>
+          <a:prstGeom prst="rect">
+            <a:avLst/>
+          </a:prstGeom>
+          <a:noFill/>
+        </p:spPr>
+        <p:txBody>
+          <a:bodyPr wrap="square">
+            <a:spAutoFit/>
+          </a:bodyPr>
+          <a:lstStyle/>
+          <a:p>
+            <a:pPr algn="l">
+              <a:defRPr sz="900" b="0">
+                <a:solidFill>
+                  <a:srgbClr val="BDBDBD"/>
+                </a:solidFill>
+                <a:latin typeface="Calibri"/>
+              </a:defRPr>
+            </a:pPr>
+            <a:r>
+              <a:t>Conntrack flushing during chaos correlates with leakage: spread 49%, dep-aware 3%. The K8s Network Programming Latency SLO measures the churn mechanism directly.</a:t>
+            </a:r>
+          </a:p>
+        </p:txBody>
+      </p:sp>
+      <p:sp>
+        <p:nvSpPr>
+          <p:cNvPr id="42" name="Rounded Rectangle 41"/>
+          <p:cNvSpPr/>
+          <p:nvPr/>
+        </p:nvSpPr>
+        <p:spPr>
+          <a:xfrm>
+            <a:off x="7315199" y="4480560"/>
+            <a:ext cx="2331720" cy="1874519"/>
+          </a:xfrm>
+          <a:prstGeom prst="roundRect">
+            <a:avLst/>
+          </a:prstGeom>
+          <a:solidFill>
+            <a:srgbClr val="121222"/>
+          </a:solidFill>
+          <a:ln w="25400">
+            <a:solidFill>
+              <a:srgbClr val="9B59B6"/>
+            </a:solidFill>
+          </a:ln>
+        </p:spPr>
+        <p:style>
+          <a:lnRef idx="1">
+            <a:schemeClr val="accent1"/>
+          </a:lnRef>
+          <a:fillRef idx="3">
+            <a:schemeClr val="accent1"/>
+          </a:fillRef>
+          <a:effectRef idx="2">
+            <a:schemeClr val="accent1"/>
+          </a:effectRef>
+          <a:fontRef idx="minor">
+            <a:schemeClr val="lt1"/>
+          </a:fontRef>
+        </p:style>
+        <p:txBody>
+          <a:bodyPr rtlCol="0" anchor="ctr"/>
+          <a:lstStyle/>
+          <a:p>
+            <a:pPr algn="ctr"/>
+          </a:p>
+        </p:txBody>
+      </p:sp>
+      <p:sp>
+        <p:nvSpPr>
+          <p:cNvPr id="43" name="Rounded Rectangle 42"/>
+          <p:cNvSpPr/>
+          <p:nvPr/>
+        </p:nvSpPr>
+        <p:spPr>
+          <a:xfrm>
+            <a:off x="7315199" y="4480560"/>
+            <a:ext cx="2331720" cy="320040"/>
+          </a:xfrm>
+          <a:prstGeom prst="roundRect">
+            <a:avLst/>
+          </a:prstGeom>
+          <a:solidFill>
+            <a:srgbClr val="9B59B6"/>
+          </a:solidFill>
+          <a:ln>
+            <a:noFill/>
+          </a:ln>
+        </p:spPr>
+        <p:style>
+          <a:lnRef idx="1">
+            <a:schemeClr val="accent1"/>
+          </a:lnRef>
+          <a:fillRef idx="3">
+            <a:schemeClr val="accent1"/>
+          </a:fillRef>
+          <a:effectRef idx="2">
+            <a:schemeClr val="accent1"/>
+          </a:effectRef>
+          <a:fontRef idx="minor">
+            <a:schemeClr val="lt1"/>
+          </a:fontRef>
+        </p:style>
+        <p:txBody>
+          <a:bodyPr rtlCol="0" anchor="ctr" wrap="square" lIns="50800" rIns="50800" tIns="25400" bIns="25400"/>
+          <a:lstStyle/>
+          <a:p>
+            <a:pPr algn="ctr">
+              <a:defRPr sz="1300" b="1">
+                <a:solidFill>
                   <a:srgbClr val="FFFFFF"/>
                 </a:solidFill>
                 <a:latin typeface="Calibri"/>
               </a:defRPr>
             </a:pPr>
             <a:r>
-              <a:t>I/O Throughput</a:t>
+              <a:t>H9</a:t>
+            </a:r>
+          </a:p>
+        </p:txBody>
+      </p:sp>
+      <p:sp>
+        <p:nvSpPr>
+          <p:cNvPr id="44" name="TextBox 43"/>
+          <p:cNvSpPr txBox="1"/>
+          <p:nvPr/>
+        </p:nvSpPr>
+        <p:spPr>
+          <a:xfrm>
+            <a:off x="7406640" y="4846320"/>
+            <a:ext cx="2148839" cy="365760"/>
+          </a:xfrm>
+          <a:prstGeom prst="rect">
+            <a:avLst/>
+          </a:prstGeom>
+          <a:noFill/>
+        </p:spPr>
+        <p:txBody>
+          <a:bodyPr wrap="square">
+            <a:spAutoFit/>
+          </a:bodyPr>
+          <a:lstStyle/>
+          <a:p>
+            <a:pPr algn="l">
+              <a:defRPr sz="1100" b="1">
+                <a:solidFill>
+                  <a:srgbClr val="9B59B6"/>
+                </a:solidFill>
+                <a:latin typeface="Calibri"/>
+              </a:defRPr>
+            </a:pPr>
+            <a:r>
+              <a:t>Scheduling latency dominates recovery</a:t>
+            </a:r>
+          </a:p>
+        </p:txBody>
+      </p:sp>
+      <p:sp>
+        <p:nvSpPr>
+          <p:cNvPr id="45" name="TextBox 44"/>
+          <p:cNvSpPr txBox="1"/>
+          <p:nvPr/>
+        </p:nvSpPr>
+        <p:spPr>
+          <a:xfrm>
+            <a:off x="7406640" y="5257800"/>
+            <a:ext cx="2148839" cy="1005839"/>
+          </a:xfrm>
+          <a:prstGeom prst="rect">
+            <a:avLst/>
+          </a:prstGeom>
+          <a:noFill/>
+        </p:spPr>
+        <p:txBody>
+          <a:bodyPr wrap="square">
+            <a:spAutoFit/>
+          </a:bodyPr>
+          <a:lstStyle/>
+          <a:p>
+            <a:pPr algn="l">
+              <a:defRPr sz="900" b="0">
+                <a:solidFill>
+                  <a:srgbClr val="BDBDBD"/>
+                </a:solidFill>
+                <a:latin typeface="Calibri"/>
+              </a:defRPr>
+            </a:pPr>
+            <a:r>
+              <a:t>Recovery time = (deletion→scheduled) + (scheduled→ready). Placement affects only the first term; the second is application-bound and ~constant across strategies.</a:t>
+            </a:r>
+          </a:p>
+        </p:txBody>
+      </p:sp>
+      <p:sp>
+        <p:nvSpPr>
+          <p:cNvPr id="46" name="Rounded Rectangle 45"/>
+          <p:cNvSpPr/>
+          <p:nvPr/>
+        </p:nvSpPr>
+        <p:spPr>
+          <a:xfrm>
+            <a:off x="9692639" y="4480560"/>
+            <a:ext cx="2331720" cy="1874519"/>
+          </a:xfrm>
+          <a:prstGeom prst="roundRect">
+            <a:avLst/>
+          </a:prstGeom>
+          <a:solidFill>
+            <a:srgbClr val="121222"/>
+          </a:solidFill>
+          <a:ln w="25400">
+            <a:solidFill>
+              <a:srgbClr val="9B59B6"/>
+            </a:solidFill>
+          </a:ln>
+        </p:spPr>
+        <p:style>
+          <a:lnRef idx="1">
+            <a:schemeClr val="accent1"/>
+          </a:lnRef>
+          <a:fillRef idx="3">
+            <a:schemeClr val="accent1"/>
+          </a:fillRef>
+          <a:effectRef idx="2">
+            <a:schemeClr val="accent1"/>
+          </a:effectRef>
+          <a:fontRef idx="minor">
+            <a:schemeClr val="lt1"/>
+          </a:fontRef>
+        </p:style>
+        <p:txBody>
+          <a:bodyPr rtlCol="0" anchor="ctr"/>
+          <a:lstStyle/>
+          <a:p>
+            <a:pPr algn="ctr"/>
+          </a:p>
+        </p:txBody>
+      </p:sp>
+      <p:sp>
+        <p:nvSpPr>
+          <p:cNvPr id="47" name="Rounded Rectangle 46"/>
+          <p:cNvSpPr/>
+          <p:nvPr/>
+        </p:nvSpPr>
+        <p:spPr>
+          <a:xfrm>
+            <a:off x="9692639" y="4480560"/>
+            <a:ext cx="2331720" cy="320040"/>
+          </a:xfrm>
+          <a:prstGeom prst="roundRect">
+            <a:avLst/>
+          </a:prstGeom>
+          <a:solidFill>
+            <a:srgbClr val="9B59B6"/>
+          </a:solidFill>
+          <a:ln>
+            <a:noFill/>
+          </a:ln>
+        </p:spPr>
+        <p:style>
+          <a:lnRef idx="1">
+            <a:schemeClr val="accent1"/>
+          </a:lnRef>
+          <a:fillRef idx="3">
+            <a:schemeClr val="accent1"/>
+          </a:fillRef>
+          <a:effectRef idx="2">
+            <a:schemeClr val="accent1"/>
+          </a:effectRef>
+          <a:fontRef idx="minor">
+            <a:schemeClr val="lt1"/>
+          </a:fontRef>
+        </p:style>
+        <p:txBody>
+          <a:bodyPr rtlCol="0" anchor="ctr" wrap="square" lIns="50800" rIns="50800" tIns="25400" bIns="25400"/>
+          <a:lstStyle/>
+          <a:p>
+            <a:pPr algn="ctr">
+              <a:defRPr sz="1300" b="1">
+                <a:solidFill>
+                  <a:srgbClr val="FFFFFF"/>
+                </a:solidFill>
+                <a:latin typeface="Calibri"/>
+              </a:defRPr>
+            </a:pPr>
+            <a:r>
+              <a:t>H10</a:t>
+            </a:r>
+          </a:p>
+        </p:txBody>
+      </p:sp>
+      <p:sp>
+        <p:nvSpPr>
+          <p:cNvPr id="48" name="TextBox 47"/>
+          <p:cNvSpPr txBox="1"/>
+          <p:nvPr/>
+        </p:nvSpPr>
+        <p:spPr>
+          <a:xfrm>
+            <a:off x="9784079" y="4846320"/>
+            <a:ext cx="2148839" cy="365760"/>
+          </a:xfrm>
+          <a:prstGeom prst="rect">
+            <a:avLst/>
+          </a:prstGeom>
+          <a:noFill/>
+        </p:spPr>
+        <p:txBody>
+          <a:bodyPr wrap="square">
+            <a:spAutoFit/>
+          </a:bodyPr>
+          <a:lstStyle/>
+          <a:p>
+            <a:pPr algn="l">
+              <a:defRPr sz="1100" b="1">
+                <a:solidFill>
+                  <a:srgbClr val="9B59B6"/>
+                </a:solidFill>
+                <a:latin typeface="Calibri"/>
+              </a:defRPr>
+            </a:pPr>
+            <a:r>
+              <a:t>Post-chaos asymmetry as fingerprint</a:t>
+            </a:r>
+          </a:p>
+        </p:txBody>
+      </p:sp>
+      <p:sp>
+        <p:nvSpPr>
+          <p:cNvPr id="49" name="TextBox 48"/>
+          <p:cNvSpPr txBox="1"/>
+          <p:nvPr/>
+        </p:nvSpPr>
+        <p:spPr>
+          <a:xfrm>
+            <a:off x="9784079" y="5257800"/>
+            <a:ext cx="2148839" cy="1005839"/>
+          </a:xfrm>
+          <a:prstGeom prst="rect">
+            <a:avLst/>
+          </a:prstGeom>
+          <a:noFill/>
+        </p:spPr>
+        <p:txBody>
+          <a:bodyPr wrap="square">
+            <a:spAutoFit/>
+          </a:bodyPr>
+          <a:lstStyle/>
+          <a:p>
+            <a:pPr algn="l">
+              <a:defRPr sz="900" b="0">
+                <a:solidFill>
+                  <a:srgbClr val="BDBDBD"/>
+                </a:solidFill>
+                <a:latin typeface="Calibri"/>
+              </a:defRPr>
+            </a:pPr>
+            <a:r>
+              <a:t>Post-chaos metrics overshoot, undershoot, or stabilise per strategy. Redis throughput varies 50-450% post-chaos; the asymmetry pattern is itself a placement fingerprint.</a:t>
+            </a:r>
+          </a:p>
+        </p:txBody>
+      </p:sp>
+      <p:sp>
+        <p:nvSpPr>
+          <p:cNvPr id="50" name="TextBox 49"/>
+          <p:cNvSpPr txBox="1"/>
+          <p:nvPr/>
+        </p:nvSpPr>
+        <p:spPr>
+          <a:xfrm>
+            <a:off x="548640" y="6446520"/>
+            <a:ext cx="11064240" cy="320040"/>
+          </a:xfrm>
+          <a:prstGeom prst="rect">
+            <a:avLst/>
+          </a:prstGeom>
+          <a:noFill/>
+        </p:spPr>
+        <p:txBody>
+          <a:bodyPr wrap="square">
+            <a:spAutoFit/>
+          </a:bodyPr>
+          <a:lstStyle/>
+          <a:p>
+            <a:pPr algn="ctr">
+              <a:defRPr sz="1000" b="0">
+                <a:solidFill>
+                  <a:srgbClr val="9090A0"/>
+                </a:solidFill>
+                <a:latin typeface="Calibri"/>
+              </a:defRPr>
+            </a:pPr>
+            <a:r>
+              <a:t>Each hypothesis is testable from ChaosProbe-collected metrics; the data column reports current evidence.</a:t>
             </a:r>
           </a:p>
         </p:txBody>
@@ -10400,11 +11743,11 @@
               </a:defRPr>
             </a:pPr>
             <a:r>
-              <a:t>• Sparrow (Ousterhout et al., 2013)</a:t>
+              <a:t>• DeathStarBench (Gan et al., 2019)</a:t>
             </a:r>
             <a:br/>
             <a:r>
-              <a:t>  Decentralized random scheduling</a:t>
+              <a:t>  Dependency-graph-aware placement</a:t>
             </a:r>
           </a:p>
           <a:p>
@@ -10423,11 +11766,11 @@
               </a:defRPr>
             </a:pPr>
             <a:r>
-              <a:t>• DeathStarBench (Gan et al., 2019)</a:t>
+              <a:t>• Mars (2011); Delimitrou (2014)</a:t>
             </a:r>
             <a:br/>
             <a:r>
-              <a:t>  Dependency-graph-aware placement</a:t>
+              <a:t>  Contention-aware co-scheduling</a:t>
             </a:r>
           </a:p>
           <a:p>
@@ -10446,11 +11789,11 @@
               </a:defRPr>
             </a:pPr>
             <a:r>
-              <a:t>• Mars (2011); Delimitrou (2014)</a:t>
+              <a:t>• Liu et al. (arXiv 2507.16109, 2025)</a:t>
             </a:r>
             <a:br/>
             <a:r>
-              <a:t>  Contention-aware co-scheduling</a:t>
+              <a:t>  Cloud-edge placement under churn</a:t>
             </a:r>
           </a:p>
         </p:txBody>
@@ -10642,11 +11985,11 @@
               </a:defRPr>
             </a:pPr>
             <a:r>
-              <a:t>• Gremlin — fault injection SaaS</a:t>
+              <a:t>• Mutiny! K8s churn injection</a:t>
             </a:r>
             <a:br/>
             <a:r>
-              <a:t>  Commercial chaos platform</a:t>
+              <a:t>  (DSN 2024) — closest peer</a:t>
             </a:r>
           </a:p>
           <a:p>
@@ -16109,7 +17452,7 @@
             </a:r>
             <a:br/>
             <a:r>
-              <a:t>2 GiB</a:t>
+              <a:t>4 GiB</a:t>
             </a:r>
           </a:p>
         </p:txBody>
@@ -16230,7 +17573,7 @@
             </a:r>
             <a:br/>
             <a:r>
-              <a:t>2 GiB</a:t>
+              <a:t>4 GiB</a:t>
             </a:r>
           </a:p>
         </p:txBody>
@@ -16508,7 +17851,7 @@
               </a:defRPr>
             </a:pPr>
             <a:r>
-              <a:t>K8s v1.28.6 • Calico CNI • containerd 1.7.11 • Total: 10 vCPU, 14 GiB</a:t>
+              <a:t>K8s v1.28.6 • Calico CNI • containerd 1.7.11 • Total: 10 vCPU, 18 GiB</a:t>
             </a:r>
           </a:p>
         </p:txBody>
@@ -22673,30 +24016,75 @@
           </a:p>
         </p:txBody>
       </p:sp>
-      <p:pic>
-        <p:nvPicPr>
-          <p:cNvPr id="4" name="Picture 3" descr="resilience_scores.png"/>
-          <p:cNvPicPr>
-            <a:picLocks noChangeAspect="1"/>
-          </p:cNvPicPr>
-          <p:nvPr/>
-        </p:nvPicPr>
-        <p:blipFill>
-          <a:blip r:embed="rId2"/>
-          <a:stretch>
-            <a:fillRect/>
-          </a:stretch>
-        </p:blipFill>
+      <p:sp>
+        <p:nvSpPr>
+          <p:cNvPr id="4" name="Rounded Rectangle 3"/>
+          <p:cNvSpPr/>
+          <p:nvPr/>
+        </p:nvSpPr>
         <p:spPr>
           <a:xfrm>
             <a:off x="457200" y="1280160"/>
             <a:ext cx="6858000" cy="4114800"/>
           </a:xfrm>
-          <a:prstGeom prst="rect">
-            <a:avLst/>
-          </a:prstGeom>
-        </p:spPr>
-      </p:pic>
+          <a:prstGeom prst="roundRect">
+            <a:avLst/>
+          </a:prstGeom>
+          <a:solidFill>
+            <a:srgbClr val="121222"/>
+          </a:solidFill>
+          <a:ln w="12700">
+            <a:solidFill>
+              <a:srgbClr val="9090A0"/>
+            </a:solidFill>
+          </a:ln>
+        </p:spPr>
+        <p:style>
+          <a:lnRef idx="1">
+            <a:schemeClr val="accent1"/>
+          </a:lnRef>
+          <a:fillRef idx="3">
+            <a:schemeClr val="accent1"/>
+          </a:fillRef>
+          <a:effectRef idx="2">
+            <a:schemeClr val="accent1"/>
+          </a:effectRef>
+          <a:fontRef idx="minor">
+            <a:schemeClr val="lt1"/>
+          </a:fontRef>
+        </p:style>
+        <p:txBody>
+          <a:bodyPr rtlCol="0" anchor="ctr" wrap="square" lIns="50800" rIns="50800" tIns="25400" bIns="25400"/>
+          <a:lstStyle/>
+          <a:p>
+            <a:pPr algn="ctr">
+              <a:defRPr sz="1100" b="0">
+                <a:solidFill>
+                  <a:srgbClr val="9090A0"/>
+                </a:solidFill>
+                <a:latin typeface="Calibri"/>
+              </a:defRPr>
+            </a:pPr>
+            <a:r>
+              <a:t>[Resilience Scores by Strategy]</a:t>
+            </a:r>
+            <a:br/>
+            <a:br/>
+            <a:r>
+              <a:t>Bar chart showing resilience score (0–100%)</a:t>
+            </a:r>
+            <a:br/>
+            <a:r>
+              <a:t>per placement strategy.</a:t>
+            </a:r>
+            <a:br/>
+            <a:br/>
+            <a:r>
+              <a:t>Generated by: chaosprobe visualize</a:t>
+            </a:r>
+          </a:p>
+        </p:txBody>
+      </p:sp>
       <p:sp>
         <p:nvSpPr>
           <p:cNvPr id="5" name="Rounded Rectangle 4"/>

</xml_diff>

<commit_message>
docs(presentation): refresh slides 4/6/13 after worker-uniform fix (#29)
Slide 4 — swap Mars-only and Gremlin bullets for Liu et al. (2025) and
Mutiny! (DSN 2024), the closest peer-reviewed 2024–2025 work. A defence
in 2026 needs to position against current literature, not 2010s only.

Slide 6 — workers are now all 4 GiB after the proxmox standardisation;
total updated to 18 GiB.

Slide 13 — Cluster scale text reflects the uniform-worker fact (removes
the previously-flagged heterogeneous-cluster confound). Adds a fourth
External Validity item, Metric portability, calling out cgroup-v2 /
Calico / etcd-version dependencies and pointing at metricAvailability
as the in-band surface that records what was actually collected.

Presentation script updated to match.

Co-authored-by: Claude Opus 4.7 (1M context) <noreply@anthropic.com>
</commit_message>
<xml_diff>
--- a/ChaosProbe_Presentation.pptx
+++ b/ChaosProbe_Presentation.pptx
@@ -3406,30 +3406,75 @@
           </a:p>
         </p:txBody>
       </p:sp>
-      <p:pic>
-        <p:nvPicPr>
-          <p:cNvPr id="4" name="Picture 3" descr="recovery_times.png"/>
-          <p:cNvPicPr>
-            <a:picLocks noChangeAspect="1"/>
-          </p:cNvPicPr>
-          <p:nvPr/>
-        </p:nvPicPr>
-        <p:blipFill>
-          <a:blip r:embed="rId2"/>
-          <a:stretch>
-            <a:fillRect/>
-          </a:stretch>
-        </p:blipFill>
+      <p:sp>
+        <p:nvSpPr>
+          <p:cNvPr id="4" name="Rounded Rectangle 3"/>
+          <p:cNvSpPr/>
+          <p:nvPr/>
+        </p:nvSpPr>
         <p:spPr>
           <a:xfrm>
             <a:off x="274320" y="1280160"/>
             <a:ext cx="5669280" cy="3200400"/>
           </a:xfrm>
-          <a:prstGeom prst="rect">
-            <a:avLst/>
-          </a:prstGeom>
-        </p:spPr>
-      </p:pic>
+          <a:prstGeom prst="roundRect">
+            <a:avLst/>
+          </a:prstGeom>
+          <a:solidFill>
+            <a:srgbClr val="121222"/>
+          </a:solidFill>
+          <a:ln w="12700">
+            <a:solidFill>
+              <a:srgbClr val="9090A0"/>
+            </a:solidFill>
+          </a:ln>
+        </p:spPr>
+        <p:style>
+          <a:lnRef idx="1">
+            <a:schemeClr val="accent1"/>
+          </a:lnRef>
+          <a:fillRef idx="3">
+            <a:schemeClr val="accent1"/>
+          </a:fillRef>
+          <a:effectRef idx="2">
+            <a:schemeClr val="accent1"/>
+          </a:effectRef>
+          <a:fontRef idx="minor">
+            <a:schemeClr val="lt1"/>
+          </a:fontRef>
+        </p:style>
+        <p:txBody>
+          <a:bodyPr rtlCol="0" anchor="ctr" wrap="square" lIns="50800" rIns="50800" tIns="25400" bIns="25400"/>
+          <a:lstStyle/>
+          <a:p>
+            <a:pPr algn="ctr">
+              <a:defRPr sz="1100" b="0">
+                <a:solidFill>
+                  <a:srgbClr val="9090A0"/>
+                </a:solidFill>
+                <a:latin typeface="Calibri"/>
+              </a:defRPr>
+            </a:pPr>
+            <a:r>
+              <a:t>[Recovery Times by Strategy]</a:t>
+            </a:r>
+            <a:br/>
+            <a:br/>
+            <a:r>
+              <a:t>Box plot: pod deletion → ready (ms)</a:t>
+            </a:r>
+            <a:br/>
+            <a:r>
+              <a:t>per placement strategy.</a:t>
+            </a:r>
+            <a:br/>
+            <a:br/>
+            <a:r>
+              <a:t>Generated by: chaosprobe visualize</a:t>
+            </a:r>
+          </a:p>
+        </p:txBody>
+      </p:sp>
       <p:sp>
         <p:nvSpPr>
           <p:cNvPr id="5" name="TextBox 4"/>
@@ -3466,30 +3511,75 @@
           </a:p>
         </p:txBody>
       </p:sp>
-      <p:pic>
-        <p:nvPicPr>
-          <p:cNvPr id="6" name="Picture 5" descr="latency_degradation.png"/>
-          <p:cNvPicPr>
-            <a:picLocks noChangeAspect="1"/>
-          </p:cNvPicPr>
-          <p:nvPr/>
-        </p:nvPicPr>
-        <p:blipFill>
-          <a:blip r:embed="rId3"/>
-          <a:stretch>
-            <a:fillRect/>
-          </a:stretch>
-        </p:blipFill>
+      <p:sp>
+        <p:nvSpPr>
+          <p:cNvPr id="6" name="Rounded Rectangle 5"/>
+          <p:cNvSpPr/>
+          <p:nvPr/>
+        </p:nvSpPr>
         <p:spPr>
           <a:xfrm>
             <a:off x="6217920" y="1280160"/>
             <a:ext cx="5669280" cy="3200400"/>
           </a:xfrm>
-          <a:prstGeom prst="rect">
-            <a:avLst/>
-          </a:prstGeom>
-        </p:spPr>
-      </p:pic>
+          <a:prstGeom prst="roundRect">
+            <a:avLst/>
+          </a:prstGeom>
+          <a:solidFill>
+            <a:srgbClr val="121222"/>
+          </a:solidFill>
+          <a:ln w="12700">
+            <a:solidFill>
+              <a:srgbClr val="9090A0"/>
+            </a:solidFill>
+          </a:ln>
+        </p:spPr>
+        <p:style>
+          <a:lnRef idx="1">
+            <a:schemeClr val="accent1"/>
+          </a:lnRef>
+          <a:fillRef idx="3">
+            <a:schemeClr val="accent1"/>
+          </a:fillRef>
+          <a:effectRef idx="2">
+            <a:schemeClr val="accent1"/>
+          </a:effectRef>
+          <a:fontRef idx="minor">
+            <a:schemeClr val="lt1"/>
+          </a:fontRef>
+        </p:style>
+        <p:txBody>
+          <a:bodyPr rtlCol="0" anchor="ctr" wrap="square" lIns="50800" rIns="50800" tIns="25400" bIns="25400"/>
+          <a:lstStyle/>
+          <a:p>
+            <a:pPr algn="ctr">
+              <a:defRPr sz="1100" b="0">
+                <a:solidFill>
+                  <a:srgbClr val="9090A0"/>
+                </a:solidFill>
+                <a:latin typeface="Calibri"/>
+              </a:defRPr>
+            </a:pPr>
+            <a:r>
+              <a:t>[Latency Degradation: Pre vs During Chaos]</a:t>
+            </a:r>
+            <a:br/>
+            <a:br/>
+            <a:r>
+              <a:t>Grouped bar chart: HTTP route latency</a:t>
+            </a:r>
+            <a:br/>
+            <a:r>
+              <a:t>pre-chaos vs during-chaos per strategy.</a:t>
+            </a:r>
+            <a:br/>
+            <a:br/>
+            <a:r>
+              <a:t>Generated by: chaosprobe visualize</a:t>
+            </a:r>
+          </a:p>
+        </p:txBody>
+      </p:sp>
       <p:sp>
         <p:nvSpPr>
           <p:cNvPr id="7" name="TextBox 6"/>
@@ -3973,30 +4063,75 @@
           </a:p>
         </p:txBody>
       </p:sp>
-      <p:pic>
-        <p:nvPicPr>
-          <p:cNvPr id="4" name="Picture 3" descr="resource_utilization.png"/>
-          <p:cNvPicPr>
-            <a:picLocks noChangeAspect="1"/>
-          </p:cNvPicPr>
-          <p:nvPr/>
-        </p:nvPicPr>
-        <p:blipFill>
-          <a:blip r:embed="rId2"/>
-          <a:stretch>
-            <a:fillRect/>
-          </a:stretch>
-        </p:blipFill>
+      <p:sp>
+        <p:nvSpPr>
+          <p:cNvPr id="4" name="Rounded Rectangle 3"/>
+          <p:cNvSpPr/>
+          <p:nvPr/>
+        </p:nvSpPr>
         <p:spPr>
           <a:xfrm>
             <a:off x="274320" y="1280160"/>
             <a:ext cx="5669280" cy="3200400"/>
           </a:xfrm>
-          <a:prstGeom prst="rect">
-            <a:avLst/>
-          </a:prstGeom>
-        </p:spPr>
-      </p:pic>
+          <a:prstGeom prst="roundRect">
+            <a:avLst/>
+          </a:prstGeom>
+          <a:solidFill>
+            <a:srgbClr val="121222"/>
+          </a:solidFill>
+          <a:ln w="12700">
+            <a:solidFill>
+              <a:srgbClr val="9090A0"/>
+            </a:solidFill>
+          </a:ln>
+        </p:spPr>
+        <p:style>
+          <a:lnRef idx="1">
+            <a:schemeClr val="accent1"/>
+          </a:lnRef>
+          <a:fillRef idx="3">
+            <a:schemeClr val="accent1"/>
+          </a:fillRef>
+          <a:effectRef idx="2">
+            <a:schemeClr val="accent1"/>
+          </a:effectRef>
+          <a:fontRef idx="minor">
+            <a:schemeClr val="lt1"/>
+          </a:fontRef>
+        </p:style>
+        <p:txBody>
+          <a:bodyPr rtlCol="0" anchor="ctr" wrap="square" lIns="50800" rIns="50800" tIns="25400" bIns="25400"/>
+          <a:lstStyle/>
+          <a:p>
+            <a:pPr algn="ctr">
+              <a:defRPr sz="1100" b="0">
+                <a:solidFill>
+                  <a:srgbClr val="9090A0"/>
+                </a:solidFill>
+                <a:latin typeface="Calibri"/>
+              </a:defRPr>
+            </a:pPr>
+            <a:r>
+              <a:t>[Resource Utilization (CPU/Memory)]</a:t>
+            </a:r>
+            <a:br/>
+            <a:br/>
+            <a:r>
+              <a:t>Per-strategy CPU and memory utilization</a:t>
+            </a:r>
+            <a:br/>
+            <a:r>
+              <a:t>across experiment phases.</a:t>
+            </a:r>
+            <a:br/>
+            <a:br/>
+            <a:r>
+              <a:t>Generated by: chaosprobe visualize</a:t>
+            </a:r>
+          </a:p>
+        </p:txBody>
+      </p:sp>
       <p:sp>
         <p:nvSpPr>
           <p:cNvPr id="5" name="TextBox 4"/>
@@ -4033,30 +4168,75 @@
           </a:p>
         </p:txBody>
       </p:sp>
-      <p:pic>
-        <p:nvPicPr>
-          <p:cNvPr id="6" name="Picture 5" descr="throughput_by_strategy.png"/>
-          <p:cNvPicPr>
-            <a:picLocks noChangeAspect="1"/>
-          </p:cNvPicPr>
-          <p:nvPr/>
-        </p:nvPicPr>
-        <p:blipFill>
-          <a:blip r:embed="rId3"/>
-          <a:stretch>
-            <a:fillRect/>
-          </a:stretch>
-        </p:blipFill>
+      <p:sp>
+        <p:nvSpPr>
+          <p:cNvPr id="6" name="Rounded Rectangle 5"/>
+          <p:cNvSpPr/>
+          <p:nvPr/>
+        </p:nvSpPr>
         <p:spPr>
           <a:xfrm>
             <a:off x="6217920" y="1280160"/>
             <a:ext cx="5669280" cy="3200400"/>
           </a:xfrm>
-          <a:prstGeom prst="rect">
-            <a:avLst/>
-          </a:prstGeom>
-        </p:spPr>
-      </p:pic>
+          <a:prstGeom prst="roundRect">
+            <a:avLst/>
+          </a:prstGeom>
+          <a:solidFill>
+            <a:srgbClr val="121222"/>
+          </a:solidFill>
+          <a:ln w="12700">
+            <a:solidFill>
+              <a:srgbClr val="9090A0"/>
+            </a:solidFill>
+          </a:ln>
+        </p:spPr>
+        <p:style>
+          <a:lnRef idx="1">
+            <a:schemeClr val="accent1"/>
+          </a:lnRef>
+          <a:fillRef idx="3">
+            <a:schemeClr val="accent1"/>
+          </a:fillRef>
+          <a:effectRef idx="2">
+            <a:schemeClr val="accent1"/>
+          </a:effectRef>
+          <a:fontRef idx="minor">
+            <a:schemeClr val="lt1"/>
+          </a:fontRef>
+        </p:style>
+        <p:txBody>
+          <a:bodyPr rtlCol="0" anchor="ctr" wrap="square" lIns="50800" rIns="50800" tIns="25400" bIns="25400"/>
+          <a:lstStyle/>
+          <a:p>
+            <a:pPr algn="ctr">
+              <a:defRPr sz="1100" b="0">
+                <a:solidFill>
+                  <a:srgbClr val="9090A0"/>
+                </a:solidFill>
+                <a:latin typeface="Calibri"/>
+              </a:defRPr>
+            </a:pPr>
+            <a:r>
+              <a:t>[I/O Throughput by Strategy]</a:t>
+            </a:r>
+            <a:br/>
+            <a:br/>
+            <a:r>
+              <a:t>Redis ops/s and disk R/W bytes/s</a:t>
+            </a:r>
+            <a:br/>
+            <a:r>
+              <a:t>per placement strategy.</a:t>
+            </a:r>
+            <a:br/>
+            <a:br/>
+            <a:r>
+              <a:t>Generated by: chaosprobe visualize</a:t>
+            </a:r>
+          </a:p>
+        </p:txBody>
+      </p:sp>
       <p:sp>
         <p:nvSpPr>
           <p:cNvPr id="7" name="TextBox 6"/>
@@ -4536,30 +4716,75 @@
           </a:p>
         </p:txBody>
       </p:sp>
-      <p:pic>
-        <p:nvPicPr>
-          <p:cNvPr id="4" name="Picture 3" descr="strategy_comparison_heatmap.png"/>
-          <p:cNvPicPr>
-            <a:picLocks noChangeAspect="1"/>
-          </p:cNvPicPr>
-          <p:nvPr/>
-        </p:nvPicPr>
-        <p:blipFill>
-          <a:blip r:embed="rId2"/>
-          <a:stretch>
-            <a:fillRect/>
-          </a:stretch>
-        </p:blipFill>
+      <p:sp>
+        <p:nvSpPr>
+          <p:cNvPr id="4" name="Rounded Rectangle 3"/>
+          <p:cNvSpPr/>
+          <p:nvPr/>
+        </p:nvSpPr>
         <p:spPr>
           <a:xfrm>
             <a:off x="274320" y="1280160"/>
             <a:ext cx="5943600" cy="3200400"/>
           </a:xfrm>
-          <a:prstGeom prst="rect">
-            <a:avLst/>
-          </a:prstGeom>
-        </p:spPr>
-      </p:pic>
+          <a:prstGeom prst="roundRect">
+            <a:avLst/>
+          </a:prstGeom>
+          <a:solidFill>
+            <a:srgbClr val="121222"/>
+          </a:solidFill>
+          <a:ln w="12700">
+            <a:solidFill>
+              <a:srgbClr val="9090A0"/>
+            </a:solidFill>
+          </a:ln>
+        </p:spPr>
+        <p:style>
+          <a:lnRef idx="1">
+            <a:schemeClr val="accent1"/>
+          </a:lnRef>
+          <a:fillRef idx="3">
+            <a:schemeClr val="accent1"/>
+          </a:fillRef>
+          <a:effectRef idx="2">
+            <a:schemeClr val="accent1"/>
+          </a:effectRef>
+          <a:fontRef idx="minor">
+            <a:schemeClr val="lt1"/>
+          </a:fontRef>
+        </p:style>
+        <p:txBody>
+          <a:bodyPr rtlCol="0" anchor="ctr" wrap="square" lIns="50800" rIns="50800" tIns="25400" bIns="25400"/>
+          <a:lstStyle/>
+          <a:p>
+            <a:pPr algn="ctr">
+              <a:defRPr sz="1100" b="0">
+                <a:solidFill>
+                  <a:srgbClr val="9090A0"/>
+                </a:solidFill>
+                <a:latin typeface="Calibri"/>
+              </a:defRPr>
+            </a:pPr>
+            <a:r>
+              <a:t>[Strategy Comparison Heatmap]</a:t>
+            </a:r>
+            <a:br/>
+            <a:br/>
+            <a:r>
+              <a:t>All thesis dimensions normalised to 0-1.</a:t>
+            </a:r>
+            <a:br/>
+            <a:r>
+              <a:t>Green = better, Red = worse.</a:t>
+            </a:r>
+            <a:br/>
+            <a:br/>
+            <a:r>
+              <a:t>Generated by: chaosprobe visualize</a:t>
+            </a:r>
+          </a:p>
+        </p:txBody>
+      </p:sp>
       <p:sp>
         <p:nvSpPr>
           <p:cNvPr id="5" name="TextBox 4"/>
@@ -6204,7 +6429,7 @@
         <p:spPr>
           <a:xfrm>
             <a:off x="6492240" y="2240280"/>
-            <a:ext cx="5120640" cy="914400"/>
+            <a:ext cx="5120640" cy="777240"/>
           </a:xfrm>
           <a:prstGeom prst="rect">
             <a:avLst/>
@@ -6226,7 +6451,7 @@
               </a:defRPr>
             </a:pPr>
             <a:r>
-              <a:t>5-node cluster (1 control plane + 4 workers, 10 vCPU, 14 GiB). Larger clusters with more nodes and resources may show different placement effects.</a:t>
+              <a:t>5-node cluster (1 control plane + 4 uniform 4-GiB workers, 10 vCPU, 18 GiB). Larger clusters may show different placement effects.</a:t>
             </a:r>
           </a:p>
         </p:txBody>
@@ -6239,7 +6464,7 @@
         </p:nvSpPr>
         <p:spPr>
           <a:xfrm>
-            <a:off x="6492240" y="3383280"/>
+            <a:off x="6492240" y="3108960"/>
             <a:ext cx="5120640" cy="274320"/>
           </a:xfrm>
           <a:prstGeom prst="rect">
@@ -6275,8 +6500,8 @@
         </p:nvSpPr>
         <p:spPr>
           <a:xfrm>
-            <a:off x="6492240" y="3703320"/>
-            <a:ext cx="5120640" cy="914400"/>
+            <a:off x="6492240" y="3429000"/>
+            <a:ext cx="5120640" cy="777240"/>
           </a:xfrm>
           <a:prstGeom prst="rect">
             <a:avLst/>
@@ -6298,7 +6523,7 @@
               </a:defRPr>
             </a:pPr>
             <a:r>
-              <a:t>Only pod-delete and pod-cpu-hog tested. Network partitions, disk faults, and memory pressure faults may reveal different strategy rankings.</a:t>
+              <a:t>Only pod-delete and pod-cpu-hog tested. Network partitions, disk faults, and memory pressure may reveal different strategy rankings.</a:t>
             </a:r>
           </a:p>
         </p:txBody>
@@ -6311,7 +6536,7 @@
         </p:nvSpPr>
         <p:spPr>
           <a:xfrm>
-            <a:off x="6492240" y="4846320"/>
+            <a:off x="6492240" y="4297680"/>
             <a:ext cx="5120640" cy="274320"/>
           </a:xfrm>
           <a:prstGeom prst="rect">
@@ -6347,8 +6572,8 @@
         </p:nvSpPr>
         <p:spPr>
           <a:xfrm>
-            <a:off x="6492240" y="5166360"/>
-            <a:ext cx="5120640" cy="914400"/>
+            <a:off x="6492240" y="4617720"/>
+            <a:ext cx="5120640" cy="777240"/>
           </a:xfrm>
           <a:prstGeom prst="rect">
             <a:avLst/>
@@ -6371,6 +6596,78 @@
             </a:pPr>
             <a:r>
               <a:t>Steady-state load (50 users, 10/s). Bursty, ramping, or production-like traffic patterns may affect results differently.</a:t>
+            </a:r>
+          </a:p>
+        </p:txBody>
+      </p:sp>
+      <p:sp>
+        <p:nvSpPr>
+          <p:cNvPr id="20" name="TextBox 19"/>
+          <p:cNvSpPr txBox="1"/>
+          <p:nvPr/>
+        </p:nvSpPr>
+        <p:spPr>
+          <a:xfrm>
+            <a:off x="6492240" y="5486400"/>
+            <a:ext cx="5120640" cy="274320"/>
+          </a:xfrm>
+          <a:prstGeom prst="rect">
+            <a:avLst/>
+          </a:prstGeom>
+          <a:noFill/>
+        </p:spPr>
+        <p:txBody>
+          <a:bodyPr wrap="square">
+            <a:spAutoFit/>
+          </a:bodyPr>
+          <a:lstStyle/>
+          <a:p>
+            <a:pPr algn="l">
+              <a:defRPr sz="1300" b="1">
+                <a:solidFill>
+                  <a:srgbClr val="FFFFFF"/>
+                </a:solidFill>
+                <a:latin typeface="Calibri"/>
+              </a:defRPr>
+            </a:pPr>
+            <a:r>
+              <a:t>Metric portability</a:t>
+            </a:r>
+          </a:p>
+        </p:txBody>
+      </p:sp>
+      <p:sp>
+        <p:nvSpPr>
+          <p:cNvPr id="21" name="TextBox 20"/>
+          <p:cNvSpPr txBox="1"/>
+          <p:nvPr/>
+        </p:nvSpPr>
+        <p:spPr>
+          <a:xfrm>
+            <a:off x="6492240" y="5806440"/>
+            <a:ext cx="5120640" cy="777240"/>
+          </a:xfrm>
+          <a:prstGeom prst="rect">
+            <a:avLst/>
+          </a:prstGeom>
+          <a:noFill/>
+        </p:spPr>
+        <p:txBody>
+          <a:bodyPr wrap="square">
+            <a:spAutoFit/>
+          </a:bodyPr>
+          <a:lstStyle/>
+          <a:p>
+            <a:pPr algn="l">
+              <a:defRPr sz="1100" b="0">
+                <a:solidFill>
+                  <a:srgbClr val="BDBDBD"/>
+                </a:solidFill>
+                <a:latin typeface="Calibri"/>
+              </a:defRPr>
+            </a:pPr>
+            <a:r>
+              <a:t>PSI requires cgroup-v2, Felix requires Calico, etcd_debugging_* is K8s-version-fragile. metricAvailability surfaces which metrics were collected per run.</a:t>
             </a:r>
           </a:p>
         </p:txBody>
@@ -9224,8 +9521,8 @@
         </p:nvSpPr>
         <p:spPr>
           <a:xfrm>
-            <a:off x="548640" y="1371600"/>
-            <a:ext cx="11064240" cy="1188720"/>
+            <a:off x="548640" y="1188720"/>
+            <a:ext cx="11064240" cy="777240"/>
           </a:xfrm>
           <a:prstGeom prst="roundRect">
             <a:avLst/>
@@ -9269,8 +9566,8 @@
         </p:nvSpPr>
         <p:spPr>
           <a:xfrm>
-            <a:off x="731520" y="1417320"/>
-            <a:ext cx="10698480" cy="320040"/>
+            <a:off x="731520" y="1280160"/>
+            <a:ext cx="10698480" cy="594360"/>
           </a:xfrm>
           <a:prstGeom prst="rect">
             <a:avLst/>
@@ -9283,16 +9580,16 @@
           </a:bodyPr>
           <a:lstStyle/>
           <a:p>
-            <a:pPr algn="l">
-              <a:defRPr sz="1400" b="1">
-                <a:solidFill>
-                  <a:srgbClr val="0096D6"/>
-                </a:solidFill>
-                <a:latin typeface="Calibri"/>
-              </a:defRPr>
-            </a:pPr>
-            <a:r>
-              <a:t>Research Question</a:t>
+            <a:pPr algn="ctr">
+              <a:defRPr sz="1600" b="1">
+                <a:solidFill>
+                  <a:srgbClr val="FFFFFF"/>
+                </a:solidFill>
+                <a:latin typeface="Calibri"/>
+              </a:defRPr>
+            </a:pPr>
+            <a:r>
+              <a:t>How do multi-dimensional metrics decompose chaos response across pod-placement strategies in Kubernetes?</a:t>
             </a:r>
           </a:p>
         </p:txBody>
@@ -9305,8 +9602,8 @@
         </p:nvSpPr>
         <p:spPr>
           <a:xfrm>
-            <a:off x="731520" y="1828800"/>
-            <a:ext cx="10698480" cy="548640"/>
+            <a:off x="182880" y="2057400"/>
+            <a:ext cx="4572000" cy="228600"/>
           </a:xfrm>
           <a:prstGeom prst="rect">
             <a:avLst/>
@@ -9319,20 +9616,16 @@
           </a:bodyPr>
           <a:lstStyle/>
           <a:p>
-            <a:pPr algn="ctr">
-              <a:defRPr sz="2200" b="1">
-                <a:solidFill>
-                  <a:srgbClr val="FFFFFF"/>
-                </a:solidFill>
-                <a:latin typeface="Calibri"/>
-              </a:defRPr>
-            </a:pPr>
-            <a:r>
-              <a:t>How does pod placement topology affect microservice resilience</a:t>
-            </a:r>
-            <a:br/>
-            <a:r>
-              <a:t>under fault injection in Kubernetes?</a:t>
+            <a:pPr algn="l">
+              <a:defRPr sz="1100" b="1">
+                <a:solidFill>
+                  <a:srgbClr val="0096D6"/>
+                </a:solidFill>
+                <a:latin typeface="Calibri"/>
+              </a:defRPr>
+            </a:pPr>
+            <a:r>
+              <a:t>Instrument design</a:t>
             </a:r>
           </a:p>
         </p:txBody>
@@ -9345,8 +9638,8 @@
         </p:nvSpPr>
         <p:spPr>
           <a:xfrm>
-            <a:off x="548640" y="2834640"/>
-            <a:ext cx="10972800" cy="320040"/>
+            <a:off x="7178040" y="2057400"/>
+            <a:ext cx="4572000" cy="228600"/>
           </a:xfrm>
           <a:prstGeom prst="rect">
             <a:avLst/>
@@ -9360,38 +9653,112 @@
           <a:lstStyle/>
           <a:p>
             <a:pPr algn="l">
-              <a:defRPr sz="1800" b="1">
-                <a:solidFill>
-                  <a:srgbClr val="2ECC71"/>
-                </a:solidFill>
-                <a:latin typeface="Calibri"/>
-              </a:defRPr>
-            </a:pPr>
-            <a:r>
-              <a:t>Hypotheses</a:t>
-            </a:r>
-          </a:p>
-        </p:txBody>
-      </p:sp>
-      <p:sp>
-        <p:nvSpPr>
-          <p:cNvPr id="8" name="Rounded Rectangle 7"/>
+              <a:defRPr sz="1100" b="1">
+                <a:solidFill>
+                  <a:srgbClr val="F39C12"/>
+                </a:solidFill>
+                <a:latin typeface="Calibri"/>
+              </a:defRPr>
+            </a:pPr>
+            <a:r>
+              <a:t>Baseline &amp; tail</a:t>
+            </a:r>
+          </a:p>
+        </p:txBody>
+      </p:sp>
+      <p:sp>
+        <p:nvSpPr>
+          <p:cNvPr id="8" name="TextBox 7"/>
+          <p:cNvSpPr txBox="1"/>
+          <p:nvPr/>
+        </p:nvSpPr>
+        <p:spPr>
+          <a:xfrm>
+            <a:off x="182880" y="4206240"/>
+            <a:ext cx="4572000" cy="228600"/>
+          </a:xfrm>
+          <a:prstGeom prst="rect">
+            <a:avLst/>
+          </a:prstGeom>
+          <a:noFill/>
+        </p:spPr>
+        <p:txBody>
+          <a:bodyPr wrap="square">
+            <a:spAutoFit/>
+          </a:bodyPr>
+          <a:lstStyle/>
+          <a:p>
+            <a:pPr algn="l">
+              <a:defRPr sz="1100" b="1">
+                <a:solidFill>
+                  <a:srgbClr val="E74C3C"/>
+                </a:solidFill>
+                <a:latin typeface="Calibri"/>
+              </a:defRPr>
+            </a:pPr>
+            <a:r>
+              <a:t>Mechanism</a:t>
+            </a:r>
+          </a:p>
+        </p:txBody>
+      </p:sp>
+      <p:sp>
+        <p:nvSpPr>
+          <p:cNvPr id="9" name="TextBox 8"/>
+          <p:cNvSpPr txBox="1"/>
+          <p:nvPr/>
+        </p:nvSpPr>
+        <p:spPr>
+          <a:xfrm>
+            <a:off x="7178040" y="4206240"/>
+            <a:ext cx="4572000" cy="228600"/>
+          </a:xfrm>
+          <a:prstGeom prst="rect">
+            <a:avLst/>
+          </a:prstGeom>
+          <a:noFill/>
+        </p:spPr>
+        <p:txBody>
+          <a:bodyPr wrap="square">
+            <a:spAutoFit/>
+          </a:bodyPr>
+          <a:lstStyle/>
+          <a:p>
+            <a:pPr algn="l">
+              <a:defRPr sz="1100" b="1">
+                <a:solidFill>
+                  <a:srgbClr val="9B59B6"/>
+                </a:solidFill>
+                <a:latin typeface="Calibri"/>
+              </a:defRPr>
+            </a:pPr>
+            <a:r>
+              <a:t>Recovery dynamics</a:t>
+            </a:r>
+          </a:p>
+        </p:txBody>
+      </p:sp>
+      <p:sp>
+        <p:nvSpPr>
+          <p:cNvPr id="10" name="Rounded Rectangle 9"/>
           <p:cNvSpPr/>
           <p:nvPr/>
         </p:nvSpPr>
         <p:spPr>
           <a:xfrm>
-            <a:off x="548640" y="3291840"/>
-            <a:ext cx="914400" cy="822960"/>
+            <a:off x="182880" y="2331720"/>
+            <a:ext cx="2331720" cy="1874519"/>
           </a:xfrm>
           <a:prstGeom prst="roundRect">
             <a:avLst/>
           </a:prstGeom>
           <a:solidFill>
-            <a:srgbClr val="E74C3C"/>
+            <a:srgbClr val="121222"/>
           </a:solidFill>
-          <a:ln>
-            <a:noFill/>
+          <a:ln w="25400">
+            <a:solidFill>
+              <a:srgbClr val="0096D6"/>
+            </a:solidFill>
           </a:ln>
         </p:spPr>
         <p:style>
@@ -9409,11 +9776,54 @@
           </a:fontRef>
         </p:style>
         <p:txBody>
+          <a:bodyPr rtlCol="0" anchor="ctr"/>
+          <a:lstStyle/>
+          <a:p>
+            <a:pPr algn="ctr"/>
+          </a:p>
+        </p:txBody>
+      </p:sp>
+      <p:sp>
+        <p:nvSpPr>
+          <p:cNvPr id="11" name="Rounded Rectangle 10"/>
+          <p:cNvSpPr/>
+          <p:nvPr/>
+        </p:nvSpPr>
+        <p:spPr>
+          <a:xfrm>
+            <a:off x="182880" y="2331720"/>
+            <a:ext cx="2331720" cy="320040"/>
+          </a:xfrm>
+          <a:prstGeom prst="roundRect">
+            <a:avLst/>
+          </a:prstGeom>
+          <a:solidFill>
+            <a:srgbClr val="0096D6"/>
+          </a:solidFill>
+          <a:ln>
+            <a:noFill/>
+          </a:ln>
+        </p:spPr>
+        <p:style>
+          <a:lnRef idx="1">
+            <a:schemeClr val="accent1"/>
+          </a:lnRef>
+          <a:fillRef idx="3">
+            <a:schemeClr val="accent1"/>
+          </a:fillRef>
+          <a:effectRef idx="2">
+            <a:schemeClr val="accent1"/>
+          </a:effectRef>
+          <a:fontRef idx="minor">
+            <a:schemeClr val="lt1"/>
+          </a:fontRef>
+        </p:style>
+        <p:txBody>
           <a:bodyPr rtlCol="0" anchor="ctr" wrap="square" lIns="50800" rIns="50800" tIns="25400" bIns="25400"/>
           <a:lstStyle/>
           <a:p>
             <a:pPr algn="ctr">
-              <a:defRPr sz="1800" b="1">
+              <a:defRPr sz="1300" b="1">
                 <a:solidFill>
                   <a:srgbClr val="FFFFFF"/>
                 </a:solidFill>
@@ -9428,14 +9838,766 @@
       </p:sp>
       <p:sp>
         <p:nvSpPr>
-          <p:cNvPr id="9" name="Rounded Rectangle 8"/>
+          <p:cNvPr id="12" name="TextBox 11"/>
+          <p:cNvSpPr txBox="1"/>
+          <p:nvPr/>
+        </p:nvSpPr>
+        <p:spPr>
+          <a:xfrm>
+            <a:off x="274320" y="2697479"/>
+            <a:ext cx="2148839" cy="365760"/>
+          </a:xfrm>
+          <a:prstGeom prst="rect">
+            <a:avLst/>
+          </a:prstGeom>
+          <a:noFill/>
+        </p:spPr>
+        <p:txBody>
+          <a:bodyPr wrap="square">
+            <a:spAutoFit/>
+          </a:bodyPr>
+          <a:lstStyle/>
+          <a:p>
+            <a:pPr algn="l">
+              <a:defRPr sz="1100" b="1">
+                <a:solidFill>
+                  <a:srgbClr val="0096D6"/>
+                </a:solidFill>
+                <a:latin typeface="Calibri"/>
+              </a:defRPr>
+            </a:pPr>
+            <a:r>
+              <a:t>Metrics carry disjoint info</a:t>
+            </a:r>
+          </a:p>
+        </p:txBody>
+      </p:sp>
+      <p:sp>
+        <p:nvSpPr>
+          <p:cNvPr id="13" name="TextBox 12"/>
+          <p:cNvSpPr txBox="1"/>
+          <p:nvPr/>
+        </p:nvSpPr>
+        <p:spPr>
+          <a:xfrm>
+            <a:off x="274320" y="3108960"/>
+            <a:ext cx="2148839" cy="1005839"/>
+          </a:xfrm>
+          <a:prstGeom prst="rect">
+            <a:avLst/>
+          </a:prstGeom>
+          <a:noFill/>
+        </p:spPr>
+        <p:txBody>
+          <a:bodyPr wrap="square">
+            <a:spAutoFit/>
+          </a:bodyPr>
+          <a:lstStyle/>
+          <a:p>
+            <a:pPr algn="l">
+              <a:defRPr sz="900" b="0">
+                <a:solidFill>
+                  <a:srgbClr val="BDBDBD"/>
+                </a:solidFill>
+                <a:latin typeface="Calibri"/>
+              </a:defRPr>
+            </a:pPr>
+            <a:r>
+              <a:t>No single metric captures full chaos response. Best-fit and spread tie on aggregate (66.3) but diverge on recovery (1452 vs 1617 ms) and latency (100 vs 150 ms during chaos).</a:t>
+            </a:r>
+          </a:p>
+        </p:txBody>
+      </p:sp>
+      <p:sp>
+        <p:nvSpPr>
+          <p:cNvPr id="14" name="Rounded Rectangle 13"/>
           <p:cNvSpPr/>
           <p:nvPr/>
         </p:nvSpPr>
         <p:spPr>
           <a:xfrm>
-            <a:off x="1645920" y="3291840"/>
-            <a:ext cx="9966960" cy="822960"/>
+            <a:off x="2560320" y="2331720"/>
+            <a:ext cx="2331720" cy="1874519"/>
+          </a:xfrm>
+          <a:prstGeom prst="roundRect">
+            <a:avLst/>
+          </a:prstGeom>
+          <a:solidFill>
+            <a:srgbClr val="121222"/>
+          </a:solidFill>
+          <a:ln w="25400">
+            <a:solidFill>
+              <a:srgbClr val="0096D6"/>
+            </a:solidFill>
+          </a:ln>
+        </p:spPr>
+        <p:style>
+          <a:lnRef idx="1">
+            <a:schemeClr val="accent1"/>
+          </a:lnRef>
+          <a:fillRef idx="3">
+            <a:schemeClr val="accent1"/>
+          </a:fillRef>
+          <a:effectRef idx="2">
+            <a:schemeClr val="accent1"/>
+          </a:effectRef>
+          <a:fontRef idx="minor">
+            <a:schemeClr val="lt1"/>
+          </a:fontRef>
+        </p:style>
+        <p:txBody>
+          <a:bodyPr rtlCol="0" anchor="ctr"/>
+          <a:lstStyle/>
+          <a:p>
+            <a:pPr algn="ctr"/>
+          </a:p>
+        </p:txBody>
+      </p:sp>
+      <p:sp>
+        <p:nvSpPr>
+          <p:cNvPr id="15" name="Rounded Rectangle 14"/>
+          <p:cNvSpPr/>
+          <p:nvPr/>
+        </p:nvSpPr>
+        <p:spPr>
+          <a:xfrm>
+            <a:off x="2560320" y="2331720"/>
+            <a:ext cx="2331720" cy="320040"/>
+          </a:xfrm>
+          <a:prstGeom prst="roundRect">
+            <a:avLst/>
+          </a:prstGeom>
+          <a:solidFill>
+            <a:srgbClr val="0096D6"/>
+          </a:solidFill>
+          <a:ln>
+            <a:noFill/>
+          </a:ln>
+        </p:spPr>
+        <p:style>
+          <a:lnRef idx="1">
+            <a:schemeClr val="accent1"/>
+          </a:lnRef>
+          <a:fillRef idx="3">
+            <a:schemeClr val="accent1"/>
+          </a:fillRef>
+          <a:effectRef idx="2">
+            <a:schemeClr val="accent1"/>
+          </a:effectRef>
+          <a:fontRef idx="minor">
+            <a:schemeClr val="lt1"/>
+          </a:fontRef>
+        </p:style>
+        <p:txBody>
+          <a:bodyPr rtlCol="0" anchor="ctr" wrap="square" lIns="50800" rIns="50800" tIns="25400" bIns="25400"/>
+          <a:lstStyle/>
+          <a:p>
+            <a:pPr algn="ctr">
+              <a:defRPr sz="1300" b="1">
+                <a:solidFill>
+                  <a:srgbClr val="FFFFFF"/>
+                </a:solidFill>
+                <a:latin typeface="Calibri"/>
+              </a:defRPr>
+            </a:pPr>
+            <a:r>
+              <a:t>H2</a:t>
+            </a:r>
+          </a:p>
+        </p:txBody>
+      </p:sp>
+      <p:sp>
+        <p:nvSpPr>
+          <p:cNvPr id="16" name="TextBox 15"/>
+          <p:cNvSpPr txBox="1"/>
+          <p:nvPr/>
+        </p:nvSpPr>
+        <p:spPr>
+          <a:xfrm>
+            <a:off x="2651760" y="2697479"/>
+            <a:ext cx="2148839" cy="365760"/>
+          </a:xfrm>
+          <a:prstGeom prst="rect">
+            <a:avLst/>
+          </a:prstGeom>
+          <a:noFill/>
+        </p:spPr>
+        <p:txBody>
+          <a:bodyPr wrap="square">
+            <a:spAutoFit/>
+          </a:bodyPr>
+          <a:lstStyle/>
+          <a:p>
+            <a:pPr algn="l">
+              <a:defRPr sz="1100" b="1">
+                <a:solidFill>
+                  <a:srgbClr val="0096D6"/>
+                </a:solidFill>
+                <a:latin typeface="Calibri"/>
+              </a:defRPr>
+            </a:pPr>
+            <a:r>
+              <a:t>Phase decomposition is necessary</a:t>
+            </a:r>
+          </a:p>
+        </p:txBody>
+      </p:sp>
+      <p:sp>
+        <p:nvSpPr>
+          <p:cNvPr id="17" name="TextBox 16"/>
+          <p:cNvSpPr txBox="1"/>
+          <p:nvPr/>
+        </p:nvSpPr>
+        <p:spPr>
+          <a:xfrm>
+            <a:off x="2651760" y="3108960"/>
+            <a:ext cx="2148839" cy="1005839"/>
+          </a:xfrm>
+          <a:prstGeom prst="rect">
+            <a:avLst/>
+          </a:prstGeom>
+          <a:noFill/>
+        </p:spPr>
+        <p:txBody>
+          <a:bodyPr wrap="square">
+            <a:spAutoFit/>
+          </a:bodyPr>
+          <a:lstStyle/>
+          <a:p>
+            <a:pPr algn="l">
+              <a:defRPr sz="900" b="0">
+                <a:solidFill>
+                  <a:srgbClr val="BDBDBD"/>
+                </a:solidFill>
+                <a:latin typeface="Calibri"/>
+              </a:defRPr>
+            </a:pPr>
+            <a:r>
+              <a:t>Pre-chaos baselines vary by placement (spread 231 ms vs colocate 78 ms on /). During-chaos absolutes are uninterpretable without phase-aware normalisation.</a:t>
+            </a:r>
+          </a:p>
+        </p:txBody>
+      </p:sp>
+      <p:sp>
+        <p:nvSpPr>
+          <p:cNvPr id="18" name="Rounded Rectangle 17"/>
+          <p:cNvSpPr/>
+          <p:nvPr/>
+        </p:nvSpPr>
+        <p:spPr>
+          <a:xfrm>
+            <a:off x="4937759" y="2331720"/>
+            <a:ext cx="2331720" cy="1874519"/>
+          </a:xfrm>
+          <a:prstGeom prst="roundRect">
+            <a:avLst/>
+          </a:prstGeom>
+          <a:solidFill>
+            <a:srgbClr val="121222"/>
+          </a:solidFill>
+          <a:ln w="25400">
+            <a:solidFill>
+              <a:srgbClr val="0096D6"/>
+            </a:solidFill>
+          </a:ln>
+        </p:spPr>
+        <p:style>
+          <a:lnRef idx="1">
+            <a:schemeClr val="accent1"/>
+          </a:lnRef>
+          <a:fillRef idx="3">
+            <a:schemeClr val="accent1"/>
+          </a:fillRef>
+          <a:effectRef idx="2">
+            <a:schemeClr val="accent1"/>
+          </a:effectRef>
+          <a:fontRef idx="minor">
+            <a:schemeClr val="lt1"/>
+          </a:fontRef>
+        </p:style>
+        <p:txBody>
+          <a:bodyPr rtlCol="0" anchor="ctr"/>
+          <a:lstStyle/>
+          <a:p>
+            <a:pPr algn="ctr"/>
+          </a:p>
+        </p:txBody>
+      </p:sp>
+      <p:sp>
+        <p:nvSpPr>
+          <p:cNvPr id="19" name="Rounded Rectangle 18"/>
+          <p:cNvSpPr/>
+          <p:nvPr/>
+        </p:nvSpPr>
+        <p:spPr>
+          <a:xfrm>
+            <a:off x="4937759" y="2331720"/>
+            <a:ext cx="2331720" cy="320040"/>
+          </a:xfrm>
+          <a:prstGeom prst="roundRect">
+            <a:avLst/>
+          </a:prstGeom>
+          <a:solidFill>
+            <a:srgbClr val="0096D6"/>
+          </a:solidFill>
+          <a:ln>
+            <a:noFill/>
+          </a:ln>
+        </p:spPr>
+        <p:style>
+          <a:lnRef idx="1">
+            <a:schemeClr val="accent1"/>
+          </a:lnRef>
+          <a:fillRef idx="3">
+            <a:schemeClr val="accent1"/>
+          </a:fillRef>
+          <a:effectRef idx="2">
+            <a:schemeClr val="accent1"/>
+          </a:effectRef>
+          <a:fontRef idx="minor">
+            <a:schemeClr val="lt1"/>
+          </a:fontRef>
+        </p:style>
+        <p:txBody>
+          <a:bodyPr rtlCol="0" anchor="ctr" wrap="square" lIns="50800" rIns="50800" tIns="25400" bIns="25400"/>
+          <a:lstStyle/>
+          <a:p>
+            <a:pPr algn="ctr">
+              <a:defRPr sz="1300" b="1">
+                <a:solidFill>
+                  <a:srgbClr val="FFFFFF"/>
+                </a:solidFill>
+                <a:latin typeface="Calibri"/>
+              </a:defRPr>
+            </a:pPr>
+            <a:r>
+              <a:t>H3</a:t>
+            </a:r>
+          </a:p>
+        </p:txBody>
+      </p:sp>
+      <p:sp>
+        <p:nvSpPr>
+          <p:cNvPr id="20" name="TextBox 19"/>
+          <p:cNvSpPr txBox="1"/>
+          <p:nvPr/>
+        </p:nvSpPr>
+        <p:spPr>
+          <a:xfrm>
+            <a:off x="5029199" y="2697479"/>
+            <a:ext cx="2148839" cy="365760"/>
+          </a:xfrm>
+          <a:prstGeom prst="rect">
+            <a:avLst/>
+          </a:prstGeom>
+          <a:noFill/>
+        </p:spPr>
+        <p:txBody>
+          <a:bodyPr wrap="square">
+            <a:spAutoFit/>
+          </a:bodyPr>
+          <a:lstStyle/>
+          <a:p>
+            <a:pPr algn="l">
+              <a:defRPr sz="1100" b="1">
+                <a:solidFill>
+                  <a:srgbClr val="0096D6"/>
+                </a:solidFill>
+                <a:latin typeface="Calibri"/>
+              </a:defRPr>
+            </a:pPr>
+            <a:r>
+              <a:t>Per-pod granularity reveals heterogeneity</a:t>
+            </a:r>
+          </a:p>
+        </p:txBody>
+      </p:sp>
+      <p:sp>
+        <p:nvSpPr>
+          <p:cNvPr id="21" name="TextBox 20"/>
+          <p:cNvSpPr txBox="1"/>
+          <p:nvPr/>
+        </p:nvSpPr>
+        <p:spPr>
+          <a:xfrm>
+            <a:off x="5029199" y="3108960"/>
+            <a:ext cx="2148839" cy="1005839"/>
+          </a:xfrm>
+          <a:prstGeom prst="rect">
+            <a:avLst/>
+          </a:prstGeom>
+          <a:noFill/>
+        </p:spPr>
+        <p:txBody>
+          <a:bodyPr wrap="square">
+            <a:spAutoFit/>
+          </a:bodyPr>
+          <a:lstStyle/>
+          <a:p>
+            <a:pPr algn="l">
+              <a:defRPr sz="900" b="0">
+                <a:solidFill>
+                  <a:srgbClr val="BDBDBD"/>
+                </a:solidFill>
+                <a:latin typeface="Calibri"/>
+              </a:defRPr>
+            </a:pPr>
+            <a:r>
+              <a:t>Cross-pod stddev within a single service is non-zero and placement-dependent. Aggregate cluster metrics miss it; per-pod LatencyProber sampling exposes it.</a:t>
+            </a:r>
+          </a:p>
+        </p:txBody>
+      </p:sp>
+      <p:sp>
+        <p:nvSpPr>
+          <p:cNvPr id="22" name="Rounded Rectangle 21"/>
+          <p:cNvSpPr/>
+          <p:nvPr/>
+        </p:nvSpPr>
+        <p:spPr>
+          <a:xfrm>
+            <a:off x="7315199" y="2331720"/>
+            <a:ext cx="2331720" cy="1874519"/>
+          </a:xfrm>
+          <a:prstGeom prst="roundRect">
+            <a:avLst/>
+          </a:prstGeom>
+          <a:solidFill>
+            <a:srgbClr val="121222"/>
+          </a:solidFill>
+          <a:ln w="25400">
+            <a:solidFill>
+              <a:srgbClr val="F39C12"/>
+            </a:solidFill>
+          </a:ln>
+        </p:spPr>
+        <p:style>
+          <a:lnRef idx="1">
+            <a:schemeClr val="accent1"/>
+          </a:lnRef>
+          <a:fillRef idx="3">
+            <a:schemeClr val="accent1"/>
+          </a:fillRef>
+          <a:effectRef idx="2">
+            <a:schemeClr val="accent1"/>
+          </a:effectRef>
+          <a:fontRef idx="minor">
+            <a:schemeClr val="lt1"/>
+          </a:fontRef>
+        </p:style>
+        <p:txBody>
+          <a:bodyPr rtlCol="0" anchor="ctr"/>
+          <a:lstStyle/>
+          <a:p>
+            <a:pPr algn="ctr"/>
+          </a:p>
+        </p:txBody>
+      </p:sp>
+      <p:sp>
+        <p:nvSpPr>
+          <p:cNvPr id="23" name="Rounded Rectangle 22"/>
+          <p:cNvSpPr/>
+          <p:nvPr/>
+        </p:nvSpPr>
+        <p:spPr>
+          <a:xfrm>
+            <a:off x="7315199" y="2331720"/>
+            <a:ext cx="2331720" cy="320040"/>
+          </a:xfrm>
+          <a:prstGeom prst="roundRect">
+            <a:avLst/>
+          </a:prstGeom>
+          <a:solidFill>
+            <a:srgbClr val="F39C12"/>
+          </a:solidFill>
+          <a:ln>
+            <a:noFill/>
+          </a:ln>
+        </p:spPr>
+        <p:style>
+          <a:lnRef idx="1">
+            <a:schemeClr val="accent1"/>
+          </a:lnRef>
+          <a:fillRef idx="3">
+            <a:schemeClr val="accent1"/>
+          </a:fillRef>
+          <a:effectRef idx="2">
+            <a:schemeClr val="accent1"/>
+          </a:effectRef>
+          <a:fontRef idx="minor">
+            <a:schemeClr val="lt1"/>
+          </a:fontRef>
+        </p:style>
+        <p:txBody>
+          <a:bodyPr rtlCol="0" anchor="ctr" wrap="square" lIns="50800" rIns="50800" tIns="25400" bIns="25400"/>
+          <a:lstStyle/>
+          <a:p>
+            <a:pPr algn="ctr">
+              <a:defRPr sz="1300" b="1">
+                <a:solidFill>
+                  <a:srgbClr val="FFFFFF"/>
+                </a:solidFill>
+                <a:latin typeface="Calibri"/>
+              </a:defRPr>
+            </a:pPr>
+            <a:r>
+              <a:t>H4</a:t>
+            </a:r>
+          </a:p>
+        </p:txBody>
+      </p:sp>
+      <p:sp>
+        <p:nvSpPr>
+          <p:cNvPr id="24" name="TextBox 23"/>
+          <p:cNvSpPr txBox="1"/>
+          <p:nvPr/>
+        </p:nvSpPr>
+        <p:spPr>
+          <a:xfrm>
+            <a:off x="7406640" y="2697479"/>
+            <a:ext cx="2148839" cy="365760"/>
+          </a:xfrm>
+          <a:prstGeom prst="rect">
+            <a:avLst/>
+          </a:prstGeom>
+          <a:noFill/>
+        </p:spPr>
+        <p:txBody>
+          <a:bodyPr wrap="square">
+            <a:spAutoFit/>
+          </a:bodyPr>
+          <a:lstStyle/>
+          <a:p>
+            <a:pPr algn="l">
+              <a:defRPr sz="1100" b="1">
+                <a:solidFill>
+                  <a:srgbClr val="F39C12"/>
+                </a:solidFill>
+                <a:latin typeface="Calibri"/>
+              </a:defRPr>
+            </a:pPr>
+            <a:r>
+              <a:t>Baseline predicts resilience</a:t>
+            </a:r>
+          </a:p>
+        </p:txBody>
+      </p:sp>
+      <p:sp>
+        <p:nvSpPr>
+          <p:cNvPr id="25" name="TextBox 24"/>
+          <p:cNvSpPr txBox="1"/>
+          <p:nvPr/>
+        </p:nvSpPr>
+        <p:spPr>
+          <a:xfrm>
+            <a:off x="7406640" y="3108960"/>
+            <a:ext cx="2148839" cy="1005839"/>
+          </a:xfrm>
+          <a:prstGeom prst="rect">
+            <a:avLst/>
+          </a:prstGeom>
+          <a:noFill/>
+        </p:spPr>
+        <p:txBody>
+          <a:bodyPr wrap="square">
+            <a:spAutoFit/>
+          </a:bodyPr>
+          <a:lstStyle/>
+          <a:p>
+            <a:pPr algn="l">
+              <a:defRPr sz="900" b="0">
+                <a:solidFill>
+                  <a:srgbClr val="BDBDBD"/>
+                </a:solidFill>
+                <a:latin typeface="Calibri"/>
+              </a:defRPr>
+            </a:pPr>
+            <a:r>
+              <a:t>Strategies with lower pre-chaos latency variance score higher under chaos. The resting-state fingerprint predicts the failure response before any fault is injected.</a:t>
+            </a:r>
+          </a:p>
+        </p:txBody>
+      </p:sp>
+      <p:sp>
+        <p:nvSpPr>
+          <p:cNvPr id="26" name="Rounded Rectangle 25"/>
+          <p:cNvSpPr/>
+          <p:nvPr/>
+        </p:nvSpPr>
+        <p:spPr>
+          <a:xfrm>
+            <a:off x="9692639" y="2331720"/>
+            <a:ext cx="2331720" cy="1874519"/>
+          </a:xfrm>
+          <a:prstGeom prst="roundRect">
+            <a:avLst/>
+          </a:prstGeom>
+          <a:solidFill>
+            <a:srgbClr val="121222"/>
+          </a:solidFill>
+          <a:ln w="25400">
+            <a:solidFill>
+              <a:srgbClr val="F39C12"/>
+            </a:solidFill>
+          </a:ln>
+        </p:spPr>
+        <p:style>
+          <a:lnRef idx="1">
+            <a:schemeClr val="accent1"/>
+          </a:lnRef>
+          <a:fillRef idx="3">
+            <a:schemeClr val="accent1"/>
+          </a:fillRef>
+          <a:effectRef idx="2">
+            <a:schemeClr val="accent1"/>
+          </a:effectRef>
+          <a:fontRef idx="minor">
+            <a:schemeClr val="lt1"/>
+          </a:fontRef>
+        </p:style>
+        <p:txBody>
+          <a:bodyPr rtlCol="0" anchor="ctr"/>
+          <a:lstStyle/>
+          <a:p>
+            <a:pPr algn="ctr"/>
+          </a:p>
+        </p:txBody>
+      </p:sp>
+      <p:sp>
+        <p:nvSpPr>
+          <p:cNvPr id="27" name="Rounded Rectangle 26"/>
+          <p:cNvSpPr/>
+          <p:nvPr/>
+        </p:nvSpPr>
+        <p:spPr>
+          <a:xfrm>
+            <a:off x="9692639" y="2331720"/>
+            <a:ext cx="2331720" cy="320040"/>
+          </a:xfrm>
+          <a:prstGeom prst="roundRect">
+            <a:avLst/>
+          </a:prstGeom>
+          <a:solidFill>
+            <a:srgbClr val="F39C12"/>
+          </a:solidFill>
+          <a:ln>
+            <a:noFill/>
+          </a:ln>
+        </p:spPr>
+        <p:style>
+          <a:lnRef idx="1">
+            <a:schemeClr val="accent1"/>
+          </a:lnRef>
+          <a:fillRef idx="3">
+            <a:schemeClr val="accent1"/>
+          </a:fillRef>
+          <a:effectRef idx="2">
+            <a:schemeClr val="accent1"/>
+          </a:effectRef>
+          <a:fontRef idx="minor">
+            <a:schemeClr val="lt1"/>
+          </a:fontRef>
+        </p:style>
+        <p:txBody>
+          <a:bodyPr rtlCol="0" anchor="ctr" wrap="square" lIns="50800" rIns="50800" tIns="25400" bIns="25400"/>
+          <a:lstStyle/>
+          <a:p>
+            <a:pPr algn="ctr">
+              <a:defRPr sz="1300" b="1">
+                <a:solidFill>
+                  <a:srgbClr val="FFFFFF"/>
+                </a:solidFill>
+                <a:latin typeface="Calibri"/>
+              </a:defRPr>
+            </a:pPr>
+            <a:r>
+              <a:t>H5</a:t>
+            </a:r>
+          </a:p>
+        </p:txBody>
+      </p:sp>
+      <p:sp>
+        <p:nvSpPr>
+          <p:cNvPr id="28" name="TextBox 27"/>
+          <p:cNvSpPr txBox="1"/>
+          <p:nvPr/>
+        </p:nvSpPr>
+        <p:spPr>
+          <a:xfrm>
+            <a:off x="9784079" y="2697479"/>
+            <a:ext cx="2148839" cy="365760"/>
+          </a:xfrm>
+          <a:prstGeom prst="rect">
+            <a:avLst/>
+          </a:prstGeom>
+          <a:noFill/>
+        </p:spPr>
+        <p:txBody>
+          <a:bodyPr wrap="square">
+            <a:spAutoFit/>
+          </a:bodyPr>
+          <a:lstStyle/>
+          <a:p>
+            <a:pPr algn="l">
+              <a:defRPr sz="1100" b="1">
+                <a:solidFill>
+                  <a:srgbClr val="F39C12"/>
+                </a:solidFill>
+                <a:latin typeface="Calibri"/>
+              </a:defRPr>
+            </a:pPr>
+            <a:r>
+              <a:t>Mean masks tail</a:t>
+            </a:r>
+          </a:p>
+        </p:txBody>
+      </p:sp>
+      <p:sp>
+        <p:nvSpPr>
+          <p:cNvPr id="29" name="TextBox 28"/>
+          <p:cNvSpPr txBox="1"/>
+          <p:nvPr/>
+        </p:nvSpPr>
+        <p:spPr>
+          <a:xfrm>
+            <a:off x="9784079" y="3108960"/>
+            <a:ext cx="2148839" cy="1005839"/>
+          </a:xfrm>
+          <a:prstGeom prst="rect">
+            <a:avLst/>
+          </a:prstGeom>
+          <a:noFill/>
+        </p:spPr>
+        <p:txBody>
+          <a:bodyPr wrap="square">
+            <a:spAutoFit/>
+          </a:bodyPr>
+          <a:lstStyle/>
+          <a:p>
+            <a:pPr algn="l">
+              <a:defRPr sz="900" b="0">
+                <a:solidFill>
+                  <a:srgbClr val="BDBDBD"/>
+                </a:solidFill>
+                <a:latin typeface="Calibri"/>
+              </a:defRPr>
+            </a:pPr>
+            <a:r>
+              <a:t>p95 latency ranking across strategies differs from mean ranking. Tail percentiles concentrate placement effects (Dean &amp; Barroso, CACM 2013).</a:t>
+            </a:r>
+          </a:p>
+        </p:txBody>
+      </p:sp>
+      <p:sp>
+        <p:nvSpPr>
+          <p:cNvPr id="30" name="Rounded Rectangle 29"/>
+          <p:cNvSpPr/>
+          <p:nvPr/>
+        </p:nvSpPr>
+        <p:spPr>
+          <a:xfrm>
+            <a:off x="182880" y="4480560"/>
+            <a:ext cx="2331720" cy="1874519"/>
           </a:xfrm>
           <a:prstGeom prst="roundRect">
             <a:avLst/>
@@ -9473,462 +10635,14 @@
       </p:sp>
       <p:sp>
         <p:nvSpPr>
-          <p:cNvPr id="10" name="TextBox 9"/>
-          <p:cNvSpPr txBox="1"/>
-          <p:nvPr/>
-        </p:nvSpPr>
-        <p:spPr>
-          <a:xfrm>
-            <a:off x="1828800" y="3310128"/>
-            <a:ext cx="9601200" cy="274320"/>
-          </a:xfrm>
-          <a:prstGeom prst="rect">
-            <a:avLst/>
-          </a:prstGeom>
-          <a:noFill/>
-        </p:spPr>
-        <p:txBody>
-          <a:bodyPr wrap="square">
-            <a:spAutoFit/>
-          </a:bodyPr>
-          <a:lstStyle/>
-          <a:p>
-            <a:pPr algn="l">
-              <a:defRPr sz="1500" b="1">
-                <a:solidFill>
-                  <a:srgbClr val="E74C3C"/>
-                </a:solidFill>
-                <a:latin typeface="Calibri"/>
-              </a:defRPr>
-            </a:pPr>
-            <a:r>
-              <a:t>Maximum contention degrades resilience</a:t>
-            </a:r>
-          </a:p>
-        </p:txBody>
-      </p:sp>
-      <p:sp>
-        <p:nvSpPr>
-          <p:cNvPr id="11" name="TextBox 10"/>
-          <p:cNvSpPr txBox="1"/>
-          <p:nvPr/>
-        </p:nvSpPr>
-        <p:spPr>
-          <a:xfrm>
-            <a:off x="1828800" y="3639312"/>
-            <a:ext cx="9601200" cy="457200"/>
-          </a:xfrm>
-          <a:prstGeom prst="rect">
-            <a:avLst/>
-          </a:prstGeom>
-          <a:noFill/>
-        </p:spPr>
-        <p:txBody>
-          <a:bodyPr wrap="square">
-            <a:spAutoFit/>
-          </a:bodyPr>
-          <a:lstStyle/>
-          <a:p>
-            <a:pPr algn="l">
-              <a:defRPr sz="1200" b="0">
-                <a:solidFill>
-                  <a:srgbClr val="BDBDBD"/>
-                </a:solidFill>
-                <a:latin typeface="Calibri"/>
-              </a:defRPr>
-            </a:pPr>
-            <a:r>
-              <a:t>Colocating all pods on a single node maximizes resource contention (CPU, memory, disk, network) and produces the worst resilience scores.</a:t>
-            </a:r>
-          </a:p>
-        </p:txBody>
-      </p:sp>
-      <p:sp>
-        <p:nvSpPr>
-          <p:cNvPr id="12" name="Rounded Rectangle 11"/>
+          <p:cNvPr id="31" name="Rounded Rectangle 30"/>
           <p:cNvSpPr/>
           <p:nvPr/>
         </p:nvSpPr>
         <p:spPr>
           <a:xfrm>
-            <a:off x="548640" y="4480560"/>
-            <a:ext cx="914400" cy="822960"/>
-          </a:xfrm>
-          <a:prstGeom prst="roundRect">
-            <a:avLst/>
-          </a:prstGeom>
-          <a:solidFill>
-            <a:srgbClr val="2ECC71"/>
-          </a:solidFill>
-          <a:ln>
-            <a:noFill/>
-          </a:ln>
-        </p:spPr>
-        <p:style>
-          <a:lnRef idx="1">
-            <a:schemeClr val="accent1"/>
-          </a:lnRef>
-          <a:fillRef idx="3">
-            <a:schemeClr val="accent1"/>
-          </a:fillRef>
-          <a:effectRef idx="2">
-            <a:schemeClr val="accent1"/>
-          </a:effectRef>
-          <a:fontRef idx="minor">
-            <a:schemeClr val="lt1"/>
-          </a:fontRef>
-        </p:style>
-        <p:txBody>
-          <a:bodyPr rtlCol="0" anchor="ctr" wrap="square" lIns="50800" rIns="50800" tIns="25400" bIns="25400"/>
-          <a:lstStyle/>
-          <a:p>
-            <a:pPr algn="ctr">
-              <a:defRPr sz="1800" b="1">
-                <a:solidFill>
-                  <a:srgbClr val="FFFFFF"/>
-                </a:solidFill>
-                <a:latin typeface="Calibri"/>
-              </a:defRPr>
-            </a:pPr>
-            <a:r>
-              <a:t>H2</a:t>
-            </a:r>
-          </a:p>
-        </p:txBody>
-      </p:sp>
-      <p:sp>
-        <p:nvSpPr>
-          <p:cNvPr id="13" name="Rounded Rectangle 12"/>
-          <p:cNvSpPr/>
-          <p:nvPr/>
-        </p:nvSpPr>
-        <p:spPr>
-          <a:xfrm>
-            <a:off x="1645920" y="4480560"/>
-            <a:ext cx="9966960" cy="822960"/>
-          </a:xfrm>
-          <a:prstGeom prst="roundRect">
-            <a:avLst/>
-          </a:prstGeom>
-          <a:solidFill>
-            <a:srgbClr val="121222"/>
-          </a:solidFill>
-          <a:ln w="25400">
-            <a:solidFill>
-              <a:srgbClr val="2ECC71"/>
-            </a:solidFill>
-          </a:ln>
-        </p:spPr>
-        <p:style>
-          <a:lnRef idx="1">
-            <a:schemeClr val="accent1"/>
-          </a:lnRef>
-          <a:fillRef idx="3">
-            <a:schemeClr val="accent1"/>
-          </a:fillRef>
-          <a:effectRef idx="2">
-            <a:schemeClr val="accent1"/>
-          </a:effectRef>
-          <a:fontRef idx="minor">
-            <a:schemeClr val="lt1"/>
-          </a:fontRef>
-        </p:style>
-        <p:txBody>
-          <a:bodyPr rtlCol="0" anchor="ctr"/>
-          <a:lstStyle/>
-          <a:p>
-            <a:pPr algn="ctr"/>
-          </a:p>
-        </p:txBody>
-      </p:sp>
-      <p:sp>
-        <p:nvSpPr>
-          <p:cNvPr id="14" name="TextBox 13"/>
-          <p:cNvSpPr txBox="1"/>
-          <p:nvPr/>
-        </p:nvSpPr>
-        <p:spPr>
-          <a:xfrm>
-            <a:off x="1828800" y="4498848"/>
-            <a:ext cx="9601200" cy="274320"/>
-          </a:xfrm>
-          <a:prstGeom prst="rect">
-            <a:avLst/>
-          </a:prstGeom>
-          <a:noFill/>
-        </p:spPr>
-        <p:txBody>
-          <a:bodyPr wrap="square">
-            <a:spAutoFit/>
-          </a:bodyPr>
-          <a:lstStyle/>
-          <a:p>
-            <a:pPr algn="l">
-              <a:defRPr sz="1500" b="1">
-                <a:solidFill>
-                  <a:srgbClr val="2ECC71"/>
-                </a:solidFill>
-                <a:latin typeface="Calibri"/>
-              </a:defRPr>
-            </a:pPr>
-            <a:r>
-              <a:t>Spreading improves fault isolation</a:t>
-            </a:r>
-          </a:p>
-        </p:txBody>
-      </p:sp>
-      <p:sp>
-        <p:nvSpPr>
-          <p:cNvPr id="15" name="TextBox 14"/>
-          <p:cNvSpPr txBox="1"/>
-          <p:nvPr/>
-        </p:nvSpPr>
-        <p:spPr>
-          <a:xfrm>
-            <a:off x="1828800" y="4828032"/>
-            <a:ext cx="9601200" cy="457200"/>
-          </a:xfrm>
-          <a:prstGeom prst="rect">
-            <a:avLst/>
-          </a:prstGeom>
-          <a:noFill/>
-        </p:spPr>
-        <p:txBody>
-          <a:bodyPr wrap="square">
-            <a:spAutoFit/>
-          </a:bodyPr>
-          <a:lstStyle/>
-          <a:p>
-            <a:pPr algn="l">
-              <a:defRPr sz="1200" b="0">
-                <a:solidFill>
-                  <a:srgbClr val="BDBDBD"/>
-                </a:solidFill>
-                <a:latin typeface="Calibri"/>
-              </a:defRPr>
-            </a:pPr>
-            <a:r>
-              <a:t>Distributing pods evenly across nodes minimizes per-node contention and limits fault blast radius, yielding the best resilience scores.</a:t>
-            </a:r>
-          </a:p>
-        </p:txBody>
-      </p:sp>
-      <p:sp>
-        <p:nvSpPr>
-          <p:cNvPr id="16" name="Rounded Rectangle 15"/>
-          <p:cNvSpPr/>
-          <p:nvPr/>
-        </p:nvSpPr>
-        <p:spPr>
-          <a:xfrm>
-            <a:off x="548640" y="5669280"/>
-            <a:ext cx="914400" cy="822960"/>
-          </a:xfrm>
-          <a:prstGeom prst="roundRect">
-            <a:avLst/>
-          </a:prstGeom>
-          <a:solidFill>
-            <a:srgbClr val="F39C12"/>
-          </a:solidFill>
-          <a:ln>
-            <a:noFill/>
-          </a:ln>
-        </p:spPr>
-        <p:style>
-          <a:lnRef idx="1">
-            <a:schemeClr val="accent1"/>
-          </a:lnRef>
-          <a:fillRef idx="3">
-            <a:schemeClr val="accent1"/>
-          </a:fillRef>
-          <a:effectRef idx="2">
-            <a:schemeClr val="accent1"/>
-          </a:effectRef>
-          <a:fontRef idx="minor">
-            <a:schemeClr val="lt1"/>
-          </a:fontRef>
-        </p:style>
-        <p:txBody>
-          <a:bodyPr rtlCol="0" anchor="ctr" wrap="square" lIns="50800" rIns="50800" tIns="25400" bIns="25400"/>
-          <a:lstStyle/>
-          <a:p>
-            <a:pPr algn="ctr">
-              <a:defRPr sz="1800" b="1">
-                <a:solidFill>
-                  <a:srgbClr val="FFFFFF"/>
-                </a:solidFill>
-                <a:latin typeface="Calibri"/>
-              </a:defRPr>
-            </a:pPr>
-            <a:r>
-              <a:t>H3</a:t>
-            </a:r>
-          </a:p>
-        </p:txBody>
-      </p:sp>
-      <p:sp>
-        <p:nvSpPr>
-          <p:cNvPr id="17" name="Rounded Rectangle 16"/>
-          <p:cNvSpPr/>
-          <p:nvPr/>
-        </p:nvSpPr>
-        <p:spPr>
-          <a:xfrm>
-            <a:off x="1645920" y="5669280"/>
-            <a:ext cx="9966960" cy="822960"/>
-          </a:xfrm>
-          <a:prstGeom prst="roundRect">
-            <a:avLst/>
-          </a:prstGeom>
-          <a:solidFill>
-            <a:srgbClr val="121222"/>
-          </a:solidFill>
-          <a:ln w="25400">
-            <a:solidFill>
-              <a:srgbClr val="F39C12"/>
-            </a:solidFill>
-          </a:ln>
-        </p:spPr>
-        <p:style>
-          <a:lnRef idx="1">
-            <a:schemeClr val="accent1"/>
-          </a:lnRef>
-          <a:fillRef idx="3">
-            <a:schemeClr val="accent1"/>
-          </a:fillRef>
-          <a:effectRef idx="2">
-            <a:schemeClr val="accent1"/>
-          </a:effectRef>
-          <a:fontRef idx="minor">
-            <a:schemeClr val="lt1"/>
-          </a:fontRef>
-        </p:style>
-        <p:txBody>
-          <a:bodyPr rtlCol="0" anchor="ctr"/>
-          <a:lstStyle/>
-          <a:p>
-            <a:pPr algn="ctr"/>
-          </a:p>
-        </p:txBody>
-      </p:sp>
-      <p:sp>
-        <p:nvSpPr>
-          <p:cNvPr id="18" name="TextBox 17"/>
-          <p:cNvSpPr txBox="1"/>
-          <p:nvPr/>
-        </p:nvSpPr>
-        <p:spPr>
-          <a:xfrm>
-            <a:off x="1828800" y="5687568"/>
-            <a:ext cx="9601200" cy="274320"/>
-          </a:xfrm>
-          <a:prstGeom prst="rect">
-            <a:avLst/>
-          </a:prstGeom>
-          <a:noFill/>
-        </p:spPr>
-        <p:txBody>
-          <a:bodyPr wrap="square">
-            <a:spAutoFit/>
-          </a:bodyPr>
-          <a:lstStyle/>
-          <a:p>
-            <a:pPr algn="l">
-              <a:defRPr sz="1500" b="1">
-                <a:solidFill>
-                  <a:srgbClr val="F39C12"/>
-                </a:solidFill>
-                <a:latin typeface="Calibri"/>
-              </a:defRPr>
-            </a:pPr>
-            <a:r>
-              <a:t>Recovery time predicts resilience</a:t>
-            </a:r>
-          </a:p>
-        </p:txBody>
-      </p:sp>
-      <p:sp>
-        <p:nvSpPr>
-          <p:cNvPr id="19" name="TextBox 18"/>
-          <p:cNvSpPr txBox="1"/>
-          <p:nvPr/>
-        </p:nvSpPr>
-        <p:spPr>
-          <a:xfrm>
-            <a:off x="1828800" y="6016752"/>
-            <a:ext cx="9601200" cy="457200"/>
-          </a:xfrm>
-          <a:prstGeom prst="rect">
-            <a:avLst/>
-          </a:prstGeom>
-          <a:noFill/>
-        </p:spPr>
-        <p:txBody>
-          <a:bodyPr wrap="square">
-            <a:spAutoFit/>
-          </a:bodyPr>
-          <a:lstStyle/>
-          <a:p>
-            <a:pPr algn="l">
-              <a:defRPr sz="1200" b="0">
-                <a:solidFill>
-                  <a:srgbClr val="BDBDBD"/>
-                </a:solidFill>
-                <a:latin typeface="Calibri"/>
-              </a:defRPr>
-            </a:pPr>
-            <a:r>
-              <a:t>Faster pod recovery yields higher resilience scores — shorter unavailability windows mean fewer probe checks fall inside the fault window (Dean–Barroso 2013).</a:t>
-            </a:r>
-          </a:p>
-        </p:txBody>
-      </p:sp>
-      <p:sp>
-        <p:nvSpPr>
-          <p:cNvPr id="20" name="TextBox 19"/>
-          <p:cNvSpPr txBox="1"/>
-          <p:nvPr/>
-        </p:nvSpPr>
-        <p:spPr>
-          <a:xfrm>
-            <a:off x="548640" y="6400800"/>
-            <a:ext cx="10972800" cy="274320"/>
-          </a:xfrm>
-          <a:prstGeom prst="rect">
-            <a:avLst/>
-          </a:prstGeom>
-          <a:noFill/>
-        </p:spPr>
-        <p:txBody>
-          <a:bodyPr wrap="square">
-            <a:spAutoFit/>
-          </a:bodyPr>
-          <a:lstStyle/>
-          <a:p>
-            <a:pPr algn="l">
-              <a:defRPr sz="1200" b="1">
-                <a:solidFill>
-                  <a:srgbClr val="9090A0"/>
-                </a:solidFill>
-                <a:latin typeface="Calibri"/>
-              </a:defRPr>
-            </a:pPr>
-            <a:r>
-              <a:t>Measured Dimensions:</a:t>
-            </a:r>
-          </a:p>
-        </p:txBody>
-      </p:sp>
-      <p:sp>
-        <p:nvSpPr>
-          <p:cNvPr id="21" name="Rounded Rectangle 20"/>
-          <p:cNvSpPr/>
-          <p:nvPr/>
-        </p:nvSpPr>
-        <p:spPr>
-          <a:xfrm>
-            <a:off x="2743200" y="6355080"/>
-            <a:ext cx="1920240" cy="320040"/>
+            <a:off x="182880" y="4480560"/>
+            <a:ext cx="2331720" cy="320040"/>
           </a:xfrm>
           <a:prstGeom prst="roundRect">
             <a:avLst/>
@@ -9959,38 +10673,112 @@
           <a:lstStyle/>
           <a:p>
             <a:pPr algn="ctr">
+              <a:defRPr sz="1300" b="1">
+                <a:solidFill>
+                  <a:srgbClr val="FFFFFF"/>
+                </a:solidFill>
+                <a:latin typeface="Calibri"/>
+              </a:defRPr>
+            </a:pPr>
+            <a:r>
+              <a:t>H6</a:t>
+            </a:r>
+          </a:p>
+        </p:txBody>
+      </p:sp>
+      <p:sp>
+        <p:nvSpPr>
+          <p:cNvPr id="32" name="TextBox 31"/>
+          <p:cNvSpPr txBox="1"/>
+          <p:nvPr/>
+        </p:nvSpPr>
+        <p:spPr>
+          <a:xfrm>
+            <a:off x="274320" y="4846320"/>
+            <a:ext cx="2148839" cy="365760"/>
+          </a:xfrm>
+          <a:prstGeom prst="rect">
+            <a:avLst/>
+          </a:prstGeom>
+          <a:noFill/>
+        </p:spPr>
+        <p:txBody>
+          <a:bodyPr wrap="square">
+            <a:spAutoFit/>
+          </a:bodyPr>
+          <a:lstStyle/>
+          <a:p>
+            <a:pPr algn="l">
               <a:defRPr sz="1100" b="1">
                 <a:solidFill>
-                  <a:srgbClr val="FFFFFF"/>
-                </a:solidFill>
-                <a:latin typeface="Calibri"/>
-              </a:defRPr>
-            </a:pPr>
-            <a:r>
-              <a:t>Recovery Time</a:t>
-            </a:r>
-          </a:p>
-        </p:txBody>
-      </p:sp>
-      <p:sp>
-        <p:nvSpPr>
-          <p:cNvPr id="22" name="Rounded Rectangle 21"/>
+                  <a:srgbClr val="E74C3C"/>
+                </a:solidFill>
+                <a:latin typeface="Calibri"/>
+              </a:defRPr>
+            </a:pPr>
+            <a:r>
+              <a:t>Cross-pod variance → leakage</a:t>
+            </a:r>
+          </a:p>
+        </p:txBody>
+      </p:sp>
+      <p:sp>
+        <p:nvSpPr>
+          <p:cNvPr id="33" name="TextBox 32"/>
+          <p:cNvSpPr txBox="1"/>
+          <p:nvPr/>
+        </p:nvSpPr>
+        <p:spPr>
+          <a:xfrm>
+            <a:off x="274320" y="5257800"/>
+            <a:ext cx="2148839" cy="1005839"/>
+          </a:xfrm>
+          <a:prstGeom prst="rect">
+            <a:avLst/>
+          </a:prstGeom>
+          <a:noFill/>
+        </p:spPr>
+        <p:txBody>
+          <a:bodyPr wrap="square">
+            <a:spAutoFit/>
+          </a:bodyPr>
+          <a:lstStyle/>
+          <a:p>
+            <a:pPr algn="l">
+              <a:defRPr sz="900" b="0">
+                <a:solidFill>
+                  <a:srgbClr val="BDBDBD"/>
+                </a:solidFill>
+                <a:latin typeface="Calibri"/>
+              </a:defRPr>
+            </a:pPr>
+            <a:r>
+              <a:t>Pre-chaos cross-node stddev predicts whether a strategy lands in the containment cluster (3-17% conntrack drop) or the leakage cluster (30-49% drop).</a:t>
+            </a:r>
+          </a:p>
+        </p:txBody>
+      </p:sp>
+      <p:sp>
+        <p:nvSpPr>
+          <p:cNvPr id="34" name="Rounded Rectangle 33"/>
           <p:cNvSpPr/>
           <p:nvPr/>
         </p:nvSpPr>
         <p:spPr>
           <a:xfrm>
-            <a:off x="4846320" y="6355080"/>
-            <a:ext cx="1920240" cy="320040"/>
+            <a:off x="2560320" y="4480560"/>
+            <a:ext cx="2331720" cy="1874519"/>
           </a:xfrm>
           <a:prstGeom prst="roundRect">
             <a:avLst/>
           </a:prstGeom>
           <a:solidFill>
-            <a:srgbClr val="2ECC71"/>
+            <a:srgbClr val="121222"/>
           </a:solidFill>
-          <a:ln>
-            <a:noFill/>
+          <a:ln w="25400">
+            <a:solidFill>
+              <a:srgbClr val="E74C3C"/>
+            </a:solidFill>
           </a:ln>
         </p:spPr>
         <p:style>
@@ -10008,39 +10796,29 @@
           </a:fontRef>
         </p:style>
         <p:txBody>
-          <a:bodyPr rtlCol="0" anchor="ctr" wrap="square" lIns="50800" rIns="50800" tIns="25400" bIns="25400"/>
-          <a:lstStyle/>
-          <a:p>
-            <a:pPr algn="ctr">
-              <a:defRPr sz="1100" b="1">
-                <a:solidFill>
-                  <a:srgbClr val="FFFFFF"/>
-                </a:solidFill>
-                <a:latin typeface="Calibri"/>
-              </a:defRPr>
-            </a:pPr>
-            <a:r>
-              <a:t>Inter-Service Latency</a:t>
-            </a:r>
-          </a:p>
-        </p:txBody>
-      </p:sp>
-      <p:sp>
-        <p:nvSpPr>
-          <p:cNvPr id="23" name="Rounded Rectangle 22"/>
+          <a:bodyPr rtlCol="0" anchor="ctr"/>
+          <a:lstStyle/>
+          <a:p>
+            <a:pPr algn="ctr"/>
+          </a:p>
+        </p:txBody>
+      </p:sp>
+      <p:sp>
+        <p:nvSpPr>
+          <p:cNvPr id="35" name="Rounded Rectangle 34"/>
           <p:cNvSpPr/>
           <p:nvPr/>
         </p:nvSpPr>
         <p:spPr>
           <a:xfrm>
-            <a:off x="6949440" y="6355080"/>
-            <a:ext cx="1920240" cy="320040"/>
+            <a:off x="2560320" y="4480560"/>
+            <a:ext cx="2331720" cy="320040"/>
           </a:xfrm>
           <a:prstGeom prst="roundRect">
             <a:avLst/>
           </a:prstGeom>
           <a:solidFill>
-            <a:srgbClr val="1ABC9C"/>
+            <a:srgbClr val="E74C3C"/>
           </a:solidFill>
           <a:ln>
             <a:noFill/>
@@ -10065,38 +10843,112 @@
           <a:lstStyle/>
           <a:p>
             <a:pPr algn="ctr">
+              <a:defRPr sz="1300" b="1">
+                <a:solidFill>
+                  <a:srgbClr val="FFFFFF"/>
+                </a:solidFill>
+                <a:latin typeface="Calibri"/>
+              </a:defRPr>
+            </a:pPr>
+            <a:r>
+              <a:t>H7</a:t>
+            </a:r>
+          </a:p>
+        </p:txBody>
+      </p:sp>
+      <p:sp>
+        <p:nvSpPr>
+          <p:cNvPr id="36" name="TextBox 35"/>
+          <p:cNvSpPr txBox="1"/>
+          <p:nvPr/>
+        </p:nvSpPr>
+        <p:spPr>
+          <a:xfrm>
+            <a:off x="2651760" y="4846320"/>
+            <a:ext cx="2148839" cy="365760"/>
+          </a:xfrm>
+          <a:prstGeom prst="rect">
+            <a:avLst/>
+          </a:prstGeom>
+          <a:noFill/>
+        </p:spPr>
+        <p:txBody>
+          <a:bodyPr wrap="square">
+            <a:spAutoFit/>
+          </a:bodyPr>
+          <a:lstStyle/>
+          <a:p>
+            <a:pPr algn="l">
               <a:defRPr sz="1100" b="1">
                 <a:solidFill>
-                  <a:srgbClr val="FFFFFF"/>
-                </a:solidFill>
-                <a:latin typeface="Calibri"/>
-              </a:defRPr>
-            </a:pPr>
-            <a:r>
-              <a:t>Resource Utilization</a:t>
-            </a:r>
-          </a:p>
-        </p:txBody>
-      </p:sp>
-      <p:sp>
-        <p:nvSpPr>
-          <p:cNvPr id="24" name="Rounded Rectangle 23"/>
+                  <a:srgbClr val="E74C3C"/>
+                </a:solidFill>
+                <a:latin typeface="Calibri"/>
+              </a:defRPr>
+            </a:pPr>
+            <a:r>
+              <a:t>CPU throttling refutes contention model</a:t>
+            </a:r>
+          </a:p>
+        </p:txBody>
+      </p:sp>
+      <p:sp>
+        <p:nvSpPr>
+          <p:cNvPr id="37" name="TextBox 36"/>
+          <p:cNvSpPr txBox="1"/>
+          <p:nvPr/>
+        </p:nvSpPr>
+        <p:spPr>
+          <a:xfrm>
+            <a:off x="2651760" y="5257800"/>
+            <a:ext cx="2148839" cy="1005839"/>
+          </a:xfrm>
+          <a:prstGeom prst="rect">
+            <a:avLst/>
+          </a:prstGeom>
+          <a:noFill/>
+        </p:spPr>
+        <p:txBody>
+          <a:bodyPr wrap="square">
+            <a:spAutoFit/>
+          </a:bodyPr>
+          <a:lstStyle/>
+          <a:p>
+            <a:pPr algn="l">
+              <a:defRPr sz="900" b="0">
+                <a:solidFill>
+                  <a:srgbClr val="BDBDBD"/>
+                </a:solidFill>
+                <a:latin typeface="Calibri"/>
+              </a:defRPr>
+            </a:pPr>
+            <a:r>
+              <a:t>Under pod-delete, colocate throttles less (0.89) than spread (1.52) — opposite of Bubble-Up's contention prediction. Mars 2011 doesn't fit churn-based faults.</a:t>
+            </a:r>
+          </a:p>
+        </p:txBody>
+      </p:sp>
+      <p:sp>
+        <p:nvSpPr>
+          <p:cNvPr id="38" name="Rounded Rectangle 37"/>
           <p:cNvSpPr/>
           <p:nvPr/>
         </p:nvSpPr>
         <p:spPr>
           <a:xfrm>
-            <a:off x="9052559" y="6355080"/>
-            <a:ext cx="1920240" cy="320040"/>
+            <a:off x="4937759" y="4480560"/>
+            <a:ext cx="2331720" cy="1874519"/>
           </a:xfrm>
           <a:prstGeom prst="roundRect">
             <a:avLst/>
           </a:prstGeom>
           <a:solidFill>
-            <a:srgbClr val="F39C12"/>
+            <a:srgbClr val="121222"/>
           </a:solidFill>
-          <a:ln>
-            <a:noFill/>
+          <a:ln w="25400">
+            <a:solidFill>
+              <a:srgbClr val="E74C3C"/>
+            </a:solidFill>
           </a:ln>
         </p:spPr>
         <p:style>
@@ -10114,19 +10966,510 @@
           </a:fontRef>
         </p:style>
         <p:txBody>
+          <a:bodyPr rtlCol="0" anchor="ctr"/>
+          <a:lstStyle/>
+          <a:p>
+            <a:pPr algn="ctr"/>
+          </a:p>
+        </p:txBody>
+      </p:sp>
+      <p:sp>
+        <p:nvSpPr>
+          <p:cNvPr id="39" name="Rounded Rectangle 38"/>
+          <p:cNvSpPr/>
+          <p:nvPr/>
+        </p:nvSpPr>
+        <p:spPr>
+          <a:xfrm>
+            <a:off x="4937759" y="4480560"/>
+            <a:ext cx="2331720" cy="320040"/>
+          </a:xfrm>
+          <a:prstGeom prst="roundRect">
+            <a:avLst/>
+          </a:prstGeom>
+          <a:solidFill>
+            <a:srgbClr val="E74C3C"/>
+          </a:solidFill>
+          <a:ln>
+            <a:noFill/>
+          </a:ln>
+        </p:spPr>
+        <p:style>
+          <a:lnRef idx="1">
+            <a:schemeClr val="accent1"/>
+          </a:lnRef>
+          <a:fillRef idx="3">
+            <a:schemeClr val="accent1"/>
+          </a:fillRef>
+          <a:effectRef idx="2">
+            <a:schemeClr val="accent1"/>
+          </a:effectRef>
+          <a:fontRef idx="minor">
+            <a:schemeClr val="lt1"/>
+          </a:fontRef>
+        </p:style>
+        <p:txBody>
           <a:bodyPr rtlCol="0" anchor="ctr" wrap="square" lIns="50800" rIns="50800" tIns="25400" bIns="25400"/>
           <a:lstStyle/>
           <a:p>
             <a:pPr algn="ctr">
+              <a:defRPr sz="1300" b="1">
+                <a:solidFill>
+                  <a:srgbClr val="FFFFFF"/>
+                </a:solidFill>
+                <a:latin typeface="Calibri"/>
+              </a:defRPr>
+            </a:pPr>
+            <a:r>
+              <a:t>H8</a:t>
+            </a:r>
+          </a:p>
+        </p:txBody>
+      </p:sp>
+      <p:sp>
+        <p:nvSpPr>
+          <p:cNvPr id="40" name="TextBox 39"/>
+          <p:cNvSpPr txBox="1"/>
+          <p:nvPr/>
+        </p:nvSpPr>
+        <p:spPr>
+          <a:xfrm>
+            <a:off x="5029199" y="4846320"/>
+            <a:ext cx="2148839" cy="365760"/>
+          </a:xfrm>
+          <a:prstGeom prst="rect">
+            <a:avLst/>
+          </a:prstGeom>
+          <a:noFill/>
+        </p:spPr>
+        <p:txBody>
+          <a:bodyPr wrap="square">
+            <a:spAutoFit/>
+          </a:bodyPr>
+          <a:lstStyle/>
+          <a:p>
+            <a:pPr algn="l">
               <a:defRPr sz="1100" b="1">
                 <a:solidFill>
+                  <a:srgbClr val="E74C3C"/>
+                </a:solidFill>
+                <a:latin typeface="Calibri"/>
+              </a:defRPr>
+            </a:pPr>
+            <a:r>
+              <a:t>SLO + conntrack signals leakage</a:t>
+            </a:r>
+          </a:p>
+        </p:txBody>
+      </p:sp>
+      <p:sp>
+        <p:nvSpPr>
+          <p:cNvPr id="41" name="TextBox 40"/>
+          <p:cNvSpPr txBox="1"/>
+          <p:nvPr/>
+        </p:nvSpPr>
+        <p:spPr>
+          <a:xfrm>
+            <a:off x="5029199" y="5257800"/>
+            <a:ext cx="2148839" cy="1005839"/>
+          </a:xfrm>
+          <a:prstGeom prst="rect">
+            <a:avLst/>
+          </a:prstGeom>
+          <a:noFill/>
+        </p:spPr>
+        <p:txBody>
+          <a:bodyPr wrap="square">
+            <a:spAutoFit/>
+          </a:bodyPr>
+          <a:lstStyle/>
+          <a:p>
+            <a:pPr algn="l">
+              <a:defRPr sz="900" b="0">
+                <a:solidFill>
+                  <a:srgbClr val="BDBDBD"/>
+                </a:solidFill>
+                <a:latin typeface="Calibri"/>
+              </a:defRPr>
+            </a:pPr>
+            <a:r>
+              <a:t>Conntrack flushing during chaos correlates with leakage: spread 49%, dep-aware 3%. The K8s Network Programming Latency SLO measures the churn mechanism directly.</a:t>
+            </a:r>
+          </a:p>
+        </p:txBody>
+      </p:sp>
+      <p:sp>
+        <p:nvSpPr>
+          <p:cNvPr id="42" name="Rounded Rectangle 41"/>
+          <p:cNvSpPr/>
+          <p:nvPr/>
+        </p:nvSpPr>
+        <p:spPr>
+          <a:xfrm>
+            <a:off x="7315199" y="4480560"/>
+            <a:ext cx="2331720" cy="1874519"/>
+          </a:xfrm>
+          <a:prstGeom prst="roundRect">
+            <a:avLst/>
+          </a:prstGeom>
+          <a:solidFill>
+            <a:srgbClr val="121222"/>
+          </a:solidFill>
+          <a:ln w="25400">
+            <a:solidFill>
+              <a:srgbClr val="9B59B6"/>
+            </a:solidFill>
+          </a:ln>
+        </p:spPr>
+        <p:style>
+          <a:lnRef idx="1">
+            <a:schemeClr val="accent1"/>
+          </a:lnRef>
+          <a:fillRef idx="3">
+            <a:schemeClr val="accent1"/>
+          </a:fillRef>
+          <a:effectRef idx="2">
+            <a:schemeClr val="accent1"/>
+          </a:effectRef>
+          <a:fontRef idx="minor">
+            <a:schemeClr val="lt1"/>
+          </a:fontRef>
+        </p:style>
+        <p:txBody>
+          <a:bodyPr rtlCol="0" anchor="ctr"/>
+          <a:lstStyle/>
+          <a:p>
+            <a:pPr algn="ctr"/>
+          </a:p>
+        </p:txBody>
+      </p:sp>
+      <p:sp>
+        <p:nvSpPr>
+          <p:cNvPr id="43" name="Rounded Rectangle 42"/>
+          <p:cNvSpPr/>
+          <p:nvPr/>
+        </p:nvSpPr>
+        <p:spPr>
+          <a:xfrm>
+            <a:off x="7315199" y="4480560"/>
+            <a:ext cx="2331720" cy="320040"/>
+          </a:xfrm>
+          <a:prstGeom prst="roundRect">
+            <a:avLst/>
+          </a:prstGeom>
+          <a:solidFill>
+            <a:srgbClr val="9B59B6"/>
+          </a:solidFill>
+          <a:ln>
+            <a:noFill/>
+          </a:ln>
+        </p:spPr>
+        <p:style>
+          <a:lnRef idx="1">
+            <a:schemeClr val="accent1"/>
+          </a:lnRef>
+          <a:fillRef idx="3">
+            <a:schemeClr val="accent1"/>
+          </a:fillRef>
+          <a:effectRef idx="2">
+            <a:schemeClr val="accent1"/>
+          </a:effectRef>
+          <a:fontRef idx="minor">
+            <a:schemeClr val="lt1"/>
+          </a:fontRef>
+        </p:style>
+        <p:txBody>
+          <a:bodyPr rtlCol="0" anchor="ctr" wrap="square" lIns="50800" rIns="50800" tIns="25400" bIns="25400"/>
+          <a:lstStyle/>
+          <a:p>
+            <a:pPr algn="ctr">
+              <a:defRPr sz="1300" b="1">
+                <a:solidFill>
                   <a:srgbClr val="FFFFFF"/>
                 </a:solidFill>
                 <a:latin typeface="Calibri"/>
               </a:defRPr>
             </a:pPr>
             <a:r>
-              <a:t>I/O Throughput</a:t>
+              <a:t>H9</a:t>
+            </a:r>
+          </a:p>
+        </p:txBody>
+      </p:sp>
+      <p:sp>
+        <p:nvSpPr>
+          <p:cNvPr id="44" name="TextBox 43"/>
+          <p:cNvSpPr txBox="1"/>
+          <p:nvPr/>
+        </p:nvSpPr>
+        <p:spPr>
+          <a:xfrm>
+            <a:off x="7406640" y="4846320"/>
+            <a:ext cx="2148839" cy="365760"/>
+          </a:xfrm>
+          <a:prstGeom prst="rect">
+            <a:avLst/>
+          </a:prstGeom>
+          <a:noFill/>
+        </p:spPr>
+        <p:txBody>
+          <a:bodyPr wrap="square">
+            <a:spAutoFit/>
+          </a:bodyPr>
+          <a:lstStyle/>
+          <a:p>
+            <a:pPr algn="l">
+              <a:defRPr sz="1100" b="1">
+                <a:solidFill>
+                  <a:srgbClr val="9B59B6"/>
+                </a:solidFill>
+                <a:latin typeface="Calibri"/>
+              </a:defRPr>
+            </a:pPr>
+            <a:r>
+              <a:t>Scheduling latency dominates recovery</a:t>
+            </a:r>
+          </a:p>
+        </p:txBody>
+      </p:sp>
+      <p:sp>
+        <p:nvSpPr>
+          <p:cNvPr id="45" name="TextBox 44"/>
+          <p:cNvSpPr txBox="1"/>
+          <p:nvPr/>
+        </p:nvSpPr>
+        <p:spPr>
+          <a:xfrm>
+            <a:off x="7406640" y="5257800"/>
+            <a:ext cx="2148839" cy="1005839"/>
+          </a:xfrm>
+          <a:prstGeom prst="rect">
+            <a:avLst/>
+          </a:prstGeom>
+          <a:noFill/>
+        </p:spPr>
+        <p:txBody>
+          <a:bodyPr wrap="square">
+            <a:spAutoFit/>
+          </a:bodyPr>
+          <a:lstStyle/>
+          <a:p>
+            <a:pPr algn="l">
+              <a:defRPr sz="900" b="0">
+                <a:solidFill>
+                  <a:srgbClr val="BDBDBD"/>
+                </a:solidFill>
+                <a:latin typeface="Calibri"/>
+              </a:defRPr>
+            </a:pPr>
+            <a:r>
+              <a:t>Recovery time = (deletion→scheduled) + (scheduled→ready). Placement affects only the first term; the second is application-bound and ~constant across strategies.</a:t>
+            </a:r>
+          </a:p>
+        </p:txBody>
+      </p:sp>
+      <p:sp>
+        <p:nvSpPr>
+          <p:cNvPr id="46" name="Rounded Rectangle 45"/>
+          <p:cNvSpPr/>
+          <p:nvPr/>
+        </p:nvSpPr>
+        <p:spPr>
+          <a:xfrm>
+            <a:off x="9692639" y="4480560"/>
+            <a:ext cx="2331720" cy="1874519"/>
+          </a:xfrm>
+          <a:prstGeom prst="roundRect">
+            <a:avLst/>
+          </a:prstGeom>
+          <a:solidFill>
+            <a:srgbClr val="121222"/>
+          </a:solidFill>
+          <a:ln w="25400">
+            <a:solidFill>
+              <a:srgbClr val="9B59B6"/>
+            </a:solidFill>
+          </a:ln>
+        </p:spPr>
+        <p:style>
+          <a:lnRef idx="1">
+            <a:schemeClr val="accent1"/>
+          </a:lnRef>
+          <a:fillRef idx="3">
+            <a:schemeClr val="accent1"/>
+          </a:fillRef>
+          <a:effectRef idx="2">
+            <a:schemeClr val="accent1"/>
+          </a:effectRef>
+          <a:fontRef idx="minor">
+            <a:schemeClr val="lt1"/>
+          </a:fontRef>
+        </p:style>
+        <p:txBody>
+          <a:bodyPr rtlCol="0" anchor="ctr"/>
+          <a:lstStyle/>
+          <a:p>
+            <a:pPr algn="ctr"/>
+          </a:p>
+        </p:txBody>
+      </p:sp>
+      <p:sp>
+        <p:nvSpPr>
+          <p:cNvPr id="47" name="Rounded Rectangle 46"/>
+          <p:cNvSpPr/>
+          <p:nvPr/>
+        </p:nvSpPr>
+        <p:spPr>
+          <a:xfrm>
+            <a:off x="9692639" y="4480560"/>
+            <a:ext cx="2331720" cy="320040"/>
+          </a:xfrm>
+          <a:prstGeom prst="roundRect">
+            <a:avLst/>
+          </a:prstGeom>
+          <a:solidFill>
+            <a:srgbClr val="9B59B6"/>
+          </a:solidFill>
+          <a:ln>
+            <a:noFill/>
+          </a:ln>
+        </p:spPr>
+        <p:style>
+          <a:lnRef idx="1">
+            <a:schemeClr val="accent1"/>
+          </a:lnRef>
+          <a:fillRef idx="3">
+            <a:schemeClr val="accent1"/>
+          </a:fillRef>
+          <a:effectRef idx="2">
+            <a:schemeClr val="accent1"/>
+          </a:effectRef>
+          <a:fontRef idx="minor">
+            <a:schemeClr val="lt1"/>
+          </a:fontRef>
+        </p:style>
+        <p:txBody>
+          <a:bodyPr rtlCol="0" anchor="ctr" wrap="square" lIns="50800" rIns="50800" tIns="25400" bIns="25400"/>
+          <a:lstStyle/>
+          <a:p>
+            <a:pPr algn="ctr">
+              <a:defRPr sz="1300" b="1">
+                <a:solidFill>
+                  <a:srgbClr val="FFFFFF"/>
+                </a:solidFill>
+                <a:latin typeface="Calibri"/>
+              </a:defRPr>
+            </a:pPr>
+            <a:r>
+              <a:t>H10</a:t>
+            </a:r>
+          </a:p>
+        </p:txBody>
+      </p:sp>
+      <p:sp>
+        <p:nvSpPr>
+          <p:cNvPr id="48" name="TextBox 47"/>
+          <p:cNvSpPr txBox="1"/>
+          <p:nvPr/>
+        </p:nvSpPr>
+        <p:spPr>
+          <a:xfrm>
+            <a:off x="9784079" y="4846320"/>
+            <a:ext cx="2148839" cy="365760"/>
+          </a:xfrm>
+          <a:prstGeom prst="rect">
+            <a:avLst/>
+          </a:prstGeom>
+          <a:noFill/>
+        </p:spPr>
+        <p:txBody>
+          <a:bodyPr wrap="square">
+            <a:spAutoFit/>
+          </a:bodyPr>
+          <a:lstStyle/>
+          <a:p>
+            <a:pPr algn="l">
+              <a:defRPr sz="1100" b="1">
+                <a:solidFill>
+                  <a:srgbClr val="9B59B6"/>
+                </a:solidFill>
+                <a:latin typeface="Calibri"/>
+              </a:defRPr>
+            </a:pPr>
+            <a:r>
+              <a:t>Post-chaos asymmetry as fingerprint</a:t>
+            </a:r>
+          </a:p>
+        </p:txBody>
+      </p:sp>
+      <p:sp>
+        <p:nvSpPr>
+          <p:cNvPr id="49" name="TextBox 48"/>
+          <p:cNvSpPr txBox="1"/>
+          <p:nvPr/>
+        </p:nvSpPr>
+        <p:spPr>
+          <a:xfrm>
+            <a:off x="9784079" y="5257800"/>
+            <a:ext cx="2148839" cy="1005839"/>
+          </a:xfrm>
+          <a:prstGeom prst="rect">
+            <a:avLst/>
+          </a:prstGeom>
+          <a:noFill/>
+        </p:spPr>
+        <p:txBody>
+          <a:bodyPr wrap="square">
+            <a:spAutoFit/>
+          </a:bodyPr>
+          <a:lstStyle/>
+          <a:p>
+            <a:pPr algn="l">
+              <a:defRPr sz="900" b="0">
+                <a:solidFill>
+                  <a:srgbClr val="BDBDBD"/>
+                </a:solidFill>
+                <a:latin typeface="Calibri"/>
+              </a:defRPr>
+            </a:pPr>
+            <a:r>
+              <a:t>Post-chaos metrics overshoot, undershoot, or stabilise per strategy. Redis throughput varies 50-450% post-chaos; the asymmetry pattern is itself a placement fingerprint.</a:t>
+            </a:r>
+          </a:p>
+        </p:txBody>
+      </p:sp>
+      <p:sp>
+        <p:nvSpPr>
+          <p:cNvPr id="50" name="TextBox 49"/>
+          <p:cNvSpPr txBox="1"/>
+          <p:nvPr/>
+        </p:nvSpPr>
+        <p:spPr>
+          <a:xfrm>
+            <a:off x="548640" y="6446520"/>
+            <a:ext cx="11064240" cy="320040"/>
+          </a:xfrm>
+          <a:prstGeom prst="rect">
+            <a:avLst/>
+          </a:prstGeom>
+          <a:noFill/>
+        </p:spPr>
+        <p:txBody>
+          <a:bodyPr wrap="square">
+            <a:spAutoFit/>
+          </a:bodyPr>
+          <a:lstStyle/>
+          <a:p>
+            <a:pPr algn="ctr">
+              <a:defRPr sz="1000" b="0">
+                <a:solidFill>
+                  <a:srgbClr val="9090A0"/>
+                </a:solidFill>
+                <a:latin typeface="Calibri"/>
+              </a:defRPr>
+            </a:pPr>
+            <a:r>
+              <a:t>Each hypothesis is testable from ChaosProbe-collected metrics; the data column reports current evidence.</a:t>
             </a:r>
           </a:p>
         </p:txBody>
@@ -10400,11 +11743,11 @@
               </a:defRPr>
             </a:pPr>
             <a:r>
-              <a:t>• Sparrow (Ousterhout et al., 2013)</a:t>
+              <a:t>• DeathStarBench (Gan et al., 2019)</a:t>
             </a:r>
             <a:br/>
             <a:r>
-              <a:t>  Decentralized random scheduling</a:t>
+              <a:t>  Dependency-graph-aware placement</a:t>
             </a:r>
           </a:p>
           <a:p>
@@ -10423,11 +11766,11 @@
               </a:defRPr>
             </a:pPr>
             <a:r>
-              <a:t>• DeathStarBench (Gan et al., 2019)</a:t>
+              <a:t>• Mars (2011); Delimitrou (2014)</a:t>
             </a:r>
             <a:br/>
             <a:r>
-              <a:t>  Dependency-graph-aware placement</a:t>
+              <a:t>  Contention-aware co-scheduling</a:t>
             </a:r>
           </a:p>
           <a:p>
@@ -10446,11 +11789,11 @@
               </a:defRPr>
             </a:pPr>
             <a:r>
-              <a:t>• Mars (2011); Delimitrou (2014)</a:t>
+              <a:t>• Liu et al. (arXiv 2507.16109, 2025)</a:t>
             </a:r>
             <a:br/>
             <a:r>
-              <a:t>  Contention-aware co-scheduling</a:t>
+              <a:t>  Cloud-edge placement under churn</a:t>
             </a:r>
           </a:p>
         </p:txBody>
@@ -10642,11 +11985,11 @@
               </a:defRPr>
             </a:pPr>
             <a:r>
-              <a:t>• Gremlin — fault injection SaaS</a:t>
+              <a:t>• Mutiny! K8s churn injection</a:t>
             </a:r>
             <a:br/>
             <a:r>
-              <a:t>  Commercial chaos platform</a:t>
+              <a:t>  (DSN 2024) — closest peer</a:t>
             </a:r>
           </a:p>
           <a:p>
@@ -16109,7 +17452,7 @@
             </a:r>
             <a:br/>
             <a:r>
-              <a:t>2 GiB</a:t>
+              <a:t>4 GiB</a:t>
             </a:r>
           </a:p>
         </p:txBody>
@@ -16230,7 +17573,7 @@
             </a:r>
             <a:br/>
             <a:r>
-              <a:t>2 GiB</a:t>
+              <a:t>4 GiB</a:t>
             </a:r>
           </a:p>
         </p:txBody>
@@ -16508,7 +17851,7 @@
               </a:defRPr>
             </a:pPr>
             <a:r>
-              <a:t>K8s v1.28.6 • Calico CNI • containerd 1.7.11 • Total: 10 vCPU, 14 GiB</a:t>
+              <a:t>K8s v1.28.6 • Calico CNI • containerd 1.7.11 • Total: 10 vCPU, 18 GiB</a:t>
             </a:r>
           </a:p>
         </p:txBody>
@@ -22673,30 +24016,75 @@
           </a:p>
         </p:txBody>
       </p:sp>
-      <p:pic>
-        <p:nvPicPr>
-          <p:cNvPr id="4" name="Picture 3" descr="resilience_scores.png"/>
-          <p:cNvPicPr>
-            <a:picLocks noChangeAspect="1"/>
-          </p:cNvPicPr>
-          <p:nvPr/>
-        </p:nvPicPr>
-        <p:blipFill>
-          <a:blip r:embed="rId2"/>
-          <a:stretch>
-            <a:fillRect/>
-          </a:stretch>
-        </p:blipFill>
+      <p:sp>
+        <p:nvSpPr>
+          <p:cNvPr id="4" name="Rounded Rectangle 3"/>
+          <p:cNvSpPr/>
+          <p:nvPr/>
+        </p:nvSpPr>
         <p:spPr>
           <a:xfrm>
             <a:off x="457200" y="1280160"/>
             <a:ext cx="6858000" cy="4114800"/>
           </a:xfrm>
-          <a:prstGeom prst="rect">
-            <a:avLst/>
-          </a:prstGeom>
-        </p:spPr>
-      </p:pic>
+          <a:prstGeom prst="roundRect">
+            <a:avLst/>
+          </a:prstGeom>
+          <a:solidFill>
+            <a:srgbClr val="121222"/>
+          </a:solidFill>
+          <a:ln w="12700">
+            <a:solidFill>
+              <a:srgbClr val="9090A0"/>
+            </a:solidFill>
+          </a:ln>
+        </p:spPr>
+        <p:style>
+          <a:lnRef idx="1">
+            <a:schemeClr val="accent1"/>
+          </a:lnRef>
+          <a:fillRef idx="3">
+            <a:schemeClr val="accent1"/>
+          </a:fillRef>
+          <a:effectRef idx="2">
+            <a:schemeClr val="accent1"/>
+          </a:effectRef>
+          <a:fontRef idx="minor">
+            <a:schemeClr val="lt1"/>
+          </a:fontRef>
+        </p:style>
+        <p:txBody>
+          <a:bodyPr rtlCol="0" anchor="ctr" wrap="square" lIns="50800" rIns="50800" tIns="25400" bIns="25400"/>
+          <a:lstStyle/>
+          <a:p>
+            <a:pPr algn="ctr">
+              <a:defRPr sz="1100" b="0">
+                <a:solidFill>
+                  <a:srgbClr val="9090A0"/>
+                </a:solidFill>
+                <a:latin typeface="Calibri"/>
+              </a:defRPr>
+            </a:pPr>
+            <a:r>
+              <a:t>[Resilience Scores by Strategy]</a:t>
+            </a:r>
+            <a:br/>
+            <a:br/>
+            <a:r>
+              <a:t>Bar chart showing resilience score (0–100%)</a:t>
+            </a:r>
+            <a:br/>
+            <a:r>
+              <a:t>per placement strategy.</a:t>
+            </a:r>
+            <a:br/>
+            <a:br/>
+            <a:r>
+              <a:t>Generated by: chaosprobe visualize</a:t>
+            </a:r>
+          </a:p>
+        </p:txBody>
+      </p:sp>
       <p:sp>
         <p:nvSpPr>
           <p:cNvPr id="5" name="Rounded Rectangle 4"/>

</xml_diff>

<commit_message>
docs(presentation): restructure thesis around primary metrics (M1-M4)
Rebuild the hypothesis set and results emphasis so the thesis rests on the
reproducible primary-source metrics, not the non-reproducible resilience score:

- Slide 3 hypotheses reordered metric-first: M1 conntrack flush (spread/default
  36-39% vs colocate -1.6%, 12/12 runs), M2 CPU throttling inversion (colocate
  1.54 < default 1.90 < spread 1.94, 11/13), M3 'spread is safer' refuted at the
  metric level, M4 score decoupled from the metrics; S1 fault-class gating and
  S2 application-bound recovery as supporting claims.
- Demote the resilience score: slide 9 retitled 'Why the Score Is Demoted (M4)';
  slide 11 elevated to 'Primary Metrics: Conntrack & CPU (M1, M2)' with conntrack
  as the headline dependent variable; discussion boxes tagged M1-M4.
- Script narration rewritten to walk M1->M4->S1/S2 and lead the results with the
  conntrack signal in place of the score.

Regenerate ChaosProbe_Presentation.pptx.
</commit_message>
<xml_diff>
--- a/ChaosProbe_Presentation.pptx
+++ b/ChaosProbe_Presentation.pptx
@@ -3602,7 +3602,7 @@
               </a:defRPr>
             </a:pPr>
             <a:r>
-              <a:t>Recovery is application-bound (H6)</a:t>
+              <a:t>Recovery is application-bound (S2)</a:t>
             </a:r>
           </a:p>
         </p:txBody>
@@ -3775,7 +3775,7 @@
               </a:defRPr>
             </a:pPr>
             <a:r>
-              <a:t>The fault signal is in the tail (H5)</a:t>
+              <a:t>The fault signal is in the tail</a:t>
             </a:r>
           </a:p>
         </p:txBody>
@@ -3929,7 +3929,7 @@
               </a:defRPr>
             </a:pPr>
             <a:r>
-              <a:t>Results — Resources &amp; Throughput</a:t>
+              <a:t>Results — Primary Metrics: Conntrack &amp; CPU (M1, M2)</a:t>
             </a:r>
           </a:p>
         </p:txBody>
@@ -4173,7 +4173,7 @@
               </a:defRPr>
             </a:pPr>
             <a:r>
-              <a:t>Throttling inverts the model (H4)</a:t>
+              <a:t>M2 — co-location lowers CPU contention</a:t>
             </a:r>
           </a:p>
         </p:txBody>
@@ -4342,7 +4342,7 @@
               </a:defRPr>
             </a:pPr>
             <a:r>
-              <a:t>Churn flushes conn-state (H3)</a:t>
+              <a:t>M1 — spreading flushes conn-state</a:t>
             </a:r>
           </a:p>
         </p:txBody>
@@ -4384,11 +4384,11 @@
               </a:defRPr>
             </a:pPr>
             <a:r>
-              <a:t>• Spread flushes 28–52% of node conntrack entries</a:t>
+              <a:t>• Spread/default flush 36–39% of node conntrack</a:t>
             </a:r>
             <a:br/>
             <a:r>
-              <a:t>  during churn; colocate stays flat (−15% to +3%)</a:t>
+              <a:t>  entries during churn; colocate stays flat (−1.6%)</a:t>
             </a:r>
           </a:p>
           <a:p>
@@ -4407,7 +4407,11 @@
               </a:defRPr>
             </a:pPr>
             <a:r>
-              <a:t>• Reproducible in all 12 runs measured</a:t>
+              <a:t>• Reproducible in all 12 runs measured — the primary,</a:t>
+            </a:r>
+            <a:br/>
+            <a:r>
+              <a:t>  large-effect fault-response metric</a:t>
             </a:r>
           </a:p>
           <a:p>
@@ -4430,7 +4434,7 @@
             </a:r>
             <a:br/>
             <a:r>
-              <a:t>  tears down — the mechanism behind the score noise</a:t>
+              <a:t>  tears down — both metrics favour co-location (M3)</a:t>
             </a:r>
           </a:p>
         </p:txBody>
@@ -5405,7 +5409,7 @@
               </a:defRPr>
             </a:pPr>
             <a:r>
-              <a:t>Score is the wrong instrument</a:t>
+              <a:t>M4 — score is the wrong instrument</a:t>
             </a:r>
           </a:p>
         </p:txBody>
@@ -5522,7 +5526,7 @@
               </a:defRPr>
             </a:pPr>
             <a:r>
-              <a:t>Mechanism layer reproduces</a:t>
+              <a:t>M1/M2 — metrics reproduce</a:t>
             </a:r>
           </a:p>
         </p:txBody>
@@ -5639,7 +5643,7 @@
               </a:defRPr>
             </a:pPr>
             <a:r>
-              <a:t>Churn-driven, not contention</a:t>
+              <a:t>M3 — churn-driven, not contention</a:t>
             </a:r>
           </a:p>
         </p:txBody>
@@ -9398,13 +9402,13 @@
             <a:pPr algn="l">
               <a:defRPr sz="1100" b="1">
                 <a:solidFill>
-                  <a:srgbClr val="0096D6"/>
-                </a:solidFill>
-                <a:latin typeface="Calibri"/>
-              </a:defRPr>
-            </a:pPr>
-            <a:r>
-              <a:t>Framework</a:t>
+                  <a:srgbClr val="E74C3C"/>
+                </a:solidFill>
+                <a:latin typeface="Calibri"/>
+              </a:defRPr>
+            </a:pPr>
+            <a:r>
+              <a:t>Primary results — metrics</a:t>
             </a:r>
           </a:p>
         </p:txBody>
@@ -9417,7 +9421,7 @@
         </p:nvSpPr>
         <p:spPr>
           <a:xfrm>
-            <a:off x="4160520" y="2331720"/>
+            <a:off x="6080760" y="2331720"/>
             <a:ext cx="3657600" cy="228600"/>
           </a:xfrm>
           <a:prstGeom prst="rect">
@@ -9434,13 +9438,13 @@
             <a:pPr algn="l">
               <a:defRPr sz="1100" b="1">
                 <a:solidFill>
-                  <a:srgbClr val="E74C3C"/>
-                </a:solidFill>
-                <a:latin typeface="Calibri"/>
-              </a:defRPr>
-            </a:pPr>
-            <a:r>
-              <a:t>Mechanism (reproducible)</a:t>
+                  <a:srgbClr val="0096D6"/>
+                </a:solidFill>
+                <a:latin typeface="Calibri"/>
+              </a:defRPr>
+            </a:pPr>
+            <a:r>
+              <a:t>Methodology</a:t>
             </a:r>
           </a:p>
         </p:txBody>
@@ -9476,7 +9480,7 @@
               </a:defRPr>
             </a:pPr>
             <a:r>
-              <a:t>Tail &amp; recovery</a:t>
+              <a:t>Context &amp; support</a:t>
             </a:r>
           </a:p>
         </p:txBody>
@@ -9490,6 +9494,516 @@
         <p:spPr>
           <a:xfrm>
             <a:off x="320040" y="2651760"/>
+            <a:ext cx="1874519" cy="3383280"/>
+          </a:xfrm>
+          <a:prstGeom prst="roundRect">
+            <a:avLst/>
+          </a:prstGeom>
+          <a:solidFill>
+            <a:srgbClr val="121222"/>
+          </a:solidFill>
+          <a:ln w="25400">
+            <a:solidFill>
+              <a:srgbClr val="E74C3C"/>
+            </a:solidFill>
+          </a:ln>
+        </p:spPr>
+        <p:style>
+          <a:lnRef idx="1">
+            <a:schemeClr val="accent1"/>
+          </a:lnRef>
+          <a:fillRef idx="3">
+            <a:schemeClr val="accent1"/>
+          </a:fillRef>
+          <a:effectRef idx="2">
+            <a:schemeClr val="accent1"/>
+          </a:effectRef>
+          <a:fontRef idx="minor">
+            <a:schemeClr val="lt1"/>
+          </a:fontRef>
+        </p:style>
+        <p:txBody>
+          <a:bodyPr rtlCol="0" anchor="ctr"/>
+          <a:lstStyle/>
+          <a:p>
+            <a:pPr algn="ctr"/>
+          </a:p>
+        </p:txBody>
+      </p:sp>
+      <p:sp>
+        <p:nvSpPr>
+          <p:cNvPr id="10" name="Rounded Rectangle 9"/>
+          <p:cNvSpPr/>
+          <p:nvPr/>
+        </p:nvSpPr>
+        <p:spPr>
+          <a:xfrm>
+            <a:off x="320040" y="2651760"/>
+            <a:ext cx="1874519" cy="320040"/>
+          </a:xfrm>
+          <a:prstGeom prst="roundRect">
+            <a:avLst/>
+          </a:prstGeom>
+          <a:solidFill>
+            <a:srgbClr val="E74C3C"/>
+          </a:solidFill>
+          <a:ln>
+            <a:noFill/>
+          </a:ln>
+        </p:spPr>
+        <p:style>
+          <a:lnRef idx="1">
+            <a:schemeClr val="accent1"/>
+          </a:lnRef>
+          <a:fillRef idx="3">
+            <a:schemeClr val="accent1"/>
+          </a:fillRef>
+          <a:effectRef idx="2">
+            <a:schemeClr val="accent1"/>
+          </a:effectRef>
+          <a:fontRef idx="minor">
+            <a:schemeClr val="lt1"/>
+          </a:fontRef>
+        </p:style>
+        <p:txBody>
+          <a:bodyPr rtlCol="0" anchor="ctr" wrap="square" lIns="50800" rIns="50800" tIns="25400" bIns="25400"/>
+          <a:lstStyle/>
+          <a:p>
+            <a:pPr algn="ctr">
+              <a:defRPr sz="1300" b="1">
+                <a:solidFill>
+                  <a:srgbClr val="FFFFFF"/>
+                </a:solidFill>
+                <a:latin typeface="Calibri"/>
+              </a:defRPr>
+            </a:pPr>
+            <a:r>
+              <a:t>M1</a:t>
+            </a:r>
+          </a:p>
+        </p:txBody>
+      </p:sp>
+      <p:sp>
+        <p:nvSpPr>
+          <p:cNvPr id="11" name="TextBox 10"/>
+          <p:cNvSpPr txBox="1"/>
+          <p:nvPr/>
+        </p:nvSpPr>
+        <p:spPr>
+          <a:xfrm>
+            <a:off x="411479" y="3017520"/>
+            <a:ext cx="1691639" cy="365760"/>
+          </a:xfrm>
+          <a:prstGeom prst="rect">
+            <a:avLst/>
+          </a:prstGeom>
+          <a:noFill/>
+        </p:spPr>
+        <p:txBody>
+          <a:bodyPr wrap="square">
+            <a:spAutoFit/>
+          </a:bodyPr>
+          <a:lstStyle/>
+          <a:p>
+            <a:pPr algn="l">
+              <a:defRPr sz="1100" b="1">
+                <a:solidFill>
+                  <a:srgbClr val="E74C3C"/>
+                </a:solidFill>
+                <a:latin typeface="Calibri"/>
+              </a:defRPr>
+            </a:pPr>
+            <a:r>
+              <a:t>Spreading flushes conn-state</a:t>
+            </a:r>
+          </a:p>
+        </p:txBody>
+      </p:sp>
+      <p:sp>
+        <p:nvSpPr>
+          <p:cNvPr id="12" name="TextBox 11"/>
+          <p:cNvSpPr txBox="1"/>
+          <p:nvPr/>
+        </p:nvSpPr>
+        <p:spPr>
+          <a:xfrm>
+            <a:off x="411479" y="3429000"/>
+            <a:ext cx="1691639" cy="2514600"/>
+          </a:xfrm>
+          <a:prstGeom prst="rect">
+            <a:avLst/>
+          </a:prstGeom>
+          <a:noFill/>
+        </p:spPr>
+        <p:txBody>
+          <a:bodyPr wrap="square">
+            <a:spAutoFit/>
+          </a:bodyPr>
+          <a:lstStyle/>
+          <a:p>
+            <a:pPr algn="l">
+              <a:defRPr sz="900" b="0">
+                <a:solidFill>
+                  <a:srgbClr val="BDBDBD"/>
+                </a:solidFill>
+                <a:latin typeface="Calibri"/>
+              </a:defRPr>
+            </a:pPr>
+            <a:r>
+              <a:t>Primary metric. Under churn, spread/default flush 36-39% of node conntrack entries; colocate stays flat (−1.6%). 12/12 runs. The reproducible fault-response signal.</a:t>
+            </a:r>
+          </a:p>
+        </p:txBody>
+      </p:sp>
+      <p:sp>
+        <p:nvSpPr>
+          <p:cNvPr id="13" name="Rounded Rectangle 12"/>
+          <p:cNvSpPr/>
+          <p:nvPr/>
+        </p:nvSpPr>
+        <p:spPr>
+          <a:xfrm>
+            <a:off x="2240279" y="2651760"/>
+            <a:ext cx="1874519" cy="3383280"/>
+          </a:xfrm>
+          <a:prstGeom prst="roundRect">
+            <a:avLst/>
+          </a:prstGeom>
+          <a:solidFill>
+            <a:srgbClr val="121222"/>
+          </a:solidFill>
+          <a:ln w="25400">
+            <a:solidFill>
+              <a:srgbClr val="E74C3C"/>
+            </a:solidFill>
+          </a:ln>
+        </p:spPr>
+        <p:style>
+          <a:lnRef idx="1">
+            <a:schemeClr val="accent1"/>
+          </a:lnRef>
+          <a:fillRef idx="3">
+            <a:schemeClr val="accent1"/>
+          </a:fillRef>
+          <a:effectRef idx="2">
+            <a:schemeClr val="accent1"/>
+          </a:effectRef>
+          <a:fontRef idx="minor">
+            <a:schemeClr val="lt1"/>
+          </a:fontRef>
+        </p:style>
+        <p:txBody>
+          <a:bodyPr rtlCol="0" anchor="ctr"/>
+          <a:lstStyle/>
+          <a:p>
+            <a:pPr algn="ctr"/>
+          </a:p>
+        </p:txBody>
+      </p:sp>
+      <p:sp>
+        <p:nvSpPr>
+          <p:cNvPr id="14" name="Rounded Rectangle 13"/>
+          <p:cNvSpPr/>
+          <p:nvPr/>
+        </p:nvSpPr>
+        <p:spPr>
+          <a:xfrm>
+            <a:off x="2240279" y="2651760"/>
+            <a:ext cx="1874519" cy="320040"/>
+          </a:xfrm>
+          <a:prstGeom prst="roundRect">
+            <a:avLst/>
+          </a:prstGeom>
+          <a:solidFill>
+            <a:srgbClr val="E74C3C"/>
+          </a:solidFill>
+          <a:ln>
+            <a:noFill/>
+          </a:ln>
+        </p:spPr>
+        <p:style>
+          <a:lnRef idx="1">
+            <a:schemeClr val="accent1"/>
+          </a:lnRef>
+          <a:fillRef idx="3">
+            <a:schemeClr val="accent1"/>
+          </a:fillRef>
+          <a:effectRef idx="2">
+            <a:schemeClr val="accent1"/>
+          </a:effectRef>
+          <a:fontRef idx="minor">
+            <a:schemeClr val="lt1"/>
+          </a:fontRef>
+        </p:style>
+        <p:txBody>
+          <a:bodyPr rtlCol="0" anchor="ctr" wrap="square" lIns="50800" rIns="50800" tIns="25400" bIns="25400"/>
+          <a:lstStyle/>
+          <a:p>
+            <a:pPr algn="ctr">
+              <a:defRPr sz="1300" b="1">
+                <a:solidFill>
+                  <a:srgbClr val="FFFFFF"/>
+                </a:solidFill>
+                <a:latin typeface="Calibri"/>
+              </a:defRPr>
+            </a:pPr>
+            <a:r>
+              <a:t>M2</a:t>
+            </a:r>
+          </a:p>
+        </p:txBody>
+      </p:sp>
+      <p:sp>
+        <p:nvSpPr>
+          <p:cNvPr id="15" name="TextBox 14"/>
+          <p:cNvSpPr txBox="1"/>
+          <p:nvPr/>
+        </p:nvSpPr>
+        <p:spPr>
+          <a:xfrm>
+            <a:off x="2331720" y="3017520"/>
+            <a:ext cx="1691639" cy="365760"/>
+          </a:xfrm>
+          <a:prstGeom prst="rect">
+            <a:avLst/>
+          </a:prstGeom>
+          <a:noFill/>
+        </p:spPr>
+        <p:txBody>
+          <a:bodyPr wrap="square">
+            <a:spAutoFit/>
+          </a:bodyPr>
+          <a:lstStyle/>
+          <a:p>
+            <a:pPr algn="l">
+              <a:defRPr sz="1100" b="1">
+                <a:solidFill>
+                  <a:srgbClr val="E74C3C"/>
+                </a:solidFill>
+                <a:latin typeface="Calibri"/>
+              </a:defRPr>
+            </a:pPr>
+            <a:r>
+              <a:t>Co-location lowers CPU contention</a:t>
+            </a:r>
+          </a:p>
+        </p:txBody>
+      </p:sp>
+      <p:sp>
+        <p:nvSpPr>
+          <p:cNvPr id="16" name="TextBox 15"/>
+          <p:cNvSpPr txBox="1"/>
+          <p:nvPr/>
+        </p:nvSpPr>
+        <p:spPr>
+          <a:xfrm>
+            <a:off x="2331720" y="3429000"/>
+            <a:ext cx="1691639" cy="2514600"/>
+          </a:xfrm>
+          <a:prstGeom prst="rect">
+            <a:avLst/>
+          </a:prstGeom>
+          <a:noFill/>
+        </p:spPr>
+        <p:txBody>
+          <a:bodyPr wrap="square">
+            <a:spAutoFit/>
+          </a:bodyPr>
+          <a:lstStyle/>
+          <a:p>
+            <a:pPr algn="l">
+              <a:defRPr sz="900" b="0">
+                <a:solidFill>
+                  <a:srgbClr val="BDBDBD"/>
+                </a:solidFill>
+                <a:latin typeface="Calibri"/>
+              </a:defRPr>
+            </a:pPr>
+            <a:r>
+              <a:t>Colocate throttles LEAST (median 1.54 vs default 1.90, spread 1.94) and has the lowest CPU usage/pressure. 11/13 runs. Contention does not scale with density under churn.</a:t>
+            </a:r>
+          </a:p>
+        </p:txBody>
+      </p:sp>
+      <p:sp>
+        <p:nvSpPr>
+          <p:cNvPr id="17" name="Rounded Rectangle 16"/>
+          <p:cNvSpPr/>
+          <p:nvPr/>
+        </p:nvSpPr>
+        <p:spPr>
+          <a:xfrm>
+            <a:off x="4160519" y="2651760"/>
+            <a:ext cx="1874519" cy="3383280"/>
+          </a:xfrm>
+          <a:prstGeom prst="roundRect">
+            <a:avLst/>
+          </a:prstGeom>
+          <a:solidFill>
+            <a:srgbClr val="121222"/>
+          </a:solidFill>
+          <a:ln w="25400">
+            <a:solidFill>
+              <a:srgbClr val="E74C3C"/>
+            </a:solidFill>
+          </a:ln>
+        </p:spPr>
+        <p:style>
+          <a:lnRef idx="1">
+            <a:schemeClr val="accent1"/>
+          </a:lnRef>
+          <a:fillRef idx="3">
+            <a:schemeClr val="accent1"/>
+          </a:fillRef>
+          <a:effectRef idx="2">
+            <a:schemeClr val="accent1"/>
+          </a:effectRef>
+          <a:fontRef idx="minor">
+            <a:schemeClr val="lt1"/>
+          </a:fontRef>
+        </p:style>
+        <p:txBody>
+          <a:bodyPr rtlCol="0" anchor="ctr"/>
+          <a:lstStyle/>
+          <a:p>
+            <a:pPr algn="ctr"/>
+          </a:p>
+        </p:txBody>
+      </p:sp>
+      <p:sp>
+        <p:nvSpPr>
+          <p:cNvPr id="18" name="Rounded Rectangle 17"/>
+          <p:cNvSpPr/>
+          <p:nvPr/>
+        </p:nvSpPr>
+        <p:spPr>
+          <a:xfrm>
+            <a:off x="4160519" y="2651760"/>
+            <a:ext cx="1874519" cy="320040"/>
+          </a:xfrm>
+          <a:prstGeom prst="roundRect">
+            <a:avLst/>
+          </a:prstGeom>
+          <a:solidFill>
+            <a:srgbClr val="E74C3C"/>
+          </a:solidFill>
+          <a:ln>
+            <a:noFill/>
+          </a:ln>
+        </p:spPr>
+        <p:style>
+          <a:lnRef idx="1">
+            <a:schemeClr val="accent1"/>
+          </a:lnRef>
+          <a:fillRef idx="3">
+            <a:schemeClr val="accent1"/>
+          </a:fillRef>
+          <a:effectRef idx="2">
+            <a:schemeClr val="accent1"/>
+          </a:effectRef>
+          <a:fontRef idx="minor">
+            <a:schemeClr val="lt1"/>
+          </a:fontRef>
+        </p:style>
+        <p:txBody>
+          <a:bodyPr rtlCol="0" anchor="ctr" wrap="square" lIns="50800" rIns="50800" tIns="25400" bIns="25400"/>
+          <a:lstStyle/>
+          <a:p>
+            <a:pPr algn="ctr">
+              <a:defRPr sz="1300" b="1">
+                <a:solidFill>
+                  <a:srgbClr val="FFFFFF"/>
+                </a:solidFill>
+                <a:latin typeface="Calibri"/>
+              </a:defRPr>
+            </a:pPr>
+            <a:r>
+              <a:t>M3</a:t>
+            </a:r>
+          </a:p>
+        </p:txBody>
+      </p:sp>
+      <p:sp>
+        <p:nvSpPr>
+          <p:cNvPr id="19" name="TextBox 18"/>
+          <p:cNvSpPr txBox="1"/>
+          <p:nvPr/>
+        </p:nvSpPr>
+        <p:spPr>
+          <a:xfrm>
+            <a:off x="4251959" y="3017520"/>
+            <a:ext cx="1691639" cy="365760"/>
+          </a:xfrm>
+          <a:prstGeom prst="rect">
+            <a:avLst/>
+          </a:prstGeom>
+          <a:noFill/>
+        </p:spPr>
+        <p:txBody>
+          <a:bodyPr wrap="square">
+            <a:spAutoFit/>
+          </a:bodyPr>
+          <a:lstStyle/>
+          <a:p>
+            <a:pPr algn="l">
+              <a:defRPr sz="1100" b="1">
+                <a:solidFill>
+                  <a:srgbClr val="E74C3C"/>
+                </a:solidFill>
+                <a:latin typeface="Calibri"/>
+              </a:defRPr>
+            </a:pPr>
+            <a:r>
+              <a:t>'Spread is safer' is refuted</a:t>
+            </a:r>
+          </a:p>
+        </p:txBody>
+      </p:sp>
+      <p:sp>
+        <p:nvSpPr>
+          <p:cNvPr id="20" name="TextBox 19"/>
+          <p:cNvSpPr txBox="1"/>
+          <p:nvPr/>
+        </p:nvSpPr>
+        <p:spPr>
+          <a:xfrm>
+            <a:off x="4251959" y="3429000"/>
+            <a:ext cx="1691639" cy="2514600"/>
+          </a:xfrm>
+          <a:prstGeom prst="rect">
+            <a:avLst/>
+          </a:prstGeom>
+          <a:noFill/>
+        </p:spPr>
+        <p:txBody>
+          <a:bodyPr wrap="square">
+            <a:spAutoFit/>
+          </a:bodyPr>
+          <a:lstStyle/>
+          <a:p>
+            <a:pPr algn="l">
+              <a:defRPr sz="900" b="0">
+                <a:solidFill>
+                  <a:srgbClr val="BDBDBD"/>
+                </a:solidFill>
+                <a:latin typeface="Calibri"/>
+              </a:defRPr>
+            </a:pPr>
+            <a:r>
+              <a:t>Both reproducible metrics favour co-location under churn. The literature's spread-isolation prescription is refuted at the metric level — not merely unmeasurable on the score.</a:t>
+            </a:r>
+          </a:p>
+        </p:txBody>
+      </p:sp>
+      <p:sp>
+        <p:nvSpPr>
+          <p:cNvPr id="21" name="Rounded Rectangle 20"/>
+          <p:cNvSpPr/>
+          <p:nvPr/>
+        </p:nvSpPr>
+        <p:spPr>
+          <a:xfrm>
+            <a:off x="6080759" y="2651760"/>
             <a:ext cx="1874519" cy="3383280"/>
           </a:xfrm>
           <a:prstGeom prst="roundRect">
@@ -9528,13 +10042,13 @@
       </p:sp>
       <p:sp>
         <p:nvSpPr>
-          <p:cNvPr id="10" name="Rounded Rectangle 9"/>
+          <p:cNvPr id="22" name="Rounded Rectangle 21"/>
           <p:cNvSpPr/>
           <p:nvPr/>
         </p:nvSpPr>
         <p:spPr>
           <a:xfrm>
-            <a:off x="320040" y="2651760"/>
+            <a:off x="6080759" y="2651760"/>
             <a:ext cx="1874519" cy="320040"/>
           </a:xfrm>
           <a:prstGeom prst="roundRect">
@@ -9574,20 +10088,20 @@
               </a:defRPr>
             </a:pPr>
             <a:r>
-              <a:t>H1</a:t>
-            </a:r>
-          </a:p>
-        </p:txBody>
-      </p:sp>
-      <p:sp>
-        <p:nvSpPr>
-          <p:cNvPr id="11" name="TextBox 10"/>
+              <a:t>M4</a:t>
+            </a:r>
+          </a:p>
+        </p:txBody>
+      </p:sp>
+      <p:sp>
+        <p:nvSpPr>
+          <p:cNvPr id="23" name="TextBox 22"/>
           <p:cNvSpPr txBox="1"/>
           <p:nvPr/>
         </p:nvSpPr>
         <p:spPr>
           <a:xfrm>
-            <a:off x="411479" y="3017520"/>
+            <a:off x="6172199" y="3017520"/>
             <a:ext cx="1691639" cy="365760"/>
           </a:xfrm>
           <a:prstGeom prst="rect">
@@ -9610,20 +10124,20 @@
               </a:defRPr>
             </a:pPr>
             <a:r>
-              <a:t>Fault class gates placement effect</a:t>
-            </a:r>
-          </a:p>
-        </p:txBody>
-      </p:sp>
-      <p:sp>
-        <p:nvSpPr>
-          <p:cNvPr id="12" name="TextBox 11"/>
+              <a:t>Score decoupled from metrics</a:t>
+            </a:r>
+          </a:p>
+        </p:txBody>
+      </p:sp>
+      <p:sp>
+        <p:nvSpPr>
+          <p:cNvPr id="24" name="TextBox 23"/>
           <p:cNvSpPr txBox="1"/>
           <p:nvPr/>
         </p:nvSpPr>
         <p:spPr>
           <a:xfrm>
-            <a:off x="411479" y="3429000"/>
+            <a:off x="6172199" y="3429000"/>
             <a:ext cx="1691639" cy="2514600"/>
           </a:xfrm>
           <a:prstGeom prst="rect">
@@ -9646,517 +10160,7 @@
               </a:defRPr>
             </a:pPr>
             <a:r>
-              <a:t>Contention (cpu-hog) yields identical resilience across all strategies (100, σ0); churn (pod-delete) differentiates them. Whether placement matters is conditional on fault class.</a:t>
-            </a:r>
-          </a:p>
-        </p:txBody>
-      </p:sp>
-      <p:sp>
-        <p:nvSpPr>
-          <p:cNvPr id="13" name="Rounded Rectangle 12"/>
-          <p:cNvSpPr/>
-          <p:nvPr/>
-        </p:nvSpPr>
-        <p:spPr>
-          <a:xfrm>
-            <a:off x="2240279" y="2651760"/>
-            <a:ext cx="1874519" cy="3383280"/>
-          </a:xfrm>
-          <a:prstGeom prst="roundRect">
-            <a:avLst/>
-          </a:prstGeom>
-          <a:solidFill>
-            <a:srgbClr val="121222"/>
-          </a:solidFill>
-          <a:ln w="25400">
-            <a:solidFill>
-              <a:srgbClr val="0096D6"/>
-            </a:solidFill>
-          </a:ln>
-        </p:spPr>
-        <p:style>
-          <a:lnRef idx="1">
-            <a:schemeClr val="accent1"/>
-          </a:lnRef>
-          <a:fillRef idx="3">
-            <a:schemeClr val="accent1"/>
-          </a:fillRef>
-          <a:effectRef idx="2">
-            <a:schemeClr val="accent1"/>
-          </a:effectRef>
-          <a:fontRef idx="minor">
-            <a:schemeClr val="lt1"/>
-          </a:fontRef>
-        </p:style>
-        <p:txBody>
-          <a:bodyPr rtlCol="0" anchor="ctr"/>
-          <a:lstStyle/>
-          <a:p>
-            <a:pPr algn="ctr"/>
-          </a:p>
-        </p:txBody>
-      </p:sp>
-      <p:sp>
-        <p:nvSpPr>
-          <p:cNvPr id="14" name="Rounded Rectangle 13"/>
-          <p:cNvSpPr/>
-          <p:nvPr/>
-        </p:nvSpPr>
-        <p:spPr>
-          <a:xfrm>
-            <a:off x="2240279" y="2651760"/>
-            <a:ext cx="1874519" cy="320040"/>
-          </a:xfrm>
-          <a:prstGeom prst="roundRect">
-            <a:avLst/>
-          </a:prstGeom>
-          <a:solidFill>
-            <a:srgbClr val="0096D6"/>
-          </a:solidFill>
-          <a:ln>
-            <a:noFill/>
-          </a:ln>
-        </p:spPr>
-        <p:style>
-          <a:lnRef idx="1">
-            <a:schemeClr val="accent1"/>
-          </a:lnRef>
-          <a:fillRef idx="3">
-            <a:schemeClr val="accent1"/>
-          </a:fillRef>
-          <a:effectRef idx="2">
-            <a:schemeClr val="accent1"/>
-          </a:effectRef>
-          <a:fontRef idx="minor">
-            <a:schemeClr val="lt1"/>
-          </a:fontRef>
-        </p:style>
-        <p:txBody>
-          <a:bodyPr rtlCol="0" anchor="ctr" wrap="square" lIns="50800" rIns="50800" tIns="25400" bIns="25400"/>
-          <a:lstStyle/>
-          <a:p>
-            <a:pPr algn="ctr">
-              <a:defRPr sz="1300" b="1">
-                <a:solidFill>
-                  <a:srgbClr val="FFFFFF"/>
-                </a:solidFill>
-                <a:latin typeface="Calibri"/>
-              </a:defRPr>
-            </a:pPr>
-            <a:r>
-              <a:t>H2</a:t>
-            </a:r>
-          </a:p>
-        </p:txBody>
-      </p:sp>
-      <p:sp>
-        <p:nvSpPr>
-          <p:cNvPr id="15" name="TextBox 14"/>
-          <p:cNvSpPr txBox="1"/>
-          <p:nvPr/>
-        </p:nvSpPr>
-        <p:spPr>
-          <a:xfrm>
-            <a:off x="2331720" y="3017520"/>
-            <a:ext cx="1691639" cy="365760"/>
-          </a:xfrm>
-          <a:prstGeom prst="rect">
-            <a:avLst/>
-          </a:prstGeom>
-          <a:noFill/>
-        </p:spPr>
-        <p:txBody>
-          <a:bodyPr wrap="square">
-            <a:spAutoFit/>
-          </a:bodyPr>
-          <a:lstStyle/>
-          <a:p>
-            <a:pPr algn="l">
-              <a:defRPr sz="1100" b="1">
-                <a:solidFill>
-                  <a:srgbClr val="0096D6"/>
-                </a:solidFill>
-                <a:latin typeface="Calibri"/>
-              </a:defRPr>
-            </a:pPr>
-            <a:r>
-              <a:t>Aggregate score is too coarse</a:t>
-            </a:r>
-          </a:p>
-        </p:txBody>
-      </p:sp>
-      <p:sp>
-        <p:nvSpPr>
-          <p:cNvPr id="16" name="TextBox 15"/>
-          <p:cNvSpPr txBox="1"/>
-          <p:nvPr/>
-        </p:nvSpPr>
-        <p:spPr>
-          <a:xfrm>
-            <a:off x="2331720" y="3429000"/>
-            <a:ext cx="1691639" cy="2514600"/>
-          </a:xfrm>
-          <a:prstGeom prst="rect">
-            <a:avLst/>
-          </a:prstGeom>
-          <a:noFill/>
-        </p:spPr>
-        <p:txBody>
-          <a:bodyPr wrap="square">
-            <a:spAutoFit/>
-          </a:bodyPr>
-          <a:lstStyle/>
-          <a:p>
-            <a:pPr algn="l">
-              <a:defRPr sz="900" b="0">
-                <a:solidFill>
-                  <a:srgbClr val="BDBDBD"/>
-                </a:solidFill>
-                <a:latin typeface="Calibri"/>
-              </a:defRPr>
-            </a:pPr>
-            <a:r>
-              <a:t>The same strategy's resilience score ranges 33-89 across 13 runs (non-reproducible), while throttling and conntrack orderings stay stable. Mechanism metrics carry the signal.</a:t>
-            </a:r>
-          </a:p>
-        </p:txBody>
-      </p:sp>
-      <p:sp>
-        <p:nvSpPr>
-          <p:cNvPr id="17" name="Rounded Rectangle 16"/>
-          <p:cNvSpPr/>
-          <p:nvPr/>
-        </p:nvSpPr>
-        <p:spPr>
-          <a:xfrm>
-            <a:off x="4160519" y="2651760"/>
-            <a:ext cx="1874519" cy="3383280"/>
-          </a:xfrm>
-          <a:prstGeom prst="roundRect">
-            <a:avLst/>
-          </a:prstGeom>
-          <a:solidFill>
-            <a:srgbClr val="121222"/>
-          </a:solidFill>
-          <a:ln w="25400">
-            <a:solidFill>
-              <a:srgbClr val="E74C3C"/>
-            </a:solidFill>
-          </a:ln>
-        </p:spPr>
-        <p:style>
-          <a:lnRef idx="1">
-            <a:schemeClr val="accent1"/>
-          </a:lnRef>
-          <a:fillRef idx="3">
-            <a:schemeClr val="accent1"/>
-          </a:fillRef>
-          <a:effectRef idx="2">
-            <a:schemeClr val="accent1"/>
-          </a:effectRef>
-          <a:fontRef idx="minor">
-            <a:schemeClr val="lt1"/>
-          </a:fontRef>
-        </p:style>
-        <p:txBody>
-          <a:bodyPr rtlCol="0" anchor="ctr"/>
-          <a:lstStyle/>
-          <a:p>
-            <a:pPr algn="ctr"/>
-          </a:p>
-        </p:txBody>
-      </p:sp>
-      <p:sp>
-        <p:nvSpPr>
-          <p:cNvPr id="18" name="Rounded Rectangle 17"/>
-          <p:cNvSpPr/>
-          <p:nvPr/>
-        </p:nvSpPr>
-        <p:spPr>
-          <a:xfrm>
-            <a:off x="4160519" y="2651760"/>
-            <a:ext cx="1874519" cy="320040"/>
-          </a:xfrm>
-          <a:prstGeom prst="roundRect">
-            <a:avLst/>
-          </a:prstGeom>
-          <a:solidFill>
-            <a:srgbClr val="E74C3C"/>
-          </a:solidFill>
-          <a:ln>
-            <a:noFill/>
-          </a:ln>
-        </p:spPr>
-        <p:style>
-          <a:lnRef idx="1">
-            <a:schemeClr val="accent1"/>
-          </a:lnRef>
-          <a:fillRef idx="3">
-            <a:schemeClr val="accent1"/>
-          </a:fillRef>
-          <a:effectRef idx="2">
-            <a:schemeClr val="accent1"/>
-          </a:effectRef>
-          <a:fontRef idx="minor">
-            <a:schemeClr val="lt1"/>
-          </a:fontRef>
-        </p:style>
-        <p:txBody>
-          <a:bodyPr rtlCol="0" anchor="ctr" wrap="square" lIns="50800" rIns="50800" tIns="25400" bIns="25400"/>
-          <a:lstStyle/>
-          <a:p>
-            <a:pPr algn="ctr">
-              <a:defRPr sz="1300" b="1">
-                <a:solidFill>
-                  <a:srgbClr val="FFFFFF"/>
-                </a:solidFill>
-                <a:latin typeface="Calibri"/>
-              </a:defRPr>
-            </a:pPr>
-            <a:r>
-              <a:t>H3</a:t>
-            </a:r>
-          </a:p>
-        </p:txBody>
-      </p:sp>
-      <p:sp>
-        <p:nvSpPr>
-          <p:cNvPr id="19" name="TextBox 18"/>
-          <p:cNvSpPr txBox="1"/>
-          <p:nvPr/>
-        </p:nvSpPr>
-        <p:spPr>
-          <a:xfrm>
-            <a:off x="4251959" y="3017520"/>
-            <a:ext cx="1691639" cy="365760"/>
-          </a:xfrm>
-          <a:prstGeom prst="rect">
-            <a:avLst/>
-          </a:prstGeom>
-          <a:noFill/>
-        </p:spPr>
-        <p:txBody>
-          <a:bodyPr wrap="square">
-            <a:spAutoFit/>
-          </a:bodyPr>
-          <a:lstStyle/>
-          <a:p>
-            <a:pPr algn="l">
-              <a:defRPr sz="1100" b="1">
-                <a:solidFill>
-                  <a:srgbClr val="E74C3C"/>
-                </a:solidFill>
-                <a:latin typeface="Calibri"/>
-              </a:defRPr>
-            </a:pPr>
-            <a:r>
-              <a:t>Churn flushes cross-node conn-state</a:t>
-            </a:r>
-          </a:p>
-        </p:txBody>
-      </p:sp>
-      <p:sp>
-        <p:nvSpPr>
-          <p:cNvPr id="20" name="TextBox 19"/>
-          <p:cNvSpPr txBox="1"/>
-          <p:nvPr/>
-        </p:nvSpPr>
-        <p:spPr>
-          <a:xfrm>
-            <a:off x="4251959" y="3429000"/>
-            <a:ext cx="1691639" cy="2514600"/>
-          </a:xfrm>
-          <a:prstGeom prst="rect">
-            <a:avLst/>
-          </a:prstGeom>
-          <a:noFill/>
-        </p:spPr>
-        <p:txBody>
-          <a:bodyPr wrap="square">
-            <a:spAutoFit/>
-          </a:bodyPr>
-          <a:lstStyle/>
-          <a:p>
-            <a:pPr algn="l">
-              <a:defRPr sz="900" b="0">
-                <a:solidFill>
-                  <a:srgbClr val="BDBDBD"/>
-                </a:solidFill>
-                <a:latin typeface="Calibri"/>
-              </a:defRPr>
-            </a:pPr>
-            <a:r>
-              <a:t>Spread flushes 28-52% of conntrack entries during churn; colocate stays flat (−15% to +3%). Reproducible in all 12 runs measured. Spreading maximises the flows churn disrupts.</a:t>
-            </a:r>
-          </a:p>
-        </p:txBody>
-      </p:sp>
-      <p:sp>
-        <p:nvSpPr>
-          <p:cNvPr id="21" name="Rounded Rectangle 20"/>
-          <p:cNvSpPr/>
-          <p:nvPr/>
-        </p:nvSpPr>
-        <p:spPr>
-          <a:xfrm>
-            <a:off x="6080759" y="2651760"/>
-            <a:ext cx="1874519" cy="3383280"/>
-          </a:xfrm>
-          <a:prstGeom prst="roundRect">
-            <a:avLst/>
-          </a:prstGeom>
-          <a:solidFill>
-            <a:srgbClr val="121222"/>
-          </a:solidFill>
-          <a:ln w="25400">
-            <a:solidFill>
-              <a:srgbClr val="E74C3C"/>
-            </a:solidFill>
-          </a:ln>
-        </p:spPr>
-        <p:style>
-          <a:lnRef idx="1">
-            <a:schemeClr val="accent1"/>
-          </a:lnRef>
-          <a:fillRef idx="3">
-            <a:schemeClr val="accent1"/>
-          </a:fillRef>
-          <a:effectRef idx="2">
-            <a:schemeClr val="accent1"/>
-          </a:effectRef>
-          <a:fontRef idx="minor">
-            <a:schemeClr val="lt1"/>
-          </a:fontRef>
-        </p:style>
-        <p:txBody>
-          <a:bodyPr rtlCol="0" anchor="ctr"/>
-          <a:lstStyle/>
-          <a:p>
-            <a:pPr algn="ctr"/>
-          </a:p>
-        </p:txBody>
-      </p:sp>
-      <p:sp>
-        <p:nvSpPr>
-          <p:cNvPr id="22" name="Rounded Rectangle 21"/>
-          <p:cNvSpPr/>
-          <p:nvPr/>
-        </p:nvSpPr>
-        <p:spPr>
-          <a:xfrm>
-            <a:off x="6080759" y="2651760"/>
-            <a:ext cx="1874519" cy="320040"/>
-          </a:xfrm>
-          <a:prstGeom prst="roundRect">
-            <a:avLst/>
-          </a:prstGeom>
-          <a:solidFill>
-            <a:srgbClr val="E74C3C"/>
-          </a:solidFill>
-          <a:ln>
-            <a:noFill/>
-          </a:ln>
-        </p:spPr>
-        <p:style>
-          <a:lnRef idx="1">
-            <a:schemeClr val="accent1"/>
-          </a:lnRef>
-          <a:fillRef idx="3">
-            <a:schemeClr val="accent1"/>
-          </a:fillRef>
-          <a:effectRef idx="2">
-            <a:schemeClr val="accent1"/>
-          </a:effectRef>
-          <a:fontRef idx="minor">
-            <a:schemeClr val="lt1"/>
-          </a:fontRef>
-        </p:style>
-        <p:txBody>
-          <a:bodyPr rtlCol="0" anchor="ctr" wrap="square" lIns="50800" rIns="50800" tIns="25400" bIns="25400"/>
-          <a:lstStyle/>
-          <a:p>
-            <a:pPr algn="ctr">
-              <a:defRPr sz="1300" b="1">
-                <a:solidFill>
-                  <a:srgbClr val="FFFFFF"/>
-                </a:solidFill>
-                <a:latin typeface="Calibri"/>
-              </a:defRPr>
-            </a:pPr>
-            <a:r>
-              <a:t>H4</a:t>
-            </a:r>
-          </a:p>
-        </p:txBody>
-      </p:sp>
-      <p:sp>
-        <p:nvSpPr>
-          <p:cNvPr id="23" name="TextBox 22"/>
-          <p:cNvSpPr txBox="1"/>
-          <p:nvPr/>
-        </p:nvSpPr>
-        <p:spPr>
-          <a:xfrm>
-            <a:off x="6172199" y="3017520"/>
-            <a:ext cx="1691639" cy="365760"/>
-          </a:xfrm>
-          <a:prstGeom prst="rect">
-            <a:avLst/>
-          </a:prstGeom>
-          <a:noFill/>
-        </p:spPr>
-        <p:txBody>
-          <a:bodyPr wrap="square">
-            <a:spAutoFit/>
-          </a:bodyPr>
-          <a:lstStyle/>
-          <a:p>
-            <a:pPr algn="l">
-              <a:defRPr sz="1100" b="1">
-                <a:solidFill>
-                  <a:srgbClr val="E74C3C"/>
-                </a:solidFill>
-                <a:latin typeface="Calibri"/>
-              </a:defRPr>
-            </a:pPr>
-            <a:r>
-              <a:t>Throttling inverts contention model</a:t>
-            </a:r>
-          </a:p>
-        </p:txBody>
-      </p:sp>
-      <p:sp>
-        <p:nvSpPr>
-          <p:cNvPr id="24" name="TextBox 23"/>
-          <p:cNvSpPr txBox="1"/>
-          <p:nvPr/>
-        </p:nvSpPr>
-        <p:spPr>
-          <a:xfrm>
-            <a:off x="6172199" y="3429000"/>
-            <a:ext cx="1691639" cy="2514600"/>
-          </a:xfrm>
-          <a:prstGeom prst="rect">
-            <a:avLst/>
-          </a:prstGeom>
-          <a:noFill/>
-        </p:spPr>
-        <p:txBody>
-          <a:bodyPr wrap="square">
-            <a:spAutoFit/>
-          </a:bodyPr>
-          <a:lstStyle/>
-          <a:p>
-            <a:pPr algn="l">
-              <a:defRPr sz="900" b="0">
-                <a:solidFill>
-                  <a:srgbClr val="BDBDBD"/>
-                </a:solidFill>
-                <a:latin typeface="Calibri"/>
-              </a:defRPr>
-            </a:pPr>
-            <a:r>
-              <a:t>Densest packing (colocate, median 1.54) throttles less than default (1.90) and spread (1.94) under churn — holds in 11/13 runs. Inverts Bubble-Up's dense=more-contention prediction.</a:t>
+              <a:t>Where conntrack &amp; CPU reproduce (≥11/13), the resilience score does NOT (33-89 across runs). The binary-probe score is a lossy instrument; the metrics are the reliable outcome.</a:t>
             </a:r>
           </a:p>
         </p:txBody>
@@ -10254,7 +10258,7 @@
               </a:defRPr>
             </a:pPr>
             <a:r>
-              <a:t>H5</a:t>
+              <a:t>S1</a:t>
             </a:r>
           </a:p>
         </p:txBody>
@@ -10290,7 +10294,7 @@
               </a:defRPr>
             </a:pPr>
             <a:r>
-              <a:t>Fault signal is in the tail</a:t>
+              <a:t>Fault class gates the effect</a:t>
             </a:r>
           </a:p>
         </p:txBody>
@@ -10326,7 +10330,7 @@
               </a:defRPr>
             </a:pPr>
             <a:r>
-              <a:t>Targeted route during chaos: mean 231 ms but p95 619 / max 3334 ms; unaffected routes stay flat at 70-110 ms. Mean-based SLOs miss the fault (Dean &amp; Barroso, CACM 2013).</a:t>
+              <a:t>Contention (cpu-hog) yields identical resilience across all strategies (100, σ0); churn differentiates them. Whether placement matters is conditional on fault class.</a:t>
             </a:r>
           </a:p>
         </p:txBody>
@@ -10424,7 +10428,7 @@
               </a:defRPr>
             </a:pPr>
             <a:r>
-              <a:t>H6</a:t>
+              <a:t>S2</a:t>
             </a:r>
           </a:p>
         </p:txBody>
@@ -10496,7 +10500,7 @@
               </a:defRPr>
             </a:pPr>
             <a:r>
-              <a:t>scheduled→ready is 84-96% of recovery time; placement only touches the 4-16% deletion→scheduled term. Placement has little leverage over how fast a pod recovers.</a:t>
+              <a:t>scheduled→ready (app startup) is 84-96% of recovery; placement touches only the 4-16% scheduling term. Recovery is application-bound, not placement-bound.</a:t>
             </a:r>
           </a:p>
         </p:txBody>
@@ -23031,7 +23035,7 @@
               </a:defRPr>
             </a:pPr>
             <a:r>
-              <a:t>Results — Resilience Scores</a:t>
+              <a:t>Results — Why the Score Is Demoted (M4)</a:t>
             </a:r>
           </a:p>
         </p:txBody>
@@ -23402,7 +23406,7 @@
               </a:defRPr>
             </a:pPr>
             <a:r>
-              <a:t>What the aggregate score can adjudicate</a:t>
+              <a:t>M4 — the score is decoupled from the reproducible metrics</a:t>
             </a:r>
           </a:p>
         </p:txBody>

</xml_diff>

<commit_message>
docs(presentation): sync deck to post-review claims (H5 separator, H2 probe correction, H6 gradient)
</commit_message>
<xml_diff>
--- a/ChaosProbe_Presentation.pptx
+++ b/ChaosProbe_Presentation.pptx
@@ -3615,15 +3615,19 @@
               </a:defRPr>
             </a:pPr>
             <a:r>
-              <a:t>• Mechanistic reading: churn tears down</a:t>
+              <a:t>• Protocol probe: TCP dominates the table</a:t>
             </a:r>
             <a:br/>
             <a:r>
-              <a:t>  cross-node flows that must reconverge;</a:t>
+              <a:t>  and DROPS at the kill cycles under BOTH</a:t>
             </a:r>
             <a:br/>
             <a:r>
-              <a:t>  node-local paths are spared</a:t>
+              <a:t>  placements (−28% / −21%) — kernel-side</a:t>
+            </a:r>
+            <a:br/>
+            <a:r>
+              <a:t>  teardown; kube-proxy never flushes TCP</a:t>
             </a:r>
           </a:p>
           <a:p>
@@ -3642,6 +3646,33 @@
               </a:defRPr>
             </a:pPr>
             <a:r>
+              <a:t>• The placement-dependent component is</a:t>
+            </a:r>
+            <a:br/>
+            <a:r>
+              <a:t>  the UDP/DNS pool: ~4× larger under</a:t>
+            </a:r>
+            <a:br/>
+            <a:r>
+              <a:t>  spread (chaos-window medians 910 vs 224)</a:t>
+            </a:r>
+          </a:p>
+          <a:p>
+            <a:pPr>
+              <a:spcBef>
+                <a:spcPts val="200"/>
+              </a:spcBef>
+              <a:spcAft>
+                <a:spcPts val="200"/>
+              </a:spcAft>
+              <a:defRPr sz="1000">
+                <a:solidFill>
+                  <a:srgbClr val="BDBDBD"/>
+                </a:solidFill>
+                <a:latin typeface="Calibri"/>
+              </a:defRPr>
+            </a:pPr>
+            <a:r>
               <a:t>• Corroborating only: CPU throttling —</a:t>
             </a:r>
             <a:br/>
@@ -3731,7 +3762,7 @@
               </a:defRPr>
             </a:pPr>
             <a:r>
-              <a:t>H2 — a reconvergence signature, deliberately not attributed to a specific code path</a:t>
+              <a:t>H2 — attribution protocol-scoped by a dedicated conntrack-composition probe</a:t>
             </a:r>
           </a:p>
         </p:txBody>
@@ -3767,7 +3798,7 @@
               </a:defRPr>
             </a:pPr>
             <a:r>
-              <a:t>The flush is reported as a measured kernel/network reconvergence signature of the kill cycle. It is not attributed to kube-proxy's active conntrack-flush path: upstream that path is UDP-only, while this workload is TCP/gRPC — re-attribution of the exact mechanism is pending.</a:t>
+              <a:t>Both paths are visible: kernel TCP teardown (kube-proxy never flushes TCP) and kube-proxy's documented UDP-only cleanup, with more to clean under spread. The campaign's flush percentages (38.5% vs 2.7%, 7/7 sessions) remain statistically primary and are not apportioned between the two paths (probe: i = 1).</a:t>
             </a:r>
           </a:p>
         </p:txBody>
@@ -4751,7 +4782,7 @@
               </a:defRPr>
             </a:pPr>
             <a:r>
-              <a:t>H5 — cross-node call fraction predicts the east-west tail</a:t>
+              <a:t>H5 — cross-node fraction separates node-local from spreading</a:t>
             </a:r>
           </a:p>
         </p:txBody>
@@ -4766,7 +4797,7 @@
         </p:nvGraphicFramePr>
         <p:xfrm>
           <a:off x="6400800" y="1691640"/>
-          <a:ext cx="5120640" cy="2285997"/>
+          <a:ext cx="5120640" cy="2468880"/>
         </p:xfrm>
         <a:graphic>
           <a:graphicData uri="http://schemas.openxmlformats.org/drawingml/2006/table">
@@ -4775,11 +4806,13 @@
                 <a:tableStyleId>{5C22544A-7EE6-4342-B048-85BDC9FD1C3A}</a:tableStyleId>
               </a:tblPr>
               <a:tblGrid>
-                <a:gridCol w="1706880"/>
-                <a:gridCol w="1706880"/>
-                <a:gridCol w="1706880"/>
+                <a:gridCol w="1024128"/>
+                <a:gridCol w="1024128"/>
+                <a:gridCol w="1024128"/>
+                <a:gridCol w="1024128"/>
+                <a:gridCol w="1024128"/>
               </a:tblGrid>
-              <a:tr h="326571">
+              <a:tr h="274320">
                 <a:tc>
                   <a:txBody>
                     <a:bodyPr wrap="square"/>
@@ -4787,7 +4820,7 @@
                     <a:p>
                       <a:pPr algn="l"/>
                       <a:r>
-                        <a:rPr sz="900" b="1">
+                        <a:rPr sz="800" b="1">
                           <a:solidFill>
                             <a:srgbClr val="FFFFFF"/>
                           </a:solidFill>
@@ -4810,13 +4843,13 @@
                     <a:p>
                       <a:pPr algn="l"/>
                       <a:r>
-                        <a:rPr sz="900" b="1">
+                        <a:rPr sz="800" b="1">
                           <a:solidFill>
                             <a:srgbClr val="FFFFFF"/>
                           </a:solidFill>
                           <a:latin typeface="Calibri"/>
                         </a:rPr>
-                        <a:t>Cross-node fraction</a:t>
+                        <a:t>frac (B1)</a:t>
                       </a:r>
                     </a:p>
                   </a:txBody>
@@ -4833,13 +4866,59 @@
                     <a:p>
                       <a:pPr algn="l"/>
                       <a:r>
-                        <a:rPr sz="900" b="1">
+                        <a:rPr sz="800" b="1">
                           <a:solidFill>
                             <a:srgbClr val="FFFFFF"/>
                           </a:solidFill>
                           <a:latin typeface="Calibri"/>
                         </a:rPr>
-                        <a:t>East-west p95 (ms)</a:t>
+                        <a:t>EW p95 (B1)</a:t>
+                      </a:r>
+                    </a:p>
+                  </a:txBody>
+                  <a:tcPr marL="76200" marR="76200" marT="38100" marB="38100">
+                    <a:solidFill>
+                      <a:srgbClr val="2ECC71"/>
+                    </a:solidFill>
+                  </a:tcPr>
+                </a:tc>
+                <a:tc>
+                  <a:txBody>
+                    <a:bodyPr wrap="square"/>
+                    <a:lstStyle/>
+                    <a:p>
+                      <a:pPr algn="l"/>
+                      <a:r>
+                        <a:rPr sz="800" b="1">
+                          <a:solidFill>
+                            <a:srgbClr val="FFFFFF"/>
+                          </a:solidFill>
+                          <a:latin typeface="Calibri"/>
+                        </a:rPr>
+                        <a:t>frac (B2)</a:t>
+                      </a:r>
+                    </a:p>
+                  </a:txBody>
+                  <a:tcPr marL="76200" marR="76200" marT="38100" marB="38100">
+                    <a:solidFill>
+                      <a:srgbClr val="2ECC71"/>
+                    </a:solidFill>
+                  </a:tcPr>
+                </a:tc>
+                <a:tc>
+                  <a:txBody>
+                    <a:bodyPr wrap="square"/>
+                    <a:lstStyle/>
+                    <a:p>
+                      <a:pPr algn="l"/>
+                      <a:r>
+                        <a:rPr sz="800" b="1">
+                          <a:solidFill>
+                            <a:srgbClr val="FFFFFF"/>
+                          </a:solidFill>
+                          <a:latin typeface="Calibri"/>
+                        </a:rPr>
+                        <a:t>EW p95 (B2)</a:t>
                       </a:r>
                     </a:p>
                   </a:txBody>
@@ -4850,7 +4929,7 @@
                   </a:tcPr>
                 </a:tc>
               </a:tr>
-              <a:tr h="326571">
+              <a:tr h="274320">
                 <a:tc>
                   <a:txBody>
                     <a:bodyPr wrap="square"/>
@@ -4858,7 +4937,7 @@
                     <a:p>
                       <a:pPr algn="l"/>
                       <a:r>
-                        <a:rPr sz="900" b="0">
+                        <a:rPr sz="800" b="0">
                           <a:solidFill>
                             <a:srgbClr val="FFFFFF"/>
                           </a:solidFill>
@@ -4881,7 +4960,7 @@
                     <a:p>
                       <a:pPr algn="l"/>
                       <a:r>
-                        <a:rPr sz="900" b="0">
+                        <a:rPr sz="800" b="0">
                           <a:solidFill>
                             <a:srgbClr val="FFFFFF"/>
                           </a:solidFill>
@@ -4904,7 +4983,7 @@
                     <a:p>
                       <a:pPr algn="l"/>
                       <a:r>
-                        <a:rPr sz="900" b="0">
+                        <a:rPr sz="800" b="0">
                           <a:solidFill>
                             <a:srgbClr val="FFFFFF"/>
                           </a:solidFill>
@@ -4920,8 +4999,6 @@
                     </a:solidFill>
                   </a:tcPr>
                 </a:tc>
-              </a:tr>
-              <a:tr h="326571">
                 <a:tc>
                   <a:txBody>
                     <a:bodyPr wrap="square"/>
@@ -4929,7 +5006,55 @@
                     <a:p>
                       <a:pPr algn="l"/>
                       <a:r>
-                        <a:rPr sz="900" b="0">
+                        <a:rPr sz="800" b="0">
+                          <a:solidFill>
+                            <a:srgbClr val="FFFFFF"/>
+                          </a:solidFill>
+                          <a:latin typeface="Calibri"/>
+                        </a:rPr>
+                        <a:t>0.00</a:t>
+                      </a:r>
+                    </a:p>
+                  </a:txBody>
+                  <a:tcPr marL="76200" marR="76200" marT="38100" marB="38100">
+                    <a:solidFill>
+                      <a:srgbClr val="2A2A3E"/>
+                    </a:solidFill>
+                  </a:tcPr>
+                </a:tc>
+                <a:tc>
+                  <a:txBody>
+                    <a:bodyPr wrap="square"/>
+                    <a:lstStyle/>
+                    <a:p>
+                      <a:pPr algn="l"/>
+                      <a:r>
+                        <a:rPr sz="800" b="0">
+                          <a:solidFill>
+                            <a:srgbClr val="FFFFFF"/>
+                          </a:solidFill>
+                          <a:latin typeface="Calibri"/>
+                        </a:rPr>
+                        <a:t>33.2</a:t>
+                      </a:r>
+                    </a:p>
+                  </a:txBody>
+                  <a:tcPr marL="76200" marR="76200" marT="38100" marB="38100">
+                    <a:solidFill>
+                      <a:srgbClr val="2A2A3E"/>
+                    </a:solidFill>
+                  </a:tcPr>
+                </a:tc>
+              </a:tr>
+              <a:tr h="274320">
+                <a:tc>
+                  <a:txBody>
+                    <a:bodyPr wrap="square"/>
+                    <a:lstStyle/>
+                    <a:p>
+                      <a:pPr algn="l"/>
+                      <a:r>
+                        <a:rPr sz="800" b="0">
                           <a:solidFill>
                             <a:srgbClr val="FFFFFF"/>
                           </a:solidFill>
@@ -4952,7 +5077,7 @@
                     <a:p>
                       <a:pPr algn="l"/>
                       <a:r>
-                        <a:rPr sz="900" b="0">
+                        <a:rPr sz="800" b="0">
                           <a:solidFill>
                             <a:srgbClr val="FFFFFF"/>
                           </a:solidFill>
@@ -4975,7 +5100,7 @@
                     <a:p>
                       <a:pPr algn="l"/>
                       <a:r>
-                        <a:rPr sz="900" b="0">
+                        <a:rPr sz="800" b="0">
                           <a:solidFill>
                             <a:srgbClr val="FFFFFF"/>
                           </a:solidFill>
@@ -4991,8 +5116,6 @@
                     </a:solidFill>
                   </a:tcPr>
                 </a:tc>
-              </a:tr>
-              <a:tr h="326571">
                 <a:tc>
                   <a:txBody>
                     <a:bodyPr wrap="square"/>
@@ -5000,7 +5123,55 @@
                     <a:p>
                       <a:pPr algn="l"/>
                       <a:r>
-                        <a:rPr sz="900" b="0">
+                        <a:rPr sz="800" b="0">
+                          <a:solidFill>
+                            <a:srgbClr val="FFFFFF"/>
+                          </a:solidFill>
+                          <a:latin typeface="Calibri"/>
+                        </a:rPr>
+                        <a:t>0.00</a:t>
+                      </a:r>
+                    </a:p>
+                  </a:txBody>
+                  <a:tcPr marL="76200" marR="76200" marT="38100" marB="38100">
+                    <a:solidFill>
+                      <a:srgbClr val="2A2A3E"/>
+                    </a:solidFill>
+                  </a:tcPr>
+                </a:tc>
+                <a:tc>
+                  <a:txBody>
+                    <a:bodyPr wrap="square"/>
+                    <a:lstStyle/>
+                    <a:p>
+                      <a:pPr algn="l"/>
+                      <a:r>
+                        <a:rPr sz="800" b="0">
+                          <a:solidFill>
+                            <a:srgbClr val="FFFFFF"/>
+                          </a:solidFill>
+                          <a:latin typeface="Calibri"/>
+                        </a:rPr>
+                        <a:t>35.7</a:t>
+                      </a:r>
+                    </a:p>
+                  </a:txBody>
+                  <a:tcPr marL="76200" marR="76200" marT="38100" marB="38100">
+                    <a:solidFill>
+                      <a:srgbClr val="2A2A3E"/>
+                    </a:solidFill>
+                  </a:tcPr>
+                </a:tc>
+              </a:tr>
+              <a:tr h="274320">
+                <a:tc>
+                  <a:txBody>
+                    <a:bodyPr wrap="square"/>
+                    <a:lstStyle/>
+                    <a:p>
+                      <a:pPr algn="l"/>
+                      <a:r>
+                        <a:rPr sz="800" b="0">
                           <a:solidFill>
                             <a:srgbClr val="FFFFFF"/>
                           </a:solidFill>
@@ -5023,7 +5194,7 @@
                     <a:p>
                       <a:pPr algn="l"/>
                       <a:r>
-                        <a:rPr sz="900" b="0">
+                        <a:rPr sz="800" b="0">
                           <a:solidFill>
                             <a:srgbClr val="FFFFFF"/>
                           </a:solidFill>
@@ -5046,7 +5217,7 @@
                     <a:p>
                       <a:pPr algn="l"/>
                       <a:r>
-                        <a:rPr sz="900" b="0">
+                        <a:rPr sz="800" b="0">
                           <a:solidFill>
                             <a:srgbClr val="FFFFFF"/>
                           </a:solidFill>
@@ -5062,8 +5233,6 @@
                     </a:solidFill>
                   </a:tcPr>
                 </a:tc>
-              </a:tr>
-              <a:tr h="326571">
                 <a:tc>
                   <a:txBody>
                     <a:bodyPr wrap="square"/>
@@ -5071,7 +5240,55 @@
                     <a:p>
                       <a:pPr algn="l"/>
                       <a:r>
-                        <a:rPr sz="900" b="0">
+                        <a:rPr sz="800" b="0">
+                          <a:solidFill>
+                            <a:srgbClr val="FFFFFF"/>
+                          </a:solidFill>
+                          <a:latin typeface="Calibri"/>
+                        </a:rPr>
+                        <a:t>0.73</a:t>
+                      </a:r>
+                    </a:p>
+                  </a:txBody>
+                  <a:tcPr marL="76200" marR="76200" marT="38100" marB="38100">
+                    <a:solidFill>
+                      <a:srgbClr val="2A2A3E"/>
+                    </a:solidFill>
+                  </a:tcPr>
+                </a:tc>
+                <a:tc>
+                  <a:txBody>
+                    <a:bodyPr wrap="square"/>
+                    <a:lstStyle/>
+                    <a:p>
+                      <a:pPr algn="l"/>
+                      <a:r>
+                        <a:rPr sz="800" b="0">
+                          <a:solidFill>
+                            <a:srgbClr val="FFFFFF"/>
+                          </a:solidFill>
+                          <a:latin typeface="Calibri"/>
+                        </a:rPr>
+                        <a:t>43.8</a:t>
+                      </a:r>
+                    </a:p>
+                  </a:txBody>
+                  <a:tcPr marL="76200" marR="76200" marT="38100" marB="38100">
+                    <a:solidFill>
+                      <a:srgbClr val="2A2A3E"/>
+                    </a:solidFill>
+                  </a:tcPr>
+                </a:tc>
+              </a:tr>
+              <a:tr h="274320">
+                <a:tc>
+                  <a:txBody>
+                    <a:bodyPr wrap="square"/>
+                    <a:lstStyle/>
+                    <a:p>
+                      <a:pPr algn="l"/>
+                      <a:r>
+                        <a:rPr sz="800" b="0">
                           <a:solidFill>
                             <a:srgbClr val="FFFFFF"/>
                           </a:solidFill>
@@ -5094,7 +5311,7 @@
                     <a:p>
                       <a:pPr algn="l"/>
                       <a:r>
-                        <a:rPr sz="900" b="0">
+                        <a:rPr sz="800" b="0">
                           <a:solidFill>
                             <a:srgbClr val="FFFFFF"/>
                           </a:solidFill>
@@ -5117,7 +5334,7 @@
                     <a:p>
                       <a:pPr algn="l"/>
                       <a:r>
-                        <a:rPr sz="900" b="0">
+                        <a:rPr sz="800" b="0">
                           <a:solidFill>
                             <a:srgbClr val="FFFFFF"/>
                           </a:solidFill>
@@ -5133,8 +5350,6 @@
                     </a:solidFill>
                   </a:tcPr>
                 </a:tc>
-              </a:tr>
-              <a:tr h="326571">
                 <a:tc>
                   <a:txBody>
                     <a:bodyPr wrap="square"/>
@@ -5142,7 +5357,406 @@
                     <a:p>
                       <a:pPr algn="l"/>
                       <a:r>
-                        <a:rPr sz="900" b="0">
+                        <a:rPr sz="800" b="0">
+                          <a:solidFill>
+                            <a:srgbClr val="FFFFFF"/>
+                          </a:solidFill>
+                          <a:latin typeface="Calibri"/>
+                        </a:rPr>
+                        <a:t>0.73</a:t>
+                      </a:r>
+                    </a:p>
+                  </a:txBody>
+                  <a:tcPr marL="76200" marR="76200" marT="38100" marB="38100">
+                    <a:solidFill>
+                      <a:srgbClr val="2A2A3E"/>
+                    </a:solidFill>
+                  </a:tcPr>
+                </a:tc>
+                <a:tc>
+                  <a:txBody>
+                    <a:bodyPr wrap="square"/>
+                    <a:lstStyle/>
+                    <a:p>
+                      <a:pPr algn="l"/>
+                      <a:r>
+                        <a:rPr sz="800" b="0">
+                          <a:solidFill>
+                            <a:srgbClr val="FFFFFF"/>
+                          </a:solidFill>
+                          <a:latin typeface="Calibri"/>
+                        </a:rPr>
+                        <a:t>44.2</a:t>
+                      </a:r>
+                    </a:p>
+                  </a:txBody>
+                  <a:tcPr marL="76200" marR="76200" marT="38100" marB="38100">
+                    <a:solidFill>
+                      <a:srgbClr val="2A2A3E"/>
+                    </a:solidFill>
+                  </a:tcPr>
+                </a:tc>
+              </a:tr>
+              <a:tr h="274320">
+                <a:tc>
+                  <a:txBody>
+                    <a:bodyPr wrap="square"/>
+                    <a:lstStyle/>
+                    <a:p>
+                      <a:pPr algn="l"/>
+                      <a:r>
+                        <a:rPr sz="800" b="0">
+                          <a:solidFill>
+                            <a:srgbClr val="FFFFFF"/>
+                          </a:solidFill>
+                          <a:latin typeface="Calibri"/>
+                        </a:rPr>
+                        <a:t>baseline</a:t>
+                      </a:r>
+                    </a:p>
+                  </a:txBody>
+                  <a:tcPr marL="76200" marR="76200" marT="38100" marB="38100">
+                    <a:solidFill>
+                      <a:srgbClr val="2A2A3E"/>
+                    </a:solidFill>
+                  </a:tcPr>
+                </a:tc>
+                <a:tc>
+                  <a:txBody>
+                    <a:bodyPr wrap="square"/>
+                    <a:lstStyle/>
+                    <a:p>
+                      <a:pPr algn="l"/>
+                      <a:r>
+                        <a:rPr sz="800" b="0">
+                          <a:solidFill>
+                            <a:srgbClr val="FFFFFF"/>
+                          </a:solidFill>
+                          <a:latin typeface="Calibri"/>
+                        </a:rPr>
+                        <a:t>0.70</a:t>
+                      </a:r>
+                    </a:p>
+                  </a:txBody>
+                  <a:tcPr marL="76200" marR="76200" marT="38100" marB="38100">
+                    <a:solidFill>
+                      <a:srgbClr val="2A2A3E"/>
+                    </a:solidFill>
+                  </a:tcPr>
+                </a:tc>
+                <a:tc>
+                  <a:txBody>
+                    <a:bodyPr wrap="square"/>
+                    <a:lstStyle/>
+                    <a:p>
+                      <a:pPr algn="l"/>
+                      <a:r>
+                        <a:rPr sz="800" b="0">
+                          <a:solidFill>
+                            <a:srgbClr val="FFFFFF"/>
+                          </a:solidFill>
+                          <a:latin typeface="Calibri"/>
+                        </a:rPr>
+                        <a:t>43.5</a:t>
+                      </a:r>
+                    </a:p>
+                  </a:txBody>
+                  <a:tcPr marL="76200" marR="76200" marT="38100" marB="38100">
+                    <a:solidFill>
+                      <a:srgbClr val="2A2A3E"/>
+                    </a:solidFill>
+                  </a:tcPr>
+                </a:tc>
+                <a:tc>
+                  <a:txBody>
+                    <a:bodyPr wrap="square"/>
+                    <a:lstStyle/>
+                    <a:p>
+                      <a:pPr algn="l"/>
+                      <a:r>
+                        <a:rPr sz="800" b="0">
+                          <a:solidFill>
+                            <a:srgbClr val="FFFFFF"/>
+                          </a:solidFill>
+                          <a:latin typeface="Calibri"/>
+                        </a:rPr>
+                        <a:t>0.78</a:t>
+                      </a:r>
+                    </a:p>
+                  </a:txBody>
+                  <a:tcPr marL="76200" marR="76200" marT="38100" marB="38100">
+                    <a:solidFill>
+                      <a:srgbClr val="2A2A3E"/>
+                    </a:solidFill>
+                  </a:tcPr>
+                </a:tc>
+                <a:tc>
+                  <a:txBody>
+                    <a:bodyPr wrap="square"/>
+                    <a:lstStyle/>
+                    <a:p>
+                      <a:pPr algn="l"/>
+                      <a:r>
+                        <a:rPr sz="800" b="0">
+                          <a:solidFill>
+                            <a:srgbClr val="FFFFFF"/>
+                          </a:solidFill>
+                          <a:latin typeface="Calibri"/>
+                        </a:rPr>
+                        <a:t>41.7</a:t>
+                      </a:r>
+                    </a:p>
+                  </a:txBody>
+                  <a:tcPr marL="76200" marR="76200" marT="38100" marB="38100">
+                    <a:solidFill>
+                      <a:srgbClr val="2A2A3E"/>
+                    </a:solidFill>
+                  </a:tcPr>
+                </a:tc>
+              </a:tr>
+              <a:tr h="274320">
+                <a:tc>
+                  <a:txBody>
+                    <a:bodyPr wrap="square"/>
+                    <a:lstStyle/>
+                    <a:p>
+                      <a:pPr algn="l"/>
+                      <a:r>
+                        <a:rPr sz="800" b="0">
+                          <a:solidFill>
+                            <a:srgbClr val="FFFFFF"/>
+                          </a:solidFill>
+                          <a:latin typeface="Calibri"/>
+                        </a:rPr>
+                        <a:t>adversarial</a:t>
+                      </a:r>
+                    </a:p>
+                  </a:txBody>
+                  <a:tcPr marL="76200" marR="76200" marT="38100" marB="38100">
+                    <a:solidFill>
+                      <a:srgbClr val="2A2A3E"/>
+                    </a:solidFill>
+                  </a:tcPr>
+                </a:tc>
+                <a:tc>
+                  <a:txBody>
+                    <a:bodyPr wrap="square"/>
+                    <a:lstStyle/>
+                    <a:p>
+                      <a:pPr algn="l"/>
+                      <a:r>
+                        <a:rPr sz="800" b="0">
+                          <a:solidFill>
+                            <a:srgbClr val="FFFFFF"/>
+                          </a:solidFill>
+                          <a:latin typeface="Calibri"/>
+                        </a:rPr>
+                        <a:t>0.80</a:t>
+                      </a:r>
+                    </a:p>
+                  </a:txBody>
+                  <a:tcPr marL="76200" marR="76200" marT="38100" marB="38100">
+                    <a:solidFill>
+                      <a:srgbClr val="2A2A3E"/>
+                    </a:solidFill>
+                  </a:tcPr>
+                </a:tc>
+                <a:tc>
+                  <a:txBody>
+                    <a:bodyPr wrap="square"/>
+                    <a:lstStyle/>
+                    <a:p>
+                      <a:pPr algn="l"/>
+                      <a:r>
+                        <a:rPr sz="800" b="0">
+                          <a:solidFill>
+                            <a:srgbClr val="FFFFFF"/>
+                          </a:solidFill>
+                          <a:latin typeface="Calibri"/>
+                        </a:rPr>
+                        <a:t>43.5</a:t>
+                      </a:r>
+                    </a:p>
+                  </a:txBody>
+                  <a:tcPr marL="76200" marR="76200" marT="38100" marB="38100">
+                    <a:solidFill>
+                      <a:srgbClr val="2A2A3E"/>
+                    </a:solidFill>
+                  </a:tcPr>
+                </a:tc>
+                <a:tc>
+                  <a:txBody>
+                    <a:bodyPr wrap="square"/>
+                    <a:lstStyle/>
+                    <a:p>
+                      <a:pPr algn="l"/>
+                      <a:r>
+                        <a:rPr sz="800" b="0">
+                          <a:solidFill>
+                            <a:srgbClr val="FFFFFF"/>
+                          </a:solidFill>
+                          <a:latin typeface="Calibri"/>
+                        </a:rPr>
+                        <a:t>0.80</a:t>
+                      </a:r>
+                    </a:p>
+                  </a:txBody>
+                  <a:tcPr marL="76200" marR="76200" marT="38100" marB="38100">
+                    <a:solidFill>
+                      <a:srgbClr val="2A2A3E"/>
+                    </a:solidFill>
+                  </a:tcPr>
+                </a:tc>
+                <a:tc>
+                  <a:txBody>
+                    <a:bodyPr wrap="square"/>
+                    <a:lstStyle/>
+                    <a:p>
+                      <a:pPr algn="l"/>
+                      <a:r>
+                        <a:rPr sz="800" b="0">
+                          <a:solidFill>
+                            <a:srgbClr val="FFFFFF"/>
+                          </a:solidFill>
+                          <a:latin typeface="Calibri"/>
+                        </a:rPr>
+                        <a:t>42.0</a:t>
+                      </a:r>
+                    </a:p>
+                  </a:txBody>
+                  <a:tcPr marL="76200" marR="76200" marT="38100" marB="38100">
+                    <a:solidFill>
+                      <a:srgbClr val="2A2A3E"/>
+                    </a:solidFill>
+                  </a:tcPr>
+                </a:tc>
+              </a:tr>
+              <a:tr h="274320">
+                <a:tc>
+                  <a:txBody>
+                    <a:bodyPr wrap="square"/>
+                    <a:lstStyle/>
+                    <a:p>
+                      <a:pPr algn="l"/>
+                      <a:r>
+                        <a:rPr sz="800" b="0">
+                          <a:solidFill>
+                            <a:srgbClr val="FFFFFF"/>
+                          </a:solidFill>
+                          <a:latin typeface="Calibri"/>
+                        </a:rPr>
+                        <a:t>default</a:t>
+                      </a:r>
+                    </a:p>
+                  </a:txBody>
+                  <a:tcPr marL="76200" marR="76200" marT="38100" marB="38100">
+                    <a:solidFill>
+                      <a:srgbClr val="2A2A3E"/>
+                    </a:solidFill>
+                  </a:tcPr>
+                </a:tc>
+                <a:tc>
+                  <a:txBody>
+                    <a:bodyPr wrap="square"/>
+                    <a:lstStyle/>
+                    <a:p>
+                      <a:pPr algn="l"/>
+                      <a:r>
+                        <a:rPr sz="800" b="0">
+                          <a:solidFill>
+                            <a:srgbClr val="FFFFFF"/>
+                          </a:solidFill>
+                          <a:latin typeface="Calibri"/>
+                        </a:rPr>
+                        <a:t>0.78</a:t>
+                      </a:r>
+                    </a:p>
+                  </a:txBody>
+                  <a:tcPr marL="76200" marR="76200" marT="38100" marB="38100">
+                    <a:solidFill>
+                      <a:srgbClr val="2A2A3E"/>
+                    </a:solidFill>
+                  </a:tcPr>
+                </a:tc>
+                <a:tc>
+                  <a:txBody>
+                    <a:bodyPr wrap="square"/>
+                    <a:lstStyle/>
+                    <a:p>
+                      <a:pPr algn="l"/>
+                      <a:r>
+                        <a:rPr sz="800" b="0">
+                          <a:solidFill>
+                            <a:srgbClr val="FFFFFF"/>
+                          </a:solidFill>
+                          <a:latin typeface="Calibri"/>
+                        </a:rPr>
+                        <a:t>45.5</a:t>
+                      </a:r>
+                    </a:p>
+                  </a:txBody>
+                  <a:tcPr marL="76200" marR="76200" marT="38100" marB="38100">
+                    <a:solidFill>
+                      <a:srgbClr val="2A2A3E"/>
+                    </a:solidFill>
+                  </a:tcPr>
+                </a:tc>
+                <a:tc>
+                  <a:txBody>
+                    <a:bodyPr wrap="square"/>
+                    <a:lstStyle/>
+                    <a:p>
+                      <a:pPr algn="l"/>
+                      <a:r>
+                        <a:rPr sz="800" b="0">
+                          <a:solidFill>
+                            <a:srgbClr val="FFFFFF"/>
+                          </a:solidFill>
+                          <a:latin typeface="Calibri"/>
+                        </a:rPr>
+                        <a:t>0.82</a:t>
+                      </a:r>
+                    </a:p>
+                  </a:txBody>
+                  <a:tcPr marL="76200" marR="76200" marT="38100" marB="38100">
+                    <a:solidFill>
+                      <a:srgbClr val="2A2A3E"/>
+                    </a:solidFill>
+                  </a:tcPr>
+                </a:tc>
+                <a:tc>
+                  <a:txBody>
+                    <a:bodyPr wrap="square"/>
+                    <a:lstStyle/>
+                    <a:p>
+                      <a:pPr algn="l"/>
+                      <a:r>
+                        <a:rPr sz="800" b="0">
+                          <a:solidFill>
+                            <a:srgbClr val="FFFFFF"/>
+                          </a:solidFill>
+                          <a:latin typeface="Calibri"/>
+                        </a:rPr>
+                        <a:t>41.6</a:t>
+                      </a:r>
+                    </a:p>
+                  </a:txBody>
+                  <a:tcPr marL="76200" marR="76200" marT="38100" marB="38100">
+                    <a:solidFill>
+                      <a:srgbClr val="2A2A3E"/>
+                    </a:solidFill>
+                  </a:tcPr>
+                </a:tc>
+              </a:tr>
+              <a:tr h="274320">
+                <a:tc>
+                  <a:txBody>
+                    <a:bodyPr wrap="square"/>
+                    <a:lstStyle/>
+                    <a:p>
+                      <a:pPr algn="l"/>
+                      <a:r>
+                        <a:rPr sz="800" b="0">
                           <a:solidFill>
                             <a:srgbClr val="FFFFFF"/>
                           </a:solidFill>
@@ -5165,7 +5779,7 @@
                     <a:p>
                       <a:pPr algn="l"/>
                       <a:r>
-                        <a:rPr sz="900" b="0">
+                        <a:rPr sz="800" b="0">
                           <a:solidFill>
                             <a:srgbClr val="FFFFFF"/>
                           </a:solidFill>
@@ -5188,38 +5802,13 @@
                     <a:p>
                       <a:pPr algn="l"/>
                       <a:r>
-                        <a:rPr sz="900" b="0">
+                        <a:rPr sz="800" b="0">
                           <a:solidFill>
                             <a:srgbClr val="FFFFFF"/>
                           </a:solidFill>
                           <a:latin typeface="Calibri"/>
                         </a:rPr>
                         <a:t>43.9</a:t>
-                      </a:r>
-                    </a:p>
-                  </a:txBody>
-                  <a:tcPr marL="76200" marR="76200" marT="38100" marB="38100">
-                    <a:solidFill>
-                      <a:srgbClr val="2A2A3E"/>
-                    </a:solidFill>
-                  </a:tcPr>
-                </a:tc>
-              </a:tr>
-              <a:tr h="326571">
-                <a:tc>
-                  <a:txBody>
-                    <a:bodyPr wrap="square"/>
-                    <a:lstStyle/>
-                    <a:p>
-                      <a:pPr algn="l"/>
-                      <a:r>
-                        <a:rPr sz="900" b="0">
-                          <a:solidFill>
-                            <a:srgbClr val="FFFFFF"/>
-                          </a:solidFill>
-                          <a:latin typeface="Calibri"/>
-                        </a:rPr>
-                        <a:t>default</a:t>
                       </a:r>
                     </a:p>
                   </a:txBody>
@@ -5236,13 +5825,13 @@
                     <a:p>
                       <a:pPr algn="l"/>
                       <a:r>
-                        <a:rPr sz="900" b="0">
+                        <a:rPr sz="800" b="0">
                           <a:solidFill>
                             <a:srgbClr val="FFFFFF"/>
                           </a:solidFill>
                           <a:latin typeface="Calibri"/>
                         </a:rPr>
-                        <a:t>0.78</a:t>
+                        <a:t>0.80</a:t>
                       </a:r>
                     </a:p>
                   </a:txBody>
@@ -5259,13 +5848,13 @@
                     <a:p>
                       <a:pPr algn="l"/>
                       <a:r>
-                        <a:rPr sz="900" b="0">
+                        <a:rPr sz="800" b="0">
                           <a:solidFill>
                             <a:srgbClr val="FFFFFF"/>
                           </a:solidFill>
                           <a:latin typeface="Calibri"/>
                         </a:rPr>
-                        <a:t>45.5</a:t>
+                        <a:t>42.8</a:t>
                       </a:r>
                     </a:p>
                   </a:txBody>
@@ -5288,8 +5877,8 @@
         </p:nvSpPr>
         <p:spPr>
           <a:xfrm>
-            <a:off x="6400800" y="4069080"/>
-            <a:ext cx="5120640" cy="1188720"/>
+            <a:off x="6400800" y="4206240"/>
+            <a:ext cx="5120640" cy="1051560"/>
           </a:xfrm>
           <a:prstGeom prst="rect">
             <a:avLst/>
@@ -5317,7 +5906,11 @@
               </a:defRPr>
             </a:pPr>
             <a:r>
-              <a:t>• Spearman ρ = 0.79 (n = 8 strategies, p &lt; 0.05)</a:t>
+              <a:t>• Node-local pair = the 2 lowest tails of 8 in BOTH</a:t>
+            </a:r>
+            <a:br/>
+            <a:r>
+              <a:t>  batches (joint null ≈ 0.0013) — ~1.25× below the rest</a:t>
             </a:r>
           </a:p>
           <a:p>
@@ -5336,15 +5929,11 @@
               </a:defRPr>
             </a:pPr>
             <a:r>
-              <a:t>• Computable from the dependency graph + placement</a:t>
+              <a:t>• Continuous ρ = 0.79 (batch 1) → 0.25 n.s. (batch 2):</a:t>
             </a:r>
             <a:br/>
             <a:r>
-              <a:t>  before any chaos — the Neo4j graph becomes</a:t>
-            </a:r>
-            <a:br/>
-            <a:r>
-              <a:t>  analytically load-bearing, not mere storage</a:t>
+              <a:t>  a replicated two-regime separator, not a smooth law</a:t>
             </a:r>
           </a:p>
         </p:txBody>
@@ -5425,7 +6014,7 @@
               </a:defRPr>
             </a:pPr>
             <a:r>
-              <a:t>Framing: empirical validation of a static pre-chaos predictor — and a coarse one</a:t>
+              <a:t>Framing: a replicated two-regime separator — not a validated smooth predictor</a:t>
             </a:r>
           </a:p>
         </p:txBody>
@@ -5461,7 +6050,7 @@
               </a:defRPr>
             </a:pPr>
             <a:r>
-              <a:t>Locality-as-objective already belongs to the literature (NetMARKS, graph-partitioning schedulers); the contribution here is validating the graph-derived fraction against measured during-load tails. The correlation is coarse — it separates the two node-local placements (colocate, best-fit) from the six spreading ones, which cluster at 0.70–0.80 — and single-batch. Note dependency-aware's partition did not co-locate as intended (0.73, spread-like).</a:t>
+              <a:t>Locality-as-objective already belongs to the literature (NetMARKS, graph-partitioning schedulers); the contribution is validating the graph-derived fraction (Neo4j graph + podPlacements, pre-chaos) against measured during-load tails in two independent batches. The continuous law is not claimed: batch 1's ρ = 0.79 was carried by best-fit's intermediate 0.13 point and collapsed to ρ = 0.25 (n.s.) when best-fit packed fully in batch 2. Note dependency-aware's partition did not co-locate as intended (0.73, spread-like, both batches).</a:t>
             </a:r>
           </a:p>
         </p:txBody>
@@ -5662,7 +6251,7 @@
         </p:nvGraphicFramePr>
         <p:xfrm>
           <a:off x="640080" y="1691640"/>
-          <a:ext cx="5577840" cy="1188720"/>
+          <a:ext cx="5577840" cy="2011674"/>
         </p:xfrm>
         <a:graphic>
           <a:graphicData uri="http://schemas.openxmlformats.org/drawingml/2006/table">
@@ -5676,7 +6265,7 @@
                 <a:gridCol w="1394460"/>
                 <a:gridCol w="1394460"/>
               </a:tblGrid>
-              <a:tr h="396240">
+              <a:tr h="287382">
                 <a:tc>
                   <a:txBody>
                     <a:bodyPr wrap="square"/>
@@ -5690,7 +6279,7 @@
                           </a:solidFill>
                           <a:latin typeface="Calibri"/>
                         </a:rPr>
-                        <a:t>Placement</a:t>
+                        <a:t>Strategy</a:t>
                       </a:r>
                     </a:p>
                   </a:txBody>
@@ -5736,7 +6325,7 @@
                           </a:solidFill>
                           <a:latin typeface="Calibri"/>
                         </a:rPr>
-                        <a:t>Blast radius</a:t>
+                        <a:t>Blast (observed)</a:t>
                       </a:r>
                     </a:p>
                   </a:txBody>
@@ -5759,7 +6348,7 @@
                           </a:solidFill>
                           <a:latin typeface="Calibri"/>
                         </a:rPr>
-                        <a:t>Target recovery</a:t>
+                        <a:t>Recovery (mean)</a:t>
                       </a:r>
                     </a:p>
                   </a:txBody>
@@ -5770,7 +6359,7 @@
                   </a:tcPr>
                 </a:tc>
               </a:tr>
-              <a:tr h="396240">
+              <a:tr h="287382">
                 <a:tc>
                   <a:txBody>
                     <a:bodyPr wrap="square"/>
@@ -5853,7 +6442,7 @@
                           </a:solidFill>
                           <a:latin typeface="Calibri"/>
                         </a:rPr>
-                        <a:t>~10.3 s</a:t>
+                        <a:t>10.8 s</a:t>
                       </a:r>
                     </a:p>
                   </a:txBody>
@@ -5864,7 +6453,289 @@
                   </a:tcPr>
                 </a:tc>
               </a:tr>
-              <a:tr h="396240">
+              <a:tr h="287382">
+                <a:tc>
+                  <a:txBody>
+                    <a:bodyPr wrap="square"/>
+                    <a:lstStyle/>
+                    <a:p>
+                      <a:pPr algn="l"/>
+                      <a:r>
+                        <a:rPr sz="900" b="0">
+                          <a:solidFill>
+                            <a:srgbClr val="FFFFFF"/>
+                          </a:solidFill>
+                          <a:latin typeface="Calibri"/>
+                        </a:rPr>
+                        <a:t>random</a:t>
+                      </a:r>
+                    </a:p>
+                  </a:txBody>
+                  <a:tcPr marL="76200" marR="76200" marT="38100" marB="38100">
+                    <a:solidFill>
+                      <a:srgbClr val="2A2A3E"/>
+                    </a:solidFill>
+                  </a:tcPr>
+                </a:tc>
+                <a:tc>
+                  <a:txBody>
+                    <a:bodyPr wrap="square"/>
+                    <a:lstStyle/>
+                    <a:p>
+                      <a:pPr algn="l"/>
+                      <a:r>
+                        <a:rPr sz="900" b="0">
+                          <a:solidFill>
+                            <a:srgbClr val="FFFFFF"/>
+                          </a:solidFill>
+                          <a:latin typeface="Calibri"/>
+                        </a:rPr>
+                        <a:t>4 / 11 services</a:t>
+                      </a:r>
+                    </a:p>
+                  </a:txBody>
+                  <a:tcPr marL="76200" marR="76200" marT="38100" marB="38100">
+                    <a:solidFill>
+                      <a:srgbClr val="2A2A3E"/>
+                    </a:solidFill>
+                  </a:tcPr>
+                </a:tc>
+                <a:tc>
+                  <a:txBody>
+                    <a:bodyPr wrap="square"/>
+                    <a:lstStyle/>
+                    <a:p>
+                      <a:pPr algn="l"/>
+                      <a:r>
+                        <a:rPr sz="900" b="0">
+                          <a:solidFill>
+                            <a:srgbClr val="FFFFFF"/>
+                          </a:solidFill>
+                          <a:latin typeface="Calibri"/>
+                        </a:rPr>
+                        <a:t>4</a:t>
+                      </a:r>
+                    </a:p>
+                  </a:txBody>
+                  <a:tcPr marL="76200" marR="76200" marT="38100" marB="38100">
+                    <a:solidFill>
+                      <a:srgbClr val="2A2A3E"/>
+                    </a:solidFill>
+                  </a:tcPr>
+                </a:tc>
+                <a:tc>
+                  <a:txBody>
+                    <a:bodyPr wrap="square"/>
+                    <a:lstStyle/>
+                    <a:p>
+                      <a:pPr algn="l"/>
+                      <a:r>
+                        <a:rPr sz="900" b="0">
+                          <a:solidFill>
+                            <a:srgbClr val="FFFFFF"/>
+                          </a:solidFill>
+                          <a:latin typeface="Calibri"/>
+                        </a:rPr>
+                        <a:t>4.6 s</a:t>
+                      </a:r>
+                    </a:p>
+                  </a:txBody>
+                  <a:tcPr marL="76200" marR="76200" marT="38100" marB="38100">
+                    <a:solidFill>
+                      <a:srgbClr val="2A2A3E"/>
+                    </a:solidFill>
+                  </a:tcPr>
+                </a:tc>
+              </a:tr>
+              <a:tr h="287382">
+                <a:tc>
+                  <a:txBody>
+                    <a:bodyPr wrap="square"/>
+                    <a:lstStyle/>
+                    <a:p>
+                      <a:pPr algn="l"/>
+                      <a:r>
+                        <a:rPr sz="900" b="0">
+                          <a:solidFill>
+                            <a:srgbClr val="FFFFFF"/>
+                          </a:solidFill>
+                          <a:latin typeface="Calibri"/>
+                        </a:rPr>
+                        <a:t>dependency-aware</a:t>
+                      </a:r>
+                    </a:p>
+                  </a:txBody>
+                  <a:tcPr marL="76200" marR="76200" marT="38100" marB="38100">
+                    <a:solidFill>
+                      <a:srgbClr val="2A2A3E"/>
+                    </a:solidFill>
+                  </a:tcPr>
+                </a:tc>
+                <a:tc>
+                  <a:txBody>
+                    <a:bodyPr wrap="square"/>
+                    <a:lstStyle/>
+                    <a:p>
+                      <a:pPr algn="l"/>
+                      <a:r>
+                        <a:rPr sz="900" b="0">
+                          <a:solidFill>
+                            <a:srgbClr val="FFFFFF"/>
+                          </a:solidFill>
+                          <a:latin typeface="Calibri"/>
+                        </a:rPr>
+                        <a:t>3 / 11 services</a:t>
+                      </a:r>
+                    </a:p>
+                  </a:txBody>
+                  <a:tcPr marL="76200" marR="76200" marT="38100" marB="38100">
+                    <a:solidFill>
+                      <a:srgbClr val="2A2A3E"/>
+                    </a:solidFill>
+                  </a:tcPr>
+                </a:tc>
+                <a:tc>
+                  <a:txBody>
+                    <a:bodyPr wrap="square"/>
+                    <a:lstStyle/>
+                    <a:p>
+                      <a:pPr algn="l"/>
+                      <a:r>
+                        <a:rPr sz="900" b="0">
+                          <a:solidFill>
+                            <a:srgbClr val="FFFFFF"/>
+                          </a:solidFill>
+                          <a:latin typeface="Calibri"/>
+                        </a:rPr>
+                        <a:t>3</a:t>
+                      </a:r>
+                    </a:p>
+                  </a:txBody>
+                  <a:tcPr marL="76200" marR="76200" marT="38100" marB="38100">
+                    <a:solidFill>
+                      <a:srgbClr val="2A2A3E"/>
+                    </a:solidFill>
+                  </a:tcPr>
+                </a:tc>
+                <a:tc>
+                  <a:txBody>
+                    <a:bodyPr wrap="square"/>
+                    <a:lstStyle/>
+                    <a:p>
+                      <a:pPr algn="l"/>
+                      <a:r>
+                        <a:rPr sz="900" b="0">
+                          <a:solidFill>
+                            <a:srgbClr val="FFFFFF"/>
+                          </a:solidFill>
+                          <a:latin typeface="Calibri"/>
+                        </a:rPr>
+                        <a:t>33.3 s</a:t>
+                      </a:r>
+                    </a:p>
+                  </a:txBody>
+                  <a:tcPr marL="76200" marR="76200" marT="38100" marB="38100">
+                    <a:solidFill>
+                      <a:srgbClr val="2A2A3E"/>
+                    </a:solidFill>
+                  </a:tcPr>
+                </a:tc>
+              </a:tr>
+              <a:tr h="287382">
+                <a:tc>
+                  <a:txBody>
+                    <a:bodyPr wrap="square"/>
+                    <a:lstStyle/>
+                    <a:p>
+                      <a:pPr algn="l"/>
+                      <a:r>
+                        <a:rPr sz="900" b="0">
+                          <a:solidFill>
+                            <a:srgbClr val="FFFFFF"/>
+                          </a:solidFill>
+                          <a:latin typeface="Calibri"/>
+                        </a:rPr>
+                        <a:t>best-fit</a:t>
+                      </a:r>
+                    </a:p>
+                  </a:txBody>
+                  <a:tcPr marL="76200" marR="76200" marT="38100" marB="38100">
+                    <a:solidFill>
+                      <a:srgbClr val="2A2A3E"/>
+                    </a:solidFill>
+                  </a:tcPr>
+                </a:tc>
+                <a:tc>
+                  <a:txBody>
+                    <a:bodyPr wrap="square"/>
+                    <a:lstStyle/>
+                    <a:p>
+                      <a:pPr algn="l"/>
+                      <a:r>
+                        <a:rPr sz="900" b="0">
+                          <a:solidFill>
+                            <a:srgbClr val="FFFFFF"/>
+                          </a:solidFill>
+                          <a:latin typeface="Calibri"/>
+                        </a:rPr>
+                        <a:t>3 / 11 services</a:t>
+                      </a:r>
+                    </a:p>
+                  </a:txBody>
+                  <a:tcPr marL="76200" marR="76200" marT="38100" marB="38100">
+                    <a:solidFill>
+                      <a:srgbClr val="2A2A3E"/>
+                    </a:solidFill>
+                  </a:tcPr>
+                </a:tc>
+                <a:tc>
+                  <a:txBody>
+                    <a:bodyPr wrap="square"/>
+                    <a:lstStyle/>
+                    <a:p>
+                      <a:pPr algn="l"/>
+                      <a:r>
+                        <a:rPr sz="900" b="0">
+                          <a:solidFill>
+                            <a:srgbClr val="FFFFFF"/>
+                          </a:solidFill>
+                          <a:latin typeface="Calibri"/>
+                        </a:rPr>
+                        <a:t>3</a:t>
+                      </a:r>
+                    </a:p>
+                  </a:txBody>
+                  <a:tcPr marL="76200" marR="76200" marT="38100" marB="38100">
+                    <a:solidFill>
+                      <a:srgbClr val="2A2A3E"/>
+                    </a:solidFill>
+                  </a:tcPr>
+                </a:tc>
+                <a:tc>
+                  <a:txBody>
+                    <a:bodyPr wrap="square"/>
+                    <a:lstStyle/>
+                    <a:p>
+                      <a:pPr algn="l"/>
+                      <a:r>
+                        <a:rPr sz="900" b="0">
+                          <a:solidFill>
+                            <a:srgbClr val="FFFFFF"/>
+                          </a:solidFill>
+                          <a:latin typeface="Calibri"/>
+                        </a:rPr>
+                        <a:t>9.7 s</a:t>
+                      </a:r>
+                    </a:p>
+                  </a:txBody>
+                  <a:tcPr marL="76200" marR="76200" marT="38100" marB="38100">
+                    <a:solidFill>
+                      <a:srgbClr val="2A2A3E"/>
+                    </a:solidFill>
+                  </a:tcPr>
+                </a:tc>
+              </a:tr>
+              <a:tr h="287382">
                 <a:tc>
                   <a:txBody>
                     <a:bodyPr wrap="square"/>
@@ -5924,7 +6795,7 @@
                           </a:solidFill>
                           <a:latin typeface="Calibri"/>
                         </a:rPr>
-                        <a:t>2 services (18%)</a:t>
+                        <a:t>2 (18%)</a:t>
                       </a:r>
                     </a:p>
                   </a:txBody>
@@ -5947,7 +6818,101 @@
                           </a:solidFill>
                           <a:latin typeface="Calibri"/>
                         </a:rPr>
-                        <a:t>~2.6 s</a:t>
+                        <a:t>2.6 s</a:t>
+                      </a:r>
+                    </a:p>
+                  </a:txBody>
+                  <a:tcPr marL="76200" marR="76200" marT="38100" marB="38100">
+                    <a:solidFill>
+                      <a:srgbClr val="2A2A3E"/>
+                    </a:solidFill>
+                  </a:tcPr>
+                </a:tc>
+              </a:tr>
+              <a:tr h="287382">
+                <a:tc>
+                  <a:txBody>
+                    <a:bodyPr wrap="square"/>
+                    <a:lstStyle/>
+                    <a:p>
+                      <a:pPr algn="l"/>
+                      <a:r>
+                        <a:rPr sz="900" b="0">
+                          <a:solidFill>
+                            <a:srgbClr val="FFFFFF"/>
+                          </a:solidFill>
+                          <a:latin typeface="Calibri"/>
+                        </a:rPr>
+                        <a:t>adversarial</a:t>
+                      </a:r>
+                    </a:p>
+                  </a:txBody>
+                  <a:tcPr marL="76200" marR="76200" marT="38100" marB="38100">
+                    <a:solidFill>
+                      <a:srgbClr val="2A2A3E"/>
+                    </a:solidFill>
+                  </a:tcPr>
+                </a:tc>
+                <a:tc>
+                  <a:txBody>
+                    <a:bodyPr wrap="square"/>
+                    <a:lstStyle/>
+                    <a:p>
+                      <a:pPr algn="l"/>
+                      <a:r>
+                        <a:rPr sz="900" b="0">
+                          <a:solidFill>
+                            <a:srgbClr val="FFFFFF"/>
+                          </a:solidFill>
+                          <a:latin typeface="Calibri"/>
+                        </a:rPr>
+                        <a:t>2 / 11 services</a:t>
+                      </a:r>
+                    </a:p>
+                  </a:txBody>
+                  <a:tcPr marL="76200" marR="76200" marT="38100" marB="38100">
+                    <a:solidFill>
+                      <a:srgbClr val="2A2A3E"/>
+                    </a:solidFill>
+                  </a:tcPr>
+                </a:tc>
+                <a:tc>
+                  <a:txBody>
+                    <a:bodyPr wrap="square"/>
+                    <a:lstStyle/>
+                    <a:p>
+                      <a:pPr algn="l"/>
+                      <a:r>
+                        <a:rPr sz="900" b="0">
+                          <a:solidFill>
+                            <a:srgbClr val="FFFFFF"/>
+                          </a:solidFill>
+                          <a:latin typeface="Calibri"/>
+                        </a:rPr>
+                        <a:t>2</a:t>
+                      </a:r>
+                    </a:p>
+                  </a:txBody>
+                  <a:tcPr marL="76200" marR="76200" marT="38100" marB="38100">
+                    <a:solidFill>
+                      <a:srgbClr val="2A2A3E"/>
+                    </a:solidFill>
+                  </a:tcPr>
+                </a:tc>
+                <a:tc>
+                  <a:txBody>
+                    <a:bodyPr wrap="square"/>
+                    <a:lstStyle/>
+                    <a:p>
+                      <a:pPr algn="l"/>
+                      <a:r>
+                        <a:rPr sz="900" b="0">
+                          <a:solidFill>
+                            <a:srgbClr val="FFFFFF"/>
+                          </a:solidFill>
+                          <a:latin typeface="Calibri"/>
+                        </a:rPr>
+                        <a:t>33.1 s</a:t>
                       </a:r>
                     </a:p>
                   </a:txBody>
@@ -5970,8 +6935,8 @@
         </p:nvSpPr>
         <p:spPr>
           <a:xfrm>
-            <a:off x="640080" y="3063240"/>
-            <a:ext cx="5577840" cy="2194560"/>
+            <a:off x="640080" y="3840480"/>
+            <a:ext cx="5577840" cy="1417320"/>
           </a:xfrm>
           <a:prstGeom prst="rect">
             <a:avLst/>
@@ -5999,15 +6964,15 @@
               </a:defRPr>
             </a:pPr>
             <a:r>
-              <a:t>• Blast radius = services at 0 ready endpoints at the</a:t>
+              <a:t>• Observed blast = placement-predicted blast for ALL 6</a:t>
             </a:r>
             <a:br/>
             <a:r>
-              <a:t>  outage trough, read from EndpointSlice snapshots —</a:t>
+              <a:t>  placing strategies — Spearman ρ = 1.0 (n = 6); read from</a:t>
             </a:r>
             <a:br/>
             <a:r>
-              <a:t>  not the score (a drain leaves every probe Unknown; H1)</a:t>
+              <a:t>  EndpointSlice troughs, not the score (probes Unknown; H1)</a:t>
             </a:r>
           </a:p>
           <a:p>
@@ -6026,13 +6991,121 @@
               </a:defRPr>
             </a:pPr>
             <a:r>
-              <a:t>• Observed blast equals the placement-predicted blast</a:t>
+              <a:t>• Recovery is NOT monotone in blast (4.6 s and 33.3 s both</a:t>
             </a:r>
             <a:br/>
             <a:r>
-              <a:t>  in every iteration, across two doctor-clean batches</a:t>
-            </a:r>
-          </a:p>
+              <a:t>  at intermediate blast) — the ~4× contrast (10.3 s vs 2.6 s)</a:t>
+            </a:r>
+            <a:br/>
+            <a:r>
+              <a:t>  is claimed only at the colocate-vs-spread extremes</a:t>
+            </a:r>
+          </a:p>
+        </p:txBody>
+      </p:sp>
+      <p:sp>
+        <p:nvSpPr>
+          <p:cNvPr id="8" name="Rounded Rectangle 7"/>
+          <p:cNvSpPr/>
+          <p:nvPr/>
+        </p:nvSpPr>
+        <p:spPr>
+          <a:xfrm>
+            <a:off x="6675120" y="1280160"/>
+            <a:ext cx="5029200" cy="4023360"/>
+          </a:xfrm>
+          <a:prstGeom prst="roundRect">
+            <a:avLst/>
+          </a:prstGeom>
+          <a:solidFill>
+            <a:srgbClr val="121222"/>
+          </a:solidFill>
+          <a:ln w="25400">
+            <a:solidFill>
+              <a:srgbClr val="9B59B6"/>
+            </a:solidFill>
+          </a:ln>
+        </p:spPr>
+        <p:style>
+          <a:lnRef idx="1">
+            <a:schemeClr val="accent1"/>
+          </a:lnRef>
+          <a:fillRef idx="3">
+            <a:schemeClr val="accent1"/>
+          </a:fillRef>
+          <a:effectRef idx="2">
+            <a:schemeClr val="accent1"/>
+          </a:effectRef>
+          <a:fontRef idx="minor">
+            <a:schemeClr val="lt1"/>
+          </a:fontRef>
+        </p:style>
+        <p:txBody>
+          <a:bodyPr rtlCol="0" anchor="ctr"/>
+          <a:lstStyle/>
+          <a:p>
+            <a:pPr algn="ctr"/>
+          </a:p>
+        </p:txBody>
+      </p:sp>
+      <p:sp>
+        <p:nvSpPr>
+          <p:cNvPr id="9" name="TextBox 8"/>
+          <p:cNvSpPr txBox="1"/>
+          <p:nvPr/>
+        </p:nvSpPr>
+        <p:spPr>
+          <a:xfrm>
+            <a:off x="6858000" y="1325880"/>
+            <a:ext cx="4663440" cy="274320"/>
+          </a:xfrm>
+          <a:prstGeom prst="rect">
+            <a:avLst/>
+          </a:prstGeom>
+          <a:noFill/>
+        </p:spPr>
+        <p:txBody>
+          <a:bodyPr wrap="square">
+            <a:spAutoFit/>
+          </a:bodyPr>
+          <a:lstStyle/>
+          <a:p>
+            <a:pPr algn="l">
+              <a:defRPr sz="1400" b="1">
+                <a:solidFill>
+                  <a:srgbClr val="9B59B6"/>
+                </a:solidFill>
+                <a:latin typeface="Calibri"/>
+              </a:defRPr>
+            </a:pPr>
+            <a:r>
+              <a:t>One placement property, two opposing consequences</a:t>
+            </a:r>
+          </a:p>
+        </p:txBody>
+      </p:sp>
+      <p:sp>
+        <p:nvSpPr>
+          <p:cNvPr id="10" name="TextBox 9"/>
+          <p:cNvSpPr txBox="1"/>
+          <p:nvPr/>
+        </p:nvSpPr>
+        <p:spPr>
+          <a:xfrm>
+            <a:off x="6858000" y="1691640"/>
+            <a:ext cx="4663440" cy="3474720"/>
+          </a:xfrm>
+          <a:prstGeom prst="rect">
+            <a:avLst/>
+          </a:prstGeom>
+          <a:noFill/>
+        </p:spPr>
+        <p:txBody>
+          <a:bodyPr wrap="square">
+            <a:spAutoFit/>
+          </a:bodyPr>
+          <a:lstStyle/>
           <a:p>
             <a:pPr>
               <a:spcBef>
@@ -6049,117 +7122,17 @@
               </a:defRPr>
             </a:pPr>
             <a:r>
-              <a:t>• Recovery scales with concentration too: 11 evicted</a:t>
+              <a:t>• colocate: best east-west tail (H5: ~33–34 ms</a:t>
             </a:r>
             <a:br/>
             <a:r>
-              <a:t>  pods reschedule at once vs 2 — ~4× slower</a:t>
-            </a:r>
-          </a:p>
-        </p:txBody>
-      </p:sp>
-      <p:sp>
-        <p:nvSpPr>
-          <p:cNvPr id="8" name="Rounded Rectangle 7"/>
-          <p:cNvSpPr/>
-          <p:nvPr/>
-        </p:nvSpPr>
-        <p:spPr>
-          <a:xfrm>
-            <a:off x="6675120" y="1280160"/>
-            <a:ext cx="5029200" cy="4023360"/>
-          </a:xfrm>
-          <a:prstGeom prst="roundRect">
-            <a:avLst/>
-          </a:prstGeom>
-          <a:solidFill>
-            <a:srgbClr val="121222"/>
-          </a:solidFill>
-          <a:ln w="25400">
-            <a:solidFill>
-              <a:srgbClr val="9B59B6"/>
-            </a:solidFill>
-          </a:ln>
-        </p:spPr>
-        <p:style>
-          <a:lnRef idx="1">
-            <a:schemeClr val="accent1"/>
-          </a:lnRef>
-          <a:fillRef idx="3">
-            <a:schemeClr val="accent1"/>
-          </a:fillRef>
-          <a:effectRef idx="2">
-            <a:schemeClr val="accent1"/>
-          </a:effectRef>
-          <a:fontRef idx="minor">
-            <a:schemeClr val="lt1"/>
-          </a:fontRef>
-        </p:style>
-        <p:txBody>
-          <a:bodyPr rtlCol="0" anchor="ctr"/>
-          <a:lstStyle/>
-          <a:p>
-            <a:pPr algn="ctr"/>
-          </a:p>
-        </p:txBody>
-      </p:sp>
-      <p:sp>
-        <p:nvSpPr>
-          <p:cNvPr id="9" name="TextBox 8"/>
-          <p:cNvSpPr txBox="1"/>
-          <p:nvPr/>
-        </p:nvSpPr>
-        <p:spPr>
-          <a:xfrm>
-            <a:off x="6858000" y="1325880"/>
-            <a:ext cx="4663440" cy="274320"/>
-          </a:xfrm>
-          <a:prstGeom prst="rect">
-            <a:avLst/>
-          </a:prstGeom>
-          <a:noFill/>
-        </p:spPr>
-        <p:txBody>
-          <a:bodyPr wrap="square">
-            <a:spAutoFit/>
-          </a:bodyPr>
-          <a:lstStyle/>
-          <a:p>
-            <a:pPr algn="l">
-              <a:defRPr sz="1400" b="1">
-                <a:solidFill>
-                  <a:srgbClr val="9B59B6"/>
-                </a:solidFill>
-                <a:latin typeface="Calibri"/>
-              </a:defRPr>
-            </a:pPr>
-            <a:r>
-              <a:t>One placement property, two opposing consequences</a:t>
-            </a:r>
-          </a:p>
-        </p:txBody>
-      </p:sp>
-      <p:sp>
-        <p:nvSpPr>
-          <p:cNvPr id="10" name="TextBox 9"/>
-          <p:cNvSpPr txBox="1"/>
-          <p:nvPr/>
-        </p:nvSpPr>
-        <p:spPr>
-          <a:xfrm>
-            <a:off x="6858000" y="1691640"/>
-            <a:ext cx="4663440" cy="3474720"/>
-          </a:xfrm>
-          <a:prstGeom prst="rect">
-            <a:avLst/>
-          </a:prstGeom>
-          <a:noFill/>
-        </p:spPr>
-        <p:txBody>
-          <a:bodyPr wrap="square">
-            <a:spAutoFit/>
-          </a:bodyPr>
-          <a:lstStyle/>
+              <a:t>  in both batches) AND worst node-failure</a:t>
+            </a:r>
+            <a:br/>
+            <a:r>
+              <a:t>  blast (100% outage) — spread is the mirror</a:t>
+            </a:r>
+          </a:p>
           <a:p>
             <a:pPr>
               <a:spcBef>
@@ -6176,15 +7149,11 @@
               </a:defRPr>
             </a:pPr>
             <a:r>
-              <a:t>• colocate: best east-west tail (H5: 33.9 ms,</a:t>
+              <a:t>• H5 is the latency face, H6 the availability</a:t>
             </a:r>
             <a:br/>
             <a:r>
-              <a:t>  lowest) AND worst node-failure blast</a:t>
-            </a:r>
-            <a:br/>
-            <a:r>
-              <a:t>  (100% outage) — spread is the mirror</a:t>
+              <a:t>  face of the same co-location metric</a:t>
             </a:r>
           </a:p>
           <a:p>
@@ -6203,11 +7172,15 @@
               </a:defRPr>
             </a:pPr>
             <a:r>
-              <a:t>• H5 is the latency face, H6 the availability</a:t>
+              <a:t>• Where placement DOES bite users in this</a:t>
             </a:r>
             <a:br/>
             <a:r>
-              <a:t>  face of the same co-location metric</a:t>
+              <a:t>  study is availability under node failure —</a:t>
+            </a:r>
+            <a:br/>
+            <a:r>
+              <a:t>  and it is predictable from the placement</a:t>
             </a:r>
           </a:p>
           <a:p>
@@ -6226,15 +7199,15 @@
               </a:defRPr>
             </a:pPr>
             <a:r>
-              <a:t>• Where placement DOES bite users in this</a:t>
+              <a:t>• Quantification of a known qualitative</a:t>
             </a:r>
             <a:br/>
             <a:r>
-              <a:t>  study is availability under node failure —</a:t>
+              <a:t>  trade-off (cell-based architectures), not</a:t>
             </a:r>
             <a:br/>
             <a:r>
-              <a:t>  and it is predictable from the placement</a:t>
+              <a:t>  a discovery</a:t>
             </a:r>
           </a:p>
           <a:p>
@@ -6253,38 +7226,11 @@
               </a:defRPr>
             </a:pPr>
             <a:r>
-              <a:t>• Quantification of a known qualitative</a:t>
+              <a:t>• Reproduced: two doctor-clean two-point</a:t>
             </a:r>
             <a:br/>
             <a:r>
-              <a:t>  trade-off (cell-based architectures), not</a:t>
-            </a:r>
-            <a:br/>
-            <a:r>
-              <a:t>  a discovery</a:t>
-            </a:r>
-          </a:p>
-          <a:p>
-            <a:pPr>
-              <a:spcBef>
-                <a:spcPts val="200"/>
-              </a:spcBef>
-              <a:spcAft>
-                <a:spcPts val="200"/>
-              </a:spcAft>
-              <a:defRPr sz="1000">
-                <a:solidFill>
-                  <a:srgbClr val="BDBDBD"/>
-                </a:solidFill>
-                <a:latin typeface="Calibri"/>
-              </a:defRPr>
-            </a:pPr>
-            <a:r>
-              <a:t>• Two-point contrast (the extremes); a</a:t>
-            </a:r>
-            <a:br/>
-            <a:r>
-              <a:t>  6-strategy gradient run extends this</a:t>
+              <a:t>  batches + a completed 6-strategy gradient</a:t>
             </a:r>
           </a:p>
         </p:txBody>
@@ -7837,7 +8783,7 @@
               </a:defRPr>
             </a:pPr>
             <a:r>
-              <a:t>The churn findings (H2, H3) rest on the colocate-vs-spread locality contrast; H5 covers all 8 placements but is single-batch; H6 is a two-point contrast of the extremes — a 6-strategy gradient run extends it. Intermediate placements are not yet validated per-hypothesis.</a:t>
+              <a:t>The churn findings (H2, H3) rest on the colocate-vs-spread locality contrast; H5 covers all 8 placements across two independent batches; H6's extremes contrast is extended by a completed 6-strategy gradient (blast ρ = 1.0) — but recovery is validated only at the extremes.</a:t>
             </a:r>
           </a:p>
         </p:txBody>
@@ -8488,7 +9434,11 @@
             </a:r>
             <a:br/>
             <a:r>
-              <a:t>  load-bearing: a pre-chaos placement predictor (H5)</a:t>
+              <a:t>  load-bearing: a replicated pre-chaos placement</a:t>
+            </a:r>
+            <a:br/>
+            <a:r>
+              <a:t>  separator (H5)</a:t>
             </a:r>
           </a:p>
           <a:p>
@@ -8857,11 +9807,15 @@
               </a:defRPr>
             </a:pPr>
             <a:r>
-              <a:t>• H6 gradient: intermediate placements between the</a:t>
+              <a:t>• Recovery dynamics across the H6 gradient — why</a:t>
             </a:r>
             <a:br/>
             <a:r>
-              <a:t>  extremes (6-strategy gradient run in flight)</a:t>
+              <a:t>  intermediate-blast placements recover</a:t>
+            </a:r>
+            <a:br/>
+            <a:r>
+              <a:t>  non-monotonically</a:t>
             </a:r>
           </a:p>
           <a:p>
@@ -8926,15 +9880,15 @@
               </a:defRPr>
             </a:pPr>
             <a:r>
-              <a:t>• Re-attribute the conntrack flush to its exact code</a:t>
+              <a:t>• Apportion the H2 flush between kernel TCP teardown</a:t>
             </a:r>
             <a:br/>
             <a:r>
-              <a:t>  path (upstream active flush is UDP-only; this</a:t>
+              <a:t>  and kube-proxy's UDP-only cleanup (steady-state,</a:t>
             </a:r>
             <a:br/>
             <a:r>
-              <a:t>  workload is TCP/gRPC)</a:t>
+              <a:t>  multi-iteration probe)</a:t>
             </a:r>
           </a:p>
           <a:p>
@@ -9646,7 +10600,7 @@
               </a:defRPr>
             </a:pPr>
             <a:r>
-              <a:t>ρ = 0.79</a:t>
+              <a:t>ρ = 1.0</a:t>
             </a:r>
           </a:p>
         </p:txBody>
@@ -9682,11 +10636,11 @@
               </a:defRPr>
             </a:pPr>
             <a:r>
-              <a:t>Graph</a:t>
+              <a:t>Blast Radius</a:t>
             </a:r>
             <a:br/>
             <a:r>
-              <a:t>Predictor</a:t>
+              <a:t>Predicted</a:t>
             </a:r>
           </a:p>
         </p:txBody>
@@ -12070,7 +13024,7 @@
               </a:defRPr>
             </a:pPr>
             <a:r>
-              <a:t>A graph metric predicts the east-west tail</a:t>
+              <a:t>A graph metric separates the placement regimes</a:t>
             </a:r>
           </a:p>
         </p:txBody>
@@ -12106,7 +13060,7 @@
               </a:defRPr>
             </a:pPr>
             <a:r>
-              <a:t>Cross-node call fraction (dependency graph + placement, pre-chaos) vs east-west p95: ρ = 0.79 (n = 8, p &lt; .05). Coarse — separates node-local from spreading placements — but makes the Neo4j graph analytically load-bearing.</a:t>
+              <a:t>Cross-node call fraction (dependency graph + placement, pre-chaos): the node-local pair (colocate, best-fit; fraction ≈ 0) takes the two lowest east-west tails of 8 in BOTH load batches (joint null ≈ 0.0013), ~1.25× below the spreading cluster. Continuous ρ = 0.79 (batch 1) did not replicate (0.25 n.s.) — a separator, not a smooth law.</a:t>
             </a:r>
           </a:p>
         </p:txBody>
@@ -12276,7 +13230,7 @@
               </a:defRPr>
             </a:pPr>
             <a:r>
-              <a:t>Node drain: colocate loses 11/11 services (100% blast, ~10.3 s recovery) vs spread 2/11 (18%, ~2.6 s); two doctor-clean batches. The co-location that wins H5's latency loses H6's availability.</a:t>
+              <a:t>Node drain: colocate loses 11/11 services (100% blast) vs spread 2/11 (18%). 6-strategy gradient: observed blast = placement-predicted blast (11, 4, 3, 3, 2, 2; ρ = 1.0, n = 6). Recovery is NOT monotone in blast — ~4× (10.3 s vs 2.6 s) only at the colocate-vs-spread extremes.</a:t>
             </a:r>
           </a:p>
         </p:txBody>
@@ -17029,7 +17983,7 @@
               </a:defRPr>
             </a:pPr>
             <a:r>
-              <a:t>Analytic weight: the churn findings (H2 conntrack reconvergence, H3 decoupling) rest on the colocate vs. spread locality contrast. All 8 placements enter the load matrix — H5's cross-node fraction is computed per strategy (n = 8) — and H6 contrasts the two extremes (colocate vs. spread) under node drain; a gradient run over the intermediate placements extends that two-point contrast.</a:t>
+              <a:t>Analytic weight: the churn findings (H2 conntrack reconvergence, H3 decoupling) rest on the colocate vs. spread locality contrast. All 8 placements enter the load matrix — H5's cross-node fraction is computed per strategy (n = 8, two independent batches) — and H6 spans the full 6-strategy gradient under node drain (observed blast = predicted for every strategy), with the recovery contrast scoped to the extremes.</a:t>
             </a:r>
           </a:p>
         </p:txBody>

</xml_diff>

<commit_message>
docs(presentation): sync deck to post-review claims (H5 separator, H2 probe correction, H6 gradient) (#254)
</commit_message>
<xml_diff>
--- a/ChaosProbe_Presentation.pptx
+++ b/ChaosProbe_Presentation.pptx
@@ -3615,15 +3615,19 @@
               </a:defRPr>
             </a:pPr>
             <a:r>
-              <a:t>• Mechanistic reading: churn tears down</a:t>
+              <a:t>• Protocol probe: TCP dominates the table</a:t>
             </a:r>
             <a:br/>
             <a:r>
-              <a:t>  cross-node flows that must reconverge;</a:t>
+              <a:t>  and DROPS at the kill cycles under BOTH</a:t>
             </a:r>
             <a:br/>
             <a:r>
-              <a:t>  node-local paths are spared</a:t>
+              <a:t>  placements (−28% / −21%) — kernel-side</a:t>
+            </a:r>
+            <a:br/>
+            <a:r>
+              <a:t>  teardown; kube-proxy never flushes TCP</a:t>
             </a:r>
           </a:p>
           <a:p>
@@ -3642,6 +3646,33 @@
               </a:defRPr>
             </a:pPr>
             <a:r>
+              <a:t>• The placement-dependent component is</a:t>
+            </a:r>
+            <a:br/>
+            <a:r>
+              <a:t>  the UDP/DNS pool: ~4× larger under</a:t>
+            </a:r>
+            <a:br/>
+            <a:r>
+              <a:t>  spread (chaos-window medians 910 vs 224)</a:t>
+            </a:r>
+          </a:p>
+          <a:p>
+            <a:pPr>
+              <a:spcBef>
+                <a:spcPts val="200"/>
+              </a:spcBef>
+              <a:spcAft>
+                <a:spcPts val="200"/>
+              </a:spcAft>
+              <a:defRPr sz="1000">
+                <a:solidFill>
+                  <a:srgbClr val="BDBDBD"/>
+                </a:solidFill>
+                <a:latin typeface="Calibri"/>
+              </a:defRPr>
+            </a:pPr>
+            <a:r>
               <a:t>• Corroborating only: CPU throttling —</a:t>
             </a:r>
             <a:br/>
@@ -3731,7 +3762,7 @@
               </a:defRPr>
             </a:pPr>
             <a:r>
-              <a:t>H2 — a reconvergence signature, deliberately not attributed to a specific code path</a:t>
+              <a:t>H2 — attribution protocol-scoped by a dedicated conntrack-composition probe</a:t>
             </a:r>
           </a:p>
         </p:txBody>
@@ -3767,7 +3798,7 @@
               </a:defRPr>
             </a:pPr>
             <a:r>
-              <a:t>The flush is reported as a measured kernel/network reconvergence signature of the kill cycle. It is not attributed to kube-proxy's active conntrack-flush path: upstream that path is UDP-only, while this workload is TCP/gRPC — re-attribution of the exact mechanism is pending.</a:t>
+              <a:t>Both paths are visible: kernel TCP teardown (kube-proxy never flushes TCP) and kube-proxy's documented UDP-only cleanup, with more to clean under spread. The campaign's flush percentages (38.5% vs 2.7%, 7/7 sessions) remain statistically primary and are not apportioned between the two paths (probe: i = 1).</a:t>
             </a:r>
           </a:p>
         </p:txBody>
@@ -4751,7 +4782,7 @@
               </a:defRPr>
             </a:pPr>
             <a:r>
-              <a:t>H5 — cross-node call fraction predicts the east-west tail</a:t>
+              <a:t>H5 — cross-node fraction separates node-local from spreading</a:t>
             </a:r>
           </a:p>
         </p:txBody>
@@ -4766,7 +4797,7 @@
         </p:nvGraphicFramePr>
         <p:xfrm>
           <a:off x="6400800" y="1691640"/>
-          <a:ext cx="5120640" cy="2285997"/>
+          <a:ext cx="5120640" cy="2468880"/>
         </p:xfrm>
         <a:graphic>
           <a:graphicData uri="http://schemas.openxmlformats.org/drawingml/2006/table">
@@ -4775,11 +4806,13 @@
                 <a:tableStyleId>{5C22544A-7EE6-4342-B048-85BDC9FD1C3A}</a:tableStyleId>
               </a:tblPr>
               <a:tblGrid>
-                <a:gridCol w="1706880"/>
-                <a:gridCol w="1706880"/>
-                <a:gridCol w="1706880"/>
+                <a:gridCol w="1024128"/>
+                <a:gridCol w="1024128"/>
+                <a:gridCol w="1024128"/>
+                <a:gridCol w="1024128"/>
+                <a:gridCol w="1024128"/>
               </a:tblGrid>
-              <a:tr h="326571">
+              <a:tr h="274320">
                 <a:tc>
                   <a:txBody>
                     <a:bodyPr wrap="square"/>
@@ -4787,7 +4820,7 @@
                     <a:p>
                       <a:pPr algn="l"/>
                       <a:r>
-                        <a:rPr sz="900" b="1">
+                        <a:rPr sz="800" b="1">
                           <a:solidFill>
                             <a:srgbClr val="FFFFFF"/>
                           </a:solidFill>
@@ -4810,13 +4843,13 @@
                     <a:p>
                       <a:pPr algn="l"/>
                       <a:r>
-                        <a:rPr sz="900" b="1">
+                        <a:rPr sz="800" b="1">
                           <a:solidFill>
                             <a:srgbClr val="FFFFFF"/>
                           </a:solidFill>
                           <a:latin typeface="Calibri"/>
                         </a:rPr>
-                        <a:t>Cross-node fraction</a:t>
+                        <a:t>frac (B1)</a:t>
                       </a:r>
                     </a:p>
                   </a:txBody>
@@ -4833,13 +4866,59 @@
                     <a:p>
                       <a:pPr algn="l"/>
                       <a:r>
-                        <a:rPr sz="900" b="1">
+                        <a:rPr sz="800" b="1">
                           <a:solidFill>
                             <a:srgbClr val="FFFFFF"/>
                           </a:solidFill>
                           <a:latin typeface="Calibri"/>
                         </a:rPr>
-                        <a:t>East-west p95 (ms)</a:t>
+                        <a:t>EW p95 (B1)</a:t>
+                      </a:r>
+                    </a:p>
+                  </a:txBody>
+                  <a:tcPr marL="76200" marR="76200" marT="38100" marB="38100">
+                    <a:solidFill>
+                      <a:srgbClr val="2ECC71"/>
+                    </a:solidFill>
+                  </a:tcPr>
+                </a:tc>
+                <a:tc>
+                  <a:txBody>
+                    <a:bodyPr wrap="square"/>
+                    <a:lstStyle/>
+                    <a:p>
+                      <a:pPr algn="l"/>
+                      <a:r>
+                        <a:rPr sz="800" b="1">
+                          <a:solidFill>
+                            <a:srgbClr val="FFFFFF"/>
+                          </a:solidFill>
+                          <a:latin typeface="Calibri"/>
+                        </a:rPr>
+                        <a:t>frac (B2)</a:t>
+                      </a:r>
+                    </a:p>
+                  </a:txBody>
+                  <a:tcPr marL="76200" marR="76200" marT="38100" marB="38100">
+                    <a:solidFill>
+                      <a:srgbClr val="2ECC71"/>
+                    </a:solidFill>
+                  </a:tcPr>
+                </a:tc>
+                <a:tc>
+                  <a:txBody>
+                    <a:bodyPr wrap="square"/>
+                    <a:lstStyle/>
+                    <a:p>
+                      <a:pPr algn="l"/>
+                      <a:r>
+                        <a:rPr sz="800" b="1">
+                          <a:solidFill>
+                            <a:srgbClr val="FFFFFF"/>
+                          </a:solidFill>
+                          <a:latin typeface="Calibri"/>
+                        </a:rPr>
+                        <a:t>EW p95 (B2)</a:t>
                       </a:r>
                     </a:p>
                   </a:txBody>
@@ -4850,7 +4929,7 @@
                   </a:tcPr>
                 </a:tc>
               </a:tr>
-              <a:tr h="326571">
+              <a:tr h="274320">
                 <a:tc>
                   <a:txBody>
                     <a:bodyPr wrap="square"/>
@@ -4858,7 +4937,7 @@
                     <a:p>
                       <a:pPr algn="l"/>
                       <a:r>
-                        <a:rPr sz="900" b="0">
+                        <a:rPr sz="800" b="0">
                           <a:solidFill>
                             <a:srgbClr val="FFFFFF"/>
                           </a:solidFill>
@@ -4881,7 +4960,7 @@
                     <a:p>
                       <a:pPr algn="l"/>
                       <a:r>
-                        <a:rPr sz="900" b="0">
+                        <a:rPr sz="800" b="0">
                           <a:solidFill>
                             <a:srgbClr val="FFFFFF"/>
                           </a:solidFill>
@@ -4904,7 +4983,7 @@
                     <a:p>
                       <a:pPr algn="l"/>
                       <a:r>
-                        <a:rPr sz="900" b="0">
+                        <a:rPr sz="800" b="0">
                           <a:solidFill>
                             <a:srgbClr val="FFFFFF"/>
                           </a:solidFill>
@@ -4920,8 +4999,6 @@
                     </a:solidFill>
                   </a:tcPr>
                 </a:tc>
-              </a:tr>
-              <a:tr h="326571">
                 <a:tc>
                   <a:txBody>
                     <a:bodyPr wrap="square"/>
@@ -4929,7 +5006,55 @@
                     <a:p>
                       <a:pPr algn="l"/>
                       <a:r>
-                        <a:rPr sz="900" b="0">
+                        <a:rPr sz="800" b="0">
+                          <a:solidFill>
+                            <a:srgbClr val="FFFFFF"/>
+                          </a:solidFill>
+                          <a:latin typeface="Calibri"/>
+                        </a:rPr>
+                        <a:t>0.00</a:t>
+                      </a:r>
+                    </a:p>
+                  </a:txBody>
+                  <a:tcPr marL="76200" marR="76200" marT="38100" marB="38100">
+                    <a:solidFill>
+                      <a:srgbClr val="2A2A3E"/>
+                    </a:solidFill>
+                  </a:tcPr>
+                </a:tc>
+                <a:tc>
+                  <a:txBody>
+                    <a:bodyPr wrap="square"/>
+                    <a:lstStyle/>
+                    <a:p>
+                      <a:pPr algn="l"/>
+                      <a:r>
+                        <a:rPr sz="800" b="0">
+                          <a:solidFill>
+                            <a:srgbClr val="FFFFFF"/>
+                          </a:solidFill>
+                          <a:latin typeface="Calibri"/>
+                        </a:rPr>
+                        <a:t>33.2</a:t>
+                      </a:r>
+                    </a:p>
+                  </a:txBody>
+                  <a:tcPr marL="76200" marR="76200" marT="38100" marB="38100">
+                    <a:solidFill>
+                      <a:srgbClr val="2A2A3E"/>
+                    </a:solidFill>
+                  </a:tcPr>
+                </a:tc>
+              </a:tr>
+              <a:tr h="274320">
+                <a:tc>
+                  <a:txBody>
+                    <a:bodyPr wrap="square"/>
+                    <a:lstStyle/>
+                    <a:p>
+                      <a:pPr algn="l"/>
+                      <a:r>
+                        <a:rPr sz="800" b="0">
                           <a:solidFill>
                             <a:srgbClr val="FFFFFF"/>
                           </a:solidFill>
@@ -4952,7 +5077,7 @@
                     <a:p>
                       <a:pPr algn="l"/>
                       <a:r>
-                        <a:rPr sz="900" b="0">
+                        <a:rPr sz="800" b="0">
                           <a:solidFill>
                             <a:srgbClr val="FFFFFF"/>
                           </a:solidFill>
@@ -4975,7 +5100,7 @@
                     <a:p>
                       <a:pPr algn="l"/>
                       <a:r>
-                        <a:rPr sz="900" b="0">
+                        <a:rPr sz="800" b="0">
                           <a:solidFill>
                             <a:srgbClr val="FFFFFF"/>
                           </a:solidFill>
@@ -4991,8 +5116,6 @@
                     </a:solidFill>
                   </a:tcPr>
                 </a:tc>
-              </a:tr>
-              <a:tr h="326571">
                 <a:tc>
                   <a:txBody>
                     <a:bodyPr wrap="square"/>
@@ -5000,7 +5123,55 @@
                     <a:p>
                       <a:pPr algn="l"/>
                       <a:r>
-                        <a:rPr sz="900" b="0">
+                        <a:rPr sz="800" b="0">
+                          <a:solidFill>
+                            <a:srgbClr val="FFFFFF"/>
+                          </a:solidFill>
+                          <a:latin typeface="Calibri"/>
+                        </a:rPr>
+                        <a:t>0.00</a:t>
+                      </a:r>
+                    </a:p>
+                  </a:txBody>
+                  <a:tcPr marL="76200" marR="76200" marT="38100" marB="38100">
+                    <a:solidFill>
+                      <a:srgbClr val="2A2A3E"/>
+                    </a:solidFill>
+                  </a:tcPr>
+                </a:tc>
+                <a:tc>
+                  <a:txBody>
+                    <a:bodyPr wrap="square"/>
+                    <a:lstStyle/>
+                    <a:p>
+                      <a:pPr algn="l"/>
+                      <a:r>
+                        <a:rPr sz="800" b="0">
+                          <a:solidFill>
+                            <a:srgbClr val="FFFFFF"/>
+                          </a:solidFill>
+                          <a:latin typeface="Calibri"/>
+                        </a:rPr>
+                        <a:t>35.7</a:t>
+                      </a:r>
+                    </a:p>
+                  </a:txBody>
+                  <a:tcPr marL="76200" marR="76200" marT="38100" marB="38100">
+                    <a:solidFill>
+                      <a:srgbClr val="2A2A3E"/>
+                    </a:solidFill>
+                  </a:tcPr>
+                </a:tc>
+              </a:tr>
+              <a:tr h="274320">
+                <a:tc>
+                  <a:txBody>
+                    <a:bodyPr wrap="square"/>
+                    <a:lstStyle/>
+                    <a:p>
+                      <a:pPr algn="l"/>
+                      <a:r>
+                        <a:rPr sz="800" b="0">
                           <a:solidFill>
                             <a:srgbClr val="FFFFFF"/>
                           </a:solidFill>
@@ -5023,7 +5194,7 @@
                     <a:p>
                       <a:pPr algn="l"/>
                       <a:r>
-                        <a:rPr sz="900" b="0">
+                        <a:rPr sz="800" b="0">
                           <a:solidFill>
                             <a:srgbClr val="FFFFFF"/>
                           </a:solidFill>
@@ -5046,7 +5217,7 @@
                     <a:p>
                       <a:pPr algn="l"/>
                       <a:r>
-                        <a:rPr sz="900" b="0">
+                        <a:rPr sz="800" b="0">
                           <a:solidFill>
                             <a:srgbClr val="FFFFFF"/>
                           </a:solidFill>
@@ -5062,8 +5233,6 @@
                     </a:solidFill>
                   </a:tcPr>
                 </a:tc>
-              </a:tr>
-              <a:tr h="326571">
                 <a:tc>
                   <a:txBody>
                     <a:bodyPr wrap="square"/>
@@ -5071,7 +5240,55 @@
                     <a:p>
                       <a:pPr algn="l"/>
                       <a:r>
-                        <a:rPr sz="900" b="0">
+                        <a:rPr sz="800" b="0">
+                          <a:solidFill>
+                            <a:srgbClr val="FFFFFF"/>
+                          </a:solidFill>
+                          <a:latin typeface="Calibri"/>
+                        </a:rPr>
+                        <a:t>0.73</a:t>
+                      </a:r>
+                    </a:p>
+                  </a:txBody>
+                  <a:tcPr marL="76200" marR="76200" marT="38100" marB="38100">
+                    <a:solidFill>
+                      <a:srgbClr val="2A2A3E"/>
+                    </a:solidFill>
+                  </a:tcPr>
+                </a:tc>
+                <a:tc>
+                  <a:txBody>
+                    <a:bodyPr wrap="square"/>
+                    <a:lstStyle/>
+                    <a:p>
+                      <a:pPr algn="l"/>
+                      <a:r>
+                        <a:rPr sz="800" b="0">
+                          <a:solidFill>
+                            <a:srgbClr val="FFFFFF"/>
+                          </a:solidFill>
+                          <a:latin typeface="Calibri"/>
+                        </a:rPr>
+                        <a:t>43.8</a:t>
+                      </a:r>
+                    </a:p>
+                  </a:txBody>
+                  <a:tcPr marL="76200" marR="76200" marT="38100" marB="38100">
+                    <a:solidFill>
+                      <a:srgbClr val="2A2A3E"/>
+                    </a:solidFill>
+                  </a:tcPr>
+                </a:tc>
+              </a:tr>
+              <a:tr h="274320">
+                <a:tc>
+                  <a:txBody>
+                    <a:bodyPr wrap="square"/>
+                    <a:lstStyle/>
+                    <a:p>
+                      <a:pPr algn="l"/>
+                      <a:r>
+                        <a:rPr sz="800" b="0">
                           <a:solidFill>
                             <a:srgbClr val="FFFFFF"/>
                           </a:solidFill>
@@ -5094,7 +5311,7 @@
                     <a:p>
                       <a:pPr algn="l"/>
                       <a:r>
-                        <a:rPr sz="900" b="0">
+                        <a:rPr sz="800" b="0">
                           <a:solidFill>
                             <a:srgbClr val="FFFFFF"/>
                           </a:solidFill>
@@ -5117,7 +5334,7 @@
                     <a:p>
                       <a:pPr algn="l"/>
                       <a:r>
-                        <a:rPr sz="900" b="0">
+                        <a:rPr sz="800" b="0">
                           <a:solidFill>
                             <a:srgbClr val="FFFFFF"/>
                           </a:solidFill>
@@ -5133,8 +5350,6 @@
                     </a:solidFill>
                   </a:tcPr>
                 </a:tc>
-              </a:tr>
-              <a:tr h="326571">
                 <a:tc>
                   <a:txBody>
                     <a:bodyPr wrap="square"/>
@@ -5142,7 +5357,406 @@
                     <a:p>
                       <a:pPr algn="l"/>
                       <a:r>
-                        <a:rPr sz="900" b="0">
+                        <a:rPr sz="800" b="0">
+                          <a:solidFill>
+                            <a:srgbClr val="FFFFFF"/>
+                          </a:solidFill>
+                          <a:latin typeface="Calibri"/>
+                        </a:rPr>
+                        <a:t>0.73</a:t>
+                      </a:r>
+                    </a:p>
+                  </a:txBody>
+                  <a:tcPr marL="76200" marR="76200" marT="38100" marB="38100">
+                    <a:solidFill>
+                      <a:srgbClr val="2A2A3E"/>
+                    </a:solidFill>
+                  </a:tcPr>
+                </a:tc>
+                <a:tc>
+                  <a:txBody>
+                    <a:bodyPr wrap="square"/>
+                    <a:lstStyle/>
+                    <a:p>
+                      <a:pPr algn="l"/>
+                      <a:r>
+                        <a:rPr sz="800" b="0">
+                          <a:solidFill>
+                            <a:srgbClr val="FFFFFF"/>
+                          </a:solidFill>
+                          <a:latin typeface="Calibri"/>
+                        </a:rPr>
+                        <a:t>44.2</a:t>
+                      </a:r>
+                    </a:p>
+                  </a:txBody>
+                  <a:tcPr marL="76200" marR="76200" marT="38100" marB="38100">
+                    <a:solidFill>
+                      <a:srgbClr val="2A2A3E"/>
+                    </a:solidFill>
+                  </a:tcPr>
+                </a:tc>
+              </a:tr>
+              <a:tr h="274320">
+                <a:tc>
+                  <a:txBody>
+                    <a:bodyPr wrap="square"/>
+                    <a:lstStyle/>
+                    <a:p>
+                      <a:pPr algn="l"/>
+                      <a:r>
+                        <a:rPr sz="800" b="0">
+                          <a:solidFill>
+                            <a:srgbClr val="FFFFFF"/>
+                          </a:solidFill>
+                          <a:latin typeface="Calibri"/>
+                        </a:rPr>
+                        <a:t>baseline</a:t>
+                      </a:r>
+                    </a:p>
+                  </a:txBody>
+                  <a:tcPr marL="76200" marR="76200" marT="38100" marB="38100">
+                    <a:solidFill>
+                      <a:srgbClr val="2A2A3E"/>
+                    </a:solidFill>
+                  </a:tcPr>
+                </a:tc>
+                <a:tc>
+                  <a:txBody>
+                    <a:bodyPr wrap="square"/>
+                    <a:lstStyle/>
+                    <a:p>
+                      <a:pPr algn="l"/>
+                      <a:r>
+                        <a:rPr sz="800" b="0">
+                          <a:solidFill>
+                            <a:srgbClr val="FFFFFF"/>
+                          </a:solidFill>
+                          <a:latin typeface="Calibri"/>
+                        </a:rPr>
+                        <a:t>0.70</a:t>
+                      </a:r>
+                    </a:p>
+                  </a:txBody>
+                  <a:tcPr marL="76200" marR="76200" marT="38100" marB="38100">
+                    <a:solidFill>
+                      <a:srgbClr val="2A2A3E"/>
+                    </a:solidFill>
+                  </a:tcPr>
+                </a:tc>
+                <a:tc>
+                  <a:txBody>
+                    <a:bodyPr wrap="square"/>
+                    <a:lstStyle/>
+                    <a:p>
+                      <a:pPr algn="l"/>
+                      <a:r>
+                        <a:rPr sz="800" b="0">
+                          <a:solidFill>
+                            <a:srgbClr val="FFFFFF"/>
+                          </a:solidFill>
+                          <a:latin typeface="Calibri"/>
+                        </a:rPr>
+                        <a:t>43.5</a:t>
+                      </a:r>
+                    </a:p>
+                  </a:txBody>
+                  <a:tcPr marL="76200" marR="76200" marT="38100" marB="38100">
+                    <a:solidFill>
+                      <a:srgbClr val="2A2A3E"/>
+                    </a:solidFill>
+                  </a:tcPr>
+                </a:tc>
+                <a:tc>
+                  <a:txBody>
+                    <a:bodyPr wrap="square"/>
+                    <a:lstStyle/>
+                    <a:p>
+                      <a:pPr algn="l"/>
+                      <a:r>
+                        <a:rPr sz="800" b="0">
+                          <a:solidFill>
+                            <a:srgbClr val="FFFFFF"/>
+                          </a:solidFill>
+                          <a:latin typeface="Calibri"/>
+                        </a:rPr>
+                        <a:t>0.78</a:t>
+                      </a:r>
+                    </a:p>
+                  </a:txBody>
+                  <a:tcPr marL="76200" marR="76200" marT="38100" marB="38100">
+                    <a:solidFill>
+                      <a:srgbClr val="2A2A3E"/>
+                    </a:solidFill>
+                  </a:tcPr>
+                </a:tc>
+                <a:tc>
+                  <a:txBody>
+                    <a:bodyPr wrap="square"/>
+                    <a:lstStyle/>
+                    <a:p>
+                      <a:pPr algn="l"/>
+                      <a:r>
+                        <a:rPr sz="800" b="0">
+                          <a:solidFill>
+                            <a:srgbClr val="FFFFFF"/>
+                          </a:solidFill>
+                          <a:latin typeface="Calibri"/>
+                        </a:rPr>
+                        <a:t>41.7</a:t>
+                      </a:r>
+                    </a:p>
+                  </a:txBody>
+                  <a:tcPr marL="76200" marR="76200" marT="38100" marB="38100">
+                    <a:solidFill>
+                      <a:srgbClr val="2A2A3E"/>
+                    </a:solidFill>
+                  </a:tcPr>
+                </a:tc>
+              </a:tr>
+              <a:tr h="274320">
+                <a:tc>
+                  <a:txBody>
+                    <a:bodyPr wrap="square"/>
+                    <a:lstStyle/>
+                    <a:p>
+                      <a:pPr algn="l"/>
+                      <a:r>
+                        <a:rPr sz="800" b="0">
+                          <a:solidFill>
+                            <a:srgbClr val="FFFFFF"/>
+                          </a:solidFill>
+                          <a:latin typeface="Calibri"/>
+                        </a:rPr>
+                        <a:t>adversarial</a:t>
+                      </a:r>
+                    </a:p>
+                  </a:txBody>
+                  <a:tcPr marL="76200" marR="76200" marT="38100" marB="38100">
+                    <a:solidFill>
+                      <a:srgbClr val="2A2A3E"/>
+                    </a:solidFill>
+                  </a:tcPr>
+                </a:tc>
+                <a:tc>
+                  <a:txBody>
+                    <a:bodyPr wrap="square"/>
+                    <a:lstStyle/>
+                    <a:p>
+                      <a:pPr algn="l"/>
+                      <a:r>
+                        <a:rPr sz="800" b="0">
+                          <a:solidFill>
+                            <a:srgbClr val="FFFFFF"/>
+                          </a:solidFill>
+                          <a:latin typeface="Calibri"/>
+                        </a:rPr>
+                        <a:t>0.80</a:t>
+                      </a:r>
+                    </a:p>
+                  </a:txBody>
+                  <a:tcPr marL="76200" marR="76200" marT="38100" marB="38100">
+                    <a:solidFill>
+                      <a:srgbClr val="2A2A3E"/>
+                    </a:solidFill>
+                  </a:tcPr>
+                </a:tc>
+                <a:tc>
+                  <a:txBody>
+                    <a:bodyPr wrap="square"/>
+                    <a:lstStyle/>
+                    <a:p>
+                      <a:pPr algn="l"/>
+                      <a:r>
+                        <a:rPr sz="800" b="0">
+                          <a:solidFill>
+                            <a:srgbClr val="FFFFFF"/>
+                          </a:solidFill>
+                          <a:latin typeface="Calibri"/>
+                        </a:rPr>
+                        <a:t>43.5</a:t>
+                      </a:r>
+                    </a:p>
+                  </a:txBody>
+                  <a:tcPr marL="76200" marR="76200" marT="38100" marB="38100">
+                    <a:solidFill>
+                      <a:srgbClr val="2A2A3E"/>
+                    </a:solidFill>
+                  </a:tcPr>
+                </a:tc>
+                <a:tc>
+                  <a:txBody>
+                    <a:bodyPr wrap="square"/>
+                    <a:lstStyle/>
+                    <a:p>
+                      <a:pPr algn="l"/>
+                      <a:r>
+                        <a:rPr sz="800" b="0">
+                          <a:solidFill>
+                            <a:srgbClr val="FFFFFF"/>
+                          </a:solidFill>
+                          <a:latin typeface="Calibri"/>
+                        </a:rPr>
+                        <a:t>0.80</a:t>
+                      </a:r>
+                    </a:p>
+                  </a:txBody>
+                  <a:tcPr marL="76200" marR="76200" marT="38100" marB="38100">
+                    <a:solidFill>
+                      <a:srgbClr val="2A2A3E"/>
+                    </a:solidFill>
+                  </a:tcPr>
+                </a:tc>
+                <a:tc>
+                  <a:txBody>
+                    <a:bodyPr wrap="square"/>
+                    <a:lstStyle/>
+                    <a:p>
+                      <a:pPr algn="l"/>
+                      <a:r>
+                        <a:rPr sz="800" b="0">
+                          <a:solidFill>
+                            <a:srgbClr val="FFFFFF"/>
+                          </a:solidFill>
+                          <a:latin typeface="Calibri"/>
+                        </a:rPr>
+                        <a:t>42.0</a:t>
+                      </a:r>
+                    </a:p>
+                  </a:txBody>
+                  <a:tcPr marL="76200" marR="76200" marT="38100" marB="38100">
+                    <a:solidFill>
+                      <a:srgbClr val="2A2A3E"/>
+                    </a:solidFill>
+                  </a:tcPr>
+                </a:tc>
+              </a:tr>
+              <a:tr h="274320">
+                <a:tc>
+                  <a:txBody>
+                    <a:bodyPr wrap="square"/>
+                    <a:lstStyle/>
+                    <a:p>
+                      <a:pPr algn="l"/>
+                      <a:r>
+                        <a:rPr sz="800" b="0">
+                          <a:solidFill>
+                            <a:srgbClr val="FFFFFF"/>
+                          </a:solidFill>
+                          <a:latin typeface="Calibri"/>
+                        </a:rPr>
+                        <a:t>default</a:t>
+                      </a:r>
+                    </a:p>
+                  </a:txBody>
+                  <a:tcPr marL="76200" marR="76200" marT="38100" marB="38100">
+                    <a:solidFill>
+                      <a:srgbClr val="2A2A3E"/>
+                    </a:solidFill>
+                  </a:tcPr>
+                </a:tc>
+                <a:tc>
+                  <a:txBody>
+                    <a:bodyPr wrap="square"/>
+                    <a:lstStyle/>
+                    <a:p>
+                      <a:pPr algn="l"/>
+                      <a:r>
+                        <a:rPr sz="800" b="0">
+                          <a:solidFill>
+                            <a:srgbClr val="FFFFFF"/>
+                          </a:solidFill>
+                          <a:latin typeface="Calibri"/>
+                        </a:rPr>
+                        <a:t>0.78</a:t>
+                      </a:r>
+                    </a:p>
+                  </a:txBody>
+                  <a:tcPr marL="76200" marR="76200" marT="38100" marB="38100">
+                    <a:solidFill>
+                      <a:srgbClr val="2A2A3E"/>
+                    </a:solidFill>
+                  </a:tcPr>
+                </a:tc>
+                <a:tc>
+                  <a:txBody>
+                    <a:bodyPr wrap="square"/>
+                    <a:lstStyle/>
+                    <a:p>
+                      <a:pPr algn="l"/>
+                      <a:r>
+                        <a:rPr sz="800" b="0">
+                          <a:solidFill>
+                            <a:srgbClr val="FFFFFF"/>
+                          </a:solidFill>
+                          <a:latin typeface="Calibri"/>
+                        </a:rPr>
+                        <a:t>45.5</a:t>
+                      </a:r>
+                    </a:p>
+                  </a:txBody>
+                  <a:tcPr marL="76200" marR="76200" marT="38100" marB="38100">
+                    <a:solidFill>
+                      <a:srgbClr val="2A2A3E"/>
+                    </a:solidFill>
+                  </a:tcPr>
+                </a:tc>
+                <a:tc>
+                  <a:txBody>
+                    <a:bodyPr wrap="square"/>
+                    <a:lstStyle/>
+                    <a:p>
+                      <a:pPr algn="l"/>
+                      <a:r>
+                        <a:rPr sz="800" b="0">
+                          <a:solidFill>
+                            <a:srgbClr val="FFFFFF"/>
+                          </a:solidFill>
+                          <a:latin typeface="Calibri"/>
+                        </a:rPr>
+                        <a:t>0.82</a:t>
+                      </a:r>
+                    </a:p>
+                  </a:txBody>
+                  <a:tcPr marL="76200" marR="76200" marT="38100" marB="38100">
+                    <a:solidFill>
+                      <a:srgbClr val="2A2A3E"/>
+                    </a:solidFill>
+                  </a:tcPr>
+                </a:tc>
+                <a:tc>
+                  <a:txBody>
+                    <a:bodyPr wrap="square"/>
+                    <a:lstStyle/>
+                    <a:p>
+                      <a:pPr algn="l"/>
+                      <a:r>
+                        <a:rPr sz="800" b="0">
+                          <a:solidFill>
+                            <a:srgbClr val="FFFFFF"/>
+                          </a:solidFill>
+                          <a:latin typeface="Calibri"/>
+                        </a:rPr>
+                        <a:t>41.6</a:t>
+                      </a:r>
+                    </a:p>
+                  </a:txBody>
+                  <a:tcPr marL="76200" marR="76200" marT="38100" marB="38100">
+                    <a:solidFill>
+                      <a:srgbClr val="2A2A3E"/>
+                    </a:solidFill>
+                  </a:tcPr>
+                </a:tc>
+              </a:tr>
+              <a:tr h="274320">
+                <a:tc>
+                  <a:txBody>
+                    <a:bodyPr wrap="square"/>
+                    <a:lstStyle/>
+                    <a:p>
+                      <a:pPr algn="l"/>
+                      <a:r>
+                        <a:rPr sz="800" b="0">
                           <a:solidFill>
                             <a:srgbClr val="FFFFFF"/>
                           </a:solidFill>
@@ -5165,7 +5779,7 @@
                     <a:p>
                       <a:pPr algn="l"/>
                       <a:r>
-                        <a:rPr sz="900" b="0">
+                        <a:rPr sz="800" b="0">
                           <a:solidFill>
                             <a:srgbClr val="FFFFFF"/>
                           </a:solidFill>
@@ -5188,38 +5802,13 @@
                     <a:p>
                       <a:pPr algn="l"/>
                       <a:r>
-                        <a:rPr sz="900" b="0">
+                        <a:rPr sz="800" b="0">
                           <a:solidFill>
                             <a:srgbClr val="FFFFFF"/>
                           </a:solidFill>
                           <a:latin typeface="Calibri"/>
                         </a:rPr>
                         <a:t>43.9</a:t>
-                      </a:r>
-                    </a:p>
-                  </a:txBody>
-                  <a:tcPr marL="76200" marR="76200" marT="38100" marB="38100">
-                    <a:solidFill>
-                      <a:srgbClr val="2A2A3E"/>
-                    </a:solidFill>
-                  </a:tcPr>
-                </a:tc>
-              </a:tr>
-              <a:tr h="326571">
-                <a:tc>
-                  <a:txBody>
-                    <a:bodyPr wrap="square"/>
-                    <a:lstStyle/>
-                    <a:p>
-                      <a:pPr algn="l"/>
-                      <a:r>
-                        <a:rPr sz="900" b="0">
-                          <a:solidFill>
-                            <a:srgbClr val="FFFFFF"/>
-                          </a:solidFill>
-                          <a:latin typeface="Calibri"/>
-                        </a:rPr>
-                        <a:t>default</a:t>
                       </a:r>
                     </a:p>
                   </a:txBody>
@@ -5236,13 +5825,13 @@
                     <a:p>
                       <a:pPr algn="l"/>
                       <a:r>
-                        <a:rPr sz="900" b="0">
+                        <a:rPr sz="800" b="0">
                           <a:solidFill>
                             <a:srgbClr val="FFFFFF"/>
                           </a:solidFill>
                           <a:latin typeface="Calibri"/>
                         </a:rPr>
-                        <a:t>0.78</a:t>
+                        <a:t>0.80</a:t>
                       </a:r>
                     </a:p>
                   </a:txBody>
@@ -5259,13 +5848,13 @@
                     <a:p>
                       <a:pPr algn="l"/>
                       <a:r>
-                        <a:rPr sz="900" b="0">
+                        <a:rPr sz="800" b="0">
                           <a:solidFill>
                             <a:srgbClr val="FFFFFF"/>
                           </a:solidFill>
                           <a:latin typeface="Calibri"/>
                         </a:rPr>
-                        <a:t>45.5</a:t>
+                        <a:t>42.8</a:t>
                       </a:r>
                     </a:p>
                   </a:txBody>
@@ -5288,8 +5877,8 @@
         </p:nvSpPr>
         <p:spPr>
           <a:xfrm>
-            <a:off x="6400800" y="4069080"/>
-            <a:ext cx="5120640" cy="1188720"/>
+            <a:off x="6400800" y="4206240"/>
+            <a:ext cx="5120640" cy="1051560"/>
           </a:xfrm>
           <a:prstGeom prst="rect">
             <a:avLst/>
@@ -5317,7 +5906,11 @@
               </a:defRPr>
             </a:pPr>
             <a:r>
-              <a:t>• Spearman ρ = 0.79 (n = 8 strategies, p &lt; 0.05)</a:t>
+              <a:t>• Node-local pair = the 2 lowest tails of 8 in BOTH</a:t>
+            </a:r>
+            <a:br/>
+            <a:r>
+              <a:t>  batches (joint null ≈ 0.0013) — ~1.25× below the rest</a:t>
             </a:r>
           </a:p>
           <a:p>
@@ -5336,15 +5929,11 @@
               </a:defRPr>
             </a:pPr>
             <a:r>
-              <a:t>• Computable from the dependency graph + placement</a:t>
+              <a:t>• Continuous ρ = 0.79 (batch 1) → 0.25 n.s. (batch 2):</a:t>
             </a:r>
             <a:br/>
             <a:r>
-              <a:t>  before any chaos — the Neo4j graph becomes</a:t>
-            </a:r>
-            <a:br/>
-            <a:r>
-              <a:t>  analytically load-bearing, not mere storage</a:t>
+              <a:t>  a replicated two-regime separator, not a smooth law</a:t>
             </a:r>
           </a:p>
         </p:txBody>
@@ -5425,7 +6014,7 @@
               </a:defRPr>
             </a:pPr>
             <a:r>
-              <a:t>Framing: empirical validation of a static pre-chaos predictor — and a coarse one</a:t>
+              <a:t>Framing: a replicated two-regime separator — not a validated smooth predictor</a:t>
             </a:r>
           </a:p>
         </p:txBody>
@@ -5461,7 +6050,7 @@
               </a:defRPr>
             </a:pPr>
             <a:r>
-              <a:t>Locality-as-objective already belongs to the literature (NetMARKS, graph-partitioning schedulers); the contribution here is validating the graph-derived fraction against measured during-load tails. The correlation is coarse — it separates the two node-local placements (colocate, best-fit) from the six spreading ones, which cluster at 0.70–0.80 — and single-batch. Note dependency-aware's partition did not co-locate as intended (0.73, spread-like).</a:t>
+              <a:t>Locality-as-objective already belongs to the literature (NetMARKS, graph-partitioning schedulers); the contribution is validating the graph-derived fraction (Neo4j graph + podPlacements, pre-chaos) against measured during-load tails in two independent batches. The continuous law is not claimed: batch 1's ρ = 0.79 was carried by best-fit's intermediate 0.13 point and collapsed to ρ = 0.25 (n.s.) when best-fit packed fully in batch 2. Note dependency-aware's partition did not co-locate as intended (0.73, spread-like, both batches).</a:t>
             </a:r>
           </a:p>
         </p:txBody>
@@ -5662,7 +6251,7 @@
         </p:nvGraphicFramePr>
         <p:xfrm>
           <a:off x="640080" y="1691640"/>
-          <a:ext cx="5577840" cy="1188720"/>
+          <a:ext cx="5577840" cy="2011674"/>
         </p:xfrm>
         <a:graphic>
           <a:graphicData uri="http://schemas.openxmlformats.org/drawingml/2006/table">
@@ -5676,7 +6265,7 @@
                 <a:gridCol w="1394460"/>
                 <a:gridCol w="1394460"/>
               </a:tblGrid>
-              <a:tr h="396240">
+              <a:tr h="287382">
                 <a:tc>
                   <a:txBody>
                     <a:bodyPr wrap="square"/>
@@ -5690,7 +6279,7 @@
                           </a:solidFill>
                           <a:latin typeface="Calibri"/>
                         </a:rPr>
-                        <a:t>Placement</a:t>
+                        <a:t>Strategy</a:t>
                       </a:r>
                     </a:p>
                   </a:txBody>
@@ -5736,7 +6325,7 @@
                           </a:solidFill>
                           <a:latin typeface="Calibri"/>
                         </a:rPr>
-                        <a:t>Blast radius</a:t>
+                        <a:t>Blast (observed)</a:t>
                       </a:r>
                     </a:p>
                   </a:txBody>
@@ -5759,7 +6348,7 @@
                           </a:solidFill>
                           <a:latin typeface="Calibri"/>
                         </a:rPr>
-                        <a:t>Target recovery</a:t>
+                        <a:t>Recovery (mean)</a:t>
                       </a:r>
                     </a:p>
                   </a:txBody>
@@ -5770,7 +6359,7 @@
                   </a:tcPr>
                 </a:tc>
               </a:tr>
-              <a:tr h="396240">
+              <a:tr h="287382">
                 <a:tc>
                   <a:txBody>
                     <a:bodyPr wrap="square"/>
@@ -5853,7 +6442,7 @@
                           </a:solidFill>
                           <a:latin typeface="Calibri"/>
                         </a:rPr>
-                        <a:t>~10.3 s</a:t>
+                        <a:t>10.8 s</a:t>
                       </a:r>
                     </a:p>
                   </a:txBody>
@@ -5864,7 +6453,289 @@
                   </a:tcPr>
                 </a:tc>
               </a:tr>
-              <a:tr h="396240">
+              <a:tr h="287382">
+                <a:tc>
+                  <a:txBody>
+                    <a:bodyPr wrap="square"/>
+                    <a:lstStyle/>
+                    <a:p>
+                      <a:pPr algn="l"/>
+                      <a:r>
+                        <a:rPr sz="900" b="0">
+                          <a:solidFill>
+                            <a:srgbClr val="FFFFFF"/>
+                          </a:solidFill>
+                          <a:latin typeface="Calibri"/>
+                        </a:rPr>
+                        <a:t>random</a:t>
+                      </a:r>
+                    </a:p>
+                  </a:txBody>
+                  <a:tcPr marL="76200" marR="76200" marT="38100" marB="38100">
+                    <a:solidFill>
+                      <a:srgbClr val="2A2A3E"/>
+                    </a:solidFill>
+                  </a:tcPr>
+                </a:tc>
+                <a:tc>
+                  <a:txBody>
+                    <a:bodyPr wrap="square"/>
+                    <a:lstStyle/>
+                    <a:p>
+                      <a:pPr algn="l"/>
+                      <a:r>
+                        <a:rPr sz="900" b="0">
+                          <a:solidFill>
+                            <a:srgbClr val="FFFFFF"/>
+                          </a:solidFill>
+                          <a:latin typeface="Calibri"/>
+                        </a:rPr>
+                        <a:t>4 / 11 services</a:t>
+                      </a:r>
+                    </a:p>
+                  </a:txBody>
+                  <a:tcPr marL="76200" marR="76200" marT="38100" marB="38100">
+                    <a:solidFill>
+                      <a:srgbClr val="2A2A3E"/>
+                    </a:solidFill>
+                  </a:tcPr>
+                </a:tc>
+                <a:tc>
+                  <a:txBody>
+                    <a:bodyPr wrap="square"/>
+                    <a:lstStyle/>
+                    <a:p>
+                      <a:pPr algn="l"/>
+                      <a:r>
+                        <a:rPr sz="900" b="0">
+                          <a:solidFill>
+                            <a:srgbClr val="FFFFFF"/>
+                          </a:solidFill>
+                          <a:latin typeface="Calibri"/>
+                        </a:rPr>
+                        <a:t>4</a:t>
+                      </a:r>
+                    </a:p>
+                  </a:txBody>
+                  <a:tcPr marL="76200" marR="76200" marT="38100" marB="38100">
+                    <a:solidFill>
+                      <a:srgbClr val="2A2A3E"/>
+                    </a:solidFill>
+                  </a:tcPr>
+                </a:tc>
+                <a:tc>
+                  <a:txBody>
+                    <a:bodyPr wrap="square"/>
+                    <a:lstStyle/>
+                    <a:p>
+                      <a:pPr algn="l"/>
+                      <a:r>
+                        <a:rPr sz="900" b="0">
+                          <a:solidFill>
+                            <a:srgbClr val="FFFFFF"/>
+                          </a:solidFill>
+                          <a:latin typeface="Calibri"/>
+                        </a:rPr>
+                        <a:t>4.6 s</a:t>
+                      </a:r>
+                    </a:p>
+                  </a:txBody>
+                  <a:tcPr marL="76200" marR="76200" marT="38100" marB="38100">
+                    <a:solidFill>
+                      <a:srgbClr val="2A2A3E"/>
+                    </a:solidFill>
+                  </a:tcPr>
+                </a:tc>
+              </a:tr>
+              <a:tr h="287382">
+                <a:tc>
+                  <a:txBody>
+                    <a:bodyPr wrap="square"/>
+                    <a:lstStyle/>
+                    <a:p>
+                      <a:pPr algn="l"/>
+                      <a:r>
+                        <a:rPr sz="900" b="0">
+                          <a:solidFill>
+                            <a:srgbClr val="FFFFFF"/>
+                          </a:solidFill>
+                          <a:latin typeface="Calibri"/>
+                        </a:rPr>
+                        <a:t>dependency-aware</a:t>
+                      </a:r>
+                    </a:p>
+                  </a:txBody>
+                  <a:tcPr marL="76200" marR="76200" marT="38100" marB="38100">
+                    <a:solidFill>
+                      <a:srgbClr val="2A2A3E"/>
+                    </a:solidFill>
+                  </a:tcPr>
+                </a:tc>
+                <a:tc>
+                  <a:txBody>
+                    <a:bodyPr wrap="square"/>
+                    <a:lstStyle/>
+                    <a:p>
+                      <a:pPr algn="l"/>
+                      <a:r>
+                        <a:rPr sz="900" b="0">
+                          <a:solidFill>
+                            <a:srgbClr val="FFFFFF"/>
+                          </a:solidFill>
+                          <a:latin typeface="Calibri"/>
+                        </a:rPr>
+                        <a:t>3 / 11 services</a:t>
+                      </a:r>
+                    </a:p>
+                  </a:txBody>
+                  <a:tcPr marL="76200" marR="76200" marT="38100" marB="38100">
+                    <a:solidFill>
+                      <a:srgbClr val="2A2A3E"/>
+                    </a:solidFill>
+                  </a:tcPr>
+                </a:tc>
+                <a:tc>
+                  <a:txBody>
+                    <a:bodyPr wrap="square"/>
+                    <a:lstStyle/>
+                    <a:p>
+                      <a:pPr algn="l"/>
+                      <a:r>
+                        <a:rPr sz="900" b="0">
+                          <a:solidFill>
+                            <a:srgbClr val="FFFFFF"/>
+                          </a:solidFill>
+                          <a:latin typeface="Calibri"/>
+                        </a:rPr>
+                        <a:t>3</a:t>
+                      </a:r>
+                    </a:p>
+                  </a:txBody>
+                  <a:tcPr marL="76200" marR="76200" marT="38100" marB="38100">
+                    <a:solidFill>
+                      <a:srgbClr val="2A2A3E"/>
+                    </a:solidFill>
+                  </a:tcPr>
+                </a:tc>
+                <a:tc>
+                  <a:txBody>
+                    <a:bodyPr wrap="square"/>
+                    <a:lstStyle/>
+                    <a:p>
+                      <a:pPr algn="l"/>
+                      <a:r>
+                        <a:rPr sz="900" b="0">
+                          <a:solidFill>
+                            <a:srgbClr val="FFFFFF"/>
+                          </a:solidFill>
+                          <a:latin typeface="Calibri"/>
+                        </a:rPr>
+                        <a:t>33.3 s</a:t>
+                      </a:r>
+                    </a:p>
+                  </a:txBody>
+                  <a:tcPr marL="76200" marR="76200" marT="38100" marB="38100">
+                    <a:solidFill>
+                      <a:srgbClr val="2A2A3E"/>
+                    </a:solidFill>
+                  </a:tcPr>
+                </a:tc>
+              </a:tr>
+              <a:tr h="287382">
+                <a:tc>
+                  <a:txBody>
+                    <a:bodyPr wrap="square"/>
+                    <a:lstStyle/>
+                    <a:p>
+                      <a:pPr algn="l"/>
+                      <a:r>
+                        <a:rPr sz="900" b="0">
+                          <a:solidFill>
+                            <a:srgbClr val="FFFFFF"/>
+                          </a:solidFill>
+                          <a:latin typeface="Calibri"/>
+                        </a:rPr>
+                        <a:t>best-fit</a:t>
+                      </a:r>
+                    </a:p>
+                  </a:txBody>
+                  <a:tcPr marL="76200" marR="76200" marT="38100" marB="38100">
+                    <a:solidFill>
+                      <a:srgbClr val="2A2A3E"/>
+                    </a:solidFill>
+                  </a:tcPr>
+                </a:tc>
+                <a:tc>
+                  <a:txBody>
+                    <a:bodyPr wrap="square"/>
+                    <a:lstStyle/>
+                    <a:p>
+                      <a:pPr algn="l"/>
+                      <a:r>
+                        <a:rPr sz="900" b="0">
+                          <a:solidFill>
+                            <a:srgbClr val="FFFFFF"/>
+                          </a:solidFill>
+                          <a:latin typeface="Calibri"/>
+                        </a:rPr>
+                        <a:t>3 / 11 services</a:t>
+                      </a:r>
+                    </a:p>
+                  </a:txBody>
+                  <a:tcPr marL="76200" marR="76200" marT="38100" marB="38100">
+                    <a:solidFill>
+                      <a:srgbClr val="2A2A3E"/>
+                    </a:solidFill>
+                  </a:tcPr>
+                </a:tc>
+                <a:tc>
+                  <a:txBody>
+                    <a:bodyPr wrap="square"/>
+                    <a:lstStyle/>
+                    <a:p>
+                      <a:pPr algn="l"/>
+                      <a:r>
+                        <a:rPr sz="900" b="0">
+                          <a:solidFill>
+                            <a:srgbClr val="FFFFFF"/>
+                          </a:solidFill>
+                          <a:latin typeface="Calibri"/>
+                        </a:rPr>
+                        <a:t>3</a:t>
+                      </a:r>
+                    </a:p>
+                  </a:txBody>
+                  <a:tcPr marL="76200" marR="76200" marT="38100" marB="38100">
+                    <a:solidFill>
+                      <a:srgbClr val="2A2A3E"/>
+                    </a:solidFill>
+                  </a:tcPr>
+                </a:tc>
+                <a:tc>
+                  <a:txBody>
+                    <a:bodyPr wrap="square"/>
+                    <a:lstStyle/>
+                    <a:p>
+                      <a:pPr algn="l"/>
+                      <a:r>
+                        <a:rPr sz="900" b="0">
+                          <a:solidFill>
+                            <a:srgbClr val="FFFFFF"/>
+                          </a:solidFill>
+                          <a:latin typeface="Calibri"/>
+                        </a:rPr>
+                        <a:t>9.7 s</a:t>
+                      </a:r>
+                    </a:p>
+                  </a:txBody>
+                  <a:tcPr marL="76200" marR="76200" marT="38100" marB="38100">
+                    <a:solidFill>
+                      <a:srgbClr val="2A2A3E"/>
+                    </a:solidFill>
+                  </a:tcPr>
+                </a:tc>
+              </a:tr>
+              <a:tr h="287382">
                 <a:tc>
                   <a:txBody>
                     <a:bodyPr wrap="square"/>
@@ -5924,7 +6795,7 @@
                           </a:solidFill>
                           <a:latin typeface="Calibri"/>
                         </a:rPr>
-                        <a:t>2 services (18%)</a:t>
+                        <a:t>2 (18%)</a:t>
                       </a:r>
                     </a:p>
                   </a:txBody>
@@ -5947,7 +6818,101 @@
                           </a:solidFill>
                           <a:latin typeface="Calibri"/>
                         </a:rPr>
-                        <a:t>~2.6 s</a:t>
+                        <a:t>2.6 s</a:t>
+                      </a:r>
+                    </a:p>
+                  </a:txBody>
+                  <a:tcPr marL="76200" marR="76200" marT="38100" marB="38100">
+                    <a:solidFill>
+                      <a:srgbClr val="2A2A3E"/>
+                    </a:solidFill>
+                  </a:tcPr>
+                </a:tc>
+              </a:tr>
+              <a:tr h="287382">
+                <a:tc>
+                  <a:txBody>
+                    <a:bodyPr wrap="square"/>
+                    <a:lstStyle/>
+                    <a:p>
+                      <a:pPr algn="l"/>
+                      <a:r>
+                        <a:rPr sz="900" b="0">
+                          <a:solidFill>
+                            <a:srgbClr val="FFFFFF"/>
+                          </a:solidFill>
+                          <a:latin typeface="Calibri"/>
+                        </a:rPr>
+                        <a:t>adversarial</a:t>
+                      </a:r>
+                    </a:p>
+                  </a:txBody>
+                  <a:tcPr marL="76200" marR="76200" marT="38100" marB="38100">
+                    <a:solidFill>
+                      <a:srgbClr val="2A2A3E"/>
+                    </a:solidFill>
+                  </a:tcPr>
+                </a:tc>
+                <a:tc>
+                  <a:txBody>
+                    <a:bodyPr wrap="square"/>
+                    <a:lstStyle/>
+                    <a:p>
+                      <a:pPr algn="l"/>
+                      <a:r>
+                        <a:rPr sz="900" b="0">
+                          <a:solidFill>
+                            <a:srgbClr val="FFFFFF"/>
+                          </a:solidFill>
+                          <a:latin typeface="Calibri"/>
+                        </a:rPr>
+                        <a:t>2 / 11 services</a:t>
+                      </a:r>
+                    </a:p>
+                  </a:txBody>
+                  <a:tcPr marL="76200" marR="76200" marT="38100" marB="38100">
+                    <a:solidFill>
+                      <a:srgbClr val="2A2A3E"/>
+                    </a:solidFill>
+                  </a:tcPr>
+                </a:tc>
+                <a:tc>
+                  <a:txBody>
+                    <a:bodyPr wrap="square"/>
+                    <a:lstStyle/>
+                    <a:p>
+                      <a:pPr algn="l"/>
+                      <a:r>
+                        <a:rPr sz="900" b="0">
+                          <a:solidFill>
+                            <a:srgbClr val="FFFFFF"/>
+                          </a:solidFill>
+                          <a:latin typeface="Calibri"/>
+                        </a:rPr>
+                        <a:t>2</a:t>
+                      </a:r>
+                    </a:p>
+                  </a:txBody>
+                  <a:tcPr marL="76200" marR="76200" marT="38100" marB="38100">
+                    <a:solidFill>
+                      <a:srgbClr val="2A2A3E"/>
+                    </a:solidFill>
+                  </a:tcPr>
+                </a:tc>
+                <a:tc>
+                  <a:txBody>
+                    <a:bodyPr wrap="square"/>
+                    <a:lstStyle/>
+                    <a:p>
+                      <a:pPr algn="l"/>
+                      <a:r>
+                        <a:rPr sz="900" b="0">
+                          <a:solidFill>
+                            <a:srgbClr val="FFFFFF"/>
+                          </a:solidFill>
+                          <a:latin typeface="Calibri"/>
+                        </a:rPr>
+                        <a:t>33.1 s</a:t>
                       </a:r>
                     </a:p>
                   </a:txBody>
@@ -5970,8 +6935,8 @@
         </p:nvSpPr>
         <p:spPr>
           <a:xfrm>
-            <a:off x="640080" y="3063240"/>
-            <a:ext cx="5577840" cy="2194560"/>
+            <a:off x="640080" y="3840480"/>
+            <a:ext cx="5577840" cy="1417320"/>
           </a:xfrm>
           <a:prstGeom prst="rect">
             <a:avLst/>
@@ -5999,15 +6964,15 @@
               </a:defRPr>
             </a:pPr>
             <a:r>
-              <a:t>• Blast radius = services at 0 ready endpoints at the</a:t>
+              <a:t>• Observed blast = placement-predicted blast for ALL 6</a:t>
             </a:r>
             <a:br/>
             <a:r>
-              <a:t>  outage trough, read from EndpointSlice snapshots —</a:t>
+              <a:t>  placing strategies — Spearman ρ = 1.0 (n = 6); read from</a:t>
             </a:r>
             <a:br/>
             <a:r>
-              <a:t>  not the score (a drain leaves every probe Unknown; H1)</a:t>
+              <a:t>  EndpointSlice troughs, not the score (probes Unknown; H1)</a:t>
             </a:r>
           </a:p>
           <a:p>
@@ -6026,13 +6991,121 @@
               </a:defRPr>
             </a:pPr>
             <a:r>
-              <a:t>• Observed blast equals the placement-predicted blast</a:t>
+              <a:t>• Recovery is NOT monotone in blast (4.6 s and 33.3 s both</a:t>
             </a:r>
             <a:br/>
             <a:r>
-              <a:t>  in every iteration, across two doctor-clean batches</a:t>
-            </a:r>
-          </a:p>
+              <a:t>  at intermediate blast) — the ~4× contrast (10.3 s vs 2.6 s)</a:t>
+            </a:r>
+            <a:br/>
+            <a:r>
+              <a:t>  is claimed only at the colocate-vs-spread extremes</a:t>
+            </a:r>
+          </a:p>
+        </p:txBody>
+      </p:sp>
+      <p:sp>
+        <p:nvSpPr>
+          <p:cNvPr id="8" name="Rounded Rectangle 7"/>
+          <p:cNvSpPr/>
+          <p:nvPr/>
+        </p:nvSpPr>
+        <p:spPr>
+          <a:xfrm>
+            <a:off x="6675120" y="1280160"/>
+            <a:ext cx="5029200" cy="4023360"/>
+          </a:xfrm>
+          <a:prstGeom prst="roundRect">
+            <a:avLst/>
+          </a:prstGeom>
+          <a:solidFill>
+            <a:srgbClr val="121222"/>
+          </a:solidFill>
+          <a:ln w="25400">
+            <a:solidFill>
+              <a:srgbClr val="9B59B6"/>
+            </a:solidFill>
+          </a:ln>
+        </p:spPr>
+        <p:style>
+          <a:lnRef idx="1">
+            <a:schemeClr val="accent1"/>
+          </a:lnRef>
+          <a:fillRef idx="3">
+            <a:schemeClr val="accent1"/>
+          </a:fillRef>
+          <a:effectRef idx="2">
+            <a:schemeClr val="accent1"/>
+          </a:effectRef>
+          <a:fontRef idx="minor">
+            <a:schemeClr val="lt1"/>
+          </a:fontRef>
+        </p:style>
+        <p:txBody>
+          <a:bodyPr rtlCol="0" anchor="ctr"/>
+          <a:lstStyle/>
+          <a:p>
+            <a:pPr algn="ctr"/>
+          </a:p>
+        </p:txBody>
+      </p:sp>
+      <p:sp>
+        <p:nvSpPr>
+          <p:cNvPr id="9" name="TextBox 8"/>
+          <p:cNvSpPr txBox="1"/>
+          <p:nvPr/>
+        </p:nvSpPr>
+        <p:spPr>
+          <a:xfrm>
+            <a:off x="6858000" y="1325880"/>
+            <a:ext cx="4663440" cy="274320"/>
+          </a:xfrm>
+          <a:prstGeom prst="rect">
+            <a:avLst/>
+          </a:prstGeom>
+          <a:noFill/>
+        </p:spPr>
+        <p:txBody>
+          <a:bodyPr wrap="square">
+            <a:spAutoFit/>
+          </a:bodyPr>
+          <a:lstStyle/>
+          <a:p>
+            <a:pPr algn="l">
+              <a:defRPr sz="1400" b="1">
+                <a:solidFill>
+                  <a:srgbClr val="9B59B6"/>
+                </a:solidFill>
+                <a:latin typeface="Calibri"/>
+              </a:defRPr>
+            </a:pPr>
+            <a:r>
+              <a:t>One placement property, two opposing consequences</a:t>
+            </a:r>
+          </a:p>
+        </p:txBody>
+      </p:sp>
+      <p:sp>
+        <p:nvSpPr>
+          <p:cNvPr id="10" name="TextBox 9"/>
+          <p:cNvSpPr txBox="1"/>
+          <p:nvPr/>
+        </p:nvSpPr>
+        <p:spPr>
+          <a:xfrm>
+            <a:off x="6858000" y="1691640"/>
+            <a:ext cx="4663440" cy="3474720"/>
+          </a:xfrm>
+          <a:prstGeom prst="rect">
+            <a:avLst/>
+          </a:prstGeom>
+          <a:noFill/>
+        </p:spPr>
+        <p:txBody>
+          <a:bodyPr wrap="square">
+            <a:spAutoFit/>
+          </a:bodyPr>
+          <a:lstStyle/>
           <a:p>
             <a:pPr>
               <a:spcBef>
@@ -6049,117 +7122,17 @@
               </a:defRPr>
             </a:pPr>
             <a:r>
-              <a:t>• Recovery scales with concentration too: 11 evicted</a:t>
+              <a:t>• colocate: best east-west tail (H5: ~33–34 ms</a:t>
             </a:r>
             <a:br/>
             <a:r>
-              <a:t>  pods reschedule at once vs 2 — ~4× slower</a:t>
-            </a:r>
-          </a:p>
-        </p:txBody>
-      </p:sp>
-      <p:sp>
-        <p:nvSpPr>
-          <p:cNvPr id="8" name="Rounded Rectangle 7"/>
-          <p:cNvSpPr/>
-          <p:nvPr/>
-        </p:nvSpPr>
-        <p:spPr>
-          <a:xfrm>
-            <a:off x="6675120" y="1280160"/>
-            <a:ext cx="5029200" cy="4023360"/>
-          </a:xfrm>
-          <a:prstGeom prst="roundRect">
-            <a:avLst/>
-          </a:prstGeom>
-          <a:solidFill>
-            <a:srgbClr val="121222"/>
-          </a:solidFill>
-          <a:ln w="25400">
-            <a:solidFill>
-              <a:srgbClr val="9B59B6"/>
-            </a:solidFill>
-          </a:ln>
-        </p:spPr>
-        <p:style>
-          <a:lnRef idx="1">
-            <a:schemeClr val="accent1"/>
-          </a:lnRef>
-          <a:fillRef idx="3">
-            <a:schemeClr val="accent1"/>
-          </a:fillRef>
-          <a:effectRef idx="2">
-            <a:schemeClr val="accent1"/>
-          </a:effectRef>
-          <a:fontRef idx="minor">
-            <a:schemeClr val="lt1"/>
-          </a:fontRef>
-        </p:style>
-        <p:txBody>
-          <a:bodyPr rtlCol="0" anchor="ctr"/>
-          <a:lstStyle/>
-          <a:p>
-            <a:pPr algn="ctr"/>
-          </a:p>
-        </p:txBody>
-      </p:sp>
-      <p:sp>
-        <p:nvSpPr>
-          <p:cNvPr id="9" name="TextBox 8"/>
-          <p:cNvSpPr txBox="1"/>
-          <p:nvPr/>
-        </p:nvSpPr>
-        <p:spPr>
-          <a:xfrm>
-            <a:off x="6858000" y="1325880"/>
-            <a:ext cx="4663440" cy="274320"/>
-          </a:xfrm>
-          <a:prstGeom prst="rect">
-            <a:avLst/>
-          </a:prstGeom>
-          <a:noFill/>
-        </p:spPr>
-        <p:txBody>
-          <a:bodyPr wrap="square">
-            <a:spAutoFit/>
-          </a:bodyPr>
-          <a:lstStyle/>
-          <a:p>
-            <a:pPr algn="l">
-              <a:defRPr sz="1400" b="1">
-                <a:solidFill>
-                  <a:srgbClr val="9B59B6"/>
-                </a:solidFill>
-                <a:latin typeface="Calibri"/>
-              </a:defRPr>
-            </a:pPr>
-            <a:r>
-              <a:t>One placement property, two opposing consequences</a:t>
-            </a:r>
-          </a:p>
-        </p:txBody>
-      </p:sp>
-      <p:sp>
-        <p:nvSpPr>
-          <p:cNvPr id="10" name="TextBox 9"/>
-          <p:cNvSpPr txBox="1"/>
-          <p:nvPr/>
-        </p:nvSpPr>
-        <p:spPr>
-          <a:xfrm>
-            <a:off x="6858000" y="1691640"/>
-            <a:ext cx="4663440" cy="3474720"/>
-          </a:xfrm>
-          <a:prstGeom prst="rect">
-            <a:avLst/>
-          </a:prstGeom>
-          <a:noFill/>
-        </p:spPr>
-        <p:txBody>
-          <a:bodyPr wrap="square">
-            <a:spAutoFit/>
-          </a:bodyPr>
-          <a:lstStyle/>
+              <a:t>  in both batches) AND worst node-failure</a:t>
+            </a:r>
+            <a:br/>
+            <a:r>
+              <a:t>  blast (100% outage) — spread is the mirror</a:t>
+            </a:r>
+          </a:p>
           <a:p>
             <a:pPr>
               <a:spcBef>
@@ -6176,15 +7149,11 @@
               </a:defRPr>
             </a:pPr>
             <a:r>
-              <a:t>• colocate: best east-west tail (H5: 33.9 ms,</a:t>
+              <a:t>• H5 is the latency face, H6 the availability</a:t>
             </a:r>
             <a:br/>
             <a:r>
-              <a:t>  lowest) AND worst node-failure blast</a:t>
-            </a:r>
-            <a:br/>
-            <a:r>
-              <a:t>  (100% outage) — spread is the mirror</a:t>
+              <a:t>  face of the same co-location metric</a:t>
             </a:r>
           </a:p>
           <a:p>
@@ -6203,11 +7172,15 @@
               </a:defRPr>
             </a:pPr>
             <a:r>
-              <a:t>• H5 is the latency face, H6 the availability</a:t>
+              <a:t>• Where placement DOES bite users in this</a:t>
             </a:r>
             <a:br/>
             <a:r>
-              <a:t>  face of the same co-location metric</a:t>
+              <a:t>  study is availability under node failure —</a:t>
+            </a:r>
+            <a:br/>
+            <a:r>
+              <a:t>  and it is predictable from the placement</a:t>
             </a:r>
           </a:p>
           <a:p>
@@ -6226,15 +7199,15 @@
               </a:defRPr>
             </a:pPr>
             <a:r>
-              <a:t>• Where placement DOES bite users in this</a:t>
+              <a:t>• Quantification of a known qualitative</a:t>
             </a:r>
             <a:br/>
             <a:r>
-              <a:t>  study is availability under node failure —</a:t>
+              <a:t>  trade-off (cell-based architectures), not</a:t>
             </a:r>
             <a:br/>
             <a:r>
-              <a:t>  and it is predictable from the placement</a:t>
+              <a:t>  a discovery</a:t>
             </a:r>
           </a:p>
           <a:p>
@@ -6253,38 +7226,11 @@
               </a:defRPr>
             </a:pPr>
             <a:r>
-              <a:t>• Quantification of a known qualitative</a:t>
+              <a:t>• Reproduced: two doctor-clean two-point</a:t>
             </a:r>
             <a:br/>
             <a:r>
-              <a:t>  trade-off (cell-based architectures), not</a:t>
-            </a:r>
-            <a:br/>
-            <a:r>
-              <a:t>  a discovery</a:t>
-            </a:r>
-          </a:p>
-          <a:p>
-            <a:pPr>
-              <a:spcBef>
-                <a:spcPts val="200"/>
-              </a:spcBef>
-              <a:spcAft>
-                <a:spcPts val="200"/>
-              </a:spcAft>
-              <a:defRPr sz="1000">
-                <a:solidFill>
-                  <a:srgbClr val="BDBDBD"/>
-                </a:solidFill>
-                <a:latin typeface="Calibri"/>
-              </a:defRPr>
-            </a:pPr>
-            <a:r>
-              <a:t>• Two-point contrast (the extremes); a</a:t>
-            </a:r>
-            <a:br/>
-            <a:r>
-              <a:t>  6-strategy gradient run extends this</a:t>
+              <a:t>  batches + a completed 6-strategy gradient</a:t>
             </a:r>
           </a:p>
         </p:txBody>
@@ -7837,7 +8783,7 @@
               </a:defRPr>
             </a:pPr>
             <a:r>
-              <a:t>The churn findings (H2, H3) rest on the colocate-vs-spread locality contrast; H5 covers all 8 placements but is single-batch; H6 is a two-point contrast of the extremes — a 6-strategy gradient run extends it. Intermediate placements are not yet validated per-hypothesis.</a:t>
+              <a:t>The churn findings (H2, H3) rest on the colocate-vs-spread locality contrast; H5 covers all 8 placements across two independent batches; H6's extremes contrast is extended by a completed 6-strategy gradient (blast ρ = 1.0) — but recovery is validated only at the extremes.</a:t>
             </a:r>
           </a:p>
         </p:txBody>
@@ -8488,7 +9434,11 @@
             </a:r>
             <a:br/>
             <a:r>
-              <a:t>  load-bearing: a pre-chaos placement predictor (H5)</a:t>
+              <a:t>  load-bearing: a replicated pre-chaos placement</a:t>
+            </a:r>
+            <a:br/>
+            <a:r>
+              <a:t>  separator (H5)</a:t>
             </a:r>
           </a:p>
           <a:p>
@@ -8857,11 +9807,15 @@
               </a:defRPr>
             </a:pPr>
             <a:r>
-              <a:t>• H6 gradient: intermediate placements between the</a:t>
+              <a:t>• Recovery dynamics across the H6 gradient — why</a:t>
             </a:r>
             <a:br/>
             <a:r>
-              <a:t>  extremes (6-strategy gradient run in flight)</a:t>
+              <a:t>  intermediate-blast placements recover</a:t>
+            </a:r>
+            <a:br/>
+            <a:r>
+              <a:t>  non-monotonically</a:t>
             </a:r>
           </a:p>
           <a:p>
@@ -8926,15 +9880,15 @@
               </a:defRPr>
             </a:pPr>
             <a:r>
-              <a:t>• Re-attribute the conntrack flush to its exact code</a:t>
+              <a:t>• Apportion the H2 flush between kernel TCP teardown</a:t>
             </a:r>
             <a:br/>
             <a:r>
-              <a:t>  path (upstream active flush is UDP-only; this</a:t>
+              <a:t>  and kube-proxy's UDP-only cleanup (steady-state,</a:t>
             </a:r>
             <a:br/>
             <a:r>
-              <a:t>  workload is TCP/gRPC)</a:t>
+              <a:t>  multi-iteration probe)</a:t>
             </a:r>
           </a:p>
           <a:p>
@@ -9646,7 +10600,7 @@
               </a:defRPr>
             </a:pPr>
             <a:r>
-              <a:t>ρ = 0.79</a:t>
+              <a:t>ρ = 1.0</a:t>
             </a:r>
           </a:p>
         </p:txBody>
@@ -9682,11 +10636,11 @@
               </a:defRPr>
             </a:pPr>
             <a:r>
-              <a:t>Graph</a:t>
+              <a:t>Blast Radius</a:t>
             </a:r>
             <a:br/>
             <a:r>
-              <a:t>Predictor</a:t>
+              <a:t>Predicted</a:t>
             </a:r>
           </a:p>
         </p:txBody>
@@ -12070,7 +13024,7 @@
               </a:defRPr>
             </a:pPr>
             <a:r>
-              <a:t>A graph metric predicts the east-west tail</a:t>
+              <a:t>A graph metric separates the placement regimes</a:t>
             </a:r>
           </a:p>
         </p:txBody>
@@ -12106,7 +13060,7 @@
               </a:defRPr>
             </a:pPr>
             <a:r>
-              <a:t>Cross-node call fraction (dependency graph + placement, pre-chaos) vs east-west p95: ρ = 0.79 (n = 8, p &lt; .05). Coarse — separates node-local from spreading placements — but makes the Neo4j graph analytically load-bearing.</a:t>
+              <a:t>Cross-node call fraction (dependency graph + placement, pre-chaos): the node-local pair (colocate, best-fit; fraction ≈ 0) takes the two lowest east-west tails of 8 in BOTH load batches (joint null ≈ 0.0013), ~1.25× below the spreading cluster. Continuous ρ = 0.79 (batch 1) did not replicate (0.25 n.s.) — a separator, not a smooth law.</a:t>
             </a:r>
           </a:p>
         </p:txBody>
@@ -12276,7 +13230,7 @@
               </a:defRPr>
             </a:pPr>
             <a:r>
-              <a:t>Node drain: colocate loses 11/11 services (100% blast, ~10.3 s recovery) vs spread 2/11 (18%, ~2.6 s); two doctor-clean batches. The co-location that wins H5's latency loses H6's availability.</a:t>
+              <a:t>Node drain: colocate loses 11/11 services (100% blast) vs spread 2/11 (18%). 6-strategy gradient: observed blast = placement-predicted blast (11, 4, 3, 3, 2, 2; ρ = 1.0, n = 6). Recovery is NOT monotone in blast — ~4× (10.3 s vs 2.6 s) only at the colocate-vs-spread extremes.</a:t>
             </a:r>
           </a:p>
         </p:txBody>
@@ -17029,7 +17983,7 @@
               </a:defRPr>
             </a:pPr>
             <a:r>
-              <a:t>Analytic weight: the churn findings (H2 conntrack reconvergence, H3 decoupling) rest on the colocate vs. spread locality contrast. All 8 placements enter the load matrix — H5's cross-node fraction is computed per strategy (n = 8) — and H6 contrasts the two extremes (colocate vs. spread) under node drain; a gradient run over the intermediate placements extends that two-point contrast.</a:t>
+              <a:t>Analytic weight: the churn findings (H2 conntrack reconvergence, H3 decoupling) rest on the colocate vs. spread locality contrast. All 8 placements enter the load matrix — H5's cross-node fraction is computed per strategy (n = 8, two independent batches) — and H6 spans the full 6-strategy gradient under node drain (observed blast = predicted for every strategy), with the recovery contrast scoped to the extremes.</a:t>
             </a:r>
           </a:p>
         </p:txBody>

</xml_diff>